<commit_message>
Poster: add the extended-model SHAP figure next to the experiment conclusions
Co-Authored-By: Claude Opus 5.5 <noreply@anthropic.com>
</commit_message>
<xml_diff>
--- a/poster/Команда_11_Постер.pptx
+++ b/poster/Команда_11_Постер.pptx
@@ -7004,7 +7004,7 @@
         <p:spPr>
           <a:xfrm>
             <a:off x="15408000" y="10656000"/>
-            <a:ext cx="12492000" cy="10445990"/>
+            <a:ext cx="12492000" cy="9324718"/>
           </a:xfrm>
           <a:prstGeom prst="roundRect">
             <a:avLst>
@@ -7329,8 +7329,8 @@
         </p:nvSpPr>
         <p:spPr>
           <a:xfrm>
-            <a:off x="15408000" y="21407990"/>
-            <a:ext cx="12492000" cy="12647182"/>
+            <a:off x="15408000" y="20286718"/>
+            <a:ext cx="12492000" cy="14889727"/>
           </a:xfrm>
           <a:prstGeom prst="roundRect">
             <a:avLst>
@@ -7377,7 +7377,7 @@
         </p:nvSpPr>
         <p:spPr>
           <a:xfrm>
-            <a:off x="15660000" y="21659990"/>
+            <a:off x="15660000" y="20538718"/>
             <a:ext cx="11988000" cy="576717"/>
           </a:xfrm>
           <a:prstGeom prst="rect">
@@ -7417,7 +7417,7 @@
         </p:nvSpPr>
         <p:spPr>
           <a:xfrm>
-            <a:off x="15660000" y="22272708"/>
+            <a:off x="15660000" y="21151436"/>
             <a:ext cx="2160000" cy="43200"/>
           </a:xfrm>
           <a:prstGeom prst="rect">
@@ -7460,7 +7460,7 @@
         </p:nvSpPr>
         <p:spPr>
           <a:xfrm>
-            <a:off x="15660000" y="22398708"/>
+            <a:off x="15660000" y="21277436"/>
             <a:ext cx="11988000" cy="1081346"/>
           </a:xfrm>
           <a:prstGeom prst="rect">
@@ -7487,25 +7487,7 @@
                 </a:solidFill>
                 <a:latin typeface="Inter"/>
               </a:rPr>
-              <a:t>Эксперимент команды: MLP (15, 15, 15), порог P(сон) ≥ 0.5, признаки motion, hr и </a:t>
-            </a:r>
-            <a:r>
-              <a:rPr sz="2000" b="1">
-                <a:solidFill>
-                  <a:srgbClr val="434B9A"/>
-                </a:solidFill>
-                <a:latin typeface="Inter"/>
-              </a:rPr>
-              <a:t>cosine</a:t>
-            </a:r>
-            <a:r>
-              <a:rPr sz="2000" b="0">
-                <a:solidFill>
-                  <a:srgbClr val="1F2233"/>
-                </a:solidFill>
-                <a:latin typeface="Inter"/>
-              </a:rPr>
-              <a:t>. Добавили 3 «быстрых» признака по 5-секундным отрезкам: m — корень из суммы дисперсий ускорения по осям, τ = 0.02 g, окно W = [t − 15, t + 45) с</a:t>
+              <a:t>Эксперимент команды: MLP (15, 15, 15), порог P(сон) ≥ 0.5, признаки motion, hr и время ночи. Добавили 3 «быстрых» признака по 5-секундным отрезкам: m — корень из суммы дисперсий ускорения по осям, τ = 0.02 g, окно W = [t − 15, t + 45) с</a:t>
             </a:r>
           </a:p>
         </p:txBody>
@@ -7526,7 +7508,7 @@
         </p:blipFill>
         <p:spPr>
           <a:xfrm>
-            <a:off x="15660000" y="23588054"/>
+            <a:off x="15660000" y="22466782"/>
             <a:ext cx="3417262" cy="779180"/>
           </a:xfrm>
           <a:prstGeom prst="rect">
@@ -7550,7 +7532,7 @@
         </p:blipFill>
         <p:spPr>
           <a:xfrm>
-            <a:off x="19754810" y="23588054"/>
+            <a:off x="19754810" y="22466782"/>
             <a:ext cx="4912133" cy="779180"/>
           </a:xfrm>
           <a:prstGeom prst="rect">
@@ -7574,7 +7556,7 @@
         </p:blipFill>
         <p:spPr>
           <a:xfrm>
-            <a:off x="25344492" y="23588054"/>
+            <a:off x="25344492" y="22466782"/>
             <a:ext cx="2303507" cy="779180"/>
           </a:xfrm>
           <a:prstGeom prst="rect">
@@ -7590,7 +7572,7 @@
         </p:nvSpPr>
         <p:spPr>
           <a:xfrm>
-            <a:off x="15660000" y="24475235"/>
+            <a:off x="15660000" y="23353962"/>
             <a:ext cx="11988000" cy="1347746"/>
           </a:xfrm>
           <a:prstGeom prst="rect">
@@ -7718,8 +7700,32 @@
         </p:blipFill>
         <p:spPr>
           <a:xfrm>
-            <a:off x="16738920" y="25822981"/>
+            <a:off x="16738920" y="24701708"/>
             <a:ext cx="9830160" cy="3667416"/>
+          </a:xfrm>
+          <a:prstGeom prst="rect">
+            <a:avLst/>
+          </a:prstGeom>
+        </p:spPr>
+      </p:pic>
+      <p:pic>
+        <p:nvPicPr>
+          <p:cNvPr id="66" name="Picture 65" descr="shap_fast_right.png"/>
+          <p:cNvPicPr>
+            <a:picLocks noChangeAspect="1"/>
+          </p:cNvPicPr>
+          <p:nvPr/>
+        </p:nvPicPr>
+        <p:blipFill>
+          <a:blip r:embed="rId16"/>
+          <a:stretch>
+            <a:fillRect/>
+          </a:stretch>
+        </p:blipFill>
+        <p:spPr>
+          <a:xfrm>
+            <a:off x="15660000" y="28477125"/>
+            <a:ext cx="5415120" cy="4928079"/>
           </a:xfrm>
           <a:prstGeom prst="rect">
             <a:avLst/>
@@ -7728,14 +7734,54 @@
       </p:pic>
       <p:sp>
         <p:nvSpPr>
-          <p:cNvPr id="66" name="TextBox 65"/>
+          <p:cNvPr id="67" name="TextBox 66"/>
           <p:cNvSpPr txBox="1"/>
           <p:nvPr/>
         </p:nvSpPr>
         <p:spPr>
           <a:xfrm>
-            <a:off x="15660000" y="29598397"/>
-            <a:ext cx="11988000" cy="2068643"/>
+            <a:off x="15660000" y="33495205"/>
+            <a:ext cx="5415120" cy="306381"/>
+          </a:xfrm>
+          <a:prstGeom prst="rect">
+            <a:avLst/>
+          </a:prstGeom>
+          <a:noFill/>
+        </p:spPr>
+        <p:txBody>
+          <a:bodyPr wrap="square" lIns="0" rIns="0" tIns="0" bIns="0" anchor="t"/>
+          <a:lstStyle/>
+          <a:p>
+            <a:pPr algn="ctr">
+              <a:lnSpc>
+                <a:spcPct val="110000"/>
+              </a:lnSpc>
+              <a:spcAft>
+                <a:spcPts val="0"/>
+              </a:spcAft>
+            </a:pPr>
+            <a:r>
+              <a:rPr sz="1700" b="0">
+                <a:solidFill>
+                  <a:srgbClr val="5B6075"/>
+                </a:solidFill>
+                <a:latin typeface="Inter"/>
+              </a:rPr>
+              <a:t>SHAP расширенного MLP (график команды)</a:t>
+            </a:r>
+          </a:p>
+        </p:txBody>
+      </p:sp>
+      <p:sp>
+        <p:nvSpPr>
+          <p:cNvPr id="68" name="TextBox 67"/>
+          <p:cNvSpPr txBox="1"/>
+          <p:nvPr/>
+        </p:nvSpPr>
+        <p:spPr>
+          <a:xfrm>
+            <a:off x="21291120" y="28677639"/>
+            <a:ext cx="6356880" cy="5031433"/>
           </a:xfrm>
           <a:prstGeom prst="rect">
             <a:avLst/>
@@ -7817,26 +7863,59 @@
               <a:buChar char="•"/>
             </a:pPr>
             <a:r>
+              <a:rPr sz="2000" b="1">
+                <a:solidFill>
+                  <a:srgbClr val="434B9A"/>
+                </a:solidFill>
+                <a:latin typeface="Inter"/>
+              </a:rPr>
+              <a:t>SHAP:</a:t>
+            </a:r>
+            <a:r>
               <a:rPr sz="2000" b="0">
                 <a:solidFill>
                   <a:srgbClr val="1F2233"/>
                 </a:solidFill>
                 <a:latin typeface="Inter"/>
               </a:rPr>
-              <a:t>Окно заглядывает на 15 с вперёд, медиана пульса — по всей записи: это анализ готовой записи</a:t>
+              <a:t> «доля движения за минуту» (|SHAP| 0.024) работает почти как motion (0.034), пик движения и относительный пульс — слабее (0.009 и 0.005); время ночи остаётся самым сильным признаком (0.049)</a:t>
+            </a:r>
+          </a:p>
+          <a:p>
+            <a:pPr algn="l" marL="270000" indent="-270000">
+              <a:lnSpc>
+                <a:spcPct val="110000"/>
+              </a:lnSpc>
+              <a:spcAft>
+                <a:spcPts val="623"/>
+              </a:spcAft>
+              <a:buClr>
+                <a:srgbClr val="434B9A"/>
+              </a:buClr>
+              <a:buFont typeface="Arial"/>
+              <a:buChar char="•"/>
+            </a:pPr>
+            <a:r>
+              <a:rPr sz="2000" b="0">
+                <a:solidFill>
+                  <a:srgbClr val="1F2233"/>
+                </a:solidFill>
+                <a:latin typeface="Inter"/>
+              </a:rPr>
+              <a:t>Окно заглядывает на 15 с вперёд, медиана пульса — по всей записи: это анализ готовой записи, а не онлайн-предсказание</a:t>
             </a:r>
           </a:p>
         </p:txBody>
       </p:sp>
       <p:sp>
         <p:nvSpPr>
-          <p:cNvPr id="67" name="TextBox 66"/>
+          <p:cNvPr id="69" name="TextBox 68"/>
           <p:cNvSpPr txBox="1"/>
           <p:nvPr/>
         </p:nvSpPr>
         <p:spPr>
           <a:xfrm>
-            <a:off x="15660000" y="31667041"/>
+            <a:off x="15660000" y="33909586"/>
             <a:ext cx="11988000" cy="612762"/>
           </a:xfrm>
           <a:prstGeom prst="rect">
@@ -7888,14 +7967,14 @@
       </p:sp>
       <p:sp>
         <p:nvSpPr>
-          <p:cNvPr id="68" name="Rounded Rectangle 67"/>
+          <p:cNvPr id="70" name="Rounded Rectangle 69"/>
           <p:cNvSpPr/>
           <p:nvPr/>
         </p:nvSpPr>
         <p:spPr>
           <a:xfrm>
-            <a:off x="15408000" y="34361172"/>
-            <a:ext cx="12492000" cy="5526827"/>
+            <a:off x="15408000" y="35482445"/>
+            <a:ext cx="12492000" cy="4405554"/>
           </a:xfrm>
           <a:prstGeom prst="roundRect">
             <a:avLst>
@@ -7936,13 +8015,13 @@
       </p:sp>
       <p:sp>
         <p:nvSpPr>
-          <p:cNvPr id="69" name="TextBox 68"/>
+          <p:cNvPr id="71" name="TextBox 70"/>
           <p:cNvSpPr txBox="1"/>
           <p:nvPr/>
         </p:nvSpPr>
         <p:spPr>
           <a:xfrm>
-            <a:off x="15660000" y="34613172"/>
+            <a:off x="15660000" y="35734445"/>
             <a:ext cx="11988000" cy="576717"/>
           </a:xfrm>
           <a:prstGeom prst="rect">
@@ -7976,13 +8055,13 @@
       </p:sp>
       <p:sp>
         <p:nvSpPr>
-          <p:cNvPr id="70" name="Rectangle 69"/>
+          <p:cNvPr id="72" name="Rectangle 71"/>
           <p:cNvSpPr/>
           <p:nvPr/>
         </p:nvSpPr>
         <p:spPr>
           <a:xfrm>
-            <a:off x="15660000" y="35225890"/>
+            <a:off x="15660000" y="36347163"/>
             <a:ext cx="2160000" cy="43200"/>
           </a:xfrm>
           <a:prstGeom prst="rect">
@@ -8019,13 +8098,13 @@
       </p:sp>
       <p:sp>
         <p:nvSpPr>
-          <p:cNvPr id="71" name="TextBox 70"/>
+          <p:cNvPr id="73" name="TextBox 72"/>
           <p:cNvSpPr txBox="1"/>
           <p:nvPr/>
         </p:nvSpPr>
         <p:spPr>
           <a:xfrm>
-            <a:off x="15660000" y="35351890"/>
+            <a:off x="15660000" y="36473163"/>
             <a:ext cx="11988000" cy="2868740"/>
           </a:xfrm>
           <a:prstGeom prst="rect">
@@ -8152,7 +8231,7 @@
       </p:sp>
       <p:sp>
         <p:nvSpPr>
-          <p:cNvPr id="72" name="TextBox 71"/>
+          <p:cNvPr id="74" name="TextBox 73"/>
           <p:cNvSpPr txBox="1"/>
           <p:nvPr/>
         </p:nvSpPr>

</xml_diff>

<commit_message>
Poster tables: paper accuracy and kappa next to ours, auto-fit column widths
- sleep/wake: the paper's accuracy is added to the "Статья" block, so every
  metric is labelled as ours or the paper's
- three classes: best accuracy and kappa at the paper's operating point, for us
  and for the paper; equalised NREM/REM shares stay alongside
- column widths are fitted to headers and values (Inter metrics), so words are
  no longer broken; the font shrinks only if a table does not fit

Co-Authored-By: Claude Opus 5.5 <noreply@anthropic.com>
</commit_message>
<xml_diff>
--- a/poster/Команда_11_Постер.pptx
+++ b/poster/Команда_11_Постер.pptx
@@ -1785,7 +1785,7 @@
         <p:spPr>
           <a:xfrm>
             <a:off x="2376000" y="10656000"/>
-            <a:ext cx="12492000" cy="7978421"/>
+            <a:ext cx="12492000" cy="7632096"/>
           </a:xfrm>
           <a:prstGeom prst="roundRect">
             <a:avLst>
@@ -2125,8 +2125,8 @@
         </p:blipFill>
         <p:spPr>
           <a:xfrm>
-            <a:off x="5505120" y="14983907"/>
-            <a:ext cx="6233760" cy="2671611"/>
+            <a:off x="5924700" y="14983907"/>
+            <a:ext cx="5394600" cy="2311971"/>
           </a:xfrm>
           <a:prstGeom prst="rect">
             <a:avLst/>
@@ -2141,7 +2141,7 @@
         </p:nvSpPr>
         <p:spPr>
           <a:xfrm>
-            <a:off x="2628000" y="17745518"/>
+            <a:off x="2628000" y="17385878"/>
             <a:ext cx="11988000" cy="612762"/>
           </a:xfrm>
           <a:prstGeom prst="rect">
@@ -2181,8 +2181,8 @@
         </p:nvSpPr>
         <p:spPr>
           <a:xfrm>
-            <a:off x="2376000" y="18940421"/>
-            <a:ext cx="12492000" cy="5341980"/>
+            <a:off x="2376000" y="18594096"/>
+            <a:ext cx="12492000" cy="5355294"/>
           </a:xfrm>
           <a:prstGeom prst="roundRect">
             <a:avLst>
@@ -2229,7 +2229,7 @@
         </p:nvSpPr>
         <p:spPr>
           <a:xfrm>
-            <a:off x="2628000" y="19192421"/>
+            <a:off x="2628000" y="18846096"/>
             <a:ext cx="11988000" cy="576717"/>
           </a:xfrm>
           <a:prstGeom prst="rect">
@@ -2269,7 +2269,7 @@
         </p:nvSpPr>
         <p:spPr>
           <a:xfrm>
-            <a:off x="2628000" y="19805139"/>
+            <a:off x="2628000" y="19458814"/>
             <a:ext cx="2160000" cy="43200"/>
           </a:xfrm>
           <a:prstGeom prst="rect">
@@ -2312,7 +2312,7 @@
         </p:nvSpPr>
         <p:spPr>
           <a:xfrm>
-            <a:off x="2628000" y="19931139"/>
+            <a:off x="2628000" y="19584814"/>
             <a:ext cx="11988000" cy="2868740"/>
           </a:xfrm>
           <a:prstGeom prst="rect">
@@ -2500,7 +2500,7 @@
         </p:blipFill>
         <p:spPr>
           <a:xfrm>
-            <a:off x="7065664" y="22799880"/>
+            <a:off x="7065664" y="22453555"/>
             <a:ext cx="3112670" cy="792000"/>
           </a:xfrm>
           <a:prstGeom prst="rect">
@@ -2516,7 +2516,7 @@
         </p:nvSpPr>
         <p:spPr>
           <a:xfrm>
-            <a:off x="2628000" y="23699880"/>
+            <a:off x="2628000" y="23353555"/>
             <a:ext cx="11988000" cy="306381"/>
           </a:xfrm>
           <a:prstGeom prst="rect">
@@ -2556,8 +2556,8 @@
         </p:nvSpPr>
         <p:spPr>
           <a:xfrm>
-            <a:off x="2376000" y="24588401"/>
-            <a:ext cx="12492000" cy="4415052"/>
+            <a:off x="2376000" y="24255390"/>
+            <a:ext cx="12492000" cy="4428367"/>
           </a:xfrm>
           <a:prstGeom prst="roundRect">
             <a:avLst>
@@ -2604,7 +2604,7 @@
         </p:nvSpPr>
         <p:spPr>
           <a:xfrm>
-            <a:off x="2628000" y="24840401"/>
+            <a:off x="2628000" y="24507390"/>
             <a:ext cx="11988000" cy="576717"/>
           </a:xfrm>
           <a:prstGeom prst="rect">
@@ -2644,7 +2644,7 @@
         </p:nvSpPr>
         <p:spPr>
           <a:xfrm>
-            <a:off x="2628000" y="25453119"/>
+            <a:off x="2628000" y="25120108"/>
             <a:ext cx="2160000" cy="43200"/>
           </a:xfrm>
           <a:prstGeom prst="rect">
@@ -2687,7 +2687,7 @@
         </p:nvSpPr>
         <p:spPr>
           <a:xfrm>
-            <a:off x="2628000" y="25579119"/>
+            <a:off x="2628000" y="25246108"/>
             <a:ext cx="11988000" cy="1708194"/>
           </a:xfrm>
           <a:prstGeom prst="rect">
@@ -2842,7 +2842,7 @@
         </p:blipFill>
         <p:spPr>
           <a:xfrm>
-            <a:off x="5922563" y="27287314"/>
+            <a:off x="5922563" y="26954303"/>
             <a:ext cx="5398872" cy="648000"/>
           </a:xfrm>
           <a:prstGeom prst="rect">
@@ -2866,7 +2866,7 @@
         </p:blipFill>
         <p:spPr>
           <a:xfrm>
-            <a:off x="5723026" y="28043314"/>
+            <a:off x="5723026" y="27710303"/>
             <a:ext cx="1572824" cy="684000"/>
           </a:xfrm>
           <a:prstGeom prst="rect">
@@ -2890,7 +2890,7 @@
         </p:blipFill>
         <p:spPr>
           <a:xfrm>
-            <a:off x="8555850" y="28043314"/>
+            <a:off x="8555850" y="27710303"/>
             <a:ext cx="2965123" cy="684000"/>
           </a:xfrm>
           <a:prstGeom prst="rect">
@@ -2906,8 +2906,8 @@
         </p:nvSpPr>
         <p:spPr>
           <a:xfrm>
-            <a:off x="2376000" y="29309454"/>
-            <a:ext cx="12492000" cy="10578545"/>
+            <a:off x="2376000" y="28989758"/>
+            <a:ext cx="12492000" cy="10898241"/>
           </a:xfrm>
           <a:prstGeom prst="roundRect">
             <a:avLst>
@@ -2954,7 +2954,7 @@
         </p:nvSpPr>
         <p:spPr>
           <a:xfrm>
-            <a:off x="2628000" y="29561454"/>
+            <a:off x="2628000" y="29241758"/>
             <a:ext cx="11988000" cy="576717"/>
           </a:xfrm>
           <a:prstGeom prst="rect">
@@ -2994,7 +2994,7 @@
         </p:nvSpPr>
         <p:spPr>
           <a:xfrm>
-            <a:off x="2628000" y="30174172"/>
+            <a:off x="2628000" y="29854475"/>
             <a:ext cx="2160000" cy="43200"/>
           </a:xfrm>
           <a:prstGeom prst="rect">
@@ -3037,7 +3037,7 @@
         </p:nvSpPr>
         <p:spPr>
           <a:xfrm>
-            <a:off x="2628000" y="30300172"/>
+            <a:off x="2628000" y="29980475"/>
             <a:ext cx="11988000" cy="306381"/>
           </a:xfrm>
           <a:prstGeom prst="rect">
@@ -3087,8 +3087,8 @@
           <p:nvPr/>
         </p:nvGraphicFramePr>
         <p:xfrm>
-          <a:off x="2628000" y="30714553"/>
-          <a:ext cx="11987995" cy="2972914"/>
+          <a:off x="2628000" y="30394857"/>
+          <a:ext cx="11987994" cy="2972914"/>
         </p:xfrm>
         <a:graphic>
           <a:graphicData uri="http://schemas.openxmlformats.org/drawingml/2006/table">
@@ -3097,35 +3097,114 @@
                 <a:tableStyleId>{5C22544A-7EE6-4342-B048-85BDC9FD1C3A}</a:tableStyleId>
               </a:tblPr>
               <a:tblGrid>
-                <a:gridCol w="3402534"/>
-                <a:gridCol w="791287"/>
-                <a:gridCol w="989108"/>
-                <a:gridCol w="949544"/>
-                <a:gridCol w="791287"/>
-                <a:gridCol w="830851"/>
-                <a:gridCol w="830851"/>
-                <a:gridCol w="870415"/>
-                <a:gridCol w="791287"/>
-                <a:gridCol w="949544"/>
-                <a:gridCol w="791287"/>
+                <a:gridCol w="2053044"/>
+                <a:gridCol w="808260"/>
+                <a:gridCol w="1082041"/>
+                <a:gridCol w="1101073"/>
+                <a:gridCol w="808260"/>
+                <a:gridCol w="808260"/>
+                <a:gridCol w="808260"/>
+                <a:gridCol w="819820"/>
+                <a:gridCol w="757931"/>
+                <a:gridCol w="1082041"/>
+                <a:gridCol w="1101073"/>
+                <a:gridCol w="757931"/>
               </a:tblGrid>
               <a:tr h="360336">
                 <a:tc>
                   <a:txBody>
+                    <a:bodyPr wrap="square"/>
+                    <a:lstStyle/>
+                    <a:p/>
+                  </a:txBody>
+                  <a:tcPr marL="64800" marR="64800" marT="21600" marB="21600" anchor="ctr">
+                    <a:solidFill>
+                      <a:srgbClr val="FFFFFF"/>
+                    </a:solidFill>
+                  </a:tcPr>
+                </a:tc>
+                <a:tc gridSpan="7">
+                  <a:txBody>
+                    <a:bodyPr wrap="square"/>
+                    <a:lstStyle/>
+                    <a:p>
+                      <a:pPr algn="ctr">
+                        <a:lnSpc>
+                          <a:spcPct val="110000"/>
+                        </a:lnSpc>
+                        <a:spcAft>
+                          <a:spcPts val="0"/>
+                        </a:spcAft>
+                      </a:pPr>
+                      <a:r>
+                        <a:rPr sz="1500" b="1">
+                          <a:solidFill>
+                            <a:srgbClr val="FFFFFF"/>
+                          </a:solidFill>
+                          <a:latin typeface="Inter"/>
+                        </a:rPr>
+                        <a:t>Наш результат (leave-one-subject-out)</a:t>
+                      </a:r>
+                    </a:p>
+                  </a:txBody>
+                  <a:tcPr marL="64800" marR="64800" marT="21600" marB="21600" anchor="ctr">
+                    <a:solidFill>
+                      <a:srgbClr val="2E3473"/>
+                    </a:solidFill>
+                  </a:tcPr>
+                </a:tc>
+                <a:tc hMerge="1">
+                  <a:txBody>
                     <a:bodyPr/>
                     <a:lstStyle/>
                     <a:p/>
                   </a:txBody>
-                  <a:tcPr anchor="ctr" marT="18000" marB="18000">
-                    <a:solidFill>
-                      <a:srgbClr val="FFFFFF"/>
-                    </a:solidFill>
-                  </a:tcPr>
-                </a:tc>
-                <a:tc gridSpan="7">
+                  <a:tcPr/>
+                </a:tc>
+                <a:tc hMerge="1">
                   <a:txBody>
                     <a:bodyPr/>
                     <a:lstStyle/>
+                    <a:p/>
+                  </a:txBody>
+                  <a:tcPr/>
+                </a:tc>
+                <a:tc hMerge="1">
+                  <a:txBody>
+                    <a:bodyPr/>
+                    <a:lstStyle/>
+                    <a:p/>
+                  </a:txBody>
+                  <a:tcPr/>
+                </a:tc>
+                <a:tc hMerge="1">
+                  <a:txBody>
+                    <a:bodyPr/>
+                    <a:lstStyle/>
+                    <a:p/>
+                  </a:txBody>
+                  <a:tcPr/>
+                </a:tc>
+                <a:tc hMerge="1">
+                  <a:txBody>
+                    <a:bodyPr/>
+                    <a:lstStyle/>
+                    <a:p/>
+                  </a:txBody>
+                  <a:tcPr/>
+                </a:tc>
+                <a:tc hMerge="1">
+                  <a:txBody>
+                    <a:bodyPr/>
+                    <a:lstStyle/>
+                    <a:p/>
+                  </a:txBody>
+                  <a:tcPr/>
+                </a:tc>
+                <a:tc gridSpan="4">
+                  <a:txBody>
+                    <a:bodyPr wrap="square"/>
+                    <a:lstStyle/>
                     <a:p>
                       <a:pPr algn="ctr">
                         <a:lnSpc>
@@ -3142,11 +3221,11 @@
                           </a:solidFill>
                           <a:latin typeface="Inter"/>
                         </a:rPr>
-                        <a:t>Наш результат (leave-one-subject-out)</a:t>
-                      </a:r>
-                    </a:p>
-                  </a:txBody>
-                  <a:tcPr anchor="ctr" marT="18000" marB="18000">
+                        <a:t>Статья (Monte Carlo)</a:t>
+                      </a:r>
+                    </a:p>
+                  </a:txBody>
+                  <a:tcPr marL="64800" marR="64800" marT="21600" marB="21600" anchor="ctr">
                     <a:solidFill>
                       <a:srgbClr val="2E3473"/>
                     </a:solidFill>
@@ -3159,76 +3238,6 @@
                     <a:p/>
                   </a:txBody>
                   <a:tcPr/>
-                </a:tc>
-                <a:tc hMerge="1">
-                  <a:txBody>
-                    <a:bodyPr/>
-                    <a:lstStyle/>
-                    <a:p/>
-                  </a:txBody>
-                  <a:tcPr/>
-                </a:tc>
-                <a:tc hMerge="1">
-                  <a:txBody>
-                    <a:bodyPr/>
-                    <a:lstStyle/>
-                    <a:p/>
-                  </a:txBody>
-                  <a:tcPr/>
-                </a:tc>
-                <a:tc hMerge="1">
-                  <a:txBody>
-                    <a:bodyPr/>
-                    <a:lstStyle/>
-                    <a:p/>
-                  </a:txBody>
-                  <a:tcPr/>
-                </a:tc>
-                <a:tc hMerge="1">
-                  <a:txBody>
-                    <a:bodyPr/>
-                    <a:lstStyle/>
-                    <a:p/>
-                  </a:txBody>
-                  <a:tcPr/>
-                </a:tc>
-                <a:tc hMerge="1">
-                  <a:txBody>
-                    <a:bodyPr/>
-                    <a:lstStyle/>
-                    <a:p/>
-                  </a:txBody>
-                  <a:tcPr/>
-                </a:tc>
-                <a:tc gridSpan="3">
-                  <a:txBody>
-                    <a:bodyPr/>
-                    <a:lstStyle/>
-                    <a:p>
-                      <a:pPr algn="ctr">
-                        <a:lnSpc>
-                          <a:spcPct val="110000"/>
-                        </a:lnSpc>
-                        <a:spcAft>
-                          <a:spcPts val="0"/>
-                        </a:spcAft>
-                      </a:pPr>
-                      <a:r>
-                        <a:rPr sz="1500" b="1">
-                          <a:solidFill>
-                            <a:srgbClr val="FFFFFF"/>
-                          </a:solidFill>
-                          <a:latin typeface="Inter"/>
-                        </a:rPr>
-                        <a:t>Статья (Monte Carlo)</a:t>
-                      </a:r>
-                    </a:p>
-                  </a:txBody>
-                  <a:tcPr anchor="ctr" marT="18000" marB="18000">
-                    <a:solidFill>
-                      <a:srgbClr val="2E3473"/>
-                    </a:solidFill>
-                  </a:tcPr>
                 </a:tc>
                 <a:tc hMerge="1">
                   <a:txBody>
@@ -3250,7 +3259,7 @@
               <a:tr h="684673">
                 <a:tc>
                   <a:txBody>
-                    <a:bodyPr/>
+                    <a:bodyPr wrap="square"/>
                     <a:lstStyle/>
                     <a:p>
                       <a:pPr algn="l">
@@ -3268,11 +3277,30 @@
                           </a:solidFill>
                           <a:latin typeface="Inter"/>
                         </a:rPr>
+                        <a:t> </a:t>
+                      </a:r>
+                    </a:p>
+                    <a:p>
+                      <a:pPr algn="l">
+                        <a:lnSpc>
+                          <a:spcPct val="110000"/>
+                        </a:lnSpc>
+                        <a:spcAft>
+                          <a:spcPts val="0"/>
+                        </a:spcAft>
+                      </a:pPr>
+                      <a:r>
+                        <a:rPr sz="1500" b="1">
+                          <a:solidFill>
+                            <a:srgbClr val="FFFFFF"/>
+                          </a:solidFill>
+                          <a:latin typeface="Inter"/>
+                        </a:rPr>
                         <a:t>Модель</a:t>
                       </a:r>
                     </a:p>
                   </a:txBody>
-                  <a:tcPr marL="64800" marR="64800" marT="28800" marB="28800" anchor="ctr">
+                  <a:tcPr marL="64800" marR="64800" marT="21600" marB="21600" anchor="ctr">
                     <a:solidFill>
                       <a:srgbClr val="434B9A"/>
                     </a:solidFill>
@@ -3280,7 +3308,7 @@
                 </a:tc>
                 <a:tc>
                   <a:txBody>
-                    <a:bodyPr/>
+                    <a:bodyPr wrap="square"/>
                     <a:lstStyle/>
                     <a:p>
                       <a:pPr algn="ctr">
@@ -3298,11 +3326,30 @@
                           </a:solidFill>
                           <a:latin typeface="Inter"/>
                         </a:rPr>
+                        <a:t> </a:t>
+                      </a:r>
+                    </a:p>
+                    <a:p>
+                      <a:pPr algn="ctr">
+                        <a:lnSpc>
+                          <a:spcPct val="110000"/>
+                        </a:lnSpc>
+                        <a:spcAft>
+                          <a:spcPts val="0"/>
+                        </a:spcAft>
+                      </a:pPr>
+                      <a:r>
+                        <a:rPr sz="1500" b="1">
+                          <a:solidFill>
+                            <a:srgbClr val="FFFFFF"/>
+                          </a:solidFill>
+                          <a:latin typeface="Inter"/>
+                        </a:rPr>
                         <a:t>AUC</a:t>
                       </a:r>
                     </a:p>
                   </a:txBody>
-                  <a:tcPr marL="64800" marR="64800" marT="28800" marB="28800" anchor="ctr">
+                  <a:tcPr marL="64800" marR="64800" marT="21600" marB="21600" anchor="ctr">
                     <a:solidFill>
                       <a:srgbClr val="434B9A"/>
                     </a:solidFill>
@@ -3310,7 +3357,7 @@
                 </a:tc>
                 <a:tc>
                   <a:txBody>
-                    <a:bodyPr/>
+                    <a:bodyPr wrap="square"/>
                     <a:lstStyle/>
                     <a:p>
                       <a:pPr algn="ctr">
@@ -3328,11 +3375,30 @@
                           </a:solidFill>
                           <a:latin typeface="Inter"/>
                         </a:rPr>
+                        <a:t> </a:t>
+                      </a:r>
+                    </a:p>
+                    <a:p>
+                      <a:pPr algn="ctr">
+                        <a:lnSpc>
+                          <a:spcPct val="110000"/>
+                        </a:lnSpc>
+                        <a:spcAft>
+                          <a:spcPts val="0"/>
+                        </a:spcAft>
+                      </a:pPr>
+                      <a:r>
+                        <a:rPr sz="1500" b="1">
+                          <a:solidFill>
+                            <a:srgbClr val="FFFFFF"/>
+                          </a:solidFill>
+                          <a:latin typeface="Inter"/>
+                        </a:rPr>
                         <a:t>Accuracy</a:t>
                       </a:r>
                     </a:p>
                   </a:txBody>
-                  <a:tcPr marL="64800" marR="64800" marT="28800" marB="28800" anchor="ctr">
+                  <a:tcPr marL="64800" marR="64800" marT="21600" marB="21600" anchor="ctr">
                     <a:solidFill>
                       <a:srgbClr val="434B9A"/>
                     </a:solidFill>
@@ -3340,7 +3406,7 @@
                 </a:tc>
                 <a:tc>
                   <a:txBody>
-                    <a:bodyPr/>
+                    <a:bodyPr wrap="square"/>
                     <a:lstStyle/>
                     <a:p>
                       <a:pPr algn="ctr">
@@ -3381,7 +3447,7 @@
                       </a:r>
                     </a:p>
                   </a:txBody>
-                  <a:tcPr marL="64800" marR="64800" marT="28800" marB="28800" anchor="ctr">
+                  <a:tcPr marL="64800" marR="64800" marT="21600" marB="21600" anchor="ctr">
                     <a:solidFill>
                       <a:srgbClr val="434B9A"/>
                     </a:solidFill>
@@ -3389,7 +3455,7 @@
                 </a:tc>
                 <a:tc>
                   <a:txBody>
-                    <a:bodyPr/>
+                    <a:bodyPr wrap="square"/>
                     <a:lstStyle/>
                     <a:p>
                       <a:pPr algn="ctr">
@@ -3407,11 +3473,30 @@
                           </a:solidFill>
                           <a:latin typeface="Inter"/>
                         </a:rPr>
+                        <a:t> </a:t>
+                      </a:r>
+                    </a:p>
+                    <a:p>
+                      <a:pPr algn="ctr">
+                        <a:lnSpc>
+                          <a:spcPct val="110000"/>
+                        </a:lnSpc>
+                        <a:spcAft>
+                          <a:spcPts val="0"/>
+                        </a:spcAft>
+                      </a:pPr>
+                      <a:r>
+                        <a:rPr sz="1500" b="1">
+                          <a:solidFill>
+                            <a:srgbClr val="FFFFFF"/>
+                          </a:solidFill>
+                          <a:latin typeface="Inter"/>
+                        </a:rPr>
                         <a:t>κ</a:t>
                       </a:r>
                     </a:p>
                   </a:txBody>
-                  <a:tcPr marL="64800" marR="64800" marT="28800" marB="28800" anchor="ctr">
+                  <a:tcPr marL="64800" marR="64800" marT="21600" marB="21600" anchor="ctr">
                     <a:solidFill>
                       <a:srgbClr val="434B9A"/>
                     </a:solidFill>
@@ -3419,7 +3504,7 @@
                 </a:tc>
                 <a:tc>
                   <a:txBody>
-                    <a:bodyPr/>
+                    <a:bodyPr wrap="square"/>
                     <a:lstStyle/>
                     <a:p>
                       <a:pPr algn="ctr">
@@ -3460,7 +3545,7 @@
                       </a:r>
                     </a:p>
                   </a:txBody>
-                  <a:tcPr marL="64800" marR="64800" marT="28800" marB="28800" anchor="ctr">
+                  <a:tcPr marL="64800" marR="64800" marT="21600" marB="21600" anchor="ctr">
                     <a:solidFill>
                       <a:srgbClr val="434B9A"/>
                     </a:solidFill>
@@ -3468,7 +3553,7 @@
                 </a:tc>
                 <a:tc>
                   <a:txBody>
-                    <a:bodyPr/>
+                    <a:bodyPr wrap="square"/>
                     <a:lstStyle/>
                     <a:p>
                       <a:pPr algn="ctr">
@@ -3509,7 +3594,7 @@
                       </a:r>
                     </a:p>
                   </a:txBody>
-                  <a:tcPr marL="64800" marR="64800" marT="28800" marB="28800" anchor="ctr">
+                  <a:tcPr marL="64800" marR="64800" marT="21600" marB="21600" anchor="ctr">
                     <a:solidFill>
                       <a:srgbClr val="434B9A"/>
                     </a:solidFill>
@@ -3517,7 +3602,7 @@
                 </a:tc>
                 <a:tc>
                   <a:txBody>
-                    <a:bodyPr/>
+                    <a:bodyPr wrap="square"/>
                     <a:lstStyle/>
                     <a:p>
                       <a:pPr algn="ctr">
@@ -3558,7 +3643,7 @@
                       </a:r>
                     </a:p>
                   </a:txBody>
-                  <a:tcPr marL="64800" marR="64800" marT="28800" marB="28800" anchor="ctr">
+                  <a:tcPr marL="64800" marR="64800" marT="21600" marB="21600" anchor="ctr">
                     <a:solidFill>
                       <a:srgbClr val="434B9A"/>
                     </a:solidFill>
@@ -3566,7 +3651,7 @@
                 </a:tc>
                 <a:tc>
                   <a:txBody>
-                    <a:bodyPr/>
+                    <a:bodyPr wrap="square"/>
                     <a:lstStyle/>
                     <a:p>
                       <a:pPr algn="ctr">
@@ -3584,11 +3669,30 @@
                           </a:solidFill>
                           <a:latin typeface="Inter"/>
                         </a:rPr>
+                        <a:t> </a:t>
+                      </a:r>
+                    </a:p>
+                    <a:p>
+                      <a:pPr algn="ctr">
+                        <a:lnSpc>
+                          <a:spcPct val="110000"/>
+                        </a:lnSpc>
+                        <a:spcAft>
+                          <a:spcPts val="0"/>
+                        </a:spcAft>
+                      </a:pPr>
+                      <a:r>
+                        <a:rPr sz="1500" b="1">
+                          <a:solidFill>
+                            <a:srgbClr val="FFFFFF"/>
+                          </a:solidFill>
+                          <a:latin typeface="Inter"/>
+                        </a:rPr>
                         <a:t>AUC</a:t>
                       </a:r>
                     </a:p>
                   </a:txBody>
-                  <a:tcPr marL="64800" marR="64800" marT="28800" marB="28800" anchor="ctr">
+                  <a:tcPr marL="64800" marR="64800" marT="21600" marB="21600" anchor="ctr">
                     <a:solidFill>
                       <a:srgbClr val="434B9A"/>
                     </a:solidFill>
@@ -3596,7 +3700,7 @@
                 </a:tc>
                 <a:tc>
                   <a:txBody>
-                    <a:bodyPr/>
+                    <a:bodyPr wrap="square"/>
                     <a:lstStyle/>
                     <a:p>
                       <a:pPr algn="ctr">
@@ -3614,6 +3718,55 @@
                           </a:solidFill>
                           <a:latin typeface="Inter"/>
                         </a:rPr>
+                        <a:t> </a:t>
+                      </a:r>
+                    </a:p>
+                    <a:p>
+                      <a:pPr algn="ctr">
+                        <a:lnSpc>
+                          <a:spcPct val="110000"/>
+                        </a:lnSpc>
+                        <a:spcAft>
+                          <a:spcPts val="0"/>
+                        </a:spcAft>
+                      </a:pPr>
+                      <a:r>
+                        <a:rPr sz="1500" b="1">
+                          <a:solidFill>
+                            <a:srgbClr val="FFFFFF"/>
+                          </a:solidFill>
+                          <a:latin typeface="Inter"/>
+                        </a:rPr>
+                        <a:t>Accuracy</a:t>
+                      </a:r>
+                    </a:p>
+                  </a:txBody>
+                  <a:tcPr marL="64800" marR="64800" marT="21600" marB="21600" anchor="ctr">
+                    <a:solidFill>
+                      <a:srgbClr val="434B9A"/>
+                    </a:solidFill>
+                  </a:tcPr>
+                </a:tc>
+                <a:tc>
+                  <a:txBody>
+                    <a:bodyPr wrap="square"/>
+                    <a:lstStyle/>
+                    <a:p>
+                      <a:pPr algn="ctr">
+                        <a:lnSpc>
+                          <a:spcPct val="110000"/>
+                        </a:lnSpc>
+                        <a:spcAft>
+                          <a:spcPts val="0"/>
+                        </a:spcAft>
+                      </a:pPr>
+                      <a:r>
+                        <a:rPr sz="1500" b="1">
+                          <a:solidFill>
+                            <a:srgbClr val="FFFFFF"/>
+                          </a:solidFill>
+                          <a:latin typeface="Inter"/>
+                        </a:rPr>
                         <a:t>Найдено</a:t>
                       </a:r>
                     </a:p>
@@ -3637,7 +3790,7 @@
                       </a:r>
                     </a:p>
                   </a:txBody>
-                  <a:tcPr marL="64800" marR="64800" marT="28800" marB="28800" anchor="ctr">
+                  <a:tcPr marL="64800" marR="64800" marT="21600" marB="21600" anchor="ctr">
                     <a:solidFill>
                       <a:srgbClr val="434B9A"/>
                     </a:solidFill>
@@ -3645,7 +3798,7 @@
                 </a:tc>
                 <a:tc>
                   <a:txBody>
-                    <a:bodyPr/>
+                    <a:bodyPr wrap="square"/>
                     <a:lstStyle/>
                     <a:p>
                       <a:pPr algn="ctr">
@@ -3663,11 +3816,30 @@
                           </a:solidFill>
                           <a:latin typeface="Inter"/>
                         </a:rPr>
+                        <a:t> </a:t>
+                      </a:r>
+                    </a:p>
+                    <a:p>
+                      <a:pPr algn="ctr">
+                        <a:lnSpc>
+                          <a:spcPct val="110000"/>
+                        </a:lnSpc>
+                        <a:spcAft>
+                          <a:spcPts val="0"/>
+                        </a:spcAft>
+                      </a:pPr>
+                      <a:r>
+                        <a:rPr sz="1500" b="1">
+                          <a:solidFill>
+                            <a:srgbClr val="FFFFFF"/>
+                          </a:solidFill>
+                          <a:latin typeface="Inter"/>
+                        </a:rPr>
                         <a:t>κ</a:t>
                       </a:r>
                     </a:p>
                   </a:txBody>
-                  <a:tcPr marL="64800" marR="64800" marT="28800" marB="28800" anchor="ctr">
+                  <a:tcPr marL="64800" marR="64800" marT="21600" marB="21600" anchor="ctr">
                     <a:solidFill>
                       <a:srgbClr val="434B9A"/>
                     </a:solidFill>
@@ -3677,7 +3849,7 @@
               <a:tr h="385581">
                 <a:tc>
                   <a:txBody>
-                    <a:bodyPr/>
+                    <a:bodyPr wrap="square"/>
                     <a:lstStyle/>
                     <a:p>
                       <a:pPr algn="l">
@@ -3695,11 +3867,11 @@
                           </a:solidFill>
                           <a:latin typeface="Inter"/>
                         </a:rPr>
-                        <a:t>Логистическая регрессия</a:t>
-                      </a:r>
-                    </a:p>
-                  </a:txBody>
-                  <a:tcPr marL="64800" marR="64800" marT="28800" marB="28800" anchor="ctr">
+                        <a:t>Лог. регрессия</a:t>
+                      </a:r>
+                    </a:p>
+                  </a:txBody>
+                  <a:tcPr marL="64800" marR="64800" marT="21600" marB="21600" anchor="ctr">
                     <a:solidFill>
                       <a:srgbClr val="FFFFFF"/>
                     </a:solidFill>
@@ -3707,7 +3879,7 @@
                 </a:tc>
                 <a:tc>
                   <a:txBody>
-                    <a:bodyPr/>
+                    <a:bodyPr wrap="square"/>
                     <a:lstStyle/>
                     <a:p>
                       <a:pPr algn="ctr">
@@ -3729,7 +3901,7 @@
                       </a:r>
                     </a:p>
                   </a:txBody>
-                  <a:tcPr marL="64800" marR="64800" marT="28800" marB="28800" anchor="ctr">
+                  <a:tcPr marL="64800" marR="64800" marT="21600" marB="21600" anchor="ctr">
                     <a:solidFill>
                       <a:srgbClr val="FFFFFF"/>
                     </a:solidFill>
@@ -3737,7 +3909,7 @@
                 </a:tc>
                 <a:tc>
                   <a:txBody>
-                    <a:bodyPr/>
+                    <a:bodyPr wrap="square"/>
                     <a:lstStyle/>
                     <a:p>
                       <a:pPr algn="ctr">
@@ -3759,7 +3931,7 @@
                       </a:r>
                     </a:p>
                   </a:txBody>
-                  <a:tcPr marL="64800" marR="64800" marT="28800" marB="28800" anchor="ctr">
+                  <a:tcPr marL="64800" marR="64800" marT="21600" marB="21600" anchor="ctr">
                     <a:solidFill>
                       <a:srgbClr val="FFFFFF"/>
                     </a:solidFill>
@@ -3767,7 +3939,7 @@
                 </a:tc>
                 <a:tc>
                   <a:txBody>
-                    <a:bodyPr/>
+                    <a:bodyPr wrap="square"/>
                     <a:lstStyle/>
                     <a:p>
                       <a:pPr algn="ctr">
@@ -3789,7 +3961,7 @@
                       </a:r>
                     </a:p>
                   </a:txBody>
-                  <a:tcPr marL="64800" marR="64800" marT="28800" marB="28800" anchor="ctr">
+                  <a:tcPr marL="64800" marR="64800" marT="21600" marB="21600" anchor="ctr">
                     <a:solidFill>
                       <a:srgbClr val="FFFFFF"/>
                     </a:solidFill>
@@ -3797,7 +3969,7 @@
                 </a:tc>
                 <a:tc>
                   <a:txBody>
-                    <a:bodyPr/>
+                    <a:bodyPr wrap="square"/>
                     <a:lstStyle/>
                     <a:p>
                       <a:pPr algn="ctr">
@@ -3819,7 +3991,7 @@
                       </a:r>
                     </a:p>
                   </a:txBody>
-                  <a:tcPr marL="64800" marR="64800" marT="28800" marB="28800" anchor="ctr">
+                  <a:tcPr marL="64800" marR="64800" marT="21600" marB="21600" anchor="ctr">
                     <a:solidFill>
                       <a:srgbClr val="FFFFFF"/>
                     </a:solidFill>
@@ -3827,7 +3999,7 @@
                 </a:tc>
                 <a:tc>
                   <a:txBody>
-                    <a:bodyPr/>
+                    <a:bodyPr wrap="square"/>
                     <a:lstStyle/>
                     <a:p>
                       <a:pPr algn="ctr">
@@ -3849,7 +4021,7 @@
                       </a:r>
                     </a:p>
                   </a:txBody>
-                  <a:tcPr marL="64800" marR="64800" marT="28800" marB="28800" anchor="ctr">
+                  <a:tcPr marL="64800" marR="64800" marT="21600" marB="21600" anchor="ctr">
                     <a:solidFill>
                       <a:srgbClr val="FFFFFF"/>
                     </a:solidFill>
@@ -3857,7 +4029,7 @@
                 </a:tc>
                 <a:tc>
                   <a:txBody>
-                    <a:bodyPr/>
+                    <a:bodyPr wrap="square"/>
                     <a:lstStyle/>
                     <a:p>
                       <a:pPr algn="ctr">
@@ -3879,7 +4051,7 @@
                       </a:r>
                     </a:p>
                   </a:txBody>
-                  <a:tcPr marL="64800" marR="64800" marT="28800" marB="28800" anchor="ctr">
+                  <a:tcPr marL="64800" marR="64800" marT="21600" marB="21600" anchor="ctr">
                     <a:solidFill>
                       <a:srgbClr val="FFFFFF"/>
                     </a:solidFill>
@@ -3887,7 +4059,7 @@
                 </a:tc>
                 <a:tc>
                   <a:txBody>
-                    <a:bodyPr/>
+                    <a:bodyPr wrap="square"/>
                     <a:lstStyle/>
                     <a:p>
                       <a:pPr algn="ctr">
@@ -3909,7 +4081,7 @@
                       </a:r>
                     </a:p>
                   </a:txBody>
-                  <a:tcPr marL="64800" marR="64800" marT="28800" marB="28800" anchor="ctr">
+                  <a:tcPr marL="64800" marR="64800" marT="21600" marB="21600" anchor="ctr">
                     <a:solidFill>
                       <a:srgbClr val="FFFFFF"/>
                     </a:solidFill>
@@ -3917,7 +4089,7 @@
                 </a:tc>
                 <a:tc>
                   <a:txBody>
-                    <a:bodyPr/>
+                    <a:bodyPr wrap="square"/>
                     <a:lstStyle/>
                     <a:p>
                       <a:pPr algn="ctr">
@@ -3939,7 +4111,7 @@
                       </a:r>
                     </a:p>
                   </a:txBody>
-                  <a:tcPr marL="64800" marR="64800" marT="28800" marB="28800" anchor="ctr">
+                  <a:tcPr marL="64800" marR="64800" marT="21600" marB="21600" anchor="ctr">
                     <a:solidFill>
                       <a:srgbClr val="FFFFFF"/>
                     </a:solidFill>
@@ -3947,7 +4119,7 @@
                 </a:tc>
                 <a:tc>
                   <a:txBody>
-                    <a:bodyPr/>
+                    <a:bodyPr wrap="square"/>
                     <a:lstStyle/>
                     <a:p>
                       <a:pPr algn="ctr">
@@ -3965,11 +4137,41 @@
                           </a:solidFill>
                           <a:latin typeface="Inter"/>
                         </a:rPr>
+                        <a:t>0.871</a:t>
+                      </a:r>
+                    </a:p>
+                  </a:txBody>
+                  <a:tcPr marL="64800" marR="64800" marT="21600" marB="21600" anchor="ctr">
+                    <a:solidFill>
+                      <a:srgbClr val="FFFFFF"/>
+                    </a:solidFill>
+                  </a:tcPr>
+                </a:tc>
+                <a:tc>
+                  <a:txBody>
+                    <a:bodyPr wrap="square"/>
+                    <a:lstStyle/>
+                    <a:p>
+                      <a:pPr algn="ctr">
+                        <a:lnSpc>
+                          <a:spcPct val="110000"/>
+                        </a:lnSpc>
+                        <a:spcAft>
+                          <a:spcPts val="0"/>
+                        </a:spcAft>
+                      </a:pPr>
+                      <a:r>
+                        <a:rPr sz="1700" b="0">
+                          <a:solidFill>
+                            <a:srgbClr val="1F2233"/>
+                          </a:solidFill>
+                          <a:latin typeface="Inter"/>
+                        </a:rPr>
                         <a:t>0.556</a:t>
                       </a:r>
                     </a:p>
                   </a:txBody>
-                  <a:tcPr marL="64800" marR="64800" marT="28800" marB="28800" anchor="ctr">
+                  <a:tcPr marL="64800" marR="64800" marT="21600" marB="21600" anchor="ctr">
                     <a:solidFill>
                       <a:srgbClr val="FFFFFF"/>
                     </a:solidFill>
@@ -3977,7 +4179,7 @@
                 </a:tc>
                 <a:tc>
                   <a:txBody>
-                    <a:bodyPr/>
+                    <a:bodyPr wrap="square"/>
                     <a:lstStyle/>
                     <a:p>
                       <a:pPr algn="ctr">
@@ -3999,7 +4201,7 @@
                       </a:r>
                     </a:p>
                   </a:txBody>
-                  <a:tcPr marL="64800" marR="64800" marT="28800" marB="28800" anchor="ctr">
+                  <a:tcPr marL="64800" marR="64800" marT="21600" marB="21600" anchor="ctr">
                     <a:solidFill>
                       <a:srgbClr val="FFFFFF"/>
                     </a:solidFill>
@@ -4009,7 +4211,7 @@
               <a:tr h="385581">
                 <a:tc>
                   <a:txBody>
-                    <a:bodyPr/>
+                    <a:bodyPr wrap="square"/>
                     <a:lstStyle/>
                     <a:p>
                       <a:pPr algn="l">
@@ -4027,11 +4229,11 @@
                           </a:solidFill>
                           <a:latin typeface="Inter"/>
                         </a:rPr>
-                        <a:t>k ближайших соседей</a:t>
-                      </a:r>
-                    </a:p>
-                  </a:txBody>
-                  <a:tcPr marL="64800" marR="64800" marT="28800" marB="28800" anchor="ctr">
+                        <a:t>kNN</a:t>
+                      </a:r>
+                    </a:p>
+                  </a:txBody>
+                  <a:tcPr marL="64800" marR="64800" marT="21600" marB="21600" anchor="ctr">
                     <a:solidFill>
                       <a:srgbClr val="F1F2FA"/>
                     </a:solidFill>
@@ -4039,7 +4241,7 @@
                 </a:tc>
                 <a:tc>
                   <a:txBody>
-                    <a:bodyPr/>
+                    <a:bodyPr wrap="square"/>
                     <a:lstStyle/>
                     <a:p>
                       <a:pPr algn="ctr">
@@ -4061,7 +4263,7 @@
                       </a:r>
                     </a:p>
                   </a:txBody>
-                  <a:tcPr marL="64800" marR="64800" marT="28800" marB="28800" anchor="ctr">
+                  <a:tcPr marL="64800" marR="64800" marT="21600" marB="21600" anchor="ctr">
                     <a:solidFill>
                       <a:srgbClr val="F1F2FA"/>
                     </a:solidFill>
@@ -4069,7 +4271,7 @@
                 </a:tc>
                 <a:tc>
                   <a:txBody>
-                    <a:bodyPr/>
+                    <a:bodyPr wrap="square"/>
                     <a:lstStyle/>
                     <a:p>
                       <a:pPr algn="ctr">
@@ -4091,7 +4293,7 @@
                       </a:r>
                     </a:p>
                   </a:txBody>
-                  <a:tcPr marL="64800" marR="64800" marT="28800" marB="28800" anchor="ctr">
+                  <a:tcPr marL="64800" marR="64800" marT="21600" marB="21600" anchor="ctr">
                     <a:solidFill>
                       <a:srgbClr val="F1F2FA"/>
                     </a:solidFill>
@@ -4099,7 +4301,7 @@
                 </a:tc>
                 <a:tc>
                   <a:txBody>
-                    <a:bodyPr/>
+                    <a:bodyPr wrap="square"/>
                     <a:lstStyle/>
                     <a:p>
                       <a:pPr algn="ctr">
@@ -4121,7 +4323,7 @@
                       </a:r>
                     </a:p>
                   </a:txBody>
-                  <a:tcPr marL="64800" marR="64800" marT="28800" marB="28800" anchor="ctr">
+                  <a:tcPr marL="64800" marR="64800" marT="21600" marB="21600" anchor="ctr">
                     <a:solidFill>
                       <a:srgbClr val="F1F2FA"/>
                     </a:solidFill>
@@ -4129,7 +4331,7 @@
                 </a:tc>
                 <a:tc>
                   <a:txBody>
-                    <a:bodyPr/>
+                    <a:bodyPr wrap="square"/>
                     <a:lstStyle/>
                     <a:p>
                       <a:pPr algn="ctr">
@@ -4151,7 +4353,7 @@
                       </a:r>
                     </a:p>
                   </a:txBody>
-                  <a:tcPr marL="64800" marR="64800" marT="28800" marB="28800" anchor="ctr">
+                  <a:tcPr marL="64800" marR="64800" marT="21600" marB="21600" anchor="ctr">
                     <a:solidFill>
                       <a:srgbClr val="F1F2FA"/>
                     </a:solidFill>
@@ -4159,7 +4361,7 @@
                 </a:tc>
                 <a:tc>
                   <a:txBody>
-                    <a:bodyPr/>
+                    <a:bodyPr wrap="square"/>
                     <a:lstStyle/>
                     <a:p>
                       <a:pPr algn="ctr">
@@ -4181,7 +4383,7 @@
                       </a:r>
                     </a:p>
                   </a:txBody>
-                  <a:tcPr marL="64800" marR="64800" marT="28800" marB="28800" anchor="ctr">
+                  <a:tcPr marL="64800" marR="64800" marT="21600" marB="21600" anchor="ctr">
                     <a:solidFill>
                       <a:srgbClr val="F1F2FA"/>
                     </a:solidFill>
@@ -4189,7 +4391,7 @@
                 </a:tc>
                 <a:tc>
                   <a:txBody>
-                    <a:bodyPr/>
+                    <a:bodyPr wrap="square"/>
                     <a:lstStyle/>
                     <a:p>
                       <a:pPr algn="ctr">
@@ -4211,7 +4413,7 @@
                       </a:r>
                     </a:p>
                   </a:txBody>
-                  <a:tcPr marL="64800" marR="64800" marT="28800" marB="28800" anchor="ctr">
+                  <a:tcPr marL="64800" marR="64800" marT="21600" marB="21600" anchor="ctr">
                     <a:solidFill>
                       <a:srgbClr val="F1F2FA"/>
                     </a:solidFill>
@@ -4219,7 +4421,7 @@
                 </a:tc>
                 <a:tc>
                   <a:txBody>
-                    <a:bodyPr/>
+                    <a:bodyPr wrap="square"/>
                     <a:lstStyle/>
                     <a:p>
                       <a:pPr algn="ctr">
@@ -4241,7 +4443,7 @@
                       </a:r>
                     </a:p>
                   </a:txBody>
-                  <a:tcPr marL="64800" marR="64800" marT="28800" marB="28800" anchor="ctr">
+                  <a:tcPr marL="64800" marR="64800" marT="21600" marB="21600" anchor="ctr">
                     <a:solidFill>
                       <a:srgbClr val="F1F2FA"/>
                     </a:solidFill>
@@ -4249,7 +4451,7 @@
                 </a:tc>
                 <a:tc>
                   <a:txBody>
-                    <a:bodyPr/>
+                    <a:bodyPr wrap="square"/>
                     <a:lstStyle/>
                     <a:p>
                       <a:pPr algn="ctr">
@@ -4271,7 +4473,7 @@
                       </a:r>
                     </a:p>
                   </a:txBody>
-                  <a:tcPr marL="64800" marR="64800" marT="28800" marB="28800" anchor="ctr">
+                  <a:tcPr marL="64800" marR="64800" marT="21600" marB="21600" anchor="ctr">
                     <a:solidFill>
                       <a:srgbClr val="F1F2FA"/>
                     </a:solidFill>
@@ -4279,7 +4481,7 @@
                 </a:tc>
                 <a:tc>
                   <a:txBody>
-                    <a:bodyPr/>
+                    <a:bodyPr wrap="square"/>
                     <a:lstStyle/>
                     <a:p>
                       <a:pPr algn="ctr">
@@ -4297,11 +4499,41 @@
                           </a:solidFill>
                           <a:latin typeface="Inter"/>
                         </a:rPr>
+                        <a:t>0.877</a:t>
+                      </a:r>
+                    </a:p>
+                  </a:txBody>
+                  <a:tcPr marL="64800" marR="64800" marT="21600" marB="21600" anchor="ctr">
+                    <a:solidFill>
+                      <a:srgbClr val="F1F2FA"/>
+                    </a:solidFill>
+                  </a:tcPr>
+                </a:tc>
+                <a:tc>
+                  <a:txBody>
+                    <a:bodyPr wrap="square"/>
+                    <a:lstStyle/>
+                    <a:p>
+                      <a:pPr algn="ctr">
+                        <a:lnSpc>
+                          <a:spcPct val="110000"/>
+                        </a:lnSpc>
+                        <a:spcAft>
+                          <a:spcPts val="0"/>
+                        </a:spcAft>
+                      </a:pPr>
+                      <a:r>
+                        <a:rPr sz="1700" b="0">
+                          <a:solidFill>
+                            <a:srgbClr val="1F2233"/>
+                          </a:solidFill>
+                          <a:latin typeface="Inter"/>
+                        </a:rPr>
                         <a:t>0.627</a:t>
                       </a:r>
                     </a:p>
                   </a:txBody>
-                  <a:tcPr marL="64800" marR="64800" marT="28800" marB="28800" anchor="ctr">
+                  <a:tcPr marL="64800" marR="64800" marT="21600" marB="21600" anchor="ctr">
                     <a:solidFill>
                       <a:srgbClr val="F1F2FA"/>
                     </a:solidFill>
@@ -4309,7 +4541,7 @@
                 </a:tc>
                 <a:tc>
                   <a:txBody>
-                    <a:bodyPr/>
+                    <a:bodyPr wrap="square"/>
                     <a:lstStyle/>
                     <a:p>
                       <a:pPr algn="ctr">
@@ -4331,7 +4563,7 @@
                       </a:r>
                     </a:p>
                   </a:txBody>
-                  <a:tcPr marL="64800" marR="64800" marT="28800" marB="28800" anchor="ctr">
+                  <a:tcPr marL="64800" marR="64800" marT="21600" marB="21600" anchor="ctr">
                     <a:solidFill>
                       <a:srgbClr val="F1F2FA"/>
                     </a:solidFill>
@@ -4341,7 +4573,7 @@
               <a:tr h="385581">
                 <a:tc>
                   <a:txBody>
-                    <a:bodyPr/>
+                    <a:bodyPr wrap="square"/>
                     <a:lstStyle/>
                     <a:p>
                       <a:pPr algn="l">
@@ -4363,7 +4595,7 @@
                       </a:r>
                     </a:p>
                   </a:txBody>
-                  <a:tcPr marL="64800" marR="64800" marT="28800" marB="28800" anchor="ctr">
+                  <a:tcPr marL="64800" marR="64800" marT="21600" marB="21600" anchor="ctr">
                     <a:solidFill>
                       <a:srgbClr val="FFFFFF"/>
                     </a:solidFill>
@@ -4371,7 +4603,7 @@
                 </a:tc>
                 <a:tc>
                   <a:txBody>
-                    <a:bodyPr/>
+                    <a:bodyPr wrap="square"/>
                     <a:lstStyle/>
                     <a:p>
                       <a:pPr algn="ctr">
@@ -4393,7 +4625,7 @@
                       </a:r>
                     </a:p>
                   </a:txBody>
-                  <a:tcPr marL="64800" marR="64800" marT="28800" marB="28800" anchor="ctr">
+                  <a:tcPr marL="64800" marR="64800" marT="21600" marB="21600" anchor="ctr">
                     <a:solidFill>
                       <a:srgbClr val="FFFFFF"/>
                     </a:solidFill>
@@ -4401,7 +4633,7 @@
                 </a:tc>
                 <a:tc>
                   <a:txBody>
-                    <a:bodyPr/>
+                    <a:bodyPr wrap="square"/>
                     <a:lstStyle/>
                     <a:p>
                       <a:pPr algn="ctr">
@@ -4423,7 +4655,7 @@
                       </a:r>
                     </a:p>
                   </a:txBody>
-                  <a:tcPr marL="64800" marR="64800" marT="28800" marB="28800" anchor="ctr">
+                  <a:tcPr marL="64800" marR="64800" marT="21600" marB="21600" anchor="ctr">
                     <a:solidFill>
                       <a:srgbClr val="FFFFFF"/>
                     </a:solidFill>
@@ -4431,7 +4663,7 @@
                 </a:tc>
                 <a:tc>
                   <a:txBody>
-                    <a:bodyPr/>
+                    <a:bodyPr wrap="square"/>
                     <a:lstStyle/>
                     <a:p>
                       <a:pPr algn="ctr">
@@ -4453,7 +4685,7 @@
                       </a:r>
                     </a:p>
                   </a:txBody>
-                  <a:tcPr marL="64800" marR="64800" marT="28800" marB="28800" anchor="ctr">
+                  <a:tcPr marL="64800" marR="64800" marT="21600" marB="21600" anchor="ctr">
                     <a:solidFill>
                       <a:srgbClr val="FFFFFF"/>
                     </a:solidFill>
@@ -4461,7 +4693,7 @@
                 </a:tc>
                 <a:tc>
                   <a:txBody>
-                    <a:bodyPr/>
+                    <a:bodyPr wrap="square"/>
                     <a:lstStyle/>
                     <a:p>
                       <a:pPr algn="ctr">
@@ -4483,7 +4715,7 @@
                       </a:r>
                     </a:p>
                   </a:txBody>
-                  <a:tcPr marL="64800" marR="64800" marT="28800" marB="28800" anchor="ctr">
+                  <a:tcPr marL="64800" marR="64800" marT="21600" marB="21600" anchor="ctr">
                     <a:solidFill>
                       <a:srgbClr val="FFFFFF"/>
                     </a:solidFill>
@@ -4491,7 +4723,7 @@
                 </a:tc>
                 <a:tc>
                   <a:txBody>
-                    <a:bodyPr/>
+                    <a:bodyPr wrap="square"/>
                     <a:lstStyle/>
                     <a:p>
                       <a:pPr algn="ctr">
@@ -4513,7 +4745,7 @@
                       </a:r>
                     </a:p>
                   </a:txBody>
-                  <a:tcPr marL="64800" marR="64800" marT="28800" marB="28800" anchor="ctr">
+                  <a:tcPr marL="64800" marR="64800" marT="21600" marB="21600" anchor="ctr">
                     <a:solidFill>
                       <a:srgbClr val="FFFFFF"/>
                     </a:solidFill>
@@ -4521,7 +4753,7 @@
                 </a:tc>
                 <a:tc>
                   <a:txBody>
-                    <a:bodyPr/>
+                    <a:bodyPr wrap="square"/>
                     <a:lstStyle/>
                     <a:p>
                       <a:pPr algn="ctr">
@@ -4543,7 +4775,7 @@
                       </a:r>
                     </a:p>
                   </a:txBody>
-                  <a:tcPr marL="64800" marR="64800" marT="28800" marB="28800" anchor="ctr">
+                  <a:tcPr marL="64800" marR="64800" marT="21600" marB="21600" anchor="ctr">
                     <a:solidFill>
                       <a:srgbClr val="FFFFFF"/>
                     </a:solidFill>
@@ -4551,7 +4783,7 @@
                 </a:tc>
                 <a:tc>
                   <a:txBody>
-                    <a:bodyPr/>
+                    <a:bodyPr wrap="square"/>
                     <a:lstStyle/>
                     <a:p>
                       <a:pPr algn="ctr">
@@ -4573,7 +4805,7 @@
                       </a:r>
                     </a:p>
                   </a:txBody>
-                  <a:tcPr marL="64800" marR="64800" marT="28800" marB="28800" anchor="ctr">
+                  <a:tcPr marL="64800" marR="64800" marT="21600" marB="21600" anchor="ctr">
                     <a:solidFill>
                       <a:srgbClr val="FFFFFF"/>
                     </a:solidFill>
@@ -4581,7 +4813,7 @@
                 </a:tc>
                 <a:tc>
                   <a:txBody>
-                    <a:bodyPr/>
+                    <a:bodyPr wrap="square"/>
                     <a:lstStyle/>
                     <a:p>
                       <a:pPr algn="ctr">
@@ -4603,7 +4835,7 @@
                       </a:r>
                     </a:p>
                   </a:txBody>
-                  <a:tcPr marL="64800" marR="64800" marT="28800" marB="28800" anchor="ctr">
+                  <a:tcPr marL="64800" marR="64800" marT="21600" marB="21600" anchor="ctr">
                     <a:solidFill>
                       <a:srgbClr val="FFFFFF"/>
                     </a:solidFill>
@@ -4611,7 +4843,7 @@
                 </a:tc>
                 <a:tc>
                   <a:txBody>
-                    <a:bodyPr/>
+                    <a:bodyPr wrap="square"/>
                     <a:lstStyle/>
                     <a:p>
                       <a:pPr algn="ctr">
@@ -4629,11 +4861,41 @@
                           </a:solidFill>
                           <a:latin typeface="Inter"/>
                         </a:rPr>
+                        <a:t>0.879</a:t>
+                      </a:r>
+                    </a:p>
+                  </a:txBody>
+                  <a:tcPr marL="64800" marR="64800" marT="21600" marB="21600" anchor="ctr">
+                    <a:solidFill>
+                      <a:srgbClr val="FFFFFF"/>
+                    </a:solidFill>
+                  </a:tcPr>
+                </a:tc>
+                <a:tc>
+                  <a:txBody>
+                    <a:bodyPr wrap="square"/>
+                    <a:lstStyle/>
+                    <a:p>
+                      <a:pPr algn="ctr">
+                        <a:lnSpc>
+                          <a:spcPct val="110000"/>
+                        </a:lnSpc>
+                        <a:spcAft>
+                          <a:spcPts val="0"/>
+                        </a:spcAft>
+                      </a:pPr>
+                      <a:r>
+                        <a:rPr sz="1700" b="0">
+                          <a:solidFill>
+                            <a:srgbClr val="1F2233"/>
+                          </a:solidFill>
+                          <a:latin typeface="Inter"/>
+                        </a:rPr>
                         <a:t>0.653</a:t>
                       </a:r>
                     </a:p>
                   </a:txBody>
-                  <a:tcPr marL="64800" marR="64800" marT="28800" marB="28800" anchor="ctr">
+                  <a:tcPr marL="64800" marR="64800" marT="21600" marB="21600" anchor="ctr">
                     <a:solidFill>
                       <a:srgbClr val="FFFFFF"/>
                     </a:solidFill>
@@ -4641,7 +4903,7 @@
                 </a:tc>
                 <a:tc>
                   <a:txBody>
-                    <a:bodyPr/>
+                    <a:bodyPr wrap="square"/>
                     <a:lstStyle/>
                     <a:p>
                       <a:pPr algn="ctr">
@@ -4663,7 +4925,7 @@
                       </a:r>
                     </a:p>
                   </a:txBody>
-                  <a:tcPr marL="64800" marR="64800" marT="28800" marB="28800" anchor="ctr">
+                  <a:tcPr marL="64800" marR="64800" marT="21600" marB="21600" anchor="ctr">
                     <a:solidFill>
                       <a:srgbClr val="FFFFFF"/>
                     </a:solidFill>
@@ -4673,7 +4935,7 @@
               <a:tr h="385581">
                 <a:tc>
                   <a:txBody>
-                    <a:bodyPr/>
+                    <a:bodyPr wrap="square"/>
                     <a:lstStyle/>
                     <a:p>
                       <a:pPr algn="l">
@@ -4695,7 +4957,7 @@
                       </a:r>
                     </a:p>
                   </a:txBody>
-                  <a:tcPr marL="64800" marR="64800" marT="28800" marB="28800" anchor="ctr">
+                  <a:tcPr marL="64800" marR="64800" marT="21600" marB="21600" anchor="ctr">
                     <a:solidFill>
                       <a:srgbClr val="F1F2FA"/>
                     </a:solidFill>
@@ -4703,7 +4965,7 @@
                 </a:tc>
                 <a:tc>
                   <a:txBody>
-                    <a:bodyPr/>
+                    <a:bodyPr wrap="square"/>
                     <a:lstStyle/>
                     <a:p>
                       <a:pPr algn="ctr">
@@ -4725,7 +4987,7 @@
                       </a:r>
                     </a:p>
                   </a:txBody>
-                  <a:tcPr marL="64800" marR="64800" marT="28800" marB="28800" anchor="ctr">
+                  <a:tcPr marL="64800" marR="64800" marT="21600" marB="21600" anchor="ctr">
                     <a:solidFill>
                       <a:srgbClr val="F1F2FA"/>
                     </a:solidFill>
@@ -4733,7 +4995,7 @@
                 </a:tc>
                 <a:tc>
                   <a:txBody>
-                    <a:bodyPr/>
+                    <a:bodyPr wrap="square"/>
                     <a:lstStyle/>
                     <a:p>
                       <a:pPr algn="ctr">
@@ -4755,7 +5017,7 @@
                       </a:r>
                     </a:p>
                   </a:txBody>
-                  <a:tcPr marL="64800" marR="64800" marT="28800" marB="28800" anchor="ctr">
+                  <a:tcPr marL="64800" marR="64800" marT="21600" marB="21600" anchor="ctr">
                     <a:solidFill>
                       <a:srgbClr val="F1F2FA"/>
                     </a:solidFill>
@@ -4763,7 +5025,7 @@
                 </a:tc>
                 <a:tc>
                   <a:txBody>
-                    <a:bodyPr/>
+                    <a:bodyPr wrap="square"/>
                     <a:lstStyle/>
                     <a:p>
                       <a:pPr algn="ctr">
@@ -4785,7 +5047,7 @@
                       </a:r>
                     </a:p>
                   </a:txBody>
-                  <a:tcPr marL="64800" marR="64800" marT="28800" marB="28800" anchor="ctr">
+                  <a:tcPr marL="64800" marR="64800" marT="21600" marB="21600" anchor="ctr">
                     <a:solidFill>
                       <a:srgbClr val="F1F2FA"/>
                     </a:solidFill>
@@ -4793,7 +5055,7 @@
                 </a:tc>
                 <a:tc>
                   <a:txBody>
-                    <a:bodyPr/>
+                    <a:bodyPr wrap="square"/>
                     <a:lstStyle/>
                     <a:p>
                       <a:pPr algn="ctr">
@@ -4815,7 +5077,7 @@
                       </a:r>
                     </a:p>
                   </a:txBody>
-                  <a:tcPr marL="64800" marR="64800" marT="28800" marB="28800" anchor="ctr">
+                  <a:tcPr marL="64800" marR="64800" marT="21600" marB="21600" anchor="ctr">
                     <a:solidFill>
                       <a:srgbClr val="F1F2FA"/>
                     </a:solidFill>
@@ -4823,7 +5085,7 @@
                 </a:tc>
                 <a:tc>
                   <a:txBody>
-                    <a:bodyPr/>
+                    <a:bodyPr wrap="square"/>
                     <a:lstStyle/>
                     <a:p>
                       <a:pPr algn="ctr">
@@ -4845,7 +5107,7 @@
                       </a:r>
                     </a:p>
                   </a:txBody>
-                  <a:tcPr marL="64800" marR="64800" marT="28800" marB="28800" anchor="ctr">
+                  <a:tcPr marL="64800" marR="64800" marT="21600" marB="21600" anchor="ctr">
                     <a:solidFill>
                       <a:srgbClr val="F1F2FA"/>
                     </a:solidFill>
@@ -4853,7 +5115,7 @@
                 </a:tc>
                 <a:tc>
                   <a:txBody>
-                    <a:bodyPr/>
+                    <a:bodyPr wrap="square"/>
                     <a:lstStyle/>
                     <a:p>
                       <a:pPr algn="ctr">
@@ -4875,7 +5137,7 @@
                       </a:r>
                     </a:p>
                   </a:txBody>
-                  <a:tcPr marL="64800" marR="64800" marT="28800" marB="28800" anchor="ctr">
+                  <a:tcPr marL="64800" marR="64800" marT="21600" marB="21600" anchor="ctr">
                     <a:solidFill>
                       <a:srgbClr val="F1F2FA"/>
                     </a:solidFill>
@@ -4883,7 +5145,7 @@
                 </a:tc>
                 <a:tc>
                   <a:txBody>
-                    <a:bodyPr/>
+                    <a:bodyPr wrap="square"/>
                     <a:lstStyle/>
                     <a:p>
                       <a:pPr algn="ctr">
@@ -4905,7 +5167,7 @@
                       </a:r>
                     </a:p>
                   </a:txBody>
-                  <a:tcPr marL="64800" marR="64800" marT="28800" marB="28800" anchor="ctr">
+                  <a:tcPr marL="64800" marR="64800" marT="21600" marB="21600" anchor="ctr">
                     <a:solidFill>
                       <a:srgbClr val="F1F2FA"/>
                     </a:solidFill>
@@ -4913,7 +5175,7 @@
                 </a:tc>
                 <a:tc>
                   <a:txBody>
-                    <a:bodyPr/>
+                    <a:bodyPr wrap="square"/>
                     <a:lstStyle/>
                     <a:p>
                       <a:pPr algn="ctr">
@@ -4935,7 +5197,7 @@
                       </a:r>
                     </a:p>
                   </a:txBody>
-                  <a:tcPr marL="64800" marR="64800" marT="28800" marB="28800" anchor="ctr">
+                  <a:tcPr marL="64800" marR="64800" marT="21600" marB="21600" anchor="ctr">
                     <a:solidFill>
                       <a:srgbClr val="F1F2FA"/>
                     </a:solidFill>
@@ -4943,7 +5205,7 @@
                 </a:tc>
                 <a:tc>
                   <a:txBody>
-                    <a:bodyPr/>
+                    <a:bodyPr wrap="square"/>
                     <a:lstStyle/>
                     <a:p>
                       <a:pPr algn="ctr">
@@ -4961,11 +5223,41 @@
                           </a:solidFill>
                           <a:latin typeface="Inter"/>
                         </a:rPr>
+                        <a:t>0.881</a:t>
+                      </a:r>
+                    </a:p>
+                  </a:txBody>
+                  <a:tcPr marL="64800" marR="64800" marT="21600" marB="21600" anchor="ctr">
+                    <a:solidFill>
+                      <a:srgbClr val="F1F2FA"/>
+                    </a:solidFill>
+                  </a:tcPr>
+                </a:tc>
+                <a:tc>
+                  <a:txBody>
+                    <a:bodyPr wrap="square"/>
+                    <a:lstStyle/>
+                    <a:p>
+                      <a:pPr algn="ctr">
+                        <a:lnSpc>
+                          <a:spcPct val="110000"/>
+                        </a:lnSpc>
+                        <a:spcAft>
+                          <a:spcPts val="0"/>
+                        </a:spcAft>
+                      </a:pPr>
+                      <a:r>
+                        <a:rPr sz="1700" b="0">
+                          <a:solidFill>
+                            <a:srgbClr val="1F2233"/>
+                          </a:solidFill>
+                          <a:latin typeface="Inter"/>
+                        </a:rPr>
                         <a:t>0.675</a:t>
                       </a:r>
                     </a:p>
                   </a:txBody>
-                  <a:tcPr marL="64800" marR="64800" marT="28800" marB="28800" anchor="ctr">
+                  <a:tcPr marL="64800" marR="64800" marT="21600" marB="21600" anchor="ctr">
                     <a:solidFill>
                       <a:srgbClr val="F1F2FA"/>
                     </a:solidFill>
@@ -4973,7 +5265,7 @@
                 </a:tc>
                 <a:tc>
                   <a:txBody>
-                    <a:bodyPr/>
+                    <a:bodyPr wrap="square"/>
                     <a:lstStyle/>
                     <a:p>
                       <a:pPr algn="ctr">
@@ -4995,7 +5287,7 @@
                       </a:r>
                     </a:p>
                   </a:txBody>
-                  <a:tcPr marL="64800" marR="64800" marT="28800" marB="28800" anchor="ctr">
+                  <a:tcPr marL="64800" marR="64800" marT="21600" marB="21600" anchor="ctr">
                     <a:solidFill>
                       <a:srgbClr val="F1F2FA"/>
                     </a:solidFill>
@@ -5005,7 +5297,7 @@
               <a:tr h="385581">
                 <a:tc>
                   <a:txBody>
-                    <a:bodyPr/>
+                    <a:bodyPr wrap="square"/>
                     <a:lstStyle/>
                     <a:p>
                       <a:pPr algn="l">
@@ -5027,7 +5319,7 @@
                       </a:r>
                     </a:p>
                   </a:txBody>
-                  <a:tcPr marL="64800" marR="64800" marT="28800" marB="28800" anchor="ctr">
+                  <a:tcPr marL="64800" marR="64800" marT="21600" marB="21600" anchor="ctr">
                     <a:solidFill>
                       <a:srgbClr val="E3E5F4"/>
                     </a:solidFill>
@@ -5035,7 +5327,7 @@
                 </a:tc>
                 <a:tc>
                   <a:txBody>
-                    <a:bodyPr/>
+                    <a:bodyPr wrap="square"/>
                     <a:lstStyle/>
                     <a:p>
                       <a:pPr algn="ctr">
@@ -5057,7 +5349,7 @@
                       </a:r>
                     </a:p>
                   </a:txBody>
-                  <a:tcPr marL="64800" marR="64800" marT="28800" marB="28800" anchor="ctr">
+                  <a:tcPr marL="64800" marR="64800" marT="21600" marB="21600" anchor="ctr">
                     <a:solidFill>
                       <a:srgbClr val="E3E5F4"/>
                     </a:solidFill>
@@ -5065,7 +5357,7 @@
                 </a:tc>
                 <a:tc>
                   <a:txBody>
-                    <a:bodyPr/>
+                    <a:bodyPr wrap="square"/>
                     <a:lstStyle/>
                     <a:p>
                       <a:pPr algn="ctr">
@@ -5087,7 +5379,7 @@
                       </a:r>
                     </a:p>
                   </a:txBody>
-                  <a:tcPr marL="64800" marR="64800" marT="28800" marB="28800" anchor="ctr">
+                  <a:tcPr marL="64800" marR="64800" marT="21600" marB="21600" anchor="ctr">
                     <a:solidFill>
                       <a:srgbClr val="E3E5F4"/>
                     </a:solidFill>
@@ -5095,7 +5387,7 @@
                 </a:tc>
                 <a:tc>
                   <a:txBody>
-                    <a:bodyPr/>
+                    <a:bodyPr wrap="square"/>
                     <a:lstStyle/>
                     <a:p>
                       <a:pPr algn="ctr">
@@ -5117,7 +5409,7 @@
                       </a:r>
                     </a:p>
                   </a:txBody>
-                  <a:tcPr marL="64800" marR="64800" marT="28800" marB="28800" anchor="ctr">
+                  <a:tcPr marL="64800" marR="64800" marT="21600" marB="21600" anchor="ctr">
                     <a:solidFill>
                       <a:srgbClr val="E3E5F4"/>
                     </a:solidFill>
@@ -5125,7 +5417,7 @@
                 </a:tc>
                 <a:tc>
                   <a:txBody>
-                    <a:bodyPr/>
+                    <a:bodyPr wrap="square"/>
                     <a:lstStyle/>
                     <a:p>
                       <a:pPr algn="ctr">
@@ -5147,7 +5439,7 @@
                       </a:r>
                     </a:p>
                   </a:txBody>
-                  <a:tcPr marL="64800" marR="64800" marT="28800" marB="28800" anchor="ctr">
+                  <a:tcPr marL="64800" marR="64800" marT="21600" marB="21600" anchor="ctr">
                     <a:solidFill>
                       <a:srgbClr val="E3E5F4"/>
                     </a:solidFill>
@@ -5155,7 +5447,7 @@
                 </a:tc>
                 <a:tc>
                   <a:txBody>
-                    <a:bodyPr/>
+                    <a:bodyPr wrap="square"/>
                     <a:lstStyle/>
                     <a:p>
                       <a:pPr algn="ctr">
@@ -5177,7 +5469,7 @@
                       </a:r>
                     </a:p>
                   </a:txBody>
-                  <a:tcPr marL="64800" marR="64800" marT="28800" marB="28800" anchor="ctr">
+                  <a:tcPr marL="64800" marR="64800" marT="21600" marB="21600" anchor="ctr">
                     <a:solidFill>
                       <a:srgbClr val="E3E5F4"/>
                     </a:solidFill>
@@ -5185,7 +5477,7 @@
                 </a:tc>
                 <a:tc>
                   <a:txBody>
-                    <a:bodyPr/>
+                    <a:bodyPr wrap="square"/>
                     <a:lstStyle/>
                     <a:p>
                       <a:pPr algn="ctr">
@@ -5207,7 +5499,7 @@
                       </a:r>
                     </a:p>
                   </a:txBody>
-                  <a:tcPr marL="64800" marR="64800" marT="28800" marB="28800" anchor="ctr">
+                  <a:tcPr marL="64800" marR="64800" marT="21600" marB="21600" anchor="ctr">
                     <a:solidFill>
                       <a:srgbClr val="E3E5F4"/>
                     </a:solidFill>
@@ -5215,7 +5507,7 @@
                 </a:tc>
                 <a:tc>
                   <a:txBody>
-                    <a:bodyPr/>
+                    <a:bodyPr wrap="square"/>
                     <a:lstStyle/>
                     <a:p>
                       <a:pPr algn="ctr">
@@ -5237,7 +5529,7 @@
                       </a:r>
                     </a:p>
                   </a:txBody>
-                  <a:tcPr marL="64800" marR="64800" marT="28800" marB="28800" anchor="ctr">
+                  <a:tcPr marL="64800" marR="64800" marT="21600" marB="21600" anchor="ctr">
                     <a:solidFill>
                       <a:srgbClr val="E3E5F4"/>
                     </a:solidFill>
@@ -5245,7 +5537,7 @@
                 </a:tc>
                 <a:tc>
                   <a:txBody>
-                    <a:bodyPr/>
+                    <a:bodyPr wrap="square"/>
                     <a:lstStyle/>
                     <a:p>
                       <a:pPr algn="ctr">
@@ -5267,7 +5559,7 @@
                       </a:r>
                     </a:p>
                   </a:txBody>
-                  <a:tcPr marL="64800" marR="64800" marT="28800" marB="28800" anchor="ctr">
+                  <a:tcPr marL="64800" marR="64800" marT="21600" marB="21600" anchor="ctr">
                     <a:solidFill>
                       <a:srgbClr val="E3E5F4"/>
                     </a:solidFill>
@@ -5275,7 +5567,7 @@
                 </a:tc>
                 <a:tc>
                   <a:txBody>
-                    <a:bodyPr/>
+                    <a:bodyPr wrap="square"/>
                     <a:lstStyle/>
                     <a:p>
                       <a:pPr algn="ctr">
@@ -5297,7 +5589,7 @@
                       </a:r>
                     </a:p>
                   </a:txBody>
-                  <a:tcPr marL="64800" marR="64800" marT="28800" marB="28800" anchor="ctr">
+                  <a:tcPr marL="64800" marR="64800" marT="21600" marB="21600" anchor="ctr">
                     <a:solidFill>
                       <a:srgbClr val="E3E5F4"/>
                     </a:solidFill>
@@ -5305,7 +5597,7 @@
                 </a:tc>
                 <a:tc>
                   <a:txBody>
-                    <a:bodyPr/>
+                    <a:bodyPr wrap="square"/>
                     <a:lstStyle/>
                     <a:p>
                       <a:pPr algn="ctr">
@@ -5327,7 +5619,37 @@
                       </a:r>
                     </a:p>
                   </a:txBody>
-                  <a:tcPr marL="64800" marR="64800" marT="28800" marB="28800" anchor="ctr">
+                  <a:tcPr marL="64800" marR="64800" marT="21600" marB="21600" anchor="ctr">
+                    <a:solidFill>
+                      <a:srgbClr val="E3E5F4"/>
+                    </a:solidFill>
+                  </a:tcPr>
+                </a:tc>
+                <a:tc>
+                  <a:txBody>
+                    <a:bodyPr wrap="square"/>
+                    <a:lstStyle/>
+                    <a:p>
+                      <a:pPr algn="ctr">
+                        <a:lnSpc>
+                          <a:spcPct val="110000"/>
+                        </a:lnSpc>
+                        <a:spcAft>
+                          <a:spcPts val="0"/>
+                        </a:spcAft>
+                      </a:pPr>
+                      <a:r>
+                        <a:rPr sz="1700" b="1">
+                          <a:solidFill>
+                            <a:srgbClr val="1F2233"/>
+                          </a:solidFill>
+                          <a:latin typeface="Inter"/>
+                        </a:rPr>
+                        <a:t>—</a:t>
+                      </a:r>
+                    </a:p>
+                  </a:txBody>
+                  <a:tcPr marL="64800" marR="64800" marT="21600" marB="21600" anchor="ctr">
                     <a:solidFill>
                       <a:srgbClr val="E3E5F4"/>
                     </a:solidFill>
@@ -5346,8 +5668,8 @@
         </p:nvSpPr>
         <p:spPr>
           <a:xfrm>
-            <a:off x="2628000" y="33795470"/>
-            <a:ext cx="11988000" cy="306381"/>
+            <a:off x="2628000" y="33475773"/>
+            <a:ext cx="11988000" cy="612762"/>
           </a:xfrm>
           <a:prstGeom prst="rect">
             <a:avLst/>
@@ -5382,7 +5704,7 @@
                 </a:solidFill>
                 <a:latin typeface="Inter"/>
               </a:rPr>
-              <a:t> (найдено 60% бодрствования; второй порог уравнивает найденные NREM и REM):</a:t>
+              <a:t> (найдено 60% бодрствования; «найдено NREM / REM» — при уравненных долях, «лучшая accuracy» и κ — в лучшей по accuracy точке, как в статье):</a:t>
             </a:r>
           </a:p>
         </p:txBody>
@@ -5396,8 +5718,8 @@
           <p:nvPr/>
         </p:nvGraphicFramePr>
         <p:xfrm>
-          <a:off x="2628000" y="34209851"/>
-          <a:ext cx="11988000" cy="2972914"/>
+          <a:off x="2628000" y="34196536"/>
+          <a:ext cx="11987995" cy="2972914"/>
         </p:xfrm>
         <a:graphic>
           <a:graphicData uri="http://schemas.openxmlformats.org/drawingml/2006/table">
@@ -5406,33 +5728,105 @@
                 <a:tableStyleId>{5C22544A-7EE6-4342-B048-85BDC9FD1C3A}</a:tableStyleId>
               </a:tblPr>
               <a:tblGrid>
-                <a:gridCol w="3818400"/>
-                <a:gridCol w="1065600"/>
-                <a:gridCol w="1065600"/>
-                <a:gridCol w="1110000"/>
-                <a:gridCol w="888000"/>
-                <a:gridCol w="976800"/>
-                <a:gridCol w="932400"/>
-                <a:gridCol w="1065600"/>
-                <a:gridCol w="1065600"/>
+                <a:gridCol w="2147461"/>
+                <a:gridCol w="1115629"/>
+                <a:gridCol w="1115629"/>
+                <a:gridCol w="1062762"/>
+                <a:gridCol w="822816"/>
+                <a:gridCol w="834376"/>
+                <a:gridCol w="822816"/>
+                <a:gridCol w="1115629"/>
+                <a:gridCol w="1115629"/>
+                <a:gridCol w="1062762"/>
+                <a:gridCol w="772486"/>
               </a:tblGrid>
               <a:tr h="360336">
                 <a:tc>
                   <a:txBody>
+                    <a:bodyPr wrap="square"/>
+                    <a:lstStyle/>
+                    <a:p/>
+                  </a:txBody>
+                  <a:tcPr marL="64800" marR="64800" marT="21600" marB="21600" anchor="ctr">
+                    <a:solidFill>
+                      <a:srgbClr val="FFFFFF"/>
+                    </a:solidFill>
+                  </a:tcPr>
+                </a:tc>
+                <a:tc gridSpan="6">
+                  <a:txBody>
+                    <a:bodyPr wrap="square"/>
+                    <a:lstStyle/>
+                    <a:p>
+                      <a:pPr algn="ctr">
+                        <a:lnSpc>
+                          <a:spcPct val="110000"/>
+                        </a:lnSpc>
+                        <a:spcAft>
+                          <a:spcPts val="0"/>
+                        </a:spcAft>
+                      </a:pPr>
+                      <a:r>
+                        <a:rPr sz="1500" b="1">
+                          <a:solidFill>
+                            <a:srgbClr val="FFFFFF"/>
+                          </a:solidFill>
+                          <a:latin typeface="Inter"/>
+                        </a:rPr>
+                        <a:t>Наш результат (leave-one-subject-out)</a:t>
+                      </a:r>
+                    </a:p>
+                  </a:txBody>
+                  <a:tcPr marL="64800" marR="64800" marT="21600" marB="21600" anchor="ctr">
+                    <a:solidFill>
+                      <a:srgbClr val="2E3473"/>
+                    </a:solidFill>
+                  </a:tcPr>
+                </a:tc>
+                <a:tc hMerge="1">
+                  <a:txBody>
                     <a:bodyPr/>
                     <a:lstStyle/>
                     <a:p/>
                   </a:txBody>
-                  <a:tcPr anchor="ctr" marT="18000" marB="18000">
-                    <a:solidFill>
-                      <a:srgbClr val="FFFFFF"/>
-                    </a:solidFill>
-                  </a:tcPr>
-                </a:tc>
-                <a:tc gridSpan="6">
+                  <a:tcPr/>
+                </a:tc>
+                <a:tc hMerge="1">
                   <a:txBody>
                     <a:bodyPr/>
                     <a:lstStyle/>
+                    <a:p/>
+                  </a:txBody>
+                  <a:tcPr/>
+                </a:tc>
+                <a:tc hMerge="1">
+                  <a:txBody>
+                    <a:bodyPr/>
+                    <a:lstStyle/>
+                    <a:p/>
+                  </a:txBody>
+                  <a:tcPr/>
+                </a:tc>
+                <a:tc hMerge="1">
+                  <a:txBody>
+                    <a:bodyPr/>
+                    <a:lstStyle/>
+                    <a:p/>
+                  </a:txBody>
+                  <a:tcPr/>
+                </a:tc>
+                <a:tc hMerge="1">
+                  <a:txBody>
+                    <a:bodyPr/>
+                    <a:lstStyle/>
+                    <a:p/>
+                  </a:txBody>
+                  <a:tcPr/>
+                </a:tc>
+                <a:tc gridSpan="4">
+                  <a:txBody>
+                    <a:bodyPr wrap="square"/>
+                    <a:lstStyle/>
                     <a:p>
                       <a:pPr algn="ctr">
                         <a:lnSpc>
@@ -5449,11 +5843,11 @@
                           </a:solidFill>
                           <a:latin typeface="Inter"/>
                         </a:rPr>
-                        <a:t>Наш результат (leave-one-subject-out)</a:t>
-                      </a:r>
-                    </a:p>
-                  </a:txBody>
-                  <a:tcPr anchor="ctr" marT="18000" marB="18000">
+                        <a:t>Статья</a:t>
+                      </a:r>
+                    </a:p>
+                  </a:txBody>
+                  <a:tcPr marL="64800" marR="64800" marT="21600" marB="21600" anchor="ctr">
                     <a:solidFill>
                       <a:srgbClr val="2E3473"/>
                     </a:solidFill>
@@ -5474,60 +5868,6 @@
                     <a:p/>
                   </a:txBody>
                   <a:tcPr/>
-                </a:tc>
-                <a:tc hMerge="1">
-                  <a:txBody>
-                    <a:bodyPr/>
-                    <a:lstStyle/>
-                    <a:p/>
-                  </a:txBody>
-                  <a:tcPr/>
-                </a:tc>
-                <a:tc hMerge="1">
-                  <a:txBody>
-                    <a:bodyPr/>
-                    <a:lstStyle/>
-                    <a:p/>
-                  </a:txBody>
-                  <a:tcPr/>
-                </a:tc>
-                <a:tc hMerge="1">
-                  <a:txBody>
-                    <a:bodyPr/>
-                    <a:lstStyle/>
-                    <a:p/>
-                  </a:txBody>
-                  <a:tcPr/>
-                </a:tc>
-                <a:tc gridSpan="2">
-                  <a:txBody>
-                    <a:bodyPr/>
-                    <a:lstStyle/>
-                    <a:p>
-                      <a:pPr algn="ctr">
-                        <a:lnSpc>
-                          <a:spcPct val="110000"/>
-                        </a:lnSpc>
-                        <a:spcAft>
-                          <a:spcPts val="0"/>
-                        </a:spcAft>
-                      </a:pPr>
-                      <a:r>
-                        <a:rPr sz="1500" b="1">
-                          <a:solidFill>
-                            <a:srgbClr val="FFFFFF"/>
-                          </a:solidFill>
-                          <a:latin typeface="Inter"/>
-                        </a:rPr>
-                        <a:t>Статья</a:t>
-                      </a:r>
-                    </a:p>
-                  </a:txBody>
-                  <a:tcPr anchor="ctr" marT="18000" marB="18000">
-                    <a:solidFill>
-                      <a:srgbClr val="2E3473"/>
-                    </a:solidFill>
-                  </a:tcPr>
                 </a:tc>
                 <a:tc hMerge="1">
                   <a:txBody>
@@ -5541,7 +5881,7 @@
               <a:tr h="684673">
                 <a:tc>
                   <a:txBody>
-                    <a:bodyPr/>
+                    <a:bodyPr wrap="square"/>
                     <a:lstStyle/>
                     <a:p>
                       <a:pPr algn="l">
@@ -5559,11 +5899,30 @@
                           </a:solidFill>
                           <a:latin typeface="Inter"/>
                         </a:rPr>
+                        <a:t> </a:t>
+                      </a:r>
+                    </a:p>
+                    <a:p>
+                      <a:pPr algn="l">
+                        <a:lnSpc>
+                          <a:spcPct val="110000"/>
+                        </a:lnSpc>
+                        <a:spcAft>
+                          <a:spcPts val="0"/>
+                        </a:spcAft>
+                      </a:pPr>
+                      <a:r>
+                        <a:rPr sz="1500" b="1">
+                          <a:solidFill>
+                            <a:srgbClr val="FFFFFF"/>
+                          </a:solidFill>
+                          <a:latin typeface="Inter"/>
+                        </a:rPr>
                         <a:t>Модель</a:t>
                       </a:r>
                     </a:p>
                   </a:txBody>
-                  <a:tcPr marL="64800" marR="64800" marT="28800" marB="28800" anchor="ctr">
+                  <a:tcPr marL="64800" marR="64800" marT="21600" marB="21600" anchor="ctr">
                     <a:solidFill>
                       <a:srgbClr val="434B9A"/>
                     </a:solidFill>
@@ -5571,7 +5930,7 @@
                 </a:tc>
                 <a:tc>
                   <a:txBody>
-                    <a:bodyPr/>
+                    <a:bodyPr wrap="square"/>
                     <a:lstStyle/>
                     <a:p>
                       <a:pPr algn="ctr">
@@ -5612,7 +5971,7 @@
                       </a:r>
                     </a:p>
                   </a:txBody>
-                  <a:tcPr marL="64800" marR="64800" marT="28800" marB="28800" anchor="ctr">
+                  <a:tcPr marL="64800" marR="64800" marT="21600" marB="21600" anchor="ctr">
                     <a:solidFill>
                       <a:srgbClr val="434B9A"/>
                     </a:solidFill>
@@ -5620,7 +5979,7 @@
                 </a:tc>
                 <a:tc>
                   <a:txBody>
-                    <a:bodyPr/>
+                    <a:bodyPr wrap="square"/>
                     <a:lstStyle/>
                     <a:p>
                       <a:pPr algn="ctr">
@@ -5661,7 +6020,7 @@
                       </a:r>
                     </a:p>
                   </a:txBody>
-                  <a:tcPr marL="64800" marR="64800" marT="28800" marB="28800" anchor="ctr">
+                  <a:tcPr marL="64800" marR="64800" marT="21600" marB="21600" anchor="ctr">
                     <a:solidFill>
                       <a:srgbClr val="434B9A"/>
                     </a:solidFill>
@@ -5669,7 +6028,7 @@
                 </a:tc>
                 <a:tc>
                   <a:txBody>
-                    <a:bodyPr/>
+                    <a:bodyPr wrap="square"/>
                     <a:lstStyle/>
                     <a:p>
                       <a:pPr algn="ctr">
@@ -5687,11 +6046,30 @@
                           </a:solidFill>
                           <a:latin typeface="Inter"/>
                         </a:rPr>
-                        <a:t>Accuracy</a:t>
-                      </a:r>
-                    </a:p>
-                  </a:txBody>
-                  <a:tcPr marL="64800" marR="64800" marT="28800" marB="28800" anchor="ctr">
+                        <a:t>Лучшая</a:t>
+                      </a:r>
+                    </a:p>
+                    <a:p>
+                      <a:pPr algn="ctr">
+                        <a:lnSpc>
+                          <a:spcPct val="110000"/>
+                        </a:lnSpc>
+                        <a:spcAft>
+                          <a:spcPts val="0"/>
+                        </a:spcAft>
+                      </a:pPr>
+                      <a:r>
+                        <a:rPr sz="1500" b="1">
+                          <a:solidFill>
+                            <a:srgbClr val="FFFFFF"/>
+                          </a:solidFill>
+                          <a:latin typeface="Inter"/>
+                        </a:rPr>
+                        <a:t>accuracy</a:t>
+                      </a:r>
+                    </a:p>
+                  </a:txBody>
+                  <a:tcPr marL="64800" marR="64800" marT="21600" marB="21600" anchor="ctr">
                     <a:solidFill>
                       <a:srgbClr val="434B9A"/>
                     </a:solidFill>
@@ -5699,7 +6077,7 @@
                 </a:tc>
                 <a:tc>
                   <a:txBody>
-                    <a:bodyPr/>
+                    <a:bodyPr wrap="square"/>
                     <a:lstStyle/>
                     <a:p>
                       <a:pPr algn="ctr">
@@ -5717,11 +6095,30 @@
                           </a:solidFill>
                           <a:latin typeface="Inter"/>
                         </a:rPr>
+                        <a:t> </a:t>
+                      </a:r>
+                    </a:p>
+                    <a:p>
+                      <a:pPr algn="ctr">
+                        <a:lnSpc>
+                          <a:spcPct val="110000"/>
+                        </a:lnSpc>
+                        <a:spcAft>
+                          <a:spcPts val="0"/>
+                        </a:spcAft>
+                      </a:pPr>
+                      <a:r>
+                        <a:rPr sz="1500" b="1">
+                          <a:solidFill>
+                            <a:srgbClr val="FFFFFF"/>
+                          </a:solidFill>
+                          <a:latin typeface="Inter"/>
+                        </a:rPr>
                         <a:t>κ</a:t>
                       </a:r>
                     </a:p>
                   </a:txBody>
-                  <a:tcPr marL="64800" marR="64800" marT="28800" marB="28800" anchor="ctr">
+                  <a:tcPr marL="64800" marR="64800" marT="21600" marB="21600" anchor="ctr">
                     <a:solidFill>
                       <a:srgbClr val="434B9A"/>
                     </a:solidFill>
@@ -5729,7 +6126,7 @@
                 </a:tc>
                 <a:tc>
                   <a:txBody>
-                    <a:bodyPr/>
+                    <a:bodyPr wrap="square"/>
                     <a:lstStyle/>
                     <a:p>
                       <a:pPr algn="ctr">
@@ -5770,7 +6167,7 @@
                       </a:r>
                     </a:p>
                   </a:txBody>
-                  <a:tcPr marL="64800" marR="64800" marT="28800" marB="28800" anchor="ctr">
+                  <a:tcPr marL="64800" marR="64800" marT="21600" marB="21600" anchor="ctr">
                     <a:solidFill>
                       <a:srgbClr val="434B9A"/>
                     </a:solidFill>
@@ -5778,7 +6175,7 @@
                 </a:tc>
                 <a:tc>
                   <a:txBody>
-                    <a:bodyPr/>
+                    <a:bodyPr wrap="square"/>
                     <a:lstStyle/>
                     <a:p>
                       <a:pPr algn="ctr">
@@ -5819,7 +6216,7 @@
                       </a:r>
                     </a:p>
                   </a:txBody>
-                  <a:tcPr marL="64800" marR="64800" marT="28800" marB="28800" anchor="ctr">
+                  <a:tcPr marL="64800" marR="64800" marT="21600" marB="21600" anchor="ctr">
                     <a:solidFill>
                       <a:srgbClr val="434B9A"/>
                     </a:solidFill>
@@ -5827,7 +6224,7 @@
                 </a:tc>
                 <a:tc>
                   <a:txBody>
-                    <a:bodyPr/>
+                    <a:bodyPr wrap="square"/>
                     <a:lstStyle/>
                     <a:p>
                       <a:pPr algn="ctr">
@@ -5868,7 +6265,7 @@
                       </a:r>
                     </a:p>
                   </a:txBody>
-                  <a:tcPr marL="64800" marR="64800" marT="28800" marB="28800" anchor="ctr">
+                  <a:tcPr marL="64800" marR="64800" marT="21600" marB="21600" anchor="ctr">
                     <a:solidFill>
                       <a:srgbClr val="434B9A"/>
                     </a:solidFill>
@@ -5876,7 +6273,7 @@
                 </a:tc>
                 <a:tc>
                   <a:txBody>
-                    <a:bodyPr/>
+                    <a:bodyPr wrap="square"/>
                     <a:lstStyle/>
                     <a:p>
                       <a:pPr algn="ctr">
@@ -5917,7 +6314,105 @@
                       </a:r>
                     </a:p>
                   </a:txBody>
-                  <a:tcPr marL="64800" marR="64800" marT="28800" marB="28800" anchor="ctr">
+                  <a:tcPr marL="64800" marR="64800" marT="21600" marB="21600" anchor="ctr">
+                    <a:solidFill>
+                      <a:srgbClr val="434B9A"/>
+                    </a:solidFill>
+                  </a:tcPr>
+                </a:tc>
+                <a:tc>
+                  <a:txBody>
+                    <a:bodyPr wrap="square"/>
+                    <a:lstStyle/>
+                    <a:p>
+                      <a:pPr algn="ctr">
+                        <a:lnSpc>
+                          <a:spcPct val="110000"/>
+                        </a:lnSpc>
+                        <a:spcAft>
+                          <a:spcPts val="0"/>
+                        </a:spcAft>
+                      </a:pPr>
+                      <a:r>
+                        <a:rPr sz="1500" b="1">
+                          <a:solidFill>
+                            <a:srgbClr val="FFFFFF"/>
+                          </a:solidFill>
+                          <a:latin typeface="Inter"/>
+                        </a:rPr>
+                        <a:t>Лучшая</a:t>
+                      </a:r>
+                    </a:p>
+                    <a:p>
+                      <a:pPr algn="ctr">
+                        <a:lnSpc>
+                          <a:spcPct val="110000"/>
+                        </a:lnSpc>
+                        <a:spcAft>
+                          <a:spcPts val="0"/>
+                        </a:spcAft>
+                      </a:pPr>
+                      <a:r>
+                        <a:rPr sz="1500" b="1">
+                          <a:solidFill>
+                            <a:srgbClr val="FFFFFF"/>
+                          </a:solidFill>
+                          <a:latin typeface="Inter"/>
+                        </a:rPr>
+                        <a:t>accuracy</a:t>
+                      </a:r>
+                    </a:p>
+                  </a:txBody>
+                  <a:tcPr marL="64800" marR="64800" marT="21600" marB="21600" anchor="ctr">
+                    <a:solidFill>
+                      <a:srgbClr val="434B9A"/>
+                    </a:solidFill>
+                  </a:tcPr>
+                </a:tc>
+                <a:tc>
+                  <a:txBody>
+                    <a:bodyPr wrap="square"/>
+                    <a:lstStyle/>
+                    <a:p>
+                      <a:pPr algn="ctr">
+                        <a:lnSpc>
+                          <a:spcPct val="110000"/>
+                        </a:lnSpc>
+                        <a:spcAft>
+                          <a:spcPts val="0"/>
+                        </a:spcAft>
+                      </a:pPr>
+                      <a:r>
+                        <a:rPr sz="1500" b="1">
+                          <a:solidFill>
+                            <a:srgbClr val="FFFFFF"/>
+                          </a:solidFill>
+                          <a:latin typeface="Inter"/>
+                        </a:rPr>
+                        <a:t> </a:t>
+                      </a:r>
+                    </a:p>
+                    <a:p>
+                      <a:pPr algn="ctr">
+                        <a:lnSpc>
+                          <a:spcPct val="110000"/>
+                        </a:lnSpc>
+                        <a:spcAft>
+                          <a:spcPts val="0"/>
+                        </a:spcAft>
+                      </a:pPr>
+                      <a:r>
+                        <a:rPr sz="1500" b="1">
+                          <a:solidFill>
+                            <a:srgbClr val="FFFFFF"/>
+                          </a:solidFill>
+                          <a:latin typeface="Inter"/>
+                        </a:rPr>
+                        <a:t>κ</a:t>
+                      </a:r>
+                    </a:p>
+                  </a:txBody>
+                  <a:tcPr marL="64800" marR="64800" marT="21600" marB="21600" anchor="ctr">
                     <a:solidFill>
                       <a:srgbClr val="434B9A"/>
                     </a:solidFill>
@@ -5927,7 +6422,7 @@
               <a:tr h="385581">
                 <a:tc>
                   <a:txBody>
-                    <a:bodyPr/>
+                    <a:bodyPr wrap="square"/>
                     <a:lstStyle/>
                     <a:p>
                       <a:pPr algn="l">
@@ -5945,11 +6440,11 @@
                           </a:solidFill>
                           <a:latin typeface="Inter"/>
                         </a:rPr>
-                        <a:t>Логистическая регрессия</a:t>
-                      </a:r>
-                    </a:p>
-                  </a:txBody>
-                  <a:tcPr marL="64800" marR="64800" marT="28800" marB="28800" anchor="ctr">
+                        <a:t>Лог. регрессия</a:t>
+                      </a:r>
+                    </a:p>
+                  </a:txBody>
+                  <a:tcPr marL="64800" marR="64800" marT="21600" marB="21600" anchor="ctr">
                     <a:solidFill>
                       <a:srgbClr val="FFFFFF"/>
                     </a:solidFill>
@@ -5957,7 +6452,7 @@
                 </a:tc>
                 <a:tc>
                   <a:txBody>
-                    <a:bodyPr/>
+                    <a:bodyPr wrap="square"/>
                     <a:lstStyle/>
                     <a:p>
                       <a:pPr algn="ctr">
@@ -5979,7 +6474,7 @@
                       </a:r>
                     </a:p>
                   </a:txBody>
-                  <a:tcPr marL="64800" marR="64800" marT="28800" marB="28800" anchor="ctr">
+                  <a:tcPr marL="64800" marR="64800" marT="21600" marB="21600" anchor="ctr">
                     <a:solidFill>
                       <a:srgbClr val="FFFFFF"/>
                     </a:solidFill>
@@ -5987,7 +6482,7 @@
                 </a:tc>
                 <a:tc>
                   <a:txBody>
-                    <a:bodyPr/>
+                    <a:bodyPr wrap="square"/>
                     <a:lstStyle/>
                     <a:p>
                       <a:pPr algn="ctr">
@@ -6009,7 +6504,7 @@
                       </a:r>
                     </a:p>
                   </a:txBody>
-                  <a:tcPr marL="64800" marR="64800" marT="28800" marB="28800" anchor="ctr">
+                  <a:tcPr marL="64800" marR="64800" marT="21600" marB="21600" anchor="ctr">
                     <a:solidFill>
                       <a:srgbClr val="FFFFFF"/>
                     </a:solidFill>
@@ -6017,7 +6512,7 @@
                 </a:tc>
                 <a:tc>
                   <a:txBody>
-                    <a:bodyPr/>
+                    <a:bodyPr wrap="square"/>
                     <a:lstStyle/>
                     <a:p>
                       <a:pPr algn="ctr">
@@ -6035,11 +6530,11 @@
                           </a:solidFill>
                           <a:latin typeface="Inter"/>
                         </a:rPr>
-                        <a:t>0.640</a:t>
-                      </a:r>
-                    </a:p>
-                  </a:txBody>
-                  <a:tcPr marL="64800" marR="64800" marT="28800" marB="28800" anchor="ctr">
+                        <a:t>0.688</a:t>
+                      </a:r>
+                    </a:p>
+                  </a:txBody>
+                  <a:tcPr marL="64800" marR="64800" marT="21600" marB="21600" anchor="ctr">
                     <a:solidFill>
                       <a:srgbClr val="FFFFFF"/>
                     </a:solidFill>
@@ -6047,7 +6542,7 @@
                 </a:tc>
                 <a:tc>
                   <a:txBody>
-                    <a:bodyPr/>
+                    <a:bodyPr wrap="square"/>
                     <a:lstStyle/>
                     <a:p>
                       <a:pPr algn="ctr">
@@ -6065,11 +6560,11 @@
                           </a:solidFill>
                           <a:latin typeface="Inter"/>
                         </a:rPr>
-                        <a:t>0.337</a:t>
-                      </a:r>
-                    </a:p>
-                  </a:txBody>
-                  <a:tcPr marL="64800" marR="64800" marT="28800" marB="28800" anchor="ctr">
+                        <a:t>0.175</a:t>
+                      </a:r>
+                    </a:p>
+                  </a:txBody>
+                  <a:tcPr marL="64800" marR="64800" marT="21600" marB="21600" anchor="ctr">
                     <a:solidFill>
                       <a:srgbClr val="FFFFFF"/>
                     </a:solidFill>
@@ -6077,7 +6572,7 @@
                 </a:tc>
                 <a:tc>
                   <a:txBody>
-                    <a:bodyPr/>
+                    <a:bodyPr wrap="square"/>
                     <a:lstStyle/>
                     <a:p>
                       <a:pPr algn="ctr">
@@ -6099,7 +6594,7 @@
                       </a:r>
                     </a:p>
                   </a:txBody>
-                  <a:tcPr marL="64800" marR="64800" marT="28800" marB="28800" anchor="ctr">
+                  <a:tcPr marL="64800" marR="64800" marT="21600" marB="21600" anchor="ctr">
                     <a:solidFill>
                       <a:srgbClr val="FFFFFF"/>
                     </a:solidFill>
@@ -6107,7 +6602,7 @@
                 </a:tc>
                 <a:tc>
                   <a:txBody>
-                    <a:bodyPr/>
+                    <a:bodyPr wrap="square"/>
                     <a:lstStyle/>
                     <a:p>
                       <a:pPr algn="ctr">
@@ -6129,7 +6624,7 @@
                       </a:r>
                     </a:p>
                   </a:txBody>
-                  <a:tcPr marL="64800" marR="64800" marT="28800" marB="28800" anchor="ctr">
+                  <a:tcPr marL="64800" marR="64800" marT="21600" marB="21600" anchor="ctr">
                     <a:solidFill>
                       <a:srgbClr val="FFFFFF"/>
                     </a:solidFill>
@@ -6137,7 +6632,7 @@
                 </a:tc>
                 <a:tc>
                   <a:txBody>
-                    <a:bodyPr/>
+                    <a:bodyPr wrap="square"/>
                     <a:lstStyle/>
                     <a:p>
                       <a:pPr algn="ctr">
@@ -6159,7 +6654,7 @@
                       </a:r>
                     </a:p>
                   </a:txBody>
-                  <a:tcPr marL="64800" marR="64800" marT="28800" marB="28800" anchor="ctr">
+                  <a:tcPr marL="64800" marR="64800" marT="21600" marB="21600" anchor="ctr">
                     <a:solidFill>
                       <a:srgbClr val="FFFFFF"/>
                     </a:solidFill>
@@ -6167,7 +6662,7 @@
                 </a:tc>
                 <a:tc>
                   <a:txBody>
-                    <a:bodyPr/>
+                    <a:bodyPr wrap="square"/>
                     <a:lstStyle/>
                     <a:p>
                       <a:pPr algn="ctr">
@@ -6189,7 +6684,67 @@
                       </a:r>
                     </a:p>
                   </a:txBody>
-                  <a:tcPr marL="64800" marR="64800" marT="28800" marB="28800" anchor="ctr">
+                  <a:tcPr marL="64800" marR="64800" marT="21600" marB="21600" anchor="ctr">
+                    <a:solidFill>
+                      <a:srgbClr val="FFFFFF"/>
+                    </a:solidFill>
+                  </a:tcPr>
+                </a:tc>
+                <a:tc>
+                  <a:txBody>
+                    <a:bodyPr wrap="square"/>
+                    <a:lstStyle/>
+                    <a:p>
+                      <a:pPr algn="ctr">
+                        <a:lnSpc>
+                          <a:spcPct val="110000"/>
+                        </a:lnSpc>
+                        <a:spcAft>
+                          <a:spcPts val="0"/>
+                        </a:spcAft>
+                      </a:pPr>
+                      <a:r>
+                        <a:rPr sz="1700" b="0">
+                          <a:solidFill>
+                            <a:srgbClr val="1F2233"/>
+                          </a:solidFill>
+                          <a:latin typeface="Inter"/>
+                        </a:rPr>
+                        <a:t>0.699</a:t>
+                      </a:r>
+                    </a:p>
+                  </a:txBody>
+                  <a:tcPr marL="64800" marR="64800" marT="21600" marB="21600" anchor="ctr">
+                    <a:solidFill>
+                      <a:srgbClr val="FFFFFF"/>
+                    </a:solidFill>
+                  </a:tcPr>
+                </a:tc>
+                <a:tc>
+                  <a:txBody>
+                    <a:bodyPr wrap="square"/>
+                    <a:lstStyle/>
+                    <a:p>
+                      <a:pPr algn="ctr">
+                        <a:lnSpc>
+                          <a:spcPct val="110000"/>
+                        </a:lnSpc>
+                        <a:spcAft>
+                          <a:spcPts val="0"/>
+                        </a:spcAft>
+                      </a:pPr>
+                      <a:r>
+                        <a:rPr sz="1700" b="0">
+                          <a:solidFill>
+                            <a:srgbClr val="1F2233"/>
+                          </a:solidFill>
+                          <a:latin typeface="Inter"/>
+                        </a:rPr>
+                        <a:t>0.130</a:t>
+                      </a:r>
+                    </a:p>
+                  </a:txBody>
+                  <a:tcPr marL="64800" marR="64800" marT="21600" marB="21600" anchor="ctr">
                     <a:solidFill>
                       <a:srgbClr val="FFFFFF"/>
                     </a:solidFill>
@@ -6199,7 +6754,7 @@
               <a:tr h="385581">
                 <a:tc>
                   <a:txBody>
-                    <a:bodyPr/>
+                    <a:bodyPr wrap="square"/>
                     <a:lstStyle/>
                     <a:p>
                       <a:pPr algn="l">
@@ -6217,11 +6772,11 @@
                           </a:solidFill>
                           <a:latin typeface="Inter"/>
                         </a:rPr>
-                        <a:t>k ближайших соседей</a:t>
-                      </a:r>
-                    </a:p>
-                  </a:txBody>
-                  <a:tcPr marL="64800" marR="64800" marT="28800" marB="28800" anchor="ctr">
+                        <a:t>kNN</a:t>
+                      </a:r>
+                    </a:p>
+                  </a:txBody>
+                  <a:tcPr marL="64800" marR="64800" marT="21600" marB="21600" anchor="ctr">
                     <a:solidFill>
                       <a:srgbClr val="F1F2FA"/>
                     </a:solidFill>
@@ -6229,7 +6784,7 @@
                 </a:tc>
                 <a:tc>
                   <a:txBody>
-                    <a:bodyPr/>
+                    <a:bodyPr wrap="square"/>
                     <a:lstStyle/>
                     <a:p>
                       <a:pPr algn="ctr">
@@ -6251,7 +6806,7 @@
                       </a:r>
                     </a:p>
                   </a:txBody>
-                  <a:tcPr marL="64800" marR="64800" marT="28800" marB="28800" anchor="ctr">
+                  <a:tcPr marL="64800" marR="64800" marT="21600" marB="21600" anchor="ctr">
                     <a:solidFill>
                       <a:srgbClr val="F1F2FA"/>
                     </a:solidFill>
@@ -6259,7 +6814,7 @@
                 </a:tc>
                 <a:tc>
                   <a:txBody>
-                    <a:bodyPr/>
+                    <a:bodyPr wrap="square"/>
                     <a:lstStyle/>
                     <a:p>
                       <a:pPr algn="ctr">
@@ -6281,7 +6836,7 @@
                       </a:r>
                     </a:p>
                   </a:txBody>
-                  <a:tcPr marL="64800" marR="64800" marT="28800" marB="28800" anchor="ctr">
+                  <a:tcPr marL="64800" marR="64800" marT="21600" marB="21600" anchor="ctr">
                     <a:solidFill>
                       <a:srgbClr val="F1F2FA"/>
                     </a:solidFill>
@@ -6289,7 +6844,7 @@
                 </a:tc>
                 <a:tc>
                   <a:txBody>
-                    <a:bodyPr/>
+                    <a:bodyPr wrap="square"/>
                     <a:lstStyle/>
                     <a:p>
                       <a:pPr algn="ctr">
@@ -6307,11 +6862,11 @@
                           </a:solidFill>
                           <a:latin typeface="Inter"/>
                         </a:rPr>
-                        <a:t>0.631</a:t>
-                      </a:r>
-                    </a:p>
-                  </a:txBody>
-                  <a:tcPr marL="64800" marR="64800" marT="28800" marB="28800" anchor="ctr">
+                        <a:t>0.697</a:t>
+                      </a:r>
+                    </a:p>
+                  </a:txBody>
+                  <a:tcPr marL="64800" marR="64800" marT="21600" marB="21600" anchor="ctr">
                     <a:solidFill>
                       <a:srgbClr val="F1F2FA"/>
                     </a:solidFill>
@@ -6319,7 +6874,7 @@
                 </a:tc>
                 <a:tc>
                   <a:txBody>
-                    <a:bodyPr/>
+                    <a:bodyPr wrap="square"/>
                     <a:lstStyle/>
                     <a:p>
                       <a:pPr algn="ctr">
@@ -6337,11 +6892,11 @@
                           </a:solidFill>
                           <a:latin typeface="Inter"/>
                         </a:rPr>
-                        <a:t>0.323</a:t>
-                      </a:r>
-                    </a:p>
-                  </a:txBody>
-                  <a:tcPr marL="64800" marR="64800" marT="28800" marB="28800" anchor="ctr">
+                        <a:t>0.184</a:t>
+                      </a:r>
+                    </a:p>
+                  </a:txBody>
+                  <a:tcPr marL="64800" marR="64800" marT="21600" marB="21600" anchor="ctr">
                     <a:solidFill>
                       <a:srgbClr val="F1F2FA"/>
                     </a:solidFill>
@@ -6349,7 +6904,7 @@
                 </a:tc>
                 <a:tc>
                   <a:txBody>
-                    <a:bodyPr/>
+                    <a:bodyPr wrap="square"/>
                     <a:lstStyle/>
                     <a:p>
                       <a:pPr algn="ctr">
@@ -6371,7 +6926,7 @@
                       </a:r>
                     </a:p>
                   </a:txBody>
-                  <a:tcPr marL="64800" marR="64800" marT="28800" marB="28800" anchor="ctr">
+                  <a:tcPr marL="64800" marR="64800" marT="21600" marB="21600" anchor="ctr">
                     <a:solidFill>
                       <a:srgbClr val="F1F2FA"/>
                     </a:solidFill>
@@ -6379,7 +6934,7 @@
                 </a:tc>
                 <a:tc>
                   <a:txBody>
-                    <a:bodyPr/>
+                    <a:bodyPr wrap="square"/>
                     <a:lstStyle/>
                     <a:p>
                       <a:pPr algn="ctr">
@@ -6401,7 +6956,7 @@
                       </a:r>
                     </a:p>
                   </a:txBody>
-                  <a:tcPr marL="64800" marR="64800" marT="28800" marB="28800" anchor="ctr">
+                  <a:tcPr marL="64800" marR="64800" marT="21600" marB="21600" anchor="ctr">
                     <a:solidFill>
                       <a:srgbClr val="F1F2FA"/>
                     </a:solidFill>
@@ -6409,7 +6964,7 @@
                 </a:tc>
                 <a:tc>
                   <a:txBody>
-                    <a:bodyPr/>
+                    <a:bodyPr wrap="square"/>
                     <a:lstStyle/>
                     <a:p>
                       <a:pPr algn="ctr">
@@ -6431,7 +6986,7 @@
                       </a:r>
                     </a:p>
                   </a:txBody>
-                  <a:tcPr marL="64800" marR="64800" marT="28800" marB="28800" anchor="ctr">
+                  <a:tcPr marL="64800" marR="64800" marT="21600" marB="21600" anchor="ctr">
                     <a:solidFill>
                       <a:srgbClr val="F1F2FA"/>
                     </a:solidFill>
@@ -6439,7 +6994,7 @@
                 </a:tc>
                 <a:tc>
                   <a:txBody>
-                    <a:bodyPr/>
+                    <a:bodyPr wrap="square"/>
                     <a:lstStyle/>
                     <a:p>
                       <a:pPr algn="ctr">
@@ -6461,7 +7016,67 @@
                       </a:r>
                     </a:p>
                   </a:txBody>
-                  <a:tcPr marL="64800" marR="64800" marT="28800" marB="28800" anchor="ctr">
+                  <a:tcPr marL="64800" marR="64800" marT="21600" marB="21600" anchor="ctr">
+                    <a:solidFill>
+                      <a:srgbClr val="F1F2FA"/>
+                    </a:solidFill>
+                  </a:tcPr>
+                </a:tc>
+                <a:tc>
+                  <a:txBody>
+                    <a:bodyPr wrap="square"/>
+                    <a:lstStyle/>
+                    <a:p>
+                      <a:pPr algn="ctr">
+                        <a:lnSpc>
+                          <a:spcPct val="110000"/>
+                        </a:lnSpc>
+                        <a:spcAft>
+                          <a:spcPts val="0"/>
+                        </a:spcAft>
+                      </a:pPr>
+                      <a:r>
+                        <a:rPr sz="1700" b="0">
+                          <a:solidFill>
+                            <a:srgbClr val="1F2233"/>
+                          </a:solidFill>
+                          <a:latin typeface="Inter"/>
+                        </a:rPr>
+                        <a:t>0.721</a:t>
+                      </a:r>
+                    </a:p>
+                  </a:txBody>
+                  <a:tcPr marL="64800" marR="64800" marT="21600" marB="21600" anchor="ctr">
+                    <a:solidFill>
+                      <a:srgbClr val="F1F2FA"/>
+                    </a:solidFill>
+                  </a:tcPr>
+                </a:tc>
+                <a:tc>
+                  <a:txBody>
+                    <a:bodyPr wrap="square"/>
+                    <a:lstStyle/>
+                    <a:p>
+                      <a:pPr algn="ctr">
+                        <a:lnSpc>
+                          <a:spcPct val="110000"/>
+                        </a:lnSpc>
+                        <a:spcAft>
+                          <a:spcPts val="0"/>
+                        </a:spcAft>
+                      </a:pPr>
+                      <a:r>
+                        <a:rPr sz="1700" b="0">
+                          <a:solidFill>
+                            <a:srgbClr val="1F2233"/>
+                          </a:solidFill>
+                          <a:latin typeface="Inter"/>
+                        </a:rPr>
+                        <a:t>0.243</a:t>
+                      </a:r>
+                    </a:p>
+                  </a:txBody>
+                  <a:tcPr marL="64800" marR="64800" marT="21600" marB="21600" anchor="ctr">
                     <a:solidFill>
                       <a:srgbClr val="F1F2FA"/>
                     </a:solidFill>
@@ -6471,7 +7086,7 @@
               <a:tr h="385581">
                 <a:tc>
                   <a:txBody>
-                    <a:bodyPr/>
+                    <a:bodyPr wrap="square"/>
                     <a:lstStyle/>
                     <a:p>
                       <a:pPr algn="l">
@@ -6493,7 +7108,7 @@
                       </a:r>
                     </a:p>
                   </a:txBody>
-                  <a:tcPr marL="64800" marR="64800" marT="28800" marB="28800" anchor="ctr">
+                  <a:tcPr marL="64800" marR="64800" marT="21600" marB="21600" anchor="ctr">
                     <a:solidFill>
                       <a:srgbClr val="FFFFFF"/>
                     </a:solidFill>
@@ -6501,7 +7116,7 @@
                 </a:tc>
                 <a:tc>
                   <a:txBody>
-                    <a:bodyPr/>
+                    <a:bodyPr wrap="square"/>
                     <a:lstStyle/>
                     <a:p>
                       <a:pPr algn="ctr">
@@ -6523,7 +7138,7 @@
                       </a:r>
                     </a:p>
                   </a:txBody>
-                  <a:tcPr marL="64800" marR="64800" marT="28800" marB="28800" anchor="ctr">
+                  <a:tcPr marL="64800" marR="64800" marT="21600" marB="21600" anchor="ctr">
                     <a:solidFill>
                       <a:srgbClr val="FFFFFF"/>
                     </a:solidFill>
@@ -6531,7 +7146,7 @@
                 </a:tc>
                 <a:tc>
                   <a:txBody>
-                    <a:bodyPr/>
+                    <a:bodyPr wrap="square"/>
                     <a:lstStyle/>
                     <a:p>
                       <a:pPr algn="ctr">
@@ -6553,7 +7168,7 @@
                       </a:r>
                     </a:p>
                   </a:txBody>
-                  <a:tcPr marL="64800" marR="64800" marT="28800" marB="28800" anchor="ctr">
+                  <a:tcPr marL="64800" marR="64800" marT="21600" marB="21600" anchor="ctr">
                     <a:solidFill>
                       <a:srgbClr val="FFFFFF"/>
                     </a:solidFill>
@@ -6561,7 +7176,7 @@
                 </a:tc>
                 <a:tc>
                   <a:txBody>
-                    <a:bodyPr/>
+                    <a:bodyPr wrap="square"/>
                     <a:lstStyle/>
                     <a:p>
                       <a:pPr algn="ctr">
@@ -6579,11 +7194,11 @@
                           </a:solidFill>
                           <a:latin typeface="Inter"/>
                         </a:rPr>
-                        <a:t>0.630</a:t>
-                      </a:r>
-                    </a:p>
-                  </a:txBody>
-                  <a:tcPr marL="64800" marR="64800" marT="28800" marB="28800" anchor="ctr">
+                        <a:t>0.695</a:t>
+                      </a:r>
+                    </a:p>
+                  </a:txBody>
+                  <a:tcPr marL="64800" marR="64800" marT="21600" marB="21600" anchor="ctr">
                     <a:solidFill>
                       <a:srgbClr val="FFFFFF"/>
                     </a:solidFill>
@@ -6591,7 +7206,7 @@
                 </a:tc>
                 <a:tc>
                   <a:txBody>
-                    <a:bodyPr/>
+                    <a:bodyPr wrap="square"/>
                     <a:lstStyle/>
                     <a:p>
                       <a:pPr algn="ctr">
@@ -6609,11 +7224,11 @@
                           </a:solidFill>
                           <a:latin typeface="Inter"/>
                         </a:rPr>
-                        <a:t>0.319</a:t>
-                      </a:r>
-                    </a:p>
-                  </a:txBody>
-                  <a:tcPr marL="64800" marR="64800" marT="28800" marB="28800" anchor="ctr">
+                        <a:t>0.249</a:t>
+                      </a:r>
+                    </a:p>
+                  </a:txBody>
+                  <a:tcPr marL="64800" marR="64800" marT="21600" marB="21600" anchor="ctr">
                     <a:solidFill>
                       <a:srgbClr val="FFFFFF"/>
                     </a:solidFill>
@@ -6621,7 +7236,7 @@
                 </a:tc>
                 <a:tc>
                   <a:txBody>
-                    <a:bodyPr/>
+                    <a:bodyPr wrap="square"/>
                     <a:lstStyle/>
                     <a:p>
                       <a:pPr algn="ctr">
@@ -6643,7 +7258,7 @@
                       </a:r>
                     </a:p>
                   </a:txBody>
-                  <a:tcPr marL="64800" marR="64800" marT="28800" marB="28800" anchor="ctr">
+                  <a:tcPr marL="64800" marR="64800" marT="21600" marB="21600" anchor="ctr">
                     <a:solidFill>
                       <a:srgbClr val="FFFFFF"/>
                     </a:solidFill>
@@ -6651,7 +7266,7 @@
                 </a:tc>
                 <a:tc>
                   <a:txBody>
-                    <a:bodyPr/>
+                    <a:bodyPr wrap="square"/>
                     <a:lstStyle/>
                     <a:p>
                       <a:pPr algn="ctr">
@@ -6673,7 +7288,7 @@
                       </a:r>
                     </a:p>
                   </a:txBody>
-                  <a:tcPr marL="64800" marR="64800" marT="28800" marB="28800" anchor="ctr">
+                  <a:tcPr marL="64800" marR="64800" marT="21600" marB="21600" anchor="ctr">
                     <a:solidFill>
                       <a:srgbClr val="FFFFFF"/>
                     </a:solidFill>
@@ -6681,7 +7296,7 @@
                 </a:tc>
                 <a:tc>
                   <a:txBody>
-                    <a:bodyPr/>
+                    <a:bodyPr wrap="square"/>
                     <a:lstStyle/>
                     <a:p>
                       <a:pPr algn="ctr">
@@ -6703,7 +7318,7 @@
                       </a:r>
                     </a:p>
                   </a:txBody>
-                  <a:tcPr marL="64800" marR="64800" marT="28800" marB="28800" anchor="ctr">
+                  <a:tcPr marL="64800" marR="64800" marT="21600" marB="21600" anchor="ctr">
                     <a:solidFill>
                       <a:srgbClr val="FFFFFF"/>
                     </a:solidFill>
@@ -6711,7 +7326,7 @@
                 </a:tc>
                 <a:tc>
                   <a:txBody>
-                    <a:bodyPr/>
+                    <a:bodyPr wrap="square"/>
                     <a:lstStyle/>
                     <a:p>
                       <a:pPr algn="ctr">
@@ -6733,7 +7348,67 @@
                       </a:r>
                     </a:p>
                   </a:txBody>
-                  <a:tcPr marL="64800" marR="64800" marT="28800" marB="28800" anchor="ctr">
+                  <a:tcPr marL="64800" marR="64800" marT="21600" marB="21600" anchor="ctr">
+                    <a:solidFill>
+                      <a:srgbClr val="FFFFFF"/>
+                    </a:solidFill>
+                  </a:tcPr>
+                </a:tc>
+                <a:tc>
+                  <a:txBody>
+                    <a:bodyPr wrap="square"/>
+                    <a:lstStyle/>
+                    <a:p>
+                      <a:pPr algn="ctr">
+                        <a:lnSpc>
+                          <a:spcPct val="110000"/>
+                        </a:lnSpc>
+                        <a:spcAft>
+                          <a:spcPts val="0"/>
+                        </a:spcAft>
+                      </a:pPr>
+                      <a:r>
+                        <a:rPr sz="1700" b="0">
+                          <a:solidFill>
+                            <a:srgbClr val="1F2233"/>
+                          </a:solidFill>
+                          <a:latin typeface="Inter"/>
+                        </a:rPr>
+                        <a:t>0.686</a:t>
+                      </a:r>
+                    </a:p>
+                  </a:txBody>
+                  <a:tcPr marL="64800" marR="64800" marT="21600" marB="21600" anchor="ctr">
+                    <a:solidFill>
+                      <a:srgbClr val="FFFFFF"/>
+                    </a:solidFill>
+                  </a:tcPr>
+                </a:tc>
+                <a:tc>
+                  <a:txBody>
+                    <a:bodyPr wrap="square"/>
+                    <a:lstStyle/>
+                    <a:p>
+                      <a:pPr algn="ctr">
+                        <a:lnSpc>
+                          <a:spcPct val="110000"/>
+                        </a:lnSpc>
+                        <a:spcAft>
+                          <a:spcPts val="0"/>
+                        </a:spcAft>
+                      </a:pPr>
+                      <a:r>
+                        <a:rPr sz="1700" b="0">
+                          <a:solidFill>
+                            <a:srgbClr val="1F2233"/>
+                          </a:solidFill>
+                          <a:latin typeface="Inter"/>
+                        </a:rPr>
+                        <a:t>0.302</a:t>
+                      </a:r>
+                    </a:p>
+                  </a:txBody>
+                  <a:tcPr marL="64800" marR="64800" marT="21600" marB="21600" anchor="ctr">
                     <a:solidFill>
                       <a:srgbClr val="FFFFFF"/>
                     </a:solidFill>
@@ -6743,7 +7418,7 @@
               <a:tr h="385581">
                 <a:tc>
                   <a:txBody>
-                    <a:bodyPr/>
+                    <a:bodyPr wrap="square"/>
                     <a:lstStyle/>
                     <a:p>
                       <a:pPr algn="l">
@@ -6765,7 +7440,7 @@
                       </a:r>
                     </a:p>
                   </a:txBody>
-                  <a:tcPr marL="64800" marR="64800" marT="28800" marB="28800" anchor="ctr">
+                  <a:tcPr marL="64800" marR="64800" marT="21600" marB="21600" anchor="ctr">
                     <a:solidFill>
                       <a:srgbClr val="F1F2FA"/>
                     </a:solidFill>
@@ -6773,7 +7448,7 @@
                 </a:tc>
                 <a:tc>
                   <a:txBody>
-                    <a:bodyPr/>
+                    <a:bodyPr wrap="square"/>
                     <a:lstStyle/>
                     <a:p>
                       <a:pPr algn="ctr">
@@ -6795,7 +7470,7 @@
                       </a:r>
                     </a:p>
                   </a:txBody>
-                  <a:tcPr marL="64800" marR="64800" marT="28800" marB="28800" anchor="ctr">
+                  <a:tcPr marL="64800" marR="64800" marT="21600" marB="21600" anchor="ctr">
                     <a:solidFill>
                       <a:srgbClr val="F1F2FA"/>
                     </a:solidFill>
@@ -6803,7 +7478,7 @@
                 </a:tc>
                 <a:tc>
                   <a:txBody>
-                    <a:bodyPr/>
+                    <a:bodyPr wrap="square"/>
                     <a:lstStyle/>
                     <a:p>
                       <a:pPr algn="ctr">
@@ -6825,7 +7500,7 @@
                       </a:r>
                     </a:p>
                   </a:txBody>
-                  <a:tcPr marL="64800" marR="64800" marT="28800" marB="28800" anchor="ctr">
+                  <a:tcPr marL="64800" marR="64800" marT="21600" marB="21600" anchor="ctr">
                     <a:solidFill>
                       <a:srgbClr val="F1F2FA"/>
                     </a:solidFill>
@@ -6833,7 +7508,7 @@
                 </a:tc>
                 <a:tc>
                   <a:txBody>
-                    <a:bodyPr/>
+                    <a:bodyPr wrap="square"/>
                     <a:lstStyle/>
                     <a:p>
                       <a:pPr algn="ctr">
@@ -6851,11 +7526,11 @@
                           </a:solidFill>
                           <a:latin typeface="Inter"/>
                         </a:rPr>
-                        <a:t>0.639</a:t>
-                      </a:r>
-                    </a:p>
-                  </a:txBody>
-                  <a:tcPr marL="64800" marR="64800" marT="28800" marB="28800" anchor="ctr">
+                        <a:t>0.707</a:t>
+                      </a:r>
+                    </a:p>
+                  </a:txBody>
+                  <a:tcPr marL="64800" marR="64800" marT="21600" marB="21600" anchor="ctr">
                     <a:solidFill>
                       <a:srgbClr val="F1F2FA"/>
                     </a:solidFill>
@@ -6863,7 +7538,7 @@
                 </a:tc>
                 <a:tc>
                   <a:txBody>
-                    <a:bodyPr/>
+                    <a:bodyPr wrap="square"/>
                     <a:lstStyle/>
                     <a:p>
                       <a:pPr algn="ctr">
@@ -6881,11 +7556,11 @@
                           </a:solidFill>
                           <a:latin typeface="Inter"/>
                         </a:rPr>
-                        <a:t>0.330</a:t>
-                      </a:r>
-                    </a:p>
-                  </a:txBody>
-                  <a:tcPr marL="64800" marR="64800" marT="28800" marB="28800" anchor="ctr">
+                        <a:t>0.228</a:t>
+                      </a:r>
+                    </a:p>
+                  </a:txBody>
+                  <a:tcPr marL="64800" marR="64800" marT="21600" marB="21600" anchor="ctr">
                     <a:solidFill>
                       <a:srgbClr val="F1F2FA"/>
                     </a:solidFill>
@@ -6893,7 +7568,7 @@
                 </a:tc>
                 <a:tc>
                   <a:txBody>
-                    <a:bodyPr/>
+                    <a:bodyPr wrap="square"/>
                     <a:lstStyle/>
                     <a:p>
                       <a:pPr algn="ctr">
@@ -6915,7 +7590,7 @@
                       </a:r>
                     </a:p>
                   </a:txBody>
-                  <a:tcPr marL="64800" marR="64800" marT="28800" marB="28800" anchor="ctr">
+                  <a:tcPr marL="64800" marR="64800" marT="21600" marB="21600" anchor="ctr">
                     <a:solidFill>
                       <a:srgbClr val="F1F2FA"/>
                     </a:solidFill>
@@ -6923,7 +7598,7 @@
                 </a:tc>
                 <a:tc>
                   <a:txBody>
-                    <a:bodyPr/>
+                    <a:bodyPr wrap="square"/>
                     <a:lstStyle/>
                     <a:p>
                       <a:pPr algn="ctr">
@@ -6945,7 +7620,7 @@
                       </a:r>
                     </a:p>
                   </a:txBody>
-                  <a:tcPr marL="64800" marR="64800" marT="28800" marB="28800" anchor="ctr">
+                  <a:tcPr marL="64800" marR="64800" marT="21600" marB="21600" anchor="ctr">
                     <a:solidFill>
                       <a:srgbClr val="F1F2FA"/>
                     </a:solidFill>
@@ -6953,7 +7628,7 @@
                 </a:tc>
                 <a:tc>
                   <a:txBody>
-                    <a:bodyPr/>
+                    <a:bodyPr wrap="square"/>
                     <a:lstStyle/>
                     <a:p>
                       <a:pPr algn="ctr">
@@ -6975,7 +7650,7 @@
                       </a:r>
                     </a:p>
                   </a:txBody>
-                  <a:tcPr marL="64800" marR="64800" marT="28800" marB="28800" anchor="ctr">
+                  <a:tcPr marL="64800" marR="64800" marT="21600" marB="21600" anchor="ctr">
                     <a:solidFill>
                       <a:srgbClr val="F1F2FA"/>
                     </a:solidFill>
@@ -6983,7 +7658,7 @@
                 </a:tc>
                 <a:tc>
                   <a:txBody>
-                    <a:bodyPr/>
+                    <a:bodyPr wrap="square"/>
                     <a:lstStyle/>
                     <a:p>
                       <a:pPr algn="ctr">
@@ -7005,7 +7680,67 @@
                       </a:r>
                     </a:p>
                   </a:txBody>
-                  <a:tcPr marL="64800" marR="64800" marT="28800" marB="28800" anchor="ctr">
+                  <a:tcPr marL="64800" marR="64800" marT="21600" marB="21600" anchor="ctr">
+                    <a:solidFill>
+                      <a:srgbClr val="F1F2FA"/>
+                    </a:solidFill>
+                  </a:tcPr>
+                </a:tc>
+                <a:tc>
+                  <a:txBody>
+                    <a:bodyPr wrap="square"/>
+                    <a:lstStyle/>
+                    <a:p>
+                      <a:pPr algn="ctr">
+                        <a:lnSpc>
+                          <a:spcPct val="110000"/>
+                        </a:lnSpc>
+                        <a:spcAft>
+                          <a:spcPts val="0"/>
+                        </a:spcAft>
+                      </a:pPr>
+                      <a:r>
+                        <a:rPr sz="1700" b="0">
+                          <a:solidFill>
+                            <a:srgbClr val="1F2233"/>
+                          </a:solidFill>
+                          <a:latin typeface="Inter"/>
+                        </a:rPr>
+                        <a:t>0.723</a:t>
+                      </a:r>
+                    </a:p>
+                  </a:txBody>
+                  <a:tcPr marL="64800" marR="64800" marT="21600" marB="21600" anchor="ctr">
+                    <a:solidFill>
+                      <a:srgbClr val="F1F2FA"/>
+                    </a:solidFill>
+                  </a:tcPr>
+                </a:tc>
+                <a:tc>
+                  <a:txBody>
+                    <a:bodyPr wrap="square"/>
+                    <a:lstStyle/>
+                    <a:p>
+                      <a:pPr algn="ctr">
+                        <a:lnSpc>
+                          <a:spcPct val="110000"/>
+                        </a:lnSpc>
+                        <a:spcAft>
+                          <a:spcPts val="0"/>
+                        </a:spcAft>
+                      </a:pPr>
+                      <a:r>
+                        <a:rPr sz="1700" b="0">
+                          <a:solidFill>
+                            <a:srgbClr val="1F2233"/>
+                          </a:solidFill>
+                          <a:latin typeface="Inter"/>
+                        </a:rPr>
+                        <a:t>0.277</a:t>
+                      </a:r>
+                    </a:p>
+                  </a:txBody>
+                  <a:tcPr marL="64800" marR="64800" marT="21600" marB="21600" anchor="ctr">
                     <a:solidFill>
                       <a:srgbClr val="F1F2FA"/>
                     </a:solidFill>
@@ -7015,7 +7750,7 @@
               <a:tr h="385581">
                 <a:tc>
                   <a:txBody>
-                    <a:bodyPr/>
+                    <a:bodyPr wrap="square"/>
                     <a:lstStyle/>
                     <a:p>
                       <a:pPr algn="l">
@@ -7037,7 +7772,7 @@
                       </a:r>
                     </a:p>
                   </a:txBody>
-                  <a:tcPr marL="64800" marR="64800" marT="28800" marB="28800" anchor="ctr">
+                  <a:tcPr marL="64800" marR="64800" marT="21600" marB="21600" anchor="ctr">
                     <a:solidFill>
                       <a:srgbClr val="E3E5F4"/>
                     </a:solidFill>
@@ -7045,7 +7780,7 @@
                 </a:tc>
                 <a:tc>
                   <a:txBody>
-                    <a:bodyPr/>
+                    <a:bodyPr wrap="square"/>
                     <a:lstStyle/>
                     <a:p>
                       <a:pPr algn="ctr">
@@ -7067,7 +7802,7 @@
                       </a:r>
                     </a:p>
                   </a:txBody>
-                  <a:tcPr marL="64800" marR="64800" marT="28800" marB="28800" anchor="ctr">
+                  <a:tcPr marL="64800" marR="64800" marT="21600" marB="21600" anchor="ctr">
                     <a:solidFill>
                       <a:srgbClr val="E3E5F4"/>
                     </a:solidFill>
@@ -7075,7 +7810,7 @@
                 </a:tc>
                 <a:tc>
                   <a:txBody>
-                    <a:bodyPr/>
+                    <a:bodyPr wrap="square"/>
                     <a:lstStyle/>
                     <a:p>
                       <a:pPr algn="ctr">
@@ -7097,7 +7832,7 @@
                       </a:r>
                     </a:p>
                   </a:txBody>
-                  <a:tcPr marL="64800" marR="64800" marT="28800" marB="28800" anchor="ctr">
+                  <a:tcPr marL="64800" marR="64800" marT="21600" marB="21600" anchor="ctr">
                     <a:solidFill>
                       <a:srgbClr val="E3E5F4"/>
                     </a:solidFill>
@@ -7105,7 +7840,7 @@
                 </a:tc>
                 <a:tc>
                   <a:txBody>
-                    <a:bodyPr/>
+                    <a:bodyPr wrap="square"/>
                     <a:lstStyle/>
                     <a:p>
                       <a:pPr algn="ctr">
@@ -7123,11 +7858,11 @@
                           </a:solidFill>
                           <a:latin typeface="Inter"/>
                         </a:rPr>
-                        <a:t>0.646</a:t>
-                      </a:r>
-                    </a:p>
-                  </a:txBody>
-                  <a:tcPr marL="64800" marR="64800" marT="28800" marB="28800" anchor="ctr">
+                        <a:t>0.704</a:t>
+                      </a:r>
+                    </a:p>
+                  </a:txBody>
+                  <a:tcPr marL="64800" marR="64800" marT="21600" marB="21600" anchor="ctr">
                     <a:solidFill>
                       <a:srgbClr val="E3E5F4"/>
                     </a:solidFill>
@@ -7135,7 +7870,7 @@
                 </a:tc>
                 <a:tc>
                   <a:txBody>
-                    <a:bodyPr/>
+                    <a:bodyPr wrap="square"/>
                     <a:lstStyle/>
                     <a:p>
                       <a:pPr algn="ctr">
@@ -7153,11 +7888,11 @@
                           </a:solidFill>
                           <a:latin typeface="Inter"/>
                         </a:rPr>
-                        <a:t>0.342</a:t>
-                      </a:r>
-                    </a:p>
-                  </a:txBody>
-                  <a:tcPr marL="64800" marR="64800" marT="28800" marB="28800" anchor="ctr">
+                        <a:t>0.244</a:t>
+                      </a:r>
+                    </a:p>
+                  </a:txBody>
+                  <a:tcPr marL="64800" marR="64800" marT="21600" marB="21600" anchor="ctr">
                     <a:solidFill>
                       <a:srgbClr val="E3E5F4"/>
                     </a:solidFill>
@@ -7165,7 +7900,7 @@
                 </a:tc>
                 <a:tc>
                   <a:txBody>
-                    <a:bodyPr/>
+                    <a:bodyPr wrap="square"/>
                     <a:lstStyle/>
                     <a:p>
                       <a:pPr algn="ctr">
@@ -7187,7 +7922,7 @@
                       </a:r>
                     </a:p>
                   </a:txBody>
-                  <a:tcPr marL="64800" marR="64800" marT="28800" marB="28800" anchor="ctr">
+                  <a:tcPr marL="64800" marR="64800" marT="21600" marB="21600" anchor="ctr">
                     <a:solidFill>
                       <a:srgbClr val="E3E5F4"/>
                     </a:solidFill>
@@ -7195,7 +7930,7 @@
                 </a:tc>
                 <a:tc>
                   <a:txBody>
-                    <a:bodyPr/>
+                    <a:bodyPr wrap="square"/>
                     <a:lstStyle/>
                     <a:p>
                       <a:pPr algn="ctr">
@@ -7217,7 +7952,7 @@
                       </a:r>
                     </a:p>
                   </a:txBody>
-                  <a:tcPr marL="64800" marR="64800" marT="28800" marB="28800" anchor="ctr">
+                  <a:tcPr marL="64800" marR="64800" marT="21600" marB="21600" anchor="ctr">
                     <a:solidFill>
                       <a:srgbClr val="E3E5F4"/>
                     </a:solidFill>
@@ -7225,7 +7960,7 @@
                 </a:tc>
                 <a:tc>
                   <a:txBody>
-                    <a:bodyPr/>
+                    <a:bodyPr wrap="square"/>
                     <a:lstStyle/>
                     <a:p>
                       <a:pPr algn="ctr">
@@ -7247,7 +7982,7 @@
                       </a:r>
                     </a:p>
                   </a:txBody>
-                  <a:tcPr marL="64800" marR="64800" marT="28800" marB="28800" anchor="ctr">
+                  <a:tcPr marL="64800" marR="64800" marT="21600" marB="21600" anchor="ctr">
                     <a:solidFill>
                       <a:srgbClr val="E3E5F4"/>
                     </a:solidFill>
@@ -7255,7 +7990,7 @@
                 </a:tc>
                 <a:tc>
                   <a:txBody>
-                    <a:bodyPr/>
+                    <a:bodyPr wrap="square"/>
                     <a:lstStyle/>
                     <a:p>
                       <a:pPr algn="ctr">
@@ -7277,7 +8012,67 @@
                       </a:r>
                     </a:p>
                   </a:txBody>
-                  <a:tcPr marL="64800" marR="64800" marT="28800" marB="28800" anchor="ctr">
+                  <a:tcPr marL="64800" marR="64800" marT="21600" marB="21600" anchor="ctr">
+                    <a:solidFill>
+                      <a:srgbClr val="E3E5F4"/>
+                    </a:solidFill>
+                  </a:tcPr>
+                </a:tc>
+                <a:tc>
+                  <a:txBody>
+                    <a:bodyPr wrap="square"/>
+                    <a:lstStyle/>
+                    <a:p>
+                      <a:pPr algn="ctr">
+                        <a:lnSpc>
+                          <a:spcPct val="110000"/>
+                        </a:lnSpc>
+                        <a:spcAft>
+                          <a:spcPts val="0"/>
+                        </a:spcAft>
+                      </a:pPr>
+                      <a:r>
+                        <a:rPr sz="1700" b="1">
+                          <a:solidFill>
+                            <a:srgbClr val="1F2233"/>
+                          </a:solidFill>
+                          <a:latin typeface="Inter"/>
+                        </a:rPr>
+                        <a:t>—</a:t>
+                      </a:r>
+                    </a:p>
+                  </a:txBody>
+                  <a:tcPr marL="64800" marR="64800" marT="21600" marB="21600" anchor="ctr">
+                    <a:solidFill>
+                      <a:srgbClr val="E3E5F4"/>
+                    </a:solidFill>
+                  </a:tcPr>
+                </a:tc>
+                <a:tc>
+                  <a:txBody>
+                    <a:bodyPr wrap="square"/>
+                    <a:lstStyle/>
+                    <a:p>
+                      <a:pPr algn="ctr">
+                        <a:lnSpc>
+                          <a:spcPct val="110000"/>
+                        </a:lnSpc>
+                        <a:spcAft>
+                          <a:spcPts val="0"/>
+                        </a:spcAft>
+                      </a:pPr>
+                      <a:r>
+                        <a:rPr sz="1700" b="1">
+                          <a:solidFill>
+                            <a:srgbClr val="1F2233"/>
+                          </a:solidFill>
+                          <a:latin typeface="Inter"/>
+                        </a:rPr>
+                        <a:t>—</a:t>
+                      </a:r>
+                    </a:p>
+                  </a:txBody>
+                  <a:tcPr marL="64800" marR="64800" marT="21600" marB="21600" anchor="ctr">
                     <a:solidFill>
                       <a:srgbClr val="E3E5F4"/>
                     </a:solidFill>
@@ -7296,7 +8091,7 @@
         </p:nvSpPr>
         <p:spPr>
           <a:xfrm>
-            <a:off x="2628000" y="37290767"/>
+            <a:off x="2628000" y="37277453"/>
             <a:ext cx="11988000" cy="2429092"/>
           </a:xfrm>
           <a:prstGeom prst="rect">

</xml_diff>

<commit_message>
Poster: smaller font, detailed explanations, paper result explained
- body text 16 pt with more detail in every card; tables 12-14 pt
- card 1: no repeated paper title, mean age only, the task described step by
  step, the paper's headline result explained (neural net, motion + hr + clock,
  threshold at 93% sleep found: 59.6% wake found, 90% of epochs correct)
- metric definitions, Shapley idea and the fast-feature experiments explained

Co-Authored-By: Claude Opus 5.5 <noreply@anthropic.com>
</commit_message>
<xml_diff>
--- a/poster/Команда_11_Постер.pptx
+++ b/poster/Команда_11_Постер.pptx
@@ -1745,7 +1745,7 @@
         <p:spPr>
           <a:xfrm>
             <a:off x="6696000" y="8640000"/>
-            <a:ext cx="21240000" cy="1728000"/>
+            <a:ext cx="21240000" cy="1512000"/>
           </a:xfrm>
           <a:prstGeom prst="rect">
             <a:avLst/>
@@ -1765,7 +1765,7 @@
               </a:spcAft>
             </a:pPr>
             <a:r>
-              <a:rPr sz="4800" b="1">
+              <a:rPr sz="4200" b="1">
                 <a:solidFill>
                   <a:srgbClr val="434B9A"/>
                 </a:solidFill>
@@ -1784,8 +1784,8 @@
         </p:nvSpPr>
         <p:spPr>
           <a:xfrm>
-            <a:off x="2376000" y="10656000"/>
-            <a:ext cx="12492000" cy="7632096"/>
+            <a:off x="2376000" y="10404000"/>
+            <a:ext cx="12492000" cy="8952686"/>
           </a:xfrm>
           <a:prstGeom prst="roundRect">
             <a:avLst>
@@ -1832,8 +1832,8 @@
         </p:nvSpPr>
         <p:spPr>
           <a:xfrm>
-            <a:off x="2628000" y="10908000"/>
-            <a:ext cx="11988000" cy="576717"/>
+            <a:off x="2628000" y="10656000"/>
+            <a:ext cx="11988000" cy="504628"/>
           </a:xfrm>
           <a:prstGeom prst="rect">
             <a:avLst/>
@@ -1853,7 +1853,7 @@
               </a:spcAft>
             </a:pPr>
             <a:r>
-              <a:rPr sz="3200" b="1">
+              <a:rPr sz="2800" b="1">
                 <a:solidFill>
                   <a:srgbClr val="434B9A"/>
                 </a:solidFill>
@@ -1872,7 +1872,7 @@
         </p:nvSpPr>
         <p:spPr>
           <a:xfrm>
-            <a:off x="2628000" y="11520717"/>
+            <a:off x="2628000" y="11196628"/>
             <a:ext cx="2160000" cy="43200"/>
           </a:xfrm>
           <a:prstGeom prst="rect">
@@ -1915,8 +1915,8 @@
         </p:nvSpPr>
         <p:spPr>
           <a:xfrm>
-            <a:off x="2628000" y="11646717"/>
-            <a:ext cx="11988000" cy="720897"/>
+            <a:off x="2628000" y="11322628"/>
+            <a:ext cx="11988000" cy="576717"/>
           </a:xfrm>
           <a:prstGeom prst="rect">
             <a:avLst/>
@@ -1936,22 +1936,22 @@
               </a:spcAft>
             </a:pPr>
             <a:r>
-              <a:rPr sz="2000" b="0">
+              <a:rPr sz="1600" b="0">
                 <a:solidFill>
                   <a:srgbClr val="1F2233"/>
                 </a:solidFill>
                 <a:latin typeface="Inter"/>
               </a:rPr>
-              <a:t>Полисомнография (PSG) точна, но для её проведения нужна лаборатория. </a:t>
-            </a:r>
-            <a:r>
-              <a:rPr sz="2000" b="1">
+              <a:t>Полисомнография (PSG) — эталон измерения сна, но нужны лаборатория, датчики на голове и специалист, поэтому сон измеряют одну-две ночи. </a:t>
+            </a:r>
+            <a:r>
+              <a:rPr sz="1600" b="1">
                 <a:solidFill>
                   <a:srgbClr val="434B9A"/>
                 </a:solidFill>
                 <a:latin typeface="Inter"/>
               </a:rPr>
-              <a:t>Можно ли размечать сон по смарт-часам?</a:t>
+              <a:t>Можно ли размечать сон по смарт-часам — каждую ночь и дома?</a:t>
             </a:r>
           </a:p>
         </p:txBody>
@@ -1964,8 +1964,8 @@
         </p:nvSpPr>
         <p:spPr>
           <a:xfrm>
-            <a:off x="2628000" y="12475615"/>
-            <a:ext cx="11988000" cy="2508292"/>
+            <a:off x="2628000" y="12007346"/>
+            <a:ext cx="11988000" cy="3805907"/>
           </a:xfrm>
           <a:prstGeom prst="rect">
             <a:avLst/>
@@ -1990,22 +1990,22 @@
               <a:buChar char="•"/>
             </a:pPr>
             <a:r>
-              <a:rPr sz="2000" b="1">
+              <a:rPr sz="1600" b="1">
                 <a:solidFill>
                   <a:srgbClr val="434B9A"/>
                 </a:solidFill>
                 <a:latin typeface="Inter"/>
               </a:rPr>
-              <a:t>Статья:</a:t>
-            </a:r>
-            <a:r>
-              <a:rPr sz="2000" b="0">
+              <a:t>Что сделали авторы:</a:t>
+            </a:r>
+            <a:r>
+              <a:rPr sz="1600" b="0">
                 <a:solidFill>
                   <a:srgbClr val="1F2233"/>
                 </a:solidFill>
                 <a:latin typeface="Inter"/>
               </a:rPr>
-              <a:t> Walch et al., SLEEP 2019 (University of Michigan): своё приложение для Apple Watch Series 2/3 дало открытые сырые данные ускорения и пульса</a:t>
+              <a:t> своё приложение для Apple Watch впервые дало сырые данные ускорения (50 раз в секунду) и пульса (оптический датчик, ≈ раз в 5 с) вместе с PSG; данные и код открыты — на них мы и работали</a:t>
             </a:r>
           </a:p>
           <a:p>
@@ -2023,7 +2023,7 @@
               <a:buChar char="•"/>
             </a:pPr>
             <a:r>
-              <a:rPr sz="2000" b="1">
+              <a:rPr sz="1600" b="1">
                 <a:solidFill>
                   <a:srgbClr val="434B9A"/>
                 </a:solidFill>
@@ -2032,13 +2032,13 @@
               <a:t>Данные:</a:t>
             </a:r>
             <a:r>
-              <a:rPr sz="2000" b="0">
+              <a:rPr sz="1600" b="0">
                 <a:solidFill>
                   <a:srgbClr val="1F2233"/>
                 </a:solidFill>
                 <a:latin typeface="Inter"/>
               </a:rPr>
-              <a:t> 31 человек (21 женщина, 29.4 ± 8.5 года): ночь с PSG + неделя с часами до неё</a:t>
+              <a:t> 31 человек (21 женщина, средний возраст 29 лет): ночь в лаборатории с PSG и часами + неделя с часами дома до неё (по шагам оценивается режим дня)</a:t>
             </a:r>
           </a:p>
           <a:p>
@@ -2056,7 +2056,7 @@
               <a:buChar char="•"/>
             </a:pPr>
             <a:r>
-              <a:rPr sz="2000" b="1">
+              <a:rPr sz="1600" b="1">
                 <a:solidFill>
                   <a:srgbClr val="434B9A"/>
                 </a:solidFill>
@@ -2065,13 +2065,49 @@
               <a:t>Задача:</a:t>
             </a:r>
             <a:r>
-              <a:rPr sz="2000" b="0">
+              <a:rPr sz="1600" b="0">
                 <a:solidFill>
                   <a:srgbClr val="1F2233"/>
                 </a:solidFill>
                 <a:latin typeface="Inter"/>
               </a:rPr>
-              <a:t> каждая эпоха 30 с — сон / бодрствование и бодрствование / NREM / REM</a:t>
+              <a:t> ночь режется на эпохи по 30 с; для каждой по данным часов нужно угадать стадию, которую по PSG поставил специалист. Две постановки: </a:t>
+            </a:r>
+            <a:r>
+              <a:rPr sz="1600" b="1">
+                <a:solidFill>
+                  <a:srgbClr val="434B9A"/>
+                </a:solidFill>
+                <a:latin typeface="Inter"/>
+              </a:rPr>
+              <a:t>сон / бодрствование</a:t>
+            </a:r>
+            <a:r>
+              <a:rPr sz="1600" b="0">
+                <a:solidFill>
+                  <a:srgbClr val="1F2233"/>
+                </a:solidFill>
+                <a:latin typeface="Inter"/>
+              </a:rPr>
+              <a:t> и </a:t>
+            </a:r>
+            <a:r>
+              <a:rPr sz="1600" b="1">
+                <a:solidFill>
+                  <a:srgbClr val="434B9A"/>
+                </a:solidFill>
+                <a:latin typeface="Inter"/>
+              </a:rPr>
+              <a:t>бодрствование / NREM / REM</a:t>
+            </a:r>
+            <a:r>
+              <a:rPr sz="1600" b="0">
+                <a:solidFill>
+                  <a:srgbClr val="1F2233"/>
+                </a:solidFill>
+                <a:latin typeface="Inter"/>
+              </a:rPr>
+              <a:t> (NREM — неглубокий и глубокий сон N1–N3, REM — сон с быстрыми движениями глаз). Из предсказаний собираются гипнограмма и показатели ночи: время сна, засыпания, пробуждений</a:t>
             </a:r>
           </a:p>
           <a:p>
@@ -2089,22 +2125,22 @@
               <a:buChar char="•"/>
             </a:pPr>
             <a:r>
-              <a:rPr sz="2000" b="1">
+              <a:rPr sz="1600" b="1">
                 <a:solidFill>
                   <a:srgbClr val="434B9A"/>
                 </a:solidFill>
                 <a:latin typeface="Inter"/>
               </a:rPr>
-              <a:t>Результат статьи:</a:t>
-            </a:r>
-            <a:r>
-              <a:rPr sz="2000" b="0">
+              <a:t>Результат статьи</a:t>
+            </a:r>
+            <a:r>
+              <a:rPr sz="1600" b="0">
                 <a:solidFill>
                   <a:srgbClr val="1F2233"/>
                 </a:solidFill>
                 <a:latin typeface="Inter"/>
               </a:rPr>
-              <a:t> 90% эпох верно (93% сна, 59.6% бодрствования); три класса — accuracy ≈ 72%; проверка на 188 людях из MESA</a:t>
+              <a:t> — лучшая модель, нейросеть на motion + hr + clock. Сон / бодрствование: порог подобран, чтобы найти 93% эпох сна; тогда найдено 59.6% эпох бодрствования и всего верно 90% эпох (κ = 0.45). Три класса: в лучшей точке верно ≈ 72% эпох. На 188 людях из исследования MESA (другой прибор и люди) — сопоставимо</a:t>
             </a:r>
           </a:p>
         </p:txBody>
@@ -2125,8 +2161,8 @@
         </p:blipFill>
         <p:spPr>
           <a:xfrm>
-            <a:off x="5924700" y="14983907"/>
-            <a:ext cx="5394600" cy="2311971"/>
+            <a:off x="5864760" y="15813253"/>
+            <a:ext cx="5514480" cy="2363348"/>
           </a:xfrm>
           <a:prstGeom prst="rect">
             <a:avLst/>
@@ -2141,8 +2177,8 @@
         </p:nvSpPr>
         <p:spPr>
           <a:xfrm>
-            <a:off x="2628000" y="17385878"/>
-            <a:ext cx="11988000" cy="612762"/>
+            <a:off x="2628000" y="18266602"/>
+            <a:ext cx="11988000" cy="756942"/>
           </a:xfrm>
           <a:prstGeom prst="rect">
             <a:avLst/>
@@ -2162,13 +2198,13 @@
               </a:spcAft>
             </a:pPr>
             <a:r>
-              <a:rPr sz="1700" b="0">
+              <a:rPr sz="1400" b="0">
                 <a:solidFill>
                   <a:srgbClr val="5B6075"/>
                 </a:solidFill>
                 <a:latin typeface="Inter"/>
               </a:rPr>
-              <a:t>Испытуемый 46343. Сверху вниз: движение (activity counts, усл. ед.), пульс (уд/мин), стадии по PSG; по оси x — часы от начала записи</a:t>
+              <a:t>Пример ночи (испытуемый 46343). Сверху вниз: движение — activity counts (условные единицы), пульс с часов (уд/мин), стадии по PSG — правильный ответ; по оси x — часы от начала записи. Видно, что движение почти всегда означает бодрствование, а ровный пульс — глубокий сон N3</a:t>
             </a:r>
           </a:p>
         </p:txBody>
@@ -2181,8 +2217,8 @@
         </p:nvSpPr>
         <p:spPr>
           <a:xfrm>
-            <a:off x="2376000" y="18594096"/>
-            <a:ext cx="12492000" cy="5355294"/>
+            <a:off x="2376000" y="19608686"/>
+            <a:ext cx="12492000" cy="5200869"/>
           </a:xfrm>
           <a:prstGeom prst="roundRect">
             <a:avLst>
@@ -2229,8 +2265,8 @@
         </p:nvSpPr>
         <p:spPr>
           <a:xfrm>
-            <a:off x="2628000" y="18846096"/>
-            <a:ext cx="11988000" cy="576717"/>
+            <a:off x="2628000" y="19860686"/>
+            <a:ext cx="11988000" cy="504628"/>
           </a:xfrm>
           <a:prstGeom prst="rect">
             <a:avLst/>
@@ -2250,13 +2286,13 @@
               </a:spcAft>
             </a:pPr>
             <a:r>
-              <a:rPr sz="3200" b="1">
+              <a:rPr sz="2800" b="1">
                 <a:solidFill>
                   <a:srgbClr val="434B9A"/>
                 </a:solidFill>
                 <a:latin typeface="Inter"/>
               </a:rPr>
-              <a:t>2. Признаки (по одному значению на эпоху)</a:t>
+              <a:t>2. Признаки: одно значение на каждую эпоху</a:t>
             </a:r>
           </a:p>
         </p:txBody>
@@ -2269,7 +2305,7 @@
         </p:nvSpPr>
         <p:spPr>
           <a:xfrm>
-            <a:off x="2628000" y="19458814"/>
+            <a:off x="2628000" y="20401314"/>
             <a:ext cx="2160000" cy="43200"/>
           </a:xfrm>
           <a:prstGeom prst="rect">
@@ -2312,8 +2348,8 @@
         </p:nvSpPr>
         <p:spPr>
           <a:xfrm>
-            <a:off x="2628000" y="19584814"/>
-            <a:ext cx="11988000" cy="2868740"/>
+            <a:off x="2628000" y="20527314"/>
+            <a:ext cx="11988000" cy="2652471"/>
           </a:xfrm>
           <a:prstGeom prst="rect">
             <a:avLst/>
@@ -2338,7 +2374,7 @@
               <a:buChar char="•"/>
             </a:pPr>
             <a:r>
-              <a:rPr sz="2000" b="1">
+              <a:rPr sz="1600" b="1">
                 <a:solidFill>
                   <a:srgbClr val="434B9A"/>
                 </a:solidFill>
@@ -2347,13 +2383,13 @@
               <a:t>motion</a:t>
             </a:r>
             <a:r>
-              <a:rPr sz="2000" b="0">
+              <a:rPr sz="1600" b="0">
                 <a:solidFill>
                   <a:srgbClr val="1F2233"/>
                 </a:solidFill>
                 <a:latin typeface="Inter"/>
               </a:rPr>
-              <a:t> — activity counts: ускорение (ось z) → фильтр 3–11 Гц → суммы за 15 с → сглаживание окном ≈ 10 мин</a:t>
+              <a:t> — сколько человек двигался: ускорение по оси z → полосовой фильтр 3–11 Гц (убирает гравитацию и шум) → суммы за 15 с («activity counts», как у актиграфов) → сглаживание окном ≈ 10 мин</a:t>
             </a:r>
           </a:p>
           <a:p>
@@ -2371,7 +2407,7 @@
               <a:buChar char="•"/>
             </a:pPr>
             <a:r>
-              <a:rPr sz="2000" b="1">
+              <a:rPr sz="1600" b="1">
                 <a:solidFill>
                   <a:srgbClr val="434B9A"/>
                 </a:solidFill>
@@ -2380,13 +2416,13 @@
               <a:t>hr</a:t>
             </a:r>
             <a:r>
-              <a:rPr sz="2000" b="0">
+              <a:rPr sz="1600" b="0">
                 <a:solidFill>
                   <a:srgbClr val="1F2233"/>
                 </a:solidFill>
                 <a:latin typeface="Inter"/>
               </a:rPr>
-              <a:t> — вариабельность пульса: стандартное отклонение за ≈ 10 мин после полосового фильтра (разность гауссиан)</a:t>
+              <a:t> — локальная вариабельность пульса: стандартное отклонение за ≈ 10 мин после полосового фильтра «разность гауссиан» (убирает дрейф за ночь); мала в глубоком сне, велика при пробуждениях</a:t>
             </a:r>
           </a:p>
           <a:p>
@@ -2404,7 +2440,7 @@
               <a:buChar char="•"/>
             </a:pPr>
             <a:r>
-              <a:rPr sz="2000" b="1">
+              <a:rPr sz="1600" b="1">
                 <a:solidFill>
                   <a:srgbClr val="434B9A"/>
                 </a:solidFill>
@@ -2413,13 +2449,13 @@
               <a:t>clock</a:t>
             </a:r>
             <a:r>
-              <a:rPr sz="2000" b="0">
+              <a:rPr sz="1600" b="0">
                 <a:solidFill>
                   <a:srgbClr val="1F2233"/>
                 </a:solidFill>
                 <a:latin typeface="Inter"/>
               </a:rPr>
-              <a:t> — суточный ритм: шаги за прошлые дни → «свет» → модель Forger (1999); ночные данные не нужны</a:t>
+              <a:t> — фаза суточного ритма: шаги за прошлые дни → оценка освещённости → модель внутренних часов Forger (1999) → волна x(t); ночные данные не нужны</a:t>
             </a:r>
           </a:p>
           <a:p>
@@ -2437,16 +2473,16 @@
               <a:buChar char="•"/>
             </a:pPr>
             <a:r>
-              <a:rPr sz="2000" b="0">
+              <a:rPr sz="1600" b="0">
                 <a:solidFill>
                   <a:srgbClr val="1F2233"/>
                 </a:solidFill>
                 <a:latin typeface="Inter"/>
               </a:rPr>
-              <a:t>В статье сравнивали и </a:t>
-            </a:r>
-            <a:r>
-              <a:rPr sz="2000" b="1">
+              <a:t>В статье сравнивали также </a:t>
+            </a:r>
+            <a:r>
+              <a:rPr sz="1600" b="1">
                 <a:solidFill>
                   <a:srgbClr val="434B9A"/>
                 </a:solidFill>
@@ -2455,16 +2491,16 @@
               <a:t>cosine</a:t>
             </a:r>
             <a:r>
-              <a:rPr sz="2000" b="0">
+              <a:rPr sz="1600" b="0">
                 <a:solidFill>
                   <a:srgbClr val="1F2233"/>
                 </a:solidFill>
                 <a:latin typeface="Inter"/>
               </a:rPr>
-              <a:t> (волна 24 ч), и </a:t>
-            </a:r>
-            <a:r>
-              <a:rPr sz="2000" b="1">
+              <a:t> (одинаковая для всех волна 24 ч) и </a:t>
+            </a:r>
+            <a:r>
+              <a:rPr sz="1600" b="1">
                 <a:solidFill>
                   <a:srgbClr val="434B9A"/>
                 </a:solidFill>
@@ -2473,13 +2509,13 @@
               <a:t>time</a:t>
             </a:r>
             <a:r>
-              <a:rPr sz="2000" b="0">
+              <a:rPr sz="1600" b="0">
                 <a:solidFill>
                   <a:srgbClr val="1F2233"/>
                 </a:solidFill>
                 <a:latin typeface="Inter"/>
               </a:rPr>
-              <a:t> (часы от отбоя)</a:t>
+              <a:t> (часы от отбоя); лучший результат — с clock</a:t>
             </a:r>
           </a:p>
         </p:txBody>
@@ -2500,8 +2536,8 @@
         </p:blipFill>
         <p:spPr>
           <a:xfrm>
-            <a:off x="7065664" y="22453555"/>
-            <a:ext cx="3112670" cy="792000"/>
+            <a:off x="7277892" y="23179786"/>
+            <a:ext cx="2688215" cy="684000"/>
           </a:xfrm>
           <a:prstGeom prst="rect">
             <a:avLst/>
@@ -2516,8 +2552,8 @@
         </p:nvSpPr>
         <p:spPr>
           <a:xfrm>
-            <a:off x="2628000" y="23353555"/>
-            <a:ext cx="11988000" cy="306381"/>
+            <a:off x="2628000" y="23971786"/>
+            <a:ext cx="11988000" cy="504628"/>
           </a:xfrm>
           <a:prstGeom prst="rect">
             <a:avLst/>
@@ -2537,13 +2573,13 @@
               </a:spcAft>
             </a:pPr>
             <a:r>
-              <a:rPr sz="1700" b="0">
+              <a:rPr sz="1400" b="0">
                 <a:solidFill>
                   <a:srgbClr val="5B6075"/>
                 </a:solidFill>
                 <a:latin typeface="Inter"/>
               </a:rPr>
-              <a:t>x — модель внутренних часов; clock = 0 — человек лёг, 1 — дно ритма (≈ 4 ч ночи)</a:t>
+              <a:t>x — состояние модели внутренних часов (без единиц). Шкала перевёрнута: clock = 0 — человек лёг, 1 — дно суточного ритма (≈ 4 ч ночи, минимум x); под утро clock снова уменьшается</a:t>
             </a:r>
           </a:p>
         </p:txBody>
@@ -2556,8 +2592,8 @@
         </p:nvSpPr>
         <p:spPr>
           <a:xfrm>
-            <a:off x="2376000" y="24255390"/>
-            <a:ext cx="12492000" cy="4428367"/>
+            <a:off x="2376000" y="25061556"/>
+            <a:ext cx="12492000" cy="5740780"/>
           </a:xfrm>
           <a:prstGeom prst="roundRect">
             <a:avLst>
@@ -2604,8 +2640,8 @@
         </p:nvSpPr>
         <p:spPr>
           <a:xfrm>
-            <a:off x="2628000" y="24507390"/>
-            <a:ext cx="11988000" cy="576717"/>
+            <a:off x="2628000" y="25313556"/>
+            <a:ext cx="11988000" cy="504628"/>
           </a:xfrm>
           <a:prstGeom prst="rect">
             <a:avLst/>
@@ -2625,13 +2661,13 @@
               </a:spcAft>
             </a:pPr>
             <a:r>
-              <a:rPr sz="3200" b="1">
+              <a:rPr sz="2800" b="1">
                 <a:solidFill>
                   <a:srgbClr val="434B9A"/>
                 </a:solidFill>
                 <a:latin typeface="Inter"/>
               </a:rPr>
-              <a:t>3. Модели и как проверяем</a:t>
+              <a:t>3. Модели, проверка и метрики</a:t>
             </a:r>
           </a:p>
         </p:txBody>
@@ -2644,7 +2680,7 @@
         </p:nvSpPr>
         <p:spPr>
           <a:xfrm>
-            <a:off x="2628000" y="25120108"/>
+            <a:off x="2628000" y="25854184"/>
             <a:ext cx="2160000" cy="43200"/>
           </a:xfrm>
           <a:prstGeom prst="rect">
@@ -2687,8 +2723,8 @@
         </p:nvSpPr>
         <p:spPr>
           <a:xfrm>
-            <a:off x="2628000" y="25246108"/>
-            <a:ext cx="11988000" cy="1708194"/>
+            <a:off x="2628000" y="25980184"/>
+            <a:ext cx="11988000" cy="1996553"/>
           </a:xfrm>
           <a:prstGeom prst="rect">
             <a:avLst/>
@@ -2713,7 +2749,7 @@
               <a:buChar char="•"/>
             </a:pPr>
             <a:r>
-              <a:rPr sz="2000" b="1">
+              <a:rPr sz="1600" b="1">
                 <a:solidFill>
                   <a:srgbClr val="434B9A"/>
                 </a:solidFill>
@@ -2722,16 +2758,16 @@
               <a:t>Модели статьи:</a:t>
             </a:r>
             <a:r>
-              <a:rPr sz="2000" b="0">
+              <a:rPr sz="1600" b="0">
                 <a:solidFill>
                   <a:srgbClr val="1F2233"/>
                 </a:solidFill>
                 <a:latin typeface="Inter"/>
               </a:rPr>
-              <a:t> логистическая регрессия, kNN (k = 500), случайный лес, MLP (15, 15, 15); </a:t>
-            </a:r>
-            <a:r>
-              <a:rPr sz="2000" b="1">
+              <a:t> логистическая регрессия, kNN (k = 500), случайный лес, нейросеть MLP (3 слоя по 15); </a:t>
+            </a:r>
+            <a:r>
+              <a:rPr sz="1600" b="1">
                 <a:solidFill>
                   <a:srgbClr val="434B9A"/>
                 </a:solidFill>
@@ -2755,7 +2791,7 @@
               <a:buChar char="•"/>
             </a:pPr>
             <a:r>
-              <a:rPr sz="2000" b="1">
+              <a:rPr sz="1600" b="1">
                 <a:solidFill>
                   <a:srgbClr val="434B9A"/>
                 </a:solidFill>
@@ -2764,13 +2800,13 @@
               <a:t>Проверка:</a:t>
             </a:r>
             <a:r>
-              <a:rPr sz="2000" b="0">
+              <a:rPr sz="1600" b="0">
                 <a:solidFill>
                   <a:srgbClr val="1F2233"/>
                 </a:solidFill>
                 <a:latin typeface="Inter"/>
               </a:rPr>
-              <a:t> в статье Monte Carlo 70/30; у нас leave-one-subject-out (31 фолд)</a:t>
+              <a:t> в статье — 50 случайных разбиений людей 70/30; у нас — leave-one-subject-out: каждого из 31 человека предсказывает модель, обученная на остальных 30</a:t>
             </a:r>
           </a:p>
           <a:p>
@@ -2788,7 +2824,7 @@
               <a:buChar char="•"/>
             </a:pPr>
             <a:r>
-              <a:rPr sz="2000" b="1">
+              <a:rPr sz="1600" b="1">
                 <a:solidFill>
                   <a:srgbClr val="434B9A"/>
                 </a:solidFill>
@@ -2797,31 +2833,13 @@
               <a:t>Порог</a:t>
             </a:r>
             <a:r>
-              <a:rPr sz="2000" b="0">
+              <a:rPr sz="1600" b="0">
                 <a:solidFill>
                   <a:srgbClr val="1F2233"/>
                 </a:solidFill>
                 <a:latin typeface="Inter"/>
               </a:rPr>
-              <a:t> на P(сон) — найти 90% сна; </a:t>
-            </a:r>
-            <a:r>
-              <a:rPr sz="2000" b="1">
-                <a:solidFill>
-                  <a:srgbClr val="434B9A"/>
-                </a:solidFill>
-                <a:latin typeface="Inter"/>
-              </a:rPr>
-              <a:t>метрики:</a:t>
-            </a:r>
-            <a:r>
-              <a:rPr sz="2000" b="0">
-                <a:solidFill>
-                  <a:srgbClr val="1F2233"/>
-                </a:solidFill>
-                <a:latin typeface="Inter"/>
-              </a:rPr>
-              <a:t> accuracy, κ, AUC + AP, PPV, F1</a:t>
+              <a:t> на P(сон) подбирается так, чтобы найти заданную долю сна (в таблицах — 90%), и смотрим, сколько найдено бодрствования</a:t>
             </a:r>
           </a:p>
         </p:txBody>
@@ -2842,17 +2860,194 @@
         </p:blipFill>
         <p:spPr>
           <a:xfrm>
-            <a:off x="5922563" y="26954303"/>
-            <a:ext cx="5398872" cy="648000"/>
+            <a:off x="6222501" y="27976738"/>
+            <a:ext cx="4798997" cy="576000"/>
           </a:xfrm>
           <a:prstGeom prst="rect">
             <a:avLst/>
           </a:prstGeom>
         </p:spPr>
       </p:pic>
+      <p:sp>
+        <p:nvSpPr>
+          <p:cNvPr id="41" name="TextBox 40"/>
+          <p:cNvSpPr txBox="1"/>
+          <p:nvPr/>
+        </p:nvSpPr>
+        <p:spPr>
+          <a:xfrm>
+            <a:off x="2628000" y="28660738"/>
+            <a:ext cx="11988000" cy="1196456"/>
+          </a:xfrm>
+          <a:prstGeom prst="rect">
+            <a:avLst/>
+          </a:prstGeom>
+          <a:noFill/>
+        </p:spPr>
+        <p:txBody>
+          <a:bodyPr wrap="square" lIns="0" rIns="0" tIns="0" bIns="0" anchor="t"/>
+          <a:lstStyle/>
+          <a:p>
+            <a:pPr algn="l" marL="270000" indent="-270000">
+              <a:lnSpc>
+                <a:spcPct val="110000"/>
+              </a:lnSpc>
+              <a:spcAft>
+                <a:spcPts val="623"/>
+              </a:spcAft>
+              <a:buClr>
+                <a:srgbClr val="434B9A"/>
+              </a:buClr>
+              <a:buFont typeface="Arial"/>
+              <a:buChar char="•"/>
+            </a:pPr>
+            <a:r>
+              <a:rPr sz="1400" b="1">
+                <a:solidFill>
+                  <a:srgbClr val="434B9A"/>
+                </a:solidFill>
+                <a:latin typeface="Inter"/>
+              </a:rPr>
+              <a:t>Accuracy</a:t>
+            </a:r>
+            <a:r>
+              <a:rPr sz="1400" b="0">
+                <a:solidFill>
+                  <a:srgbClr val="1F2233"/>
+                </a:solidFill>
+                <a:latin typeface="Inter"/>
+              </a:rPr>
+              <a:t> — доля верных эпох; </a:t>
+            </a:r>
+            <a:r>
+              <a:rPr sz="1400" b="1">
+                <a:solidFill>
+                  <a:srgbClr val="434B9A"/>
+                </a:solidFill>
+                <a:latin typeface="Inter"/>
+              </a:rPr>
+              <a:t>Найдено wake</a:t>
+            </a:r>
+            <a:r>
+              <a:rPr sz="1400" b="0">
+                <a:solidFill>
+                  <a:srgbClr val="1F2233"/>
+                </a:solidFill>
+                <a:latin typeface="Inter"/>
+              </a:rPr>
+              <a:t> — доля эпох бодрствования, названных бодрствованием (специфичность); </a:t>
+            </a:r>
+            <a:r>
+              <a:rPr sz="1400" b="1">
+                <a:solidFill>
+                  <a:srgbClr val="434B9A"/>
+                </a:solidFill>
+                <a:latin typeface="Inter"/>
+              </a:rPr>
+              <a:t>κ</a:t>
+            </a:r>
+            <a:r>
+              <a:rPr sz="1400" b="0">
+                <a:solidFill>
+                  <a:srgbClr val="1F2233"/>
+                </a:solidFill>
+                <a:latin typeface="Inter"/>
+              </a:rPr>
+              <a:t> — согласие с PSG сверх случайного (0 — как монетка, 1 — полное)</a:t>
+            </a:r>
+          </a:p>
+          <a:p>
+            <a:pPr algn="l" marL="270000" indent="-270000">
+              <a:lnSpc>
+                <a:spcPct val="110000"/>
+              </a:lnSpc>
+              <a:spcAft>
+                <a:spcPts val="623"/>
+              </a:spcAft>
+              <a:buClr>
+                <a:srgbClr val="434B9A"/>
+              </a:buClr>
+              <a:buFont typeface="Arial"/>
+              <a:buChar char="•"/>
+            </a:pPr>
+            <a:r>
+              <a:rPr sz="1400" b="1">
+                <a:solidFill>
+                  <a:srgbClr val="434B9A"/>
+                </a:solidFill>
+                <a:latin typeface="Inter"/>
+              </a:rPr>
+              <a:t>AUC</a:t>
+            </a:r>
+            <a:r>
+              <a:rPr sz="1400" b="0">
+                <a:solidFill>
+                  <a:srgbClr val="1F2233"/>
+                </a:solidFill>
+                <a:latin typeface="Inter"/>
+              </a:rPr>
+              <a:t> — качество упорядочивания эпох по всем порогам (0.5 — случайно); </a:t>
+            </a:r>
+            <a:r>
+              <a:rPr sz="1400" b="1">
+                <a:solidFill>
+                  <a:srgbClr val="434B9A"/>
+                </a:solidFill>
+                <a:latin typeface="Inter"/>
+              </a:rPr>
+              <a:t>AP wake</a:t>
+            </a:r>
+            <a:r>
+              <a:rPr sz="1400" b="0">
+                <a:solidFill>
+                  <a:srgbClr val="1F2233"/>
+                </a:solidFill>
+                <a:latin typeface="Inter"/>
+              </a:rPr>
+              <a:t> — площадь под кривой precision–recall для бодрствования (случайно — 0.084); </a:t>
+            </a:r>
+            <a:r>
+              <a:rPr sz="1400" b="1">
+                <a:solidFill>
+                  <a:srgbClr val="434B9A"/>
+                </a:solidFill>
+                <a:latin typeface="Inter"/>
+              </a:rPr>
+              <a:t>F1</a:t>
+            </a:r>
+            <a:r>
+              <a:rPr sz="1400" b="0">
+                <a:solidFill>
+                  <a:srgbClr val="1F2233"/>
+                </a:solidFill>
+                <a:latin typeface="Inter"/>
+              </a:rPr>
+              <a:t> — среднее гармоническое точности и полноты класса, </a:t>
+            </a:r>
+            <a:r>
+              <a:rPr sz="1400" b="1">
+                <a:solidFill>
+                  <a:srgbClr val="434B9A"/>
+                </a:solidFill>
+                <a:latin typeface="Inter"/>
+              </a:rPr>
+              <a:t>Macro F1</a:t>
+            </a:r>
+            <a:r>
+              <a:rPr sz="1400" b="0">
+                <a:solidFill>
+                  <a:srgbClr val="1F2233"/>
+                </a:solidFill>
+                <a:latin typeface="Inter"/>
+              </a:rPr>
+              <a:t> — среднее по классам</a:t>
+            </a:r>
+          </a:p>
+        </p:txBody>
+      </p:sp>
       <p:pic>
         <p:nvPicPr>
-          <p:cNvPr id="41" name="Picture 40" descr="formula_kappa.png"/>
+          <p:cNvPr id="42" name="Picture 41" descr="formula_kappa.png"/>
           <p:cNvPicPr>
             <a:picLocks noChangeAspect="1"/>
           </p:cNvPicPr>
@@ -2866,8 +3061,8 @@
         </p:blipFill>
         <p:spPr>
           <a:xfrm>
-            <a:off x="5723026" y="27710303"/>
-            <a:ext cx="1572824" cy="684000"/>
+            <a:off x="5961865" y="29857194"/>
+            <a:ext cx="1407263" cy="612000"/>
           </a:xfrm>
           <a:prstGeom prst="rect">
             <a:avLst/>
@@ -2876,7 +3071,7 @@
       </p:pic>
       <p:pic>
         <p:nvPicPr>
-          <p:cNvPr id="42" name="Picture 41" descr="formula_f1.png"/>
+          <p:cNvPr id="43" name="Picture 42" descr="formula_f1.png"/>
           <p:cNvPicPr>
             <a:picLocks noChangeAspect="1"/>
           </p:cNvPicPr>
@@ -2890,8 +3085,8 @@
         </p:blipFill>
         <p:spPr>
           <a:xfrm>
-            <a:off x="8555850" y="27710303"/>
-            <a:ext cx="2965123" cy="684000"/>
+            <a:off x="8629129" y="29857194"/>
+            <a:ext cx="2653004" cy="612000"/>
           </a:xfrm>
           <a:prstGeom prst="rect">
             <a:avLst/>
@@ -2900,14 +3095,14 @@
       </p:pic>
       <p:sp>
         <p:nvSpPr>
-          <p:cNvPr id="43" name="Rounded Rectangle 42"/>
+          <p:cNvPr id="44" name="Rounded Rectangle 43"/>
           <p:cNvSpPr/>
           <p:nvPr/>
         </p:nvSpPr>
         <p:spPr>
           <a:xfrm>
-            <a:off x="2376000" y="28989758"/>
-            <a:ext cx="12492000" cy="10898241"/>
+            <a:off x="2376000" y="31054336"/>
+            <a:ext cx="12492000" cy="9121663"/>
           </a:xfrm>
           <a:prstGeom prst="roundRect">
             <a:avLst>
@@ -2948,14 +3143,14 @@
       </p:sp>
       <p:sp>
         <p:nvSpPr>
-          <p:cNvPr id="44" name="TextBox 43"/>
+          <p:cNvPr id="45" name="TextBox 44"/>
           <p:cNvSpPr txBox="1"/>
           <p:nvPr/>
         </p:nvSpPr>
         <p:spPr>
           <a:xfrm>
-            <a:off x="2628000" y="29241758"/>
-            <a:ext cx="11988000" cy="576717"/>
+            <a:off x="2628000" y="31306336"/>
+            <a:ext cx="11988000" cy="504628"/>
           </a:xfrm>
           <a:prstGeom prst="rect">
             <a:avLst/>
@@ -2975,7 +3170,7 @@
               </a:spcAft>
             </a:pPr>
             <a:r>
-              <a:rPr sz="3200" b="1">
+              <a:rPr sz="2800" b="1">
                 <a:solidFill>
                   <a:srgbClr val="434B9A"/>
                 </a:solidFill>
@@ -2988,13 +3183,13 @@
       </p:sp>
       <p:sp>
         <p:nvSpPr>
-          <p:cNvPr id="45" name="Rectangle 44"/>
+          <p:cNvPr id="46" name="Rectangle 45"/>
           <p:cNvSpPr/>
           <p:nvPr/>
         </p:nvSpPr>
         <p:spPr>
           <a:xfrm>
-            <a:off x="2628000" y="29854475"/>
+            <a:off x="2628000" y="31846964"/>
             <a:ext cx="2160000" cy="43200"/>
           </a:xfrm>
           <a:prstGeom prst="rect">
@@ -3031,14 +3226,14 @@
       </p:sp>
       <p:sp>
         <p:nvSpPr>
-          <p:cNvPr id="46" name="TextBox 45"/>
+          <p:cNvPr id="47" name="TextBox 46"/>
           <p:cNvSpPr txBox="1"/>
           <p:nvPr/>
         </p:nvSpPr>
         <p:spPr>
           <a:xfrm>
-            <a:off x="2628000" y="29980475"/>
-            <a:ext cx="11988000" cy="306381"/>
+            <a:off x="2628000" y="31972964"/>
+            <a:ext cx="11988000" cy="252314"/>
           </a:xfrm>
           <a:prstGeom prst="rect">
             <a:avLst/>
@@ -3058,7 +3253,7 @@
               </a:spcAft>
             </a:pPr>
             <a:r>
-              <a:rPr sz="1700" b="1">
+              <a:rPr sz="1400" b="1">
                 <a:solidFill>
                   <a:srgbClr val="434B9A"/>
                 </a:solidFill>
@@ -3067,28 +3262,28 @@
               <a:t>Сон / бодрствование</a:t>
             </a:r>
             <a:r>
-              <a:rPr sz="1700" b="0">
+              <a:rPr sz="1400" b="0">
                 <a:solidFill>
                   <a:srgbClr val="1F2233"/>
                 </a:solidFill>
                 <a:latin typeface="Inter"/>
               </a:rPr>
-              <a:t> (motion + hr + clock; порог подобран так, чтобы найти 90% сна):</a:t>
+              <a:t> (признаки motion + hr + clock; порог найдёт 90% сна):</a:t>
             </a:r>
           </a:p>
         </p:txBody>
       </p:sp>
       <p:graphicFrame>
         <p:nvGraphicFramePr>
-          <p:cNvPr id="47" name="Table 46"/>
+          <p:cNvPr id="48" name="Table 47"/>
           <p:cNvGraphicFramePr>
             <a:graphicFrameLocks noGrp="1"/>
           </p:cNvGraphicFramePr>
           <p:nvPr/>
         </p:nvGraphicFramePr>
         <p:xfrm>
-          <a:off x="2628000" y="30394857"/>
-          <a:ext cx="11987994" cy="2972914"/>
+          <a:off x="2628000" y="32333278"/>
+          <a:ext cx="11987993" cy="2540377"/>
         </p:xfrm>
         <a:graphic>
           <a:graphicData uri="http://schemas.openxmlformats.org/drawingml/2006/table">
@@ -3097,20 +3292,20 @@
                 <a:tableStyleId>{5C22544A-7EE6-4342-B048-85BDC9FD1C3A}</a:tableStyleId>
               </a:tblPr>
               <a:tblGrid>
-                <a:gridCol w="2053044"/>
-                <a:gridCol w="808260"/>
-                <a:gridCol w="1082041"/>
-                <a:gridCol w="1101073"/>
-                <a:gridCol w="808260"/>
-                <a:gridCol w="808260"/>
-                <a:gridCol w="808260"/>
-                <a:gridCol w="819820"/>
-                <a:gridCol w="757931"/>
-                <a:gridCol w="1082041"/>
-                <a:gridCol w="1101073"/>
-                <a:gridCol w="757931"/>
+                <a:gridCol w="2451676"/>
+                <a:gridCol w="797371"/>
+                <a:gridCol w="1001791"/>
+                <a:gridCol w="1017016"/>
+                <a:gridCol w="797371"/>
+                <a:gridCol w="797371"/>
+                <a:gridCol w="797371"/>
+                <a:gridCol w="797371"/>
+                <a:gridCol w="755924"/>
+                <a:gridCol w="1001791"/>
+                <a:gridCol w="1017016"/>
+                <a:gridCol w="755924"/>
               </a:tblGrid>
-              <a:tr h="360336">
+              <a:tr h="306269">
                 <a:tc>
                   <a:txBody>
                     <a:bodyPr wrap="square"/>
@@ -3137,7 +3332,7 @@
                         </a:spcAft>
                       </a:pPr>
                       <a:r>
-                        <a:rPr sz="1500" b="1">
+                        <a:rPr sz="1200" b="1">
                           <a:solidFill>
                             <a:srgbClr val="FFFFFF"/>
                           </a:solidFill>
@@ -3215,7 +3410,7 @@
                         </a:spcAft>
                       </a:pPr>
                       <a:r>
-                        <a:rPr sz="1500" b="1">
+                        <a:rPr sz="1200" b="1">
                           <a:solidFill>
                             <a:srgbClr val="FFFFFF"/>
                           </a:solidFill>
@@ -3256,7 +3451,7 @@
                   <a:tcPr/>
                 </a:tc>
               </a:tr>
-              <a:tr h="684673">
+              <a:tr h="576538">
                 <a:tc>
                   <a:txBody>
                     <a:bodyPr wrap="square"/>
@@ -3271,7 +3466,7 @@
                         </a:spcAft>
                       </a:pPr>
                       <a:r>
-                        <a:rPr sz="1500" b="1">
+                        <a:rPr sz="1200" b="1">
                           <a:solidFill>
                             <a:srgbClr val="FFFFFF"/>
                           </a:solidFill>
@@ -3290,7 +3485,7 @@
                         </a:spcAft>
                       </a:pPr>
                       <a:r>
-                        <a:rPr sz="1500" b="1">
+                        <a:rPr sz="1200" b="1">
                           <a:solidFill>
                             <a:srgbClr val="FFFFFF"/>
                           </a:solidFill>
@@ -3320,7 +3515,7 @@
                         </a:spcAft>
                       </a:pPr>
                       <a:r>
-                        <a:rPr sz="1500" b="1">
+                        <a:rPr sz="1200" b="1">
                           <a:solidFill>
                             <a:srgbClr val="FFFFFF"/>
                           </a:solidFill>
@@ -3339,7 +3534,7 @@
                         </a:spcAft>
                       </a:pPr>
                       <a:r>
-                        <a:rPr sz="1500" b="1">
+                        <a:rPr sz="1200" b="1">
                           <a:solidFill>
                             <a:srgbClr val="FFFFFF"/>
                           </a:solidFill>
@@ -3369,7 +3564,7 @@
                         </a:spcAft>
                       </a:pPr>
                       <a:r>
-                        <a:rPr sz="1500" b="1">
+                        <a:rPr sz="1200" b="1">
                           <a:solidFill>
                             <a:srgbClr val="FFFFFF"/>
                           </a:solidFill>
@@ -3388,7 +3583,7 @@
                         </a:spcAft>
                       </a:pPr>
                       <a:r>
-                        <a:rPr sz="1500" b="1">
+                        <a:rPr sz="1200" b="1">
                           <a:solidFill>
                             <a:srgbClr val="FFFFFF"/>
                           </a:solidFill>
@@ -3418,7 +3613,7 @@
                         </a:spcAft>
                       </a:pPr>
                       <a:r>
-                        <a:rPr sz="1500" b="1">
+                        <a:rPr sz="1200" b="1">
                           <a:solidFill>
                             <a:srgbClr val="FFFFFF"/>
                           </a:solidFill>
@@ -3437,7 +3632,7 @@
                         </a:spcAft>
                       </a:pPr>
                       <a:r>
-                        <a:rPr sz="1500" b="1">
+                        <a:rPr sz="1200" b="1">
                           <a:solidFill>
                             <a:srgbClr val="FFFFFF"/>
                           </a:solidFill>
@@ -3467,7 +3662,7 @@
                         </a:spcAft>
                       </a:pPr>
                       <a:r>
-                        <a:rPr sz="1500" b="1">
+                        <a:rPr sz="1200" b="1">
                           <a:solidFill>
                             <a:srgbClr val="FFFFFF"/>
                           </a:solidFill>
@@ -3486,7 +3681,7 @@
                         </a:spcAft>
                       </a:pPr>
                       <a:r>
-                        <a:rPr sz="1500" b="1">
+                        <a:rPr sz="1200" b="1">
                           <a:solidFill>
                             <a:srgbClr val="FFFFFF"/>
                           </a:solidFill>
@@ -3516,7 +3711,7 @@
                         </a:spcAft>
                       </a:pPr>
                       <a:r>
-                        <a:rPr sz="1500" b="1">
+                        <a:rPr sz="1200" b="1">
                           <a:solidFill>
                             <a:srgbClr val="FFFFFF"/>
                           </a:solidFill>
@@ -3535,7 +3730,7 @@
                         </a:spcAft>
                       </a:pPr>
                       <a:r>
-                        <a:rPr sz="1500" b="1">
+                        <a:rPr sz="1200" b="1">
                           <a:solidFill>
                             <a:srgbClr val="FFFFFF"/>
                           </a:solidFill>
@@ -3565,7 +3760,7 @@
                         </a:spcAft>
                       </a:pPr>
                       <a:r>
-                        <a:rPr sz="1500" b="1">
+                        <a:rPr sz="1200" b="1">
                           <a:solidFill>
                             <a:srgbClr val="FFFFFF"/>
                           </a:solidFill>
@@ -3584,7 +3779,7 @@
                         </a:spcAft>
                       </a:pPr>
                       <a:r>
-                        <a:rPr sz="1500" b="1">
+                        <a:rPr sz="1200" b="1">
                           <a:solidFill>
                             <a:srgbClr val="FFFFFF"/>
                           </a:solidFill>
@@ -3614,7 +3809,7 @@
                         </a:spcAft>
                       </a:pPr>
                       <a:r>
-                        <a:rPr sz="1500" b="1">
+                        <a:rPr sz="1200" b="1">
                           <a:solidFill>
                             <a:srgbClr val="FFFFFF"/>
                           </a:solidFill>
@@ -3633,7 +3828,7 @@
                         </a:spcAft>
                       </a:pPr>
                       <a:r>
-                        <a:rPr sz="1500" b="1">
+                        <a:rPr sz="1200" b="1">
                           <a:solidFill>
                             <a:srgbClr val="FFFFFF"/>
                           </a:solidFill>
@@ -3663,7 +3858,7 @@
                         </a:spcAft>
                       </a:pPr>
                       <a:r>
-                        <a:rPr sz="1500" b="1">
+                        <a:rPr sz="1200" b="1">
                           <a:solidFill>
                             <a:srgbClr val="FFFFFF"/>
                           </a:solidFill>
@@ -3682,7 +3877,7 @@
                         </a:spcAft>
                       </a:pPr>
                       <a:r>
-                        <a:rPr sz="1500" b="1">
+                        <a:rPr sz="1200" b="1">
                           <a:solidFill>
                             <a:srgbClr val="FFFFFF"/>
                           </a:solidFill>
@@ -3712,7 +3907,7 @@
                         </a:spcAft>
                       </a:pPr>
                       <a:r>
-                        <a:rPr sz="1500" b="1">
+                        <a:rPr sz="1200" b="1">
                           <a:solidFill>
                             <a:srgbClr val="FFFFFF"/>
                           </a:solidFill>
@@ -3731,7 +3926,7 @@
                         </a:spcAft>
                       </a:pPr>
                       <a:r>
-                        <a:rPr sz="1500" b="1">
+                        <a:rPr sz="1200" b="1">
                           <a:solidFill>
                             <a:srgbClr val="FFFFFF"/>
                           </a:solidFill>
@@ -3761,7 +3956,7 @@
                         </a:spcAft>
                       </a:pPr>
                       <a:r>
-                        <a:rPr sz="1500" b="1">
+                        <a:rPr sz="1200" b="1">
                           <a:solidFill>
                             <a:srgbClr val="FFFFFF"/>
                           </a:solidFill>
@@ -3780,7 +3975,7 @@
                         </a:spcAft>
                       </a:pPr>
                       <a:r>
-                        <a:rPr sz="1500" b="1">
+                        <a:rPr sz="1200" b="1">
                           <a:solidFill>
                             <a:srgbClr val="FFFFFF"/>
                           </a:solidFill>
@@ -3810,7 +4005,7 @@
                         </a:spcAft>
                       </a:pPr>
                       <a:r>
-                        <a:rPr sz="1500" b="1">
+                        <a:rPr sz="1200" b="1">
                           <a:solidFill>
                             <a:srgbClr val="FFFFFF"/>
                           </a:solidFill>
@@ -3829,7 +4024,7 @@
                         </a:spcAft>
                       </a:pPr>
                       <a:r>
-                        <a:rPr sz="1500" b="1">
+                        <a:rPr sz="1200" b="1">
                           <a:solidFill>
                             <a:srgbClr val="FFFFFF"/>
                           </a:solidFill>
@@ -3846,7 +4041,7 @@
                   </a:tcPr>
                 </a:tc>
               </a:tr>
-              <a:tr h="385581">
+              <a:tr h="331514">
                 <a:tc>
                   <a:txBody>
                     <a:bodyPr wrap="square"/>
@@ -3861,7 +4056,7 @@
                         </a:spcAft>
                       </a:pPr>
                       <a:r>
-                        <a:rPr sz="1700" b="0">
+                        <a:rPr sz="1400" b="0">
                           <a:solidFill>
                             <a:srgbClr val="1F2233"/>
                           </a:solidFill>
@@ -3891,7 +4086,7 @@
                         </a:spcAft>
                       </a:pPr>
                       <a:r>
-                        <a:rPr sz="1700" b="0">
+                        <a:rPr sz="1400" b="0">
                           <a:solidFill>
                             <a:srgbClr val="1F2233"/>
                           </a:solidFill>
@@ -3921,7 +4116,7 @@
                         </a:spcAft>
                       </a:pPr>
                       <a:r>
-                        <a:rPr sz="1700" b="0">
+                        <a:rPr sz="1400" b="0">
                           <a:solidFill>
                             <a:srgbClr val="1F2233"/>
                           </a:solidFill>
@@ -3951,7 +4146,7 @@
                         </a:spcAft>
                       </a:pPr>
                       <a:r>
-                        <a:rPr sz="1700" b="0">
+                        <a:rPr sz="1400" b="0">
                           <a:solidFill>
                             <a:srgbClr val="1F2233"/>
                           </a:solidFill>
@@ -3981,7 +4176,7 @@
                         </a:spcAft>
                       </a:pPr>
                       <a:r>
-                        <a:rPr sz="1700" b="0">
+                        <a:rPr sz="1400" b="0">
                           <a:solidFill>
                             <a:srgbClr val="1F2233"/>
                           </a:solidFill>
@@ -4011,7 +4206,7 @@
                         </a:spcAft>
                       </a:pPr>
                       <a:r>
-                        <a:rPr sz="1700" b="0">
+                        <a:rPr sz="1400" b="0">
                           <a:solidFill>
                             <a:srgbClr val="1F2233"/>
                           </a:solidFill>
@@ -4041,7 +4236,7 @@
                         </a:spcAft>
                       </a:pPr>
                       <a:r>
-                        <a:rPr sz="1700" b="0">
+                        <a:rPr sz="1400" b="0">
                           <a:solidFill>
                             <a:srgbClr val="1F2233"/>
                           </a:solidFill>
@@ -4071,7 +4266,7 @@
                         </a:spcAft>
                       </a:pPr>
                       <a:r>
-                        <a:rPr sz="1700" b="0">
+                        <a:rPr sz="1400" b="0">
                           <a:solidFill>
                             <a:srgbClr val="1F2233"/>
                           </a:solidFill>
@@ -4101,7 +4296,7 @@
                         </a:spcAft>
                       </a:pPr>
                       <a:r>
-                        <a:rPr sz="1700" b="0">
+                        <a:rPr sz="1400" b="0">
                           <a:solidFill>
                             <a:srgbClr val="1F2233"/>
                           </a:solidFill>
@@ -4131,7 +4326,7 @@
                         </a:spcAft>
                       </a:pPr>
                       <a:r>
-                        <a:rPr sz="1700" b="0">
+                        <a:rPr sz="1400" b="0">
                           <a:solidFill>
                             <a:srgbClr val="1F2233"/>
                           </a:solidFill>
@@ -4161,7 +4356,7 @@
                         </a:spcAft>
                       </a:pPr>
                       <a:r>
-                        <a:rPr sz="1700" b="0">
+                        <a:rPr sz="1400" b="0">
                           <a:solidFill>
                             <a:srgbClr val="1F2233"/>
                           </a:solidFill>
@@ -4191,7 +4386,7 @@
                         </a:spcAft>
                       </a:pPr>
                       <a:r>
-                        <a:rPr sz="1700" b="0">
+                        <a:rPr sz="1400" b="0">
                           <a:solidFill>
                             <a:srgbClr val="1F2233"/>
                           </a:solidFill>
@@ -4208,7 +4403,7 @@
                   </a:tcPr>
                 </a:tc>
               </a:tr>
-              <a:tr h="385581">
+              <a:tr h="331514">
                 <a:tc>
                   <a:txBody>
                     <a:bodyPr wrap="square"/>
@@ -4223,7 +4418,7 @@
                         </a:spcAft>
                       </a:pPr>
                       <a:r>
-                        <a:rPr sz="1700" b="0">
+                        <a:rPr sz="1400" b="0">
                           <a:solidFill>
                             <a:srgbClr val="1F2233"/>
                           </a:solidFill>
@@ -4253,7 +4448,7 @@
                         </a:spcAft>
                       </a:pPr>
                       <a:r>
-                        <a:rPr sz="1700" b="0">
+                        <a:rPr sz="1400" b="0">
                           <a:solidFill>
                             <a:srgbClr val="1F2233"/>
                           </a:solidFill>
@@ -4283,7 +4478,7 @@
                         </a:spcAft>
                       </a:pPr>
                       <a:r>
-                        <a:rPr sz="1700" b="0">
+                        <a:rPr sz="1400" b="0">
                           <a:solidFill>
                             <a:srgbClr val="1F2233"/>
                           </a:solidFill>
@@ -4313,7 +4508,7 @@
                         </a:spcAft>
                       </a:pPr>
                       <a:r>
-                        <a:rPr sz="1700" b="0">
+                        <a:rPr sz="1400" b="0">
                           <a:solidFill>
                             <a:srgbClr val="1F2233"/>
                           </a:solidFill>
@@ -4343,7 +4538,7 @@
                         </a:spcAft>
                       </a:pPr>
                       <a:r>
-                        <a:rPr sz="1700" b="0">
+                        <a:rPr sz="1400" b="0">
                           <a:solidFill>
                             <a:srgbClr val="1F2233"/>
                           </a:solidFill>
@@ -4373,7 +4568,7 @@
                         </a:spcAft>
                       </a:pPr>
                       <a:r>
-                        <a:rPr sz="1700" b="0">
+                        <a:rPr sz="1400" b="0">
                           <a:solidFill>
                             <a:srgbClr val="1F2233"/>
                           </a:solidFill>
@@ -4403,7 +4598,7 @@
                         </a:spcAft>
                       </a:pPr>
                       <a:r>
-                        <a:rPr sz="1700" b="0">
+                        <a:rPr sz="1400" b="0">
                           <a:solidFill>
                             <a:srgbClr val="1F2233"/>
                           </a:solidFill>
@@ -4433,7 +4628,7 @@
                         </a:spcAft>
                       </a:pPr>
                       <a:r>
-                        <a:rPr sz="1700" b="0">
+                        <a:rPr sz="1400" b="0">
                           <a:solidFill>
                             <a:srgbClr val="1F2233"/>
                           </a:solidFill>
@@ -4463,7 +4658,7 @@
                         </a:spcAft>
                       </a:pPr>
                       <a:r>
-                        <a:rPr sz="1700" b="0">
+                        <a:rPr sz="1400" b="0">
                           <a:solidFill>
                             <a:srgbClr val="1F2233"/>
                           </a:solidFill>
@@ -4493,7 +4688,7 @@
                         </a:spcAft>
                       </a:pPr>
                       <a:r>
-                        <a:rPr sz="1700" b="0">
+                        <a:rPr sz="1400" b="0">
                           <a:solidFill>
                             <a:srgbClr val="1F2233"/>
                           </a:solidFill>
@@ -4523,7 +4718,7 @@
                         </a:spcAft>
                       </a:pPr>
                       <a:r>
-                        <a:rPr sz="1700" b="0">
+                        <a:rPr sz="1400" b="0">
                           <a:solidFill>
                             <a:srgbClr val="1F2233"/>
                           </a:solidFill>
@@ -4553,7 +4748,7 @@
                         </a:spcAft>
                       </a:pPr>
                       <a:r>
-                        <a:rPr sz="1700" b="0">
+                        <a:rPr sz="1400" b="0">
                           <a:solidFill>
                             <a:srgbClr val="1F2233"/>
                           </a:solidFill>
@@ -4570,7 +4765,7 @@
                   </a:tcPr>
                 </a:tc>
               </a:tr>
-              <a:tr h="385581">
+              <a:tr h="331514">
                 <a:tc>
                   <a:txBody>
                     <a:bodyPr wrap="square"/>
@@ -4585,7 +4780,7 @@
                         </a:spcAft>
                       </a:pPr>
                       <a:r>
-                        <a:rPr sz="1700" b="0">
+                        <a:rPr sz="1400" b="0">
                           <a:solidFill>
                             <a:srgbClr val="1F2233"/>
                           </a:solidFill>
@@ -4615,7 +4810,7 @@
                         </a:spcAft>
                       </a:pPr>
                       <a:r>
-                        <a:rPr sz="1700" b="0">
+                        <a:rPr sz="1400" b="0">
                           <a:solidFill>
                             <a:srgbClr val="1F2233"/>
                           </a:solidFill>
@@ -4645,7 +4840,7 @@
                         </a:spcAft>
                       </a:pPr>
                       <a:r>
-                        <a:rPr sz="1700" b="0">
+                        <a:rPr sz="1400" b="0">
                           <a:solidFill>
                             <a:srgbClr val="1F2233"/>
                           </a:solidFill>
@@ -4675,7 +4870,7 @@
                         </a:spcAft>
                       </a:pPr>
                       <a:r>
-                        <a:rPr sz="1700" b="0">
+                        <a:rPr sz="1400" b="0">
                           <a:solidFill>
                             <a:srgbClr val="1F2233"/>
                           </a:solidFill>
@@ -4705,7 +4900,7 @@
                         </a:spcAft>
                       </a:pPr>
                       <a:r>
-                        <a:rPr sz="1700" b="0">
+                        <a:rPr sz="1400" b="0">
                           <a:solidFill>
                             <a:srgbClr val="1F2233"/>
                           </a:solidFill>
@@ -4735,7 +4930,7 @@
                         </a:spcAft>
                       </a:pPr>
                       <a:r>
-                        <a:rPr sz="1700" b="0">
+                        <a:rPr sz="1400" b="0">
                           <a:solidFill>
                             <a:srgbClr val="1F2233"/>
                           </a:solidFill>
@@ -4765,7 +4960,7 @@
                         </a:spcAft>
                       </a:pPr>
                       <a:r>
-                        <a:rPr sz="1700" b="0">
+                        <a:rPr sz="1400" b="0">
                           <a:solidFill>
                             <a:srgbClr val="1F2233"/>
                           </a:solidFill>
@@ -4795,7 +4990,7 @@
                         </a:spcAft>
                       </a:pPr>
                       <a:r>
-                        <a:rPr sz="1700" b="0">
+                        <a:rPr sz="1400" b="0">
                           <a:solidFill>
                             <a:srgbClr val="1F2233"/>
                           </a:solidFill>
@@ -4825,7 +5020,7 @@
                         </a:spcAft>
                       </a:pPr>
                       <a:r>
-                        <a:rPr sz="1700" b="0">
+                        <a:rPr sz="1400" b="0">
                           <a:solidFill>
                             <a:srgbClr val="1F2233"/>
                           </a:solidFill>
@@ -4855,7 +5050,7 @@
                         </a:spcAft>
                       </a:pPr>
                       <a:r>
-                        <a:rPr sz="1700" b="0">
+                        <a:rPr sz="1400" b="0">
                           <a:solidFill>
                             <a:srgbClr val="1F2233"/>
                           </a:solidFill>
@@ -4885,7 +5080,7 @@
                         </a:spcAft>
                       </a:pPr>
                       <a:r>
-                        <a:rPr sz="1700" b="0">
+                        <a:rPr sz="1400" b="0">
                           <a:solidFill>
                             <a:srgbClr val="1F2233"/>
                           </a:solidFill>
@@ -4915,7 +5110,7 @@
                         </a:spcAft>
                       </a:pPr>
                       <a:r>
-                        <a:rPr sz="1700" b="0">
+                        <a:rPr sz="1400" b="0">
                           <a:solidFill>
                             <a:srgbClr val="1F2233"/>
                           </a:solidFill>
@@ -4932,7 +5127,7 @@
                   </a:tcPr>
                 </a:tc>
               </a:tr>
-              <a:tr h="385581">
+              <a:tr h="331514">
                 <a:tc>
                   <a:txBody>
                     <a:bodyPr wrap="square"/>
@@ -4947,7 +5142,7 @@
                         </a:spcAft>
                       </a:pPr>
                       <a:r>
-                        <a:rPr sz="1700" b="0">
+                        <a:rPr sz="1400" b="0">
                           <a:solidFill>
                             <a:srgbClr val="1F2233"/>
                           </a:solidFill>
@@ -4977,7 +5172,7 @@
                         </a:spcAft>
                       </a:pPr>
                       <a:r>
-                        <a:rPr sz="1700" b="0">
+                        <a:rPr sz="1400" b="0">
                           <a:solidFill>
                             <a:srgbClr val="1F2233"/>
                           </a:solidFill>
@@ -5007,7 +5202,7 @@
                         </a:spcAft>
                       </a:pPr>
                       <a:r>
-                        <a:rPr sz="1700" b="0">
+                        <a:rPr sz="1400" b="0">
                           <a:solidFill>
                             <a:srgbClr val="1F2233"/>
                           </a:solidFill>
@@ -5037,7 +5232,7 @@
                         </a:spcAft>
                       </a:pPr>
                       <a:r>
-                        <a:rPr sz="1700" b="0">
+                        <a:rPr sz="1400" b="0">
                           <a:solidFill>
                             <a:srgbClr val="1F2233"/>
                           </a:solidFill>
@@ -5067,7 +5262,7 @@
                         </a:spcAft>
                       </a:pPr>
                       <a:r>
-                        <a:rPr sz="1700" b="0">
+                        <a:rPr sz="1400" b="0">
                           <a:solidFill>
                             <a:srgbClr val="1F2233"/>
                           </a:solidFill>
@@ -5097,7 +5292,7 @@
                         </a:spcAft>
                       </a:pPr>
                       <a:r>
-                        <a:rPr sz="1700" b="0">
+                        <a:rPr sz="1400" b="0">
                           <a:solidFill>
                             <a:srgbClr val="1F2233"/>
                           </a:solidFill>
@@ -5127,7 +5322,7 @@
                         </a:spcAft>
                       </a:pPr>
                       <a:r>
-                        <a:rPr sz="1700" b="0">
+                        <a:rPr sz="1400" b="0">
                           <a:solidFill>
                             <a:srgbClr val="1F2233"/>
                           </a:solidFill>
@@ -5157,7 +5352,7 @@
                         </a:spcAft>
                       </a:pPr>
                       <a:r>
-                        <a:rPr sz="1700" b="0">
+                        <a:rPr sz="1400" b="0">
                           <a:solidFill>
                             <a:srgbClr val="1F2233"/>
                           </a:solidFill>
@@ -5187,7 +5382,7 @@
                         </a:spcAft>
                       </a:pPr>
                       <a:r>
-                        <a:rPr sz="1700" b="0">
+                        <a:rPr sz="1400" b="0">
                           <a:solidFill>
                             <a:srgbClr val="1F2233"/>
                           </a:solidFill>
@@ -5217,7 +5412,7 @@
                         </a:spcAft>
                       </a:pPr>
                       <a:r>
-                        <a:rPr sz="1700" b="0">
+                        <a:rPr sz="1400" b="0">
                           <a:solidFill>
                             <a:srgbClr val="1F2233"/>
                           </a:solidFill>
@@ -5247,7 +5442,7 @@
                         </a:spcAft>
                       </a:pPr>
                       <a:r>
-                        <a:rPr sz="1700" b="0">
+                        <a:rPr sz="1400" b="0">
                           <a:solidFill>
                             <a:srgbClr val="1F2233"/>
                           </a:solidFill>
@@ -5277,7 +5472,7 @@
                         </a:spcAft>
                       </a:pPr>
                       <a:r>
-                        <a:rPr sz="1700" b="0">
+                        <a:rPr sz="1400" b="0">
                           <a:solidFill>
                             <a:srgbClr val="1F2233"/>
                           </a:solidFill>
@@ -5294,7 +5489,7 @@
                   </a:tcPr>
                 </a:tc>
               </a:tr>
-              <a:tr h="385581">
+              <a:tr h="331514">
                 <a:tc>
                   <a:txBody>
                     <a:bodyPr wrap="square"/>
@@ -5309,7 +5504,7 @@
                         </a:spcAft>
                       </a:pPr>
                       <a:r>
-                        <a:rPr sz="1700" b="1">
+                        <a:rPr sz="1400" b="1">
                           <a:solidFill>
                             <a:srgbClr val="1F2233"/>
                           </a:solidFill>
@@ -5339,7 +5534,7 @@
                         </a:spcAft>
                       </a:pPr>
                       <a:r>
-                        <a:rPr sz="1700" b="1">
+                        <a:rPr sz="1400" b="1">
                           <a:solidFill>
                             <a:srgbClr val="1F2233"/>
                           </a:solidFill>
@@ -5369,7 +5564,7 @@
                         </a:spcAft>
                       </a:pPr>
                       <a:r>
-                        <a:rPr sz="1700" b="1">
+                        <a:rPr sz="1400" b="1">
                           <a:solidFill>
                             <a:srgbClr val="1F2233"/>
                           </a:solidFill>
@@ -5399,7 +5594,7 @@
                         </a:spcAft>
                       </a:pPr>
                       <a:r>
-                        <a:rPr sz="1700" b="1">
+                        <a:rPr sz="1400" b="1">
                           <a:solidFill>
                             <a:srgbClr val="1F2233"/>
                           </a:solidFill>
@@ -5429,7 +5624,7 @@
                         </a:spcAft>
                       </a:pPr>
                       <a:r>
-                        <a:rPr sz="1700" b="1">
+                        <a:rPr sz="1400" b="1">
                           <a:solidFill>
                             <a:srgbClr val="1F2233"/>
                           </a:solidFill>
@@ -5459,7 +5654,7 @@
                         </a:spcAft>
                       </a:pPr>
                       <a:r>
-                        <a:rPr sz="1700" b="1">
+                        <a:rPr sz="1400" b="1">
                           <a:solidFill>
                             <a:srgbClr val="1F2233"/>
                           </a:solidFill>
@@ -5489,7 +5684,7 @@
                         </a:spcAft>
                       </a:pPr>
                       <a:r>
-                        <a:rPr sz="1700" b="1">
+                        <a:rPr sz="1400" b="1">
                           <a:solidFill>
                             <a:srgbClr val="1F2233"/>
                           </a:solidFill>
@@ -5519,7 +5714,7 @@
                         </a:spcAft>
                       </a:pPr>
                       <a:r>
-                        <a:rPr sz="1700" b="1">
+                        <a:rPr sz="1400" b="1">
                           <a:solidFill>
                             <a:srgbClr val="1F2233"/>
                           </a:solidFill>
@@ -5549,7 +5744,7 @@
                         </a:spcAft>
                       </a:pPr>
                       <a:r>
-                        <a:rPr sz="1700" b="1">
+                        <a:rPr sz="1400" b="1">
                           <a:solidFill>
                             <a:srgbClr val="1F2233"/>
                           </a:solidFill>
@@ -5579,7 +5774,7 @@
                         </a:spcAft>
                       </a:pPr>
                       <a:r>
-                        <a:rPr sz="1700" b="1">
+                        <a:rPr sz="1400" b="1">
                           <a:solidFill>
                             <a:srgbClr val="1F2233"/>
                           </a:solidFill>
@@ -5609,7 +5804,7 @@
                         </a:spcAft>
                       </a:pPr>
                       <a:r>
-                        <a:rPr sz="1700" b="1">
+                        <a:rPr sz="1400" b="1">
                           <a:solidFill>
                             <a:srgbClr val="1F2233"/>
                           </a:solidFill>
@@ -5639,7 +5834,7 @@
                         </a:spcAft>
                       </a:pPr>
                       <a:r>
-                        <a:rPr sz="1700" b="1">
+                        <a:rPr sz="1400" b="1">
                           <a:solidFill>
                             <a:srgbClr val="1F2233"/>
                           </a:solidFill>
@@ -5662,14 +5857,14 @@
       </p:graphicFrame>
       <p:sp>
         <p:nvSpPr>
-          <p:cNvPr id="48" name="TextBox 47"/>
+          <p:cNvPr id="49" name="TextBox 48"/>
           <p:cNvSpPr txBox="1"/>
           <p:nvPr/>
         </p:nvSpPr>
         <p:spPr>
           <a:xfrm>
-            <a:off x="2628000" y="33475773"/>
-            <a:ext cx="11988000" cy="612762"/>
+            <a:off x="2628000" y="34981656"/>
+            <a:ext cx="11988000" cy="504628"/>
           </a:xfrm>
           <a:prstGeom prst="rect">
             <a:avLst/>
@@ -5689,7 +5884,7 @@
               </a:spcAft>
             </a:pPr>
             <a:r>
-              <a:rPr sz="1700" b="1">
+              <a:rPr sz="1400" b="1">
                 <a:solidFill>
                   <a:srgbClr val="434B9A"/>
                 </a:solidFill>
@@ -5698,7 +5893,7 @@
               <a:t>Три класса</a:t>
             </a:r>
             <a:r>
-              <a:rPr sz="1700" b="0">
+              <a:rPr sz="1400" b="0">
                 <a:solidFill>
                   <a:srgbClr val="1F2233"/>
                 </a:solidFill>
@@ -5711,15 +5906,15 @@
       </p:sp>
       <p:graphicFrame>
         <p:nvGraphicFramePr>
-          <p:cNvPr id="49" name="Table 48"/>
+          <p:cNvPr id="50" name="Table 49"/>
           <p:cNvGraphicFramePr>
             <a:graphicFrameLocks noGrp="1"/>
           </p:cNvGraphicFramePr>
           <p:nvPr/>
         </p:nvGraphicFramePr>
         <p:xfrm>
-          <a:off x="2628000" y="34196536"/>
-          <a:ext cx="11987995" cy="2972914"/>
+          <a:off x="2628000" y="35594285"/>
+          <a:ext cx="11987995" cy="2540377"/>
         </p:xfrm>
         <a:graphic>
           <a:graphicData uri="http://schemas.openxmlformats.org/drawingml/2006/table">
@@ -5728,19 +5923,19 @@
                 <a:tableStyleId>{5C22544A-7EE6-4342-B048-85BDC9FD1C3A}</a:tableStyleId>
               </a:tblPr>
               <a:tblGrid>
-                <a:gridCol w="2147461"/>
-                <a:gridCol w="1115629"/>
-                <a:gridCol w="1115629"/>
-                <a:gridCol w="1062762"/>
-                <a:gridCol w="822816"/>
-                <a:gridCol w="834376"/>
-                <a:gridCol w="822816"/>
-                <a:gridCol w="1115629"/>
-                <a:gridCol w="1115629"/>
-                <a:gridCol w="1062762"/>
-                <a:gridCol w="772486"/>
+                <a:gridCol w="2558951"/>
+                <a:gridCol w="1043366"/>
+                <a:gridCol w="1043366"/>
+                <a:gridCol w="1001072"/>
+                <a:gridCol w="823721"/>
+                <a:gridCol w="823721"/>
+                <a:gridCol w="823721"/>
+                <a:gridCol w="1043366"/>
+                <a:gridCol w="1043366"/>
+                <a:gridCol w="1001072"/>
+                <a:gridCol w="782273"/>
               </a:tblGrid>
-              <a:tr h="360336">
+              <a:tr h="306269">
                 <a:tc>
                   <a:txBody>
                     <a:bodyPr wrap="square"/>
@@ -5767,7 +5962,7 @@
                         </a:spcAft>
                       </a:pPr>
                       <a:r>
-                        <a:rPr sz="1500" b="1">
+                        <a:rPr sz="1200" b="1">
                           <a:solidFill>
                             <a:srgbClr val="FFFFFF"/>
                           </a:solidFill>
@@ -5837,7 +6032,7 @@
                         </a:spcAft>
                       </a:pPr>
                       <a:r>
-                        <a:rPr sz="1500" b="1">
+                        <a:rPr sz="1200" b="1">
                           <a:solidFill>
                             <a:srgbClr val="FFFFFF"/>
                           </a:solidFill>
@@ -5878,7 +6073,7 @@
                   <a:tcPr/>
                 </a:tc>
               </a:tr>
-              <a:tr h="684673">
+              <a:tr h="576538">
                 <a:tc>
                   <a:txBody>
                     <a:bodyPr wrap="square"/>
@@ -5893,7 +6088,7 @@
                         </a:spcAft>
                       </a:pPr>
                       <a:r>
-                        <a:rPr sz="1500" b="1">
+                        <a:rPr sz="1200" b="1">
                           <a:solidFill>
                             <a:srgbClr val="FFFFFF"/>
                           </a:solidFill>
@@ -5912,7 +6107,7 @@
                         </a:spcAft>
                       </a:pPr>
                       <a:r>
-                        <a:rPr sz="1500" b="1">
+                        <a:rPr sz="1200" b="1">
                           <a:solidFill>
                             <a:srgbClr val="FFFFFF"/>
                           </a:solidFill>
@@ -5942,7 +6137,7 @@
                         </a:spcAft>
                       </a:pPr>
                       <a:r>
-                        <a:rPr sz="1500" b="1">
+                        <a:rPr sz="1200" b="1">
                           <a:solidFill>
                             <a:srgbClr val="FFFFFF"/>
                           </a:solidFill>
@@ -5961,7 +6156,7 @@
                         </a:spcAft>
                       </a:pPr>
                       <a:r>
-                        <a:rPr sz="1500" b="1">
+                        <a:rPr sz="1200" b="1">
                           <a:solidFill>
                             <a:srgbClr val="FFFFFF"/>
                           </a:solidFill>
@@ -5991,7 +6186,7 @@
                         </a:spcAft>
                       </a:pPr>
                       <a:r>
-                        <a:rPr sz="1500" b="1">
+                        <a:rPr sz="1200" b="1">
                           <a:solidFill>
                             <a:srgbClr val="FFFFFF"/>
                           </a:solidFill>
@@ -6010,7 +6205,7 @@
                         </a:spcAft>
                       </a:pPr>
                       <a:r>
-                        <a:rPr sz="1500" b="1">
+                        <a:rPr sz="1200" b="1">
                           <a:solidFill>
                             <a:srgbClr val="FFFFFF"/>
                           </a:solidFill>
@@ -6040,7 +6235,7 @@
                         </a:spcAft>
                       </a:pPr>
                       <a:r>
-                        <a:rPr sz="1500" b="1">
+                        <a:rPr sz="1200" b="1">
                           <a:solidFill>
                             <a:srgbClr val="FFFFFF"/>
                           </a:solidFill>
@@ -6059,7 +6254,7 @@
                         </a:spcAft>
                       </a:pPr>
                       <a:r>
-                        <a:rPr sz="1500" b="1">
+                        <a:rPr sz="1200" b="1">
                           <a:solidFill>
                             <a:srgbClr val="FFFFFF"/>
                           </a:solidFill>
@@ -6089,7 +6284,7 @@
                         </a:spcAft>
                       </a:pPr>
                       <a:r>
-                        <a:rPr sz="1500" b="1">
+                        <a:rPr sz="1200" b="1">
                           <a:solidFill>
                             <a:srgbClr val="FFFFFF"/>
                           </a:solidFill>
@@ -6108,7 +6303,7 @@
                         </a:spcAft>
                       </a:pPr>
                       <a:r>
-                        <a:rPr sz="1500" b="1">
+                        <a:rPr sz="1200" b="1">
                           <a:solidFill>
                             <a:srgbClr val="FFFFFF"/>
                           </a:solidFill>
@@ -6138,7 +6333,7 @@
                         </a:spcAft>
                       </a:pPr>
                       <a:r>
-                        <a:rPr sz="1500" b="1">
+                        <a:rPr sz="1200" b="1">
                           <a:solidFill>
                             <a:srgbClr val="FFFFFF"/>
                           </a:solidFill>
@@ -6157,7 +6352,7 @@
                         </a:spcAft>
                       </a:pPr>
                       <a:r>
-                        <a:rPr sz="1500" b="1">
+                        <a:rPr sz="1200" b="1">
                           <a:solidFill>
                             <a:srgbClr val="FFFFFF"/>
                           </a:solidFill>
@@ -6187,7 +6382,7 @@
                         </a:spcAft>
                       </a:pPr>
                       <a:r>
-                        <a:rPr sz="1500" b="1">
+                        <a:rPr sz="1200" b="1">
                           <a:solidFill>
                             <a:srgbClr val="FFFFFF"/>
                           </a:solidFill>
@@ -6206,7 +6401,7 @@
                         </a:spcAft>
                       </a:pPr>
                       <a:r>
-                        <a:rPr sz="1500" b="1">
+                        <a:rPr sz="1200" b="1">
                           <a:solidFill>
                             <a:srgbClr val="FFFFFF"/>
                           </a:solidFill>
@@ -6236,7 +6431,7 @@
                         </a:spcAft>
                       </a:pPr>
                       <a:r>
-                        <a:rPr sz="1500" b="1">
+                        <a:rPr sz="1200" b="1">
                           <a:solidFill>
                             <a:srgbClr val="FFFFFF"/>
                           </a:solidFill>
@@ -6255,7 +6450,7 @@
                         </a:spcAft>
                       </a:pPr>
                       <a:r>
-                        <a:rPr sz="1500" b="1">
+                        <a:rPr sz="1200" b="1">
                           <a:solidFill>
                             <a:srgbClr val="FFFFFF"/>
                           </a:solidFill>
@@ -6285,7 +6480,7 @@
                         </a:spcAft>
                       </a:pPr>
                       <a:r>
-                        <a:rPr sz="1500" b="1">
+                        <a:rPr sz="1200" b="1">
                           <a:solidFill>
                             <a:srgbClr val="FFFFFF"/>
                           </a:solidFill>
@@ -6304,7 +6499,7 @@
                         </a:spcAft>
                       </a:pPr>
                       <a:r>
-                        <a:rPr sz="1500" b="1">
+                        <a:rPr sz="1200" b="1">
                           <a:solidFill>
                             <a:srgbClr val="FFFFFF"/>
                           </a:solidFill>
@@ -6334,7 +6529,7 @@
                         </a:spcAft>
                       </a:pPr>
                       <a:r>
-                        <a:rPr sz="1500" b="1">
+                        <a:rPr sz="1200" b="1">
                           <a:solidFill>
                             <a:srgbClr val="FFFFFF"/>
                           </a:solidFill>
@@ -6353,7 +6548,7 @@
                         </a:spcAft>
                       </a:pPr>
                       <a:r>
-                        <a:rPr sz="1500" b="1">
+                        <a:rPr sz="1200" b="1">
                           <a:solidFill>
                             <a:srgbClr val="FFFFFF"/>
                           </a:solidFill>
@@ -6383,7 +6578,7 @@
                         </a:spcAft>
                       </a:pPr>
                       <a:r>
-                        <a:rPr sz="1500" b="1">
+                        <a:rPr sz="1200" b="1">
                           <a:solidFill>
                             <a:srgbClr val="FFFFFF"/>
                           </a:solidFill>
@@ -6402,7 +6597,7 @@
                         </a:spcAft>
                       </a:pPr>
                       <a:r>
-                        <a:rPr sz="1500" b="1">
+                        <a:rPr sz="1200" b="1">
                           <a:solidFill>
                             <a:srgbClr val="FFFFFF"/>
                           </a:solidFill>
@@ -6419,7 +6614,7 @@
                   </a:tcPr>
                 </a:tc>
               </a:tr>
-              <a:tr h="385581">
+              <a:tr h="331514">
                 <a:tc>
                   <a:txBody>
                     <a:bodyPr wrap="square"/>
@@ -6434,7 +6629,7 @@
                         </a:spcAft>
                       </a:pPr>
                       <a:r>
-                        <a:rPr sz="1700" b="0">
+                        <a:rPr sz="1400" b="0">
                           <a:solidFill>
                             <a:srgbClr val="1F2233"/>
                           </a:solidFill>
@@ -6464,7 +6659,7 @@
                         </a:spcAft>
                       </a:pPr>
                       <a:r>
-                        <a:rPr sz="1700" b="0">
+                        <a:rPr sz="1400" b="0">
                           <a:solidFill>
                             <a:srgbClr val="1F2233"/>
                           </a:solidFill>
@@ -6494,7 +6689,7 @@
                         </a:spcAft>
                       </a:pPr>
                       <a:r>
-                        <a:rPr sz="1700" b="0">
+                        <a:rPr sz="1400" b="0">
                           <a:solidFill>
                             <a:srgbClr val="1F2233"/>
                           </a:solidFill>
@@ -6524,7 +6719,7 @@
                         </a:spcAft>
                       </a:pPr>
                       <a:r>
-                        <a:rPr sz="1700" b="0">
+                        <a:rPr sz="1400" b="0">
                           <a:solidFill>
                             <a:srgbClr val="1F2233"/>
                           </a:solidFill>
@@ -6554,7 +6749,7 @@
                         </a:spcAft>
                       </a:pPr>
                       <a:r>
-                        <a:rPr sz="1700" b="0">
+                        <a:rPr sz="1400" b="0">
                           <a:solidFill>
                             <a:srgbClr val="1F2233"/>
                           </a:solidFill>
@@ -6584,7 +6779,7 @@
                         </a:spcAft>
                       </a:pPr>
                       <a:r>
-                        <a:rPr sz="1700" b="0">
+                        <a:rPr sz="1400" b="0">
                           <a:solidFill>
                             <a:srgbClr val="1F2233"/>
                           </a:solidFill>
@@ -6614,7 +6809,7 @@
                         </a:spcAft>
                       </a:pPr>
                       <a:r>
-                        <a:rPr sz="1700" b="0">
+                        <a:rPr sz="1400" b="0">
                           <a:solidFill>
                             <a:srgbClr val="1F2233"/>
                           </a:solidFill>
@@ -6644,7 +6839,7 @@
                         </a:spcAft>
                       </a:pPr>
                       <a:r>
-                        <a:rPr sz="1700" b="0">
+                        <a:rPr sz="1400" b="0">
                           <a:solidFill>
                             <a:srgbClr val="1F2233"/>
                           </a:solidFill>
@@ -6674,7 +6869,7 @@
                         </a:spcAft>
                       </a:pPr>
                       <a:r>
-                        <a:rPr sz="1700" b="0">
+                        <a:rPr sz="1400" b="0">
                           <a:solidFill>
                             <a:srgbClr val="1F2233"/>
                           </a:solidFill>
@@ -6704,7 +6899,7 @@
                         </a:spcAft>
                       </a:pPr>
                       <a:r>
-                        <a:rPr sz="1700" b="0">
+                        <a:rPr sz="1400" b="0">
                           <a:solidFill>
                             <a:srgbClr val="1F2233"/>
                           </a:solidFill>
@@ -6734,7 +6929,7 @@
                         </a:spcAft>
                       </a:pPr>
                       <a:r>
-                        <a:rPr sz="1700" b="0">
+                        <a:rPr sz="1400" b="0">
                           <a:solidFill>
                             <a:srgbClr val="1F2233"/>
                           </a:solidFill>
@@ -6751,7 +6946,7 @@
                   </a:tcPr>
                 </a:tc>
               </a:tr>
-              <a:tr h="385581">
+              <a:tr h="331514">
                 <a:tc>
                   <a:txBody>
                     <a:bodyPr wrap="square"/>
@@ -6766,7 +6961,7 @@
                         </a:spcAft>
                       </a:pPr>
                       <a:r>
-                        <a:rPr sz="1700" b="0">
+                        <a:rPr sz="1400" b="0">
                           <a:solidFill>
                             <a:srgbClr val="1F2233"/>
                           </a:solidFill>
@@ -6796,7 +6991,7 @@
                         </a:spcAft>
                       </a:pPr>
                       <a:r>
-                        <a:rPr sz="1700" b="0">
+                        <a:rPr sz="1400" b="0">
                           <a:solidFill>
                             <a:srgbClr val="1F2233"/>
                           </a:solidFill>
@@ -6826,7 +7021,7 @@
                         </a:spcAft>
                       </a:pPr>
                       <a:r>
-                        <a:rPr sz="1700" b="0">
+                        <a:rPr sz="1400" b="0">
                           <a:solidFill>
                             <a:srgbClr val="1F2233"/>
                           </a:solidFill>
@@ -6856,7 +7051,7 @@
                         </a:spcAft>
                       </a:pPr>
                       <a:r>
-                        <a:rPr sz="1700" b="0">
+                        <a:rPr sz="1400" b="0">
                           <a:solidFill>
                             <a:srgbClr val="1F2233"/>
                           </a:solidFill>
@@ -6886,7 +7081,7 @@
                         </a:spcAft>
                       </a:pPr>
                       <a:r>
-                        <a:rPr sz="1700" b="0">
+                        <a:rPr sz="1400" b="0">
                           <a:solidFill>
                             <a:srgbClr val="1F2233"/>
                           </a:solidFill>
@@ -6916,7 +7111,7 @@
                         </a:spcAft>
                       </a:pPr>
                       <a:r>
-                        <a:rPr sz="1700" b="0">
+                        <a:rPr sz="1400" b="0">
                           <a:solidFill>
                             <a:srgbClr val="1F2233"/>
                           </a:solidFill>
@@ -6946,7 +7141,7 @@
                         </a:spcAft>
                       </a:pPr>
                       <a:r>
-                        <a:rPr sz="1700" b="0">
+                        <a:rPr sz="1400" b="0">
                           <a:solidFill>
                             <a:srgbClr val="1F2233"/>
                           </a:solidFill>
@@ -6976,7 +7171,7 @@
                         </a:spcAft>
                       </a:pPr>
                       <a:r>
-                        <a:rPr sz="1700" b="0">
+                        <a:rPr sz="1400" b="0">
                           <a:solidFill>
                             <a:srgbClr val="1F2233"/>
                           </a:solidFill>
@@ -7006,7 +7201,7 @@
                         </a:spcAft>
                       </a:pPr>
                       <a:r>
-                        <a:rPr sz="1700" b="0">
+                        <a:rPr sz="1400" b="0">
                           <a:solidFill>
                             <a:srgbClr val="1F2233"/>
                           </a:solidFill>
@@ -7036,7 +7231,7 @@
                         </a:spcAft>
                       </a:pPr>
                       <a:r>
-                        <a:rPr sz="1700" b="0">
+                        <a:rPr sz="1400" b="0">
                           <a:solidFill>
                             <a:srgbClr val="1F2233"/>
                           </a:solidFill>
@@ -7066,7 +7261,7 @@
                         </a:spcAft>
                       </a:pPr>
                       <a:r>
-                        <a:rPr sz="1700" b="0">
+                        <a:rPr sz="1400" b="0">
                           <a:solidFill>
                             <a:srgbClr val="1F2233"/>
                           </a:solidFill>
@@ -7083,7 +7278,7 @@
                   </a:tcPr>
                 </a:tc>
               </a:tr>
-              <a:tr h="385581">
+              <a:tr h="331514">
                 <a:tc>
                   <a:txBody>
                     <a:bodyPr wrap="square"/>
@@ -7098,7 +7293,7 @@
                         </a:spcAft>
                       </a:pPr>
                       <a:r>
-                        <a:rPr sz="1700" b="0">
+                        <a:rPr sz="1400" b="0">
                           <a:solidFill>
                             <a:srgbClr val="1F2233"/>
                           </a:solidFill>
@@ -7128,7 +7323,7 @@
                         </a:spcAft>
                       </a:pPr>
                       <a:r>
-                        <a:rPr sz="1700" b="0">
+                        <a:rPr sz="1400" b="0">
                           <a:solidFill>
                             <a:srgbClr val="1F2233"/>
                           </a:solidFill>
@@ -7158,7 +7353,7 @@
                         </a:spcAft>
                       </a:pPr>
                       <a:r>
-                        <a:rPr sz="1700" b="0">
+                        <a:rPr sz="1400" b="0">
                           <a:solidFill>
                             <a:srgbClr val="1F2233"/>
                           </a:solidFill>
@@ -7188,7 +7383,7 @@
                         </a:spcAft>
                       </a:pPr>
                       <a:r>
-                        <a:rPr sz="1700" b="0">
+                        <a:rPr sz="1400" b="0">
                           <a:solidFill>
                             <a:srgbClr val="1F2233"/>
                           </a:solidFill>
@@ -7218,7 +7413,7 @@
                         </a:spcAft>
                       </a:pPr>
                       <a:r>
-                        <a:rPr sz="1700" b="0">
+                        <a:rPr sz="1400" b="0">
                           <a:solidFill>
                             <a:srgbClr val="1F2233"/>
                           </a:solidFill>
@@ -7248,7 +7443,7 @@
                         </a:spcAft>
                       </a:pPr>
                       <a:r>
-                        <a:rPr sz="1700" b="0">
+                        <a:rPr sz="1400" b="0">
                           <a:solidFill>
                             <a:srgbClr val="1F2233"/>
                           </a:solidFill>
@@ -7278,7 +7473,7 @@
                         </a:spcAft>
                       </a:pPr>
                       <a:r>
-                        <a:rPr sz="1700" b="0">
+                        <a:rPr sz="1400" b="0">
                           <a:solidFill>
                             <a:srgbClr val="1F2233"/>
                           </a:solidFill>
@@ -7308,7 +7503,7 @@
                         </a:spcAft>
                       </a:pPr>
                       <a:r>
-                        <a:rPr sz="1700" b="0">
+                        <a:rPr sz="1400" b="0">
                           <a:solidFill>
                             <a:srgbClr val="1F2233"/>
                           </a:solidFill>
@@ -7338,7 +7533,7 @@
                         </a:spcAft>
                       </a:pPr>
                       <a:r>
-                        <a:rPr sz="1700" b="0">
+                        <a:rPr sz="1400" b="0">
                           <a:solidFill>
                             <a:srgbClr val="1F2233"/>
                           </a:solidFill>
@@ -7368,7 +7563,7 @@
                         </a:spcAft>
                       </a:pPr>
                       <a:r>
-                        <a:rPr sz="1700" b="0">
+                        <a:rPr sz="1400" b="0">
                           <a:solidFill>
                             <a:srgbClr val="1F2233"/>
                           </a:solidFill>
@@ -7398,7 +7593,7 @@
                         </a:spcAft>
                       </a:pPr>
                       <a:r>
-                        <a:rPr sz="1700" b="0">
+                        <a:rPr sz="1400" b="0">
                           <a:solidFill>
                             <a:srgbClr val="1F2233"/>
                           </a:solidFill>
@@ -7415,7 +7610,7 @@
                   </a:tcPr>
                 </a:tc>
               </a:tr>
-              <a:tr h="385581">
+              <a:tr h="331514">
                 <a:tc>
                   <a:txBody>
                     <a:bodyPr wrap="square"/>
@@ -7430,7 +7625,7 @@
                         </a:spcAft>
                       </a:pPr>
                       <a:r>
-                        <a:rPr sz="1700" b="0">
+                        <a:rPr sz="1400" b="0">
                           <a:solidFill>
                             <a:srgbClr val="1F2233"/>
                           </a:solidFill>
@@ -7460,7 +7655,7 @@
                         </a:spcAft>
                       </a:pPr>
                       <a:r>
-                        <a:rPr sz="1700" b="0">
+                        <a:rPr sz="1400" b="0">
                           <a:solidFill>
                             <a:srgbClr val="1F2233"/>
                           </a:solidFill>
@@ -7490,7 +7685,7 @@
                         </a:spcAft>
                       </a:pPr>
                       <a:r>
-                        <a:rPr sz="1700" b="0">
+                        <a:rPr sz="1400" b="0">
                           <a:solidFill>
                             <a:srgbClr val="1F2233"/>
                           </a:solidFill>
@@ -7520,7 +7715,7 @@
                         </a:spcAft>
                       </a:pPr>
                       <a:r>
-                        <a:rPr sz="1700" b="0">
+                        <a:rPr sz="1400" b="0">
                           <a:solidFill>
                             <a:srgbClr val="1F2233"/>
                           </a:solidFill>
@@ -7550,7 +7745,7 @@
                         </a:spcAft>
                       </a:pPr>
                       <a:r>
-                        <a:rPr sz="1700" b="0">
+                        <a:rPr sz="1400" b="0">
                           <a:solidFill>
                             <a:srgbClr val="1F2233"/>
                           </a:solidFill>
@@ -7580,7 +7775,7 @@
                         </a:spcAft>
                       </a:pPr>
                       <a:r>
-                        <a:rPr sz="1700" b="0">
+                        <a:rPr sz="1400" b="0">
                           <a:solidFill>
                             <a:srgbClr val="1F2233"/>
                           </a:solidFill>
@@ -7610,7 +7805,7 @@
                         </a:spcAft>
                       </a:pPr>
                       <a:r>
-                        <a:rPr sz="1700" b="0">
+                        <a:rPr sz="1400" b="0">
                           <a:solidFill>
                             <a:srgbClr val="1F2233"/>
                           </a:solidFill>
@@ -7640,7 +7835,7 @@
                         </a:spcAft>
                       </a:pPr>
                       <a:r>
-                        <a:rPr sz="1700" b="0">
+                        <a:rPr sz="1400" b="0">
                           <a:solidFill>
                             <a:srgbClr val="1F2233"/>
                           </a:solidFill>
@@ -7670,7 +7865,7 @@
                         </a:spcAft>
                       </a:pPr>
                       <a:r>
-                        <a:rPr sz="1700" b="0">
+                        <a:rPr sz="1400" b="0">
                           <a:solidFill>
                             <a:srgbClr val="1F2233"/>
                           </a:solidFill>
@@ -7700,7 +7895,7 @@
                         </a:spcAft>
                       </a:pPr>
                       <a:r>
-                        <a:rPr sz="1700" b="0">
+                        <a:rPr sz="1400" b="0">
                           <a:solidFill>
                             <a:srgbClr val="1F2233"/>
                           </a:solidFill>
@@ -7730,7 +7925,7 @@
                         </a:spcAft>
                       </a:pPr>
                       <a:r>
-                        <a:rPr sz="1700" b="0">
+                        <a:rPr sz="1400" b="0">
                           <a:solidFill>
                             <a:srgbClr val="1F2233"/>
                           </a:solidFill>
@@ -7747,7 +7942,7 @@
                   </a:tcPr>
                 </a:tc>
               </a:tr>
-              <a:tr h="385581">
+              <a:tr h="331514">
                 <a:tc>
                   <a:txBody>
                     <a:bodyPr wrap="square"/>
@@ -7762,7 +7957,7 @@
                         </a:spcAft>
                       </a:pPr>
                       <a:r>
-                        <a:rPr sz="1700" b="1">
+                        <a:rPr sz="1400" b="1">
                           <a:solidFill>
                             <a:srgbClr val="1F2233"/>
                           </a:solidFill>
@@ -7792,7 +7987,7 @@
                         </a:spcAft>
                       </a:pPr>
                       <a:r>
-                        <a:rPr sz="1700" b="1">
+                        <a:rPr sz="1400" b="1">
                           <a:solidFill>
                             <a:srgbClr val="1F2233"/>
                           </a:solidFill>
@@ -7822,7 +8017,7 @@
                         </a:spcAft>
                       </a:pPr>
                       <a:r>
-                        <a:rPr sz="1700" b="1">
+                        <a:rPr sz="1400" b="1">
                           <a:solidFill>
                             <a:srgbClr val="1F2233"/>
                           </a:solidFill>
@@ -7852,7 +8047,7 @@
                         </a:spcAft>
                       </a:pPr>
                       <a:r>
-                        <a:rPr sz="1700" b="1">
+                        <a:rPr sz="1400" b="1">
                           <a:solidFill>
                             <a:srgbClr val="1F2233"/>
                           </a:solidFill>
@@ -7882,7 +8077,7 @@
                         </a:spcAft>
                       </a:pPr>
                       <a:r>
-                        <a:rPr sz="1700" b="1">
+                        <a:rPr sz="1400" b="1">
                           <a:solidFill>
                             <a:srgbClr val="1F2233"/>
                           </a:solidFill>
@@ -7912,7 +8107,7 @@
                         </a:spcAft>
                       </a:pPr>
                       <a:r>
-                        <a:rPr sz="1700" b="1">
+                        <a:rPr sz="1400" b="1">
                           <a:solidFill>
                             <a:srgbClr val="1F2233"/>
                           </a:solidFill>
@@ -7942,7 +8137,7 @@
                         </a:spcAft>
                       </a:pPr>
                       <a:r>
-                        <a:rPr sz="1700" b="1">
+                        <a:rPr sz="1400" b="1">
                           <a:solidFill>
                             <a:srgbClr val="1F2233"/>
                           </a:solidFill>
@@ -7972,7 +8167,7 @@
                         </a:spcAft>
                       </a:pPr>
                       <a:r>
-                        <a:rPr sz="1700" b="1">
+                        <a:rPr sz="1400" b="1">
                           <a:solidFill>
                             <a:srgbClr val="1F2233"/>
                           </a:solidFill>
@@ -8002,7 +8197,7 @@
                         </a:spcAft>
                       </a:pPr>
                       <a:r>
-                        <a:rPr sz="1700" b="1">
+                        <a:rPr sz="1400" b="1">
                           <a:solidFill>
                             <a:srgbClr val="1F2233"/>
                           </a:solidFill>
@@ -8032,7 +8227,7 @@
                         </a:spcAft>
                       </a:pPr>
                       <a:r>
-                        <a:rPr sz="1700" b="1">
+                        <a:rPr sz="1400" b="1">
                           <a:solidFill>
                             <a:srgbClr val="1F2233"/>
                           </a:solidFill>
@@ -8062,7 +8257,7 @@
                         </a:spcAft>
                       </a:pPr>
                       <a:r>
-                        <a:rPr sz="1700" b="1">
+                        <a:rPr sz="1400" b="1">
                           <a:solidFill>
                             <a:srgbClr val="1F2233"/>
                           </a:solidFill>
@@ -8085,14 +8280,14 @@
       </p:graphicFrame>
       <p:sp>
         <p:nvSpPr>
-          <p:cNvPr id="50" name="TextBox 49"/>
+          <p:cNvPr id="51" name="TextBox 50"/>
           <p:cNvSpPr txBox="1"/>
           <p:nvPr/>
         </p:nvSpPr>
         <p:spPr>
           <a:xfrm>
-            <a:off x="2628000" y="37277453"/>
-            <a:ext cx="11988000" cy="2429092"/>
+            <a:off x="2628000" y="38242663"/>
+            <a:ext cx="11988000" cy="1708194"/>
           </a:xfrm>
           <a:prstGeom prst="rect">
             <a:avLst/>
@@ -8117,22 +8312,22 @@
               <a:buChar char="•"/>
             </a:pPr>
             <a:r>
-              <a:rPr sz="2000" b="1">
+              <a:rPr sz="1600" b="1">
                 <a:solidFill>
                   <a:srgbClr val="434B9A"/>
                 </a:solidFill>
                 <a:latin typeface="Inter"/>
               </a:rPr>
-              <a:t>AUC и доли стадий совпали со статьёй</a:t>
-            </a:r>
-            <a:r>
-              <a:rPr sz="2000" b="0">
+              <a:t>Совпало:</a:t>
+            </a:r>
+            <a:r>
+              <a:rPr sz="1600" b="0">
                 <a:solidFill>
                   <a:srgbClr val="1F2233"/>
                 </a:solidFill>
                 <a:latin typeface="Inter"/>
               </a:rPr>
-              <a:t> (±0.01–0.02); CatBoost лучший, но отрыв в тысячных: качество упирается в признаки</a:t>
+              <a:t> AUC, accuracy и доли найденных стадий — в пределах 0.01–0.03 от статьи при другой схеме проверки. CatBoost лучший по большинству метрик, но отрыв в тысячных: качество упирается в признаки</a:t>
             </a:r>
           </a:p>
           <a:p>
@@ -8150,7 +8345,7 @@
               <a:buChar char="•"/>
             </a:pPr>
             <a:r>
-              <a:rPr sz="2000" b="1">
+              <a:rPr sz="1600" b="1">
                 <a:solidFill>
                   <a:srgbClr val="434B9A"/>
                 </a:solidFill>
@@ -8159,13 +8354,13 @@
               <a:t>Accuracy обманчива:</a:t>
             </a:r>
             <a:r>
-              <a:rPr sz="2000" b="0">
+              <a:rPr sz="1600" b="0">
                 <a:solidFill>
                   <a:srgbClr val="1F2233"/>
                 </a:solidFill>
                 <a:latin typeface="Inter"/>
               </a:rPr>
-              <a:t> «всегда сон» даёт 0.916 &gt; 0.88 у моделей (бодрствование — 8.4% эпох)</a:t>
+              <a:t> бодрствование — 8.4% эпох, и «всегда сон» даёт 0.916 &gt; 0.88 у всех моделей</a:t>
             </a:r>
           </a:p>
           <a:p>
@@ -8183,45 +8378,36 @@
               <a:buChar char="•"/>
             </a:pPr>
             <a:r>
-              <a:rPr sz="2000" b="0">
+              <a:rPr sz="1600" b="1">
+                <a:solidFill>
+                  <a:srgbClr val="434B9A"/>
+                </a:solidFill>
+                <a:latin typeface="Inter"/>
+              </a:rPr>
+              <a:t>Слабость:</a:t>
+            </a:r>
+            <a:r>
+              <a:rPr sz="1600" b="0">
                 <a:solidFill>
                   <a:srgbClr val="1F2233"/>
                 </a:solidFill>
                 <a:latin typeface="Inter"/>
               </a:rPr>
-              <a:t>Верна лишь </a:t>
-            </a:r>
-            <a:r>
-              <a:rPr sz="2000" b="1">
-                <a:solidFill>
-                  <a:srgbClr val="434B9A"/>
-                </a:solidFill>
-                <a:latin typeface="Inter"/>
-              </a:rPr>
-              <a:t>каждая третья</a:t>
-            </a:r>
-            <a:r>
-              <a:rPr sz="2000" b="0">
-                <a:solidFill>
-                  <a:srgbClr val="1F2233"/>
-                </a:solidFill>
-                <a:latin typeface="Inter"/>
-              </a:rPr>
-              <a:t> метка «бодрствование» (PPV 0.36–0.39); REM — самый трудный класс (F1 ≈ 0.5)</a:t>
+              <a:t> найдено ≈ 2/3 бодрствования, но верна лишь каждая третья метка «бодрствование» (PPV 0.36–0.39): тихое бодрствование без движения не видно. REM — самый трудный (F1 ≈ 0.5)</a:t>
             </a:r>
           </a:p>
         </p:txBody>
       </p:sp>
       <p:sp>
         <p:nvSpPr>
-          <p:cNvPr id="51" name="Rounded Rectangle 50"/>
+          <p:cNvPr id="52" name="Rounded Rectangle 51"/>
           <p:cNvSpPr/>
           <p:nvPr/>
         </p:nvSpPr>
         <p:spPr>
           <a:xfrm>
-            <a:off x="15408000" y="10656000"/>
-            <a:ext cx="12492000" cy="9324718"/>
+            <a:off x="15408000" y="10404000"/>
+            <a:ext cx="12492000" cy="10125355"/>
           </a:xfrm>
           <a:prstGeom prst="roundRect">
             <a:avLst>
@@ -8262,14 +8448,14 @@
       </p:sp>
       <p:sp>
         <p:nvSpPr>
-          <p:cNvPr id="52" name="TextBox 51"/>
+          <p:cNvPr id="53" name="TextBox 52"/>
           <p:cNvSpPr txBox="1"/>
           <p:nvPr/>
         </p:nvSpPr>
         <p:spPr>
           <a:xfrm>
-            <a:off x="15660000" y="10908000"/>
-            <a:ext cx="11988000" cy="576717"/>
+            <a:off x="15660000" y="10656000"/>
+            <a:ext cx="11988000" cy="504628"/>
           </a:xfrm>
           <a:prstGeom prst="rect">
             <a:avLst/>
@@ -8289,7 +8475,7 @@
               </a:spcAft>
             </a:pPr>
             <a:r>
-              <a:rPr sz="3200" b="1">
+              <a:rPr sz="2800" b="1">
                 <a:solidFill>
                   <a:srgbClr val="434B9A"/>
                 </a:solidFill>
@@ -8302,13 +8488,13 @@
       </p:sp>
       <p:sp>
         <p:nvSpPr>
-          <p:cNvPr id="53" name="Rectangle 52"/>
+          <p:cNvPr id="54" name="Rectangle 53"/>
           <p:cNvSpPr/>
           <p:nvPr/>
         </p:nvSpPr>
         <p:spPr>
           <a:xfrm>
-            <a:off x="15660000" y="11520717"/>
+            <a:off x="15660000" y="11196628"/>
             <a:ext cx="2160000" cy="43200"/>
           </a:xfrm>
           <a:prstGeom prst="rect">
@@ -8345,7 +8531,7 @@
       </p:sp>
       <p:pic>
         <p:nvPicPr>
-          <p:cNvPr id="54" name="Picture 53" descr="formula_shapley.png"/>
+          <p:cNvPr id="55" name="Picture 54" descr="formula_shapley.png"/>
           <p:cNvPicPr>
             <a:picLocks noChangeAspect="1"/>
           </p:cNvPicPr>
@@ -8359,8 +8545,8 @@
         </p:blipFill>
         <p:spPr>
           <a:xfrm>
-            <a:off x="18476136" y="11646717"/>
-            <a:ext cx="6355726" cy="864000"/>
+            <a:off x="19005780" y="11322628"/>
+            <a:ext cx="5296438" cy="720000"/>
           </a:xfrm>
           <a:prstGeom prst="rect">
             <a:avLst/>
@@ -8369,14 +8555,14 @@
       </p:pic>
       <p:sp>
         <p:nvSpPr>
-          <p:cNvPr id="55" name="TextBox 54"/>
+          <p:cNvPr id="56" name="TextBox 55"/>
           <p:cNvSpPr txBox="1"/>
           <p:nvPr/>
         </p:nvSpPr>
         <p:spPr>
           <a:xfrm>
-            <a:off x="15660000" y="12618717"/>
-            <a:ext cx="11988000" cy="2789540"/>
+            <a:off x="15660000" y="12150628"/>
+            <a:ext cx="11988000" cy="3517548"/>
           </a:xfrm>
           <a:prstGeom prst="rect">
             <a:avLst/>
@@ -8401,13 +8587,22 @@
               <a:buChar char="•"/>
             </a:pPr>
             <a:r>
-              <a:rPr sz="2000" b="0">
+              <a:rPr sz="1600" b="1">
+                <a:solidFill>
+                  <a:srgbClr val="434B9A"/>
+                </a:solidFill>
+                <a:latin typeface="Inter"/>
+              </a:rPr>
+              <a:t>Идея:</a:t>
+            </a:r>
+            <a:r>
+              <a:rPr sz="1600" b="0">
                 <a:solidFill>
                   <a:srgbClr val="1F2233"/>
                 </a:solidFill>
                 <a:latin typeface="Inter"/>
               </a:rPr>
-              <a:t>Модель переобучается на всех 7 непустых подмножествах {motion, hr, clock}; вклад признака — средний прирост метрики по всем порядкам добавления (сумма вкладов = качество полной модели − случайной)</a:t>
+              <a:t> признаки — «игроки», качество модели — «выигрыш». Модель переобучается на всех 7 непустых подмножествах {motion, hr, clock}; вклад признака φᵢ — его средний прирост метрики по всем порядкам добавления. Отсчёт — от случайной модели (AUC 0.5), сумма вкладов = качество полной модели − 0.5</a:t>
             </a:r>
           </a:p>
           <a:p>
@@ -8425,58 +8620,22 @@
               <a:buChar char="•"/>
             </a:pPr>
             <a:r>
-              <a:rPr sz="2000" b="1">
+              <a:rPr sz="1600" b="1">
                 <a:solidFill>
                   <a:srgbClr val="434B9A"/>
                 </a:solidFill>
                 <a:latin typeface="Inter"/>
               </a:rPr>
-              <a:t>motion — около половины</a:t>
-            </a:r>
-            <a:r>
-              <a:rPr sz="2000" b="0">
+              <a:t>Почему не просто «качество одного признака»:</a:t>
+            </a:r>
+            <a:r>
+              <a:rPr sz="1600" b="0">
                 <a:solidFill>
                   <a:srgbClr val="1F2233"/>
                 </a:solidFill>
                 <a:latin typeface="Inter"/>
               </a:rPr>
-              <a:t> прироста, </a:t>
-            </a:r>
-            <a:r>
-              <a:rPr sz="2000" b="1">
-                <a:solidFill>
-                  <a:srgbClr val="434B9A"/>
-                </a:solidFill>
-                <a:latin typeface="Inter"/>
-              </a:rPr>
-              <a:t>clock — четверть–треть</a:t>
-            </a:r>
-            <a:r>
-              <a:rPr sz="2000" b="0">
-                <a:solidFill>
-                  <a:srgbClr val="1F2233"/>
-                </a:solidFill>
-                <a:latin typeface="Inter"/>
-              </a:rPr>
-              <a:t>, </a:t>
-            </a:r>
-            <a:r>
-              <a:rPr sz="2000" b="1">
-                <a:solidFill>
-                  <a:srgbClr val="434B9A"/>
-                </a:solidFill>
-                <a:latin typeface="Inter"/>
-              </a:rPr>
-              <a:t>hr — меньше всех</a:t>
-            </a:r>
-            <a:r>
-              <a:rPr sz="2000" b="0">
-                <a:solidFill>
-                  <a:srgbClr val="1F2233"/>
-                </a:solidFill>
-                <a:latin typeface="Inter"/>
-              </a:rPr>
-              <a:t> (для поиска бодрствования — 12–18%): одинаково у всех пяти моделей</a:t>
+              <a:t> признаки частично дублируют друг друга (при движении растёт и пульс). Motion, добавленный первым, даёт +0.29 AUC, а последним — лишь +0.05. Шепли делит общую информацию поровну</a:t>
             </a:r>
           </a:p>
           <a:p>
@@ -8494,29 +8653,62 @@
               <a:buChar char="•"/>
             </a:pPr>
             <a:r>
-              <a:rPr sz="2000" b="1">
+              <a:rPr sz="1600" b="1">
                 <a:solidFill>
                   <a:srgbClr val="434B9A"/>
                 </a:solidFill>
                 <a:latin typeface="Inter"/>
               </a:rPr>
-              <a:t>SHAP по эпохам:</a:t>
-            </a:r>
-            <a:r>
-              <a:rPr sz="2000" b="0">
+              <a:t>Результат:</a:t>
+            </a:r>
+            <a:r>
+              <a:rPr sz="1600" b="0">
                 <a:solidFill>
                   <a:srgbClr val="1F2233"/>
                 </a:solidFill>
                 <a:latin typeface="Inter"/>
               </a:rPr>
-              <a:t> покой → сон, движение → бодрствование, начало ночи → бодрствование, ровный пульс → чуть к сну</a:t>
+              <a:t> motion — около половины прироста, clock — четверть–треть, hr — меньше всех; картина одинакова у всех пяти моделей. Для поиска бодрствования (AP wake) доля пульса падает до 12%: он помогает упорядочить эпохи в целом, но почти не помогает точно находить бодрствование</a:t>
+            </a:r>
+          </a:p>
+          <a:p>
+            <a:pPr algn="l" marL="270000" indent="-270000">
+              <a:lnSpc>
+                <a:spcPct val="110000"/>
+              </a:lnSpc>
+              <a:spcAft>
+                <a:spcPts val="623"/>
+              </a:spcAft>
+              <a:buClr>
+                <a:srgbClr val="434B9A"/>
+              </a:buClr>
+              <a:buFont typeface="Arial"/>
+              <a:buChar char="•"/>
+            </a:pPr>
+            <a:r>
+              <a:rPr sz="1600" b="1">
+                <a:solidFill>
+                  <a:srgbClr val="434B9A"/>
+                </a:solidFill>
+                <a:latin typeface="Inter"/>
+              </a:rPr>
+              <a:t>SHAP по эпохам</a:t>
+            </a:r>
+            <a:r>
+              <a:rPr sz="1600" b="0">
+                <a:solidFill>
+                  <a:srgbClr val="1F2233"/>
+                </a:solidFill>
+                <a:latin typeface="Inter"/>
+              </a:rPr>
+              <a:t> (вклад признака в P(сон) конкретной эпохи): покой → сон, движение → бодрствование, начало ночи → бодрствование, ровный пульс → немного к сну</a:t>
             </a:r>
           </a:p>
         </p:txBody>
       </p:sp>
       <p:pic>
         <p:nvPicPr>
-          <p:cNvPr id="56" name="Picture 55" descr="shapley_poster.png"/>
+          <p:cNvPr id="57" name="Picture 56" descr="shapley_poster.png"/>
           <p:cNvPicPr>
             <a:picLocks noChangeAspect="1"/>
           </p:cNvPicPr>
@@ -8530,8 +8722,8 @@
         </p:blipFill>
         <p:spPr>
           <a:xfrm>
-            <a:off x="16379280" y="15408258"/>
-            <a:ext cx="10549440" cy="3918363"/>
+            <a:off x="16499160" y="15668176"/>
+            <a:ext cx="10309680" cy="3829309"/>
           </a:xfrm>
           <a:prstGeom prst="rect">
             <a:avLst/>
@@ -8540,14 +8732,14 @@
       </p:pic>
       <p:sp>
         <p:nvSpPr>
-          <p:cNvPr id="57" name="Rounded Rectangle 56"/>
+          <p:cNvPr id="58" name="Rounded Rectangle 57"/>
           <p:cNvSpPr/>
           <p:nvPr/>
         </p:nvSpPr>
         <p:spPr>
           <a:xfrm>
-            <a:off x="15408000" y="20286718"/>
-            <a:ext cx="12492000" cy="14889727"/>
+            <a:off x="15408000" y="20781355"/>
+            <a:ext cx="12492000" cy="14936033"/>
           </a:xfrm>
           <a:prstGeom prst="roundRect">
             <a:avLst>
@@ -8588,14 +8780,14 @@
       </p:sp>
       <p:sp>
         <p:nvSpPr>
-          <p:cNvPr id="58" name="TextBox 57"/>
+          <p:cNvPr id="59" name="TextBox 58"/>
           <p:cNvSpPr txBox="1"/>
           <p:nvPr/>
         </p:nvSpPr>
         <p:spPr>
           <a:xfrm>
-            <a:off x="15660000" y="20538718"/>
-            <a:ext cx="11988000" cy="576717"/>
+            <a:off x="15660000" y="21033355"/>
+            <a:ext cx="11988000" cy="504628"/>
           </a:xfrm>
           <a:prstGeom prst="rect">
             <a:avLst/>
@@ -8615,7 +8807,7 @@
               </a:spcAft>
             </a:pPr>
             <a:r>
-              <a:rPr sz="3200" b="1">
+              <a:rPr sz="2800" b="1">
                 <a:solidFill>
                   <a:srgbClr val="434B9A"/>
                 </a:solidFill>
@@ -8628,13 +8820,13 @@
       </p:sp>
       <p:sp>
         <p:nvSpPr>
-          <p:cNvPr id="59" name="Rectangle 58"/>
+          <p:cNvPr id="60" name="Rectangle 59"/>
           <p:cNvSpPr/>
           <p:nvPr/>
         </p:nvSpPr>
         <p:spPr>
           <a:xfrm>
-            <a:off x="15660000" y="21151436"/>
+            <a:off x="15660000" y="21573984"/>
             <a:ext cx="2160000" cy="43200"/>
           </a:xfrm>
           <a:prstGeom prst="rect">
@@ -8671,14 +8863,14 @@
       </p:sp>
       <p:sp>
         <p:nvSpPr>
-          <p:cNvPr id="60" name="TextBox 59"/>
+          <p:cNvPr id="61" name="TextBox 60"/>
           <p:cNvSpPr txBox="1"/>
           <p:nvPr/>
         </p:nvSpPr>
         <p:spPr>
           <a:xfrm>
-            <a:off x="15660000" y="21277436"/>
-            <a:ext cx="11988000" cy="1081346"/>
+            <a:off x="15660000" y="21699984"/>
+            <a:ext cx="11988000" cy="865076"/>
           </a:xfrm>
           <a:prstGeom prst="rect">
             <a:avLst/>
@@ -8698,20 +8890,20 @@
               </a:spcAft>
             </a:pPr>
             <a:r>
-              <a:rPr sz="2000" b="0">
+              <a:rPr sz="1600" b="0">
                 <a:solidFill>
                   <a:srgbClr val="1F2233"/>
                 </a:solidFill>
                 <a:latin typeface="Inter"/>
               </a:rPr>
-              <a:t>Эксперимент команды: MLP (15, 15, 15), порог P(сон) ≥ 0.5, признаки motion, hr и время ночи. Добавили 3 «быстрых» признака по 5-секундным отрезкам: m — корень из суммы дисперсий ускорения по осям, τ = 0.02 g, окно W = [t − 15, t + 45) с</a:t>
+              <a:t>Эксперимент команды: нейросеть MLP (15, 15, 15), порог P(сон) ≥ 0.5, признаки motion, hr и время ночи. Добавили 3 «быстрых» признака, которые считаются по 5-секундным отрезкам: m — корень из суммы дисперсий ускорения по трём осям, τ = 0.02 g, минутное окно W = [t − 15, t + 45) с</a:t>
             </a:r>
           </a:p>
         </p:txBody>
       </p:sp>
       <p:pic>
         <p:nvPicPr>
-          <p:cNvPr id="61" name="Picture 60" descr="formula_fpeak.png"/>
+          <p:cNvPr id="62" name="Picture 61" descr="formula_fpeak.png"/>
           <p:cNvPicPr>
             <a:picLocks noChangeAspect="1"/>
           </p:cNvPicPr>
@@ -8725,8 +8917,8 @@
         </p:blipFill>
         <p:spPr>
           <a:xfrm>
-            <a:off x="15660000" y="22466782"/>
-            <a:ext cx="3417262" cy="779180"/>
+            <a:off x="16266976" y="22673060"/>
+            <a:ext cx="2999828" cy="684000"/>
           </a:xfrm>
           <a:prstGeom prst="rect">
             <a:avLst/>
@@ -8735,7 +8927,7 @@
       </p:pic>
       <p:pic>
         <p:nvPicPr>
-          <p:cNvPr id="62" name="Picture 61" descr="formula_factive.png"/>
+          <p:cNvPr id="63" name="Picture 62" descr="formula_factive.png"/>
           <p:cNvPicPr>
             <a:picLocks noChangeAspect="1"/>
           </p:cNvPicPr>
@@ -8749,8 +8941,8 @@
         </p:blipFill>
         <p:spPr>
           <a:xfrm>
-            <a:off x="19754810" y="22466782"/>
-            <a:ext cx="4912133" cy="779180"/>
+            <a:off x="19986804" y="22673060"/>
+            <a:ext cx="4312095" cy="684000"/>
           </a:xfrm>
           <a:prstGeom prst="rect">
             <a:avLst/>
@@ -8759,7 +8951,7 @@
       </p:pic>
       <p:pic>
         <p:nvPicPr>
-          <p:cNvPr id="63" name="Picture 62" descr="formula_fhr.png"/>
+          <p:cNvPr id="64" name="Picture 63" descr="formula_fhr.png"/>
           <p:cNvPicPr>
             <a:picLocks noChangeAspect="1"/>
           </p:cNvPicPr>
@@ -8773,8 +8965,8 @@
         </p:blipFill>
         <p:spPr>
           <a:xfrm>
-            <a:off x="25344492" y="22466782"/>
-            <a:ext cx="2303507" cy="779180"/>
+            <a:off x="25018899" y="22673060"/>
+            <a:ext cx="2022124" cy="684000"/>
           </a:xfrm>
           <a:prstGeom prst="rect">
             <a:avLst/>
@@ -8783,14 +8975,14 @@
       </p:pic>
       <p:sp>
         <p:nvSpPr>
-          <p:cNvPr id="64" name="TextBox 63"/>
+          <p:cNvPr id="65" name="TextBox 64"/>
           <p:cNvSpPr txBox="1"/>
           <p:nvPr/>
         </p:nvSpPr>
         <p:spPr>
           <a:xfrm>
-            <a:off x="15660000" y="23353962"/>
-            <a:ext cx="11988000" cy="1347746"/>
+            <a:off x="15660000" y="23465060"/>
+            <a:ext cx="11988000" cy="1708194"/>
           </a:xfrm>
           <a:prstGeom prst="rect">
             <a:avLst/>
@@ -8815,7 +9007,7 @@
               <a:buChar char="•"/>
             </a:pPr>
             <a:r>
-              <a:rPr sz="2000" b="1">
+              <a:rPr sz="1600" b="1">
                 <a:solidFill>
                   <a:srgbClr val="434B9A"/>
                 </a:solidFill>
@@ -8824,13 +9016,13 @@
               <a:t>f_peak</a:t>
             </a:r>
             <a:r>
-              <a:rPr sz="2000" b="0">
+              <a:rPr sz="1600" b="0">
                 <a:solidFill>
                   <a:srgbClr val="1F2233"/>
                 </a:solidFill>
                 <a:latin typeface="Inter"/>
               </a:rPr>
-              <a:t> — самый сильный короткий всплеск движения в эпохе (логарифм гасит выбросы)</a:t>
+              <a:t> — самый сильный короткий всплеск движения в эпохе; логарифм гасит редкие очень большие значения (при max m = 0.04 g получаем ln 3 ≈ 1.1)</a:t>
             </a:r>
           </a:p>
           <a:p>
@@ -8848,7 +9040,7 @@
               <a:buChar char="•"/>
             </a:pPr>
             <a:r>
-              <a:rPr sz="2000" b="1">
+              <a:rPr sz="1600" b="1">
                 <a:solidFill>
                   <a:srgbClr val="434B9A"/>
                 </a:solidFill>
@@ -8857,13 +9049,13 @@
               <a:t>f_active</a:t>
             </a:r>
             <a:r>
-              <a:rPr sz="2000" b="0">
+              <a:rPr sz="1600" b="0">
                 <a:solidFill>
                   <a:srgbClr val="1F2233"/>
                 </a:solidFill>
                 <a:latin typeface="Inter"/>
               </a:rPr>
-              <a:t> — как часто двигались в течение минуты: доля 5-секундных отрезков с m ≥ τ</a:t>
+              <a:t> — как часто двигались в течение минуты: доля 5-секундных отрезков с m ≥ τ (от 0 до 1)</a:t>
             </a:r>
           </a:p>
           <a:p>
@@ -8881,7 +9073,7 @@
               <a:buChar char="•"/>
             </a:pPr>
             <a:r>
-              <a:rPr sz="2000" b="1">
+              <a:rPr sz="1600" b="1">
                 <a:solidFill>
                   <a:srgbClr val="434B9A"/>
                 </a:solidFill>
@@ -8890,20 +9082,20 @@
               <a:t>f_HR</a:t>
             </a:r>
             <a:r>
-              <a:rPr sz="2000" b="0">
+              <a:rPr sz="1600" b="0">
                 <a:solidFill>
                   <a:srgbClr val="1F2233"/>
                 </a:solidFill>
                 <a:latin typeface="Inter"/>
               </a:rPr>
-              <a:t> — пульс за минуту относительно медианы записи: +0.1 — на 10% выше обычного</a:t>
+              <a:t> — средний пульс за минуту относительно медианы всей записи: +0.1 — на 10% выше обычного для этого человека, −0.05 — на 5% ниже</a:t>
             </a:r>
           </a:p>
         </p:txBody>
       </p:sp>
       <p:pic>
         <p:nvPicPr>
-          <p:cNvPr id="65" name="Picture 64" descr="experiments.png"/>
+          <p:cNvPr id="66" name="Picture 65" descr="experiments.png"/>
           <p:cNvPicPr>
             <a:picLocks noChangeAspect="1"/>
           </p:cNvPicPr>
@@ -8917,32 +9109,8 @@
         </p:blipFill>
         <p:spPr>
           <a:xfrm>
-            <a:off x="16738920" y="24701708"/>
-            <a:ext cx="9830160" cy="3667416"/>
-          </a:xfrm>
-          <a:prstGeom prst="rect">
-            <a:avLst/>
-          </a:prstGeom>
-        </p:spPr>
-      </p:pic>
-      <p:pic>
-        <p:nvPicPr>
-          <p:cNvPr id="66" name="Picture 65" descr="shap_fast_right.png"/>
-          <p:cNvPicPr>
-            <a:picLocks noChangeAspect="1"/>
-          </p:cNvPicPr>
-          <p:nvPr/>
-        </p:nvPicPr>
-        <p:blipFill>
-          <a:blip r:embed="rId16"/>
-          <a:stretch>
-            <a:fillRect/>
-          </a:stretch>
-        </p:blipFill>
-        <p:spPr>
-          <a:xfrm>
-            <a:off x="15660000" y="28477125"/>
-            <a:ext cx="5415120" cy="4928079"/>
+            <a:off x="17218440" y="25173255"/>
+            <a:ext cx="8871120" cy="3309620"/>
           </a:xfrm>
           <a:prstGeom prst="rect">
             <a:avLst/>
@@ -8957,8 +9125,8 @@
         </p:nvSpPr>
         <p:spPr>
           <a:xfrm>
-            <a:off x="15660000" y="33495205"/>
-            <a:ext cx="5415120" cy="306381"/>
+            <a:off x="15660000" y="28572875"/>
+            <a:ext cx="11988000" cy="252314"/>
           </a:xfrm>
           <a:prstGeom prst="rect">
             <a:avLst/>
@@ -8978,7 +9146,71 @@
               </a:spcAft>
             </a:pPr>
             <a:r>
-              <a:rPr sz="1700" b="0">
+              <a:rPr sz="1400" b="0">
+                <a:solidFill>
+                  <a:srgbClr val="5B6075"/>
+                </a:solidFill>
+                <a:latin typeface="Inter"/>
+              </a:rPr>
+              <a:t>Все варианты, которые пробовала команда: точка правее пунктира — лучше исходной модели</a:t>
+            </a:r>
+          </a:p>
+        </p:txBody>
+      </p:sp>
+      <p:pic>
+        <p:nvPicPr>
+          <p:cNvPr id="68" name="Picture 67" descr="shap_fast_right.png"/>
+          <p:cNvPicPr>
+            <a:picLocks noChangeAspect="1"/>
+          </p:cNvPicPr>
+          <p:nvPr/>
+        </p:nvPicPr>
+        <p:blipFill>
+          <a:blip r:embed="rId16"/>
+          <a:stretch>
+            <a:fillRect/>
+          </a:stretch>
+        </p:blipFill>
+        <p:spPr>
+          <a:xfrm>
+            <a:off x="15660000" y="28933189"/>
+            <a:ext cx="5179680" cy="4713815"/>
+          </a:xfrm>
+          <a:prstGeom prst="rect">
+            <a:avLst/>
+          </a:prstGeom>
+        </p:spPr>
+      </p:pic>
+      <p:sp>
+        <p:nvSpPr>
+          <p:cNvPr id="69" name="TextBox 68"/>
+          <p:cNvSpPr txBox="1"/>
+          <p:nvPr/>
+        </p:nvSpPr>
+        <p:spPr>
+          <a:xfrm>
+            <a:off x="15660000" y="33737005"/>
+            <a:ext cx="5179680" cy="252314"/>
+          </a:xfrm>
+          <a:prstGeom prst="rect">
+            <a:avLst/>
+          </a:prstGeom>
+          <a:noFill/>
+        </p:spPr>
+        <p:txBody>
+          <a:bodyPr wrap="square" lIns="0" rIns="0" tIns="0" bIns="0" anchor="t"/>
+          <a:lstStyle/>
+          <a:p>
+            <a:pPr algn="ctr">
+              <a:lnSpc>
+                <a:spcPct val="110000"/>
+              </a:lnSpc>
+              <a:spcAft>
+                <a:spcPts val="0"/>
+              </a:spcAft>
+            </a:pPr>
+            <a:r>
+              <a:rPr sz="1400" b="0">
                 <a:solidFill>
                   <a:srgbClr val="5B6075"/>
                 </a:solidFill>
@@ -8991,14 +9223,14 @@
       </p:sp>
       <p:sp>
         <p:nvSpPr>
-          <p:cNvPr id="68" name="TextBox 67"/>
+          <p:cNvPr id="70" name="TextBox 69"/>
           <p:cNvSpPr txBox="1"/>
           <p:nvPr/>
         </p:nvSpPr>
         <p:spPr>
           <a:xfrm>
-            <a:off x="21291120" y="28677639"/>
-            <a:ext cx="6356880" cy="5031433"/>
+            <a:off x="21055680" y="28933189"/>
+            <a:ext cx="6592320" cy="5247702"/>
           </a:xfrm>
           <a:prstGeom prst="rect">
             <a:avLst/>
@@ -9023,22 +9255,22 @@
               <a:buChar char="•"/>
             </a:pPr>
             <a:r>
-              <a:rPr sz="2000" b="1">
+              <a:rPr sz="1600" b="1">
                 <a:solidFill>
                   <a:srgbClr val="434B9A"/>
                 </a:solidFill>
                 <a:latin typeface="Inter"/>
               </a:rPr>
-              <a:t>Лучше всего — исходные + 3 быстрых признака:</a:t>
-            </a:r>
-            <a:r>
-              <a:rPr sz="2000" b="0">
+              <a:t>Лучше всего — исходные признаки + 3 быстрых:</a:t>
+            </a:r>
+            <a:r>
+              <a:rPr sz="1600" b="0">
                 <a:solidFill>
                   <a:srgbClr val="1F2233"/>
                 </a:solidFill>
                 <a:latin typeface="Inter"/>
               </a:rPr>
-              <a:t> κ 0.496 → 0.534, AUC 0.908 → 0.917</a:t>
+              <a:t> κ 0.496 → 0.534, AUC 0.908 → 0.917. Быстрые признаки ловят короткие движения и учащение пульса, которые сглаженный motion «размазывает» по 10 минутам</a:t>
             </a:r>
           </a:p>
           <a:p>
@@ -9056,13 +9288,40 @@
               <a:buChar char="•"/>
             </a:pPr>
             <a:r>
-              <a:rPr sz="2000" b="0">
+              <a:rPr sz="1600" b="1">
+                <a:solidFill>
+                  <a:srgbClr val="434B9A"/>
+                </a:solidFill>
+                <a:latin typeface="Inter"/>
+              </a:rPr>
+              <a:t>Помогают</a:t>
+            </a:r>
+            <a:r>
+              <a:rPr sz="1600" b="0">
                 <a:solidFill>
                   <a:srgbClr val="1F2233"/>
                 </a:solidFill>
                 <a:latin typeface="Inter"/>
               </a:rPr>
-              <a:t>Помогают соседние эпохи и окно; повтор примеров бодрствования и признаки без сглаживания — нет</a:t>
+              <a:t> соседние эпохи и статистики короткого окна: сон «липкий», контекст соседних минут подсказывает стадию. </a:t>
+            </a:r>
+            <a:r>
+              <a:rPr sz="1600" b="1">
+                <a:solidFill>
+                  <a:srgbClr val="434B9A"/>
+                </a:solidFill>
+                <a:latin typeface="Inter"/>
+              </a:rPr>
+              <a:t>Не помогают</a:t>
+            </a:r>
+            <a:r>
+              <a:rPr sz="1600" b="0">
+                <a:solidFill>
+                  <a:srgbClr val="1F2233"/>
+                </a:solidFill>
+                <a:latin typeface="Inter"/>
+              </a:rPr>
+              <a:t> повтор примеров бодрствования (модель переобучается на редких примерах, AUC падает) и разности соседних эпох без сглаживания (слишком шумные)</a:t>
             </a:r>
           </a:p>
           <a:p>
@@ -9080,22 +9339,22 @@
               <a:buChar char="•"/>
             </a:pPr>
             <a:r>
-              <a:rPr sz="2000" b="1">
+              <a:rPr sz="1600" b="1">
                 <a:solidFill>
                   <a:srgbClr val="434B9A"/>
                 </a:solidFill>
                 <a:latin typeface="Inter"/>
               </a:rPr>
-              <a:t>SHAP:</a:t>
-            </a:r>
-            <a:r>
-              <a:rPr sz="2000" b="0">
+              <a:t>SHAP расширенной модели:</a:t>
+            </a:r>
+            <a:r>
+              <a:rPr sz="1600" b="0">
                 <a:solidFill>
                   <a:srgbClr val="1F2233"/>
                 </a:solidFill>
                 <a:latin typeface="Inter"/>
               </a:rPr>
-              <a:t> «доля движения за минуту» (|SHAP| 0.024) работает почти как motion (0.034), пик движения и относительный пульс — слабее (0.009 и 0.005); время ночи остаётся самым сильным признаком (0.049)</a:t>
+              <a:t> доля движения за минуту (|SHAP| 0.024) работает почти как motion (0.034); пик движения и относительный пульс слабее (0.009 и 0.005); время ночи остаётся самым сильным признаком (0.049)</a:t>
             </a:r>
           </a:p>
           <a:p>
@@ -9113,27 +9372,36 @@
               <a:buChar char="•"/>
             </a:pPr>
             <a:r>
-              <a:rPr sz="2000" b="0">
+              <a:rPr sz="1600" b="1">
+                <a:solidFill>
+                  <a:srgbClr val="434B9A"/>
+                </a:solidFill>
+                <a:latin typeface="Inter"/>
+              </a:rPr>
+              <a:t>Ограничение:</a:t>
+            </a:r>
+            <a:r>
+              <a:rPr sz="1600" b="0">
                 <a:solidFill>
                   <a:srgbClr val="1F2233"/>
                 </a:solidFill>
                 <a:latin typeface="Inter"/>
               </a:rPr>
-              <a:t>Окно заглядывает на 15 с вперёд, медиана пульса — по всей записи: это анализ готовой записи, а не онлайн-предсказание</a:t>
+              <a:t> окно заглядывает на 15 с вперёд, а медиана пульса берётся по всей записи — это анализ готовой записи, а не предсказание в реальном времени</a:t>
             </a:r>
           </a:p>
         </p:txBody>
       </p:sp>
       <p:sp>
         <p:nvSpPr>
-          <p:cNvPr id="69" name="TextBox 68"/>
+          <p:cNvPr id="71" name="TextBox 70"/>
           <p:cNvSpPr txBox="1"/>
           <p:nvPr/>
         </p:nvSpPr>
         <p:spPr>
           <a:xfrm>
-            <a:off x="15660000" y="33909586"/>
-            <a:ext cx="11988000" cy="612762"/>
+            <a:off x="15660000" y="34180892"/>
+            <a:ext cx="11988000" cy="504628"/>
           </a:xfrm>
           <a:prstGeom prst="rect">
             <a:avLst/>
@@ -9153,7 +9421,7 @@
               </a:spcAft>
             </a:pPr>
             <a:r>
-              <a:rPr sz="1700" b="0">
+              <a:rPr sz="1400" b="0">
                 <a:solidFill>
                   <a:srgbClr val="1F2233"/>
                 </a:solidFill>
@@ -9162,7 +9430,7 @@
               <a:t>Те же признаки добавлены к </a:t>
             </a:r>
             <a:r>
-              <a:rPr sz="1700" b="1">
+              <a:rPr sz="1400" b="1">
                 <a:solidFill>
                   <a:srgbClr val="434B9A"/>
                 </a:solidFill>
@@ -9171,27 +9439,27 @@
               <a:t>CatBoost</a:t>
             </a:r>
             <a:r>
-              <a:rPr sz="1700" b="0">
+              <a:rPr sz="1400" b="0">
                 <a:solidFill>
                   <a:srgbClr val="1F2233"/>
                 </a:solidFill>
                 <a:latin typeface="Inter"/>
               </a:rPr>
-              <a:t> и нейросети в общей постановке проекта (motion, hr, clock; LOSO): python repro/10_fast_features.py — после запуска таблица появится здесь</a:t>
+              <a:t> и нейросети в общей постановке проекта (motion, hr, clock; leave-one-subject-out): python repro/10_fast_features.py — после запуска таблица появится здесь</a:t>
             </a:r>
           </a:p>
         </p:txBody>
       </p:sp>
       <p:sp>
         <p:nvSpPr>
-          <p:cNvPr id="70" name="Rounded Rectangle 69"/>
+          <p:cNvPr id="72" name="Rounded Rectangle 71"/>
           <p:cNvSpPr/>
           <p:nvPr/>
         </p:nvSpPr>
         <p:spPr>
           <a:xfrm>
-            <a:off x="15408000" y="35482445"/>
-            <a:ext cx="12492000" cy="4405554"/>
+            <a:off x="15408000" y="35969389"/>
+            <a:ext cx="12492000" cy="4206610"/>
           </a:xfrm>
           <a:prstGeom prst="roundRect">
             <a:avLst>
@@ -9232,14 +9500,14 @@
       </p:sp>
       <p:sp>
         <p:nvSpPr>
-          <p:cNvPr id="71" name="TextBox 70"/>
+          <p:cNvPr id="73" name="TextBox 72"/>
           <p:cNvSpPr txBox="1"/>
           <p:nvPr/>
         </p:nvSpPr>
         <p:spPr>
           <a:xfrm>
-            <a:off x="15660000" y="35734445"/>
-            <a:ext cx="11988000" cy="576717"/>
+            <a:off x="15660000" y="36221389"/>
+            <a:ext cx="11988000" cy="504628"/>
           </a:xfrm>
           <a:prstGeom prst="rect">
             <a:avLst/>
@@ -9259,7 +9527,7 @@
               </a:spcAft>
             </a:pPr>
             <a:r>
-              <a:rPr sz="3200" b="1">
+              <a:rPr sz="2800" b="1">
                 <a:solidFill>
                   <a:srgbClr val="434B9A"/>
                 </a:solidFill>
@@ -9272,13 +9540,13 @@
       </p:sp>
       <p:sp>
         <p:nvSpPr>
-          <p:cNvPr id="72" name="Rectangle 71"/>
+          <p:cNvPr id="74" name="Rectangle 73"/>
           <p:cNvSpPr/>
           <p:nvPr/>
         </p:nvSpPr>
         <p:spPr>
           <a:xfrm>
-            <a:off x="15660000" y="36347163"/>
+            <a:off x="15660000" y="36762017"/>
             <a:ext cx="2160000" cy="43200"/>
           </a:xfrm>
           <a:prstGeom prst="rect">
@@ -9315,14 +9583,14 @@
       </p:sp>
       <p:sp>
         <p:nvSpPr>
-          <p:cNvPr id="73" name="TextBox 72"/>
+          <p:cNvPr id="75" name="TextBox 74"/>
           <p:cNvSpPr txBox="1"/>
           <p:nvPr/>
         </p:nvSpPr>
         <p:spPr>
           <a:xfrm>
-            <a:off x="15660000" y="36473163"/>
-            <a:ext cx="11988000" cy="2868740"/>
+            <a:off x="15660000" y="36888017"/>
+            <a:ext cx="11988000" cy="2364112"/>
           </a:xfrm>
           <a:prstGeom prst="rect">
             <a:avLst/>
@@ -9342,7 +9610,7 @@
               </a:spcAft>
             </a:pPr>
             <a:r>
-              <a:rPr sz="2000" b="1">
+              <a:rPr sz="1600" b="1">
                 <a:solidFill>
                   <a:srgbClr val="434B9A"/>
                 </a:solidFill>
@@ -9351,13 +9619,31 @@
               <a:t>1.</a:t>
             </a:r>
             <a:r>
-              <a:rPr sz="2000" b="0">
+              <a:rPr sz="1600" b="0">
                 <a:solidFill>
                   <a:srgbClr val="1F2233"/>
                 </a:solidFill>
                 <a:latin typeface="Inter"/>
               </a:rPr>
-              <a:t> Воспроизвели статью: AUC 0.86–0.88 и доли найденных стадий — как у авторов; CatBoost — AUC 0.880</a:t>
+              <a:t> </a:t>
+            </a:r>
+            <a:r>
+              <a:rPr sz="1600" b="1">
+                <a:solidFill>
+                  <a:srgbClr val="434B9A"/>
+                </a:solidFill>
+                <a:latin typeface="Inter"/>
+              </a:rPr>
+              <a:t>Воспроизвели статью</a:t>
+            </a:r>
+            <a:r>
+              <a:rPr sz="1600" b="0">
+                <a:solidFill>
+                  <a:srgbClr val="1F2233"/>
+                </a:solidFill>
+                <a:latin typeface="Inter"/>
+              </a:rPr>
+              <a:t> на открытых данных и современном Python: AUC 0.86–0.88 и доли найденных стадий — как у авторов; добавленный CatBoost — AUC 0.880, лучший, но с минимальным отрывом</a:t>
             </a:r>
           </a:p>
           <a:p>
@@ -9370,7 +9656,7 @@
               </a:spcAft>
             </a:pPr>
             <a:r>
-              <a:rPr sz="2000" b="1">
+              <a:rPr sz="1600" b="1">
                 <a:solidFill>
                   <a:srgbClr val="434B9A"/>
                 </a:solidFill>
@@ -9379,13 +9665,31 @@
               <a:t>2.</a:t>
             </a:r>
             <a:r>
-              <a:rPr sz="2000" b="0">
+              <a:rPr sz="1600" b="0">
                 <a:solidFill>
                   <a:srgbClr val="1F2233"/>
                 </a:solidFill>
                 <a:latin typeface="Inter"/>
               </a:rPr>
-              <a:t> Главное — движение и время ночи (clock); пульс добавляет меньше всего</a:t>
+              <a:t> </a:t>
+            </a:r>
+            <a:r>
+              <a:rPr sz="1600" b="1">
+                <a:solidFill>
+                  <a:srgbClr val="434B9A"/>
+                </a:solidFill>
+                <a:latin typeface="Inter"/>
+              </a:rPr>
+              <a:t>Главные признаки</a:t>
+            </a:r>
+            <a:r>
+              <a:rPr sz="1600" b="0">
+                <a:solidFill>
+                  <a:srgbClr val="1F2233"/>
+                </a:solidFill>
+                <a:latin typeface="Inter"/>
+              </a:rPr>
+              <a:t> — движение и время ночи (clock); пульс добавляет меньше всего, особенно для поиска бодрствования</a:t>
             </a:r>
           </a:p>
           <a:p>
@@ -9398,7 +9702,7 @@
               </a:spcAft>
             </a:pPr>
             <a:r>
-              <a:rPr sz="2000" b="1">
+              <a:rPr sz="1600" b="1">
                 <a:solidFill>
                   <a:srgbClr val="434B9A"/>
                 </a:solidFill>
@@ -9407,13 +9711,31 @@
               <a:t>3.</a:t>
             </a:r>
             <a:r>
-              <a:rPr sz="2000" b="0">
+              <a:rPr sz="1600" b="0">
                 <a:solidFill>
                   <a:srgbClr val="1F2233"/>
                 </a:solidFill>
                 <a:latin typeface="Inter"/>
               </a:rPr>
-              <a:t> Слабое место — тихое бодрствование без движения и REM; accuracy это скрывает, нужны κ, F1 и AP</a:t>
+              <a:t> </a:t>
+            </a:r>
+            <a:r>
+              <a:rPr sz="1600" b="1">
+                <a:solidFill>
+                  <a:srgbClr val="434B9A"/>
+                </a:solidFill>
+                <a:latin typeface="Inter"/>
+              </a:rPr>
+              <a:t>Слабые места</a:t>
+            </a:r>
+            <a:r>
+              <a:rPr sz="1600" b="0">
+                <a:solidFill>
+                  <a:srgbClr val="1F2233"/>
+                </a:solidFill>
+                <a:latin typeface="Inter"/>
+              </a:rPr>
+              <a:t> — тихое бодрствование без движения и REM; accuracy это скрывает, поэтому нужны κ, F1 и AP</a:t>
             </a:r>
           </a:p>
           <a:p>
@@ -9426,7 +9748,7 @@
               </a:spcAft>
             </a:pPr>
             <a:r>
-              <a:rPr sz="2000" b="1">
+              <a:rPr sz="1600" b="1">
                 <a:solidFill>
                   <a:srgbClr val="434B9A"/>
                 </a:solidFill>
@@ -9435,26 +9757,44 @@
               <a:t>4.</a:t>
             </a:r>
             <a:r>
-              <a:rPr sz="2000" b="0">
+              <a:rPr sz="1600" b="0">
                 <a:solidFill>
                   <a:srgbClr val="1F2233"/>
                 </a:solidFill>
                 <a:latin typeface="Inter"/>
               </a:rPr>
-              <a:t> Быстрые признаки движения и пульса поднимают κ MLP с 0.496 до 0.534 и AUC с 0.908 до 0.917</a:t>
+              <a:t> </a:t>
+            </a:r>
+            <a:r>
+              <a:rPr sz="1600" b="1">
+                <a:solidFill>
+                  <a:srgbClr val="434B9A"/>
+                </a:solidFill>
+                <a:latin typeface="Inter"/>
+              </a:rPr>
+              <a:t>Быстрые признаки</a:t>
+            </a:r>
+            <a:r>
+              <a:rPr sz="1600" b="0">
+                <a:solidFill>
+                  <a:srgbClr val="1F2233"/>
+                </a:solidFill>
+                <a:latin typeface="Inter"/>
+              </a:rPr>
+              <a:t> движения и пульса за 5 секунд — минуту поднимают κ нейросети с 0.496 до 0.534 и AUC с 0.908 до 0.917; их проверка на CatBoost — в репозитории</a:t>
             </a:r>
           </a:p>
         </p:txBody>
       </p:sp>
       <p:sp>
         <p:nvSpPr>
-          <p:cNvPr id="74" name="TextBox 73"/>
+          <p:cNvPr id="76" name="TextBox 75"/>
           <p:cNvSpPr txBox="1"/>
           <p:nvPr/>
         </p:nvSpPr>
         <p:spPr>
           <a:xfrm>
-            <a:off x="2376000" y="40104000"/>
+            <a:off x="2376000" y="40391999"/>
             <a:ext cx="25524000" cy="864000"/>
           </a:xfrm>
           <a:prstGeom prst="rect">

</xml_diff>

<commit_message>
Poster: larger night chart with a "how to read" panel beside it
Co-Authored-By: Claude Opus 5.5 <noreply@anthropic.com>
</commit_message>
<xml_diff>
--- a/poster/Команда_11_Постер.pptx
+++ b/poster/Команда_11_Постер.pptx
@@ -1785,7 +1785,7 @@
         <p:spPr>
           <a:xfrm>
             <a:off x="2376000" y="10404000"/>
-            <a:ext cx="12492000" cy="8952686"/>
+            <a:ext cx="12492000" cy="9300823"/>
           </a:xfrm>
           <a:prstGeom prst="roundRect">
             <a:avLst>
@@ -2005,7 +2005,7 @@
                 </a:solidFill>
                 <a:latin typeface="Inter"/>
               </a:rPr>
-              <a:t> своё приложение для Apple Watch впервые дало сырые данные ускорения (50 раз в секунду) и пульса (оптический датчик, ≈ раз в 5 с) вместе с PSG; данные и код открыты — на них мы и работали</a:t>
+              <a:t> своё приложение для Apple Watch впервые дало сырые данные ускорения (50 раз в секунду) и пульса (≈ раз в 5 с) одновременно с PSG; данные и код открыты</a:t>
             </a:r>
           </a:p>
           <a:p>
@@ -2161,8 +2161,8 @@
         </p:blipFill>
         <p:spPr>
           <a:xfrm>
-            <a:off x="5864760" y="15813253"/>
-            <a:ext cx="5514480" cy="2363348"/>
+            <a:off x="2628000" y="15813253"/>
+            <a:ext cx="6474600" cy="3296160"/>
           </a:xfrm>
           <a:prstGeom prst="rect">
             <a:avLst/>
@@ -2177,8 +2177,8 @@
         </p:nvSpPr>
         <p:spPr>
           <a:xfrm>
-            <a:off x="2628000" y="18266602"/>
-            <a:ext cx="11988000" cy="756942"/>
+            <a:off x="2628000" y="19199413"/>
+            <a:ext cx="6474600" cy="252314"/>
           </a:xfrm>
           <a:prstGeom prst="rect">
             <a:avLst/>
@@ -2204,21 +2204,214 @@
                 </a:solidFill>
                 <a:latin typeface="Inter"/>
               </a:rPr>
-              <a:t>Пример ночи (испытуемый 46343). Сверху вниз: движение — activity counts (условные единицы), пульс с часов (уд/мин), стадии по PSG — правильный ответ; по оси x — часы от начала записи. Видно, что движение почти всегда означает бодрствование, а ровный пульс — глубокий сон N3</a:t>
+              <a:t>Испытуемый 46343; движение — activity counts (усл. ед.)</a:t>
             </a:r>
           </a:p>
         </p:txBody>
       </p:sp>
       <p:sp>
         <p:nvSpPr>
-          <p:cNvPr id="30" name="Rounded Rectangle 29"/>
+          <p:cNvPr id="30" name="TextBox 29"/>
+          <p:cNvSpPr txBox="1"/>
+          <p:nvPr/>
+        </p:nvSpPr>
+        <p:spPr>
+          <a:xfrm>
+            <a:off x="9318600" y="16198120"/>
+            <a:ext cx="5297400" cy="252314"/>
+          </a:xfrm>
+          <a:prstGeom prst="rect">
+            <a:avLst/>
+          </a:prstGeom>
+          <a:noFill/>
+        </p:spPr>
+        <p:txBody>
+          <a:bodyPr wrap="square" lIns="0" rIns="0" tIns="0" bIns="0" anchor="t"/>
+          <a:lstStyle/>
+          <a:p>
+            <a:pPr algn="l">
+              <a:lnSpc>
+                <a:spcPct val="110000"/>
+              </a:lnSpc>
+              <a:spcAft>
+                <a:spcPts val="0"/>
+              </a:spcAft>
+            </a:pPr>
+            <a:r>
+              <a:rPr sz="1400" b="1">
+                <a:solidFill>
+                  <a:srgbClr val="434B9A"/>
+                </a:solidFill>
+                <a:latin typeface="Inter"/>
+              </a:rPr>
+              <a:t>Как читать:</a:t>
+            </a:r>
+          </a:p>
+        </p:txBody>
+      </p:sp>
+      <p:sp>
+        <p:nvSpPr>
+          <p:cNvPr id="31" name="TextBox 30"/>
+          <p:cNvSpPr txBox="1"/>
+          <p:nvPr/>
+        </p:nvSpPr>
+        <p:spPr>
+          <a:xfrm>
+            <a:off x="9318600" y="16558434"/>
+            <a:ext cx="5297400" cy="2616426"/>
+          </a:xfrm>
+          <a:prstGeom prst="rect">
+            <a:avLst/>
+          </a:prstGeom>
+          <a:noFill/>
+        </p:spPr>
+        <p:txBody>
+          <a:bodyPr wrap="square" lIns="0" rIns="0" tIns="0" bIns="0" anchor="t"/>
+          <a:lstStyle/>
+          <a:p>
+            <a:pPr algn="l" marL="270000" indent="-270000">
+              <a:lnSpc>
+                <a:spcPct val="110000"/>
+              </a:lnSpc>
+              <a:spcAft>
+                <a:spcPts val="623"/>
+              </a:spcAft>
+              <a:buClr>
+                <a:srgbClr val="434B9A"/>
+              </a:buClr>
+              <a:buFont typeface="Arial"/>
+              <a:buChar char="•"/>
+            </a:pPr>
+            <a:r>
+              <a:rPr sz="1400" b="1">
+                <a:solidFill>
+                  <a:srgbClr val="434B9A"/>
+                </a:solidFill>
+                <a:latin typeface="Inter"/>
+              </a:rPr>
+              <a:t>Движение</a:t>
+            </a:r>
+            <a:r>
+              <a:rPr sz="1400" b="0">
+                <a:solidFill>
+                  <a:srgbClr val="1F2233"/>
+                </a:solidFill>
+                <a:latin typeface="Inter"/>
+              </a:rPr>
+              <a:t> во сне почти всегда 0; пики — пробуждения или ворочания</a:t>
+            </a:r>
+          </a:p>
+          <a:p>
+            <a:pPr algn="l" marL="270000" indent="-270000">
+              <a:lnSpc>
+                <a:spcPct val="110000"/>
+              </a:lnSpc>
+              <a:spcAft>
+                <a:spcPts val="623"/>
+              </a:spcAft>
+              <a:buClr>
+                <a:srgbClr val="434B9A"/>
+              </a:buClr>
+              <a:buFont typeface="Arial"/>
+              <a:buChar char="•"/>
+            </a:pPr>
+            <a:r>
+              <a:rPr sz="1400" b="1">
+                <a:solidFill>
+                  <a:srgbClr val="434B9A"/>
+                </a:solidFill>
+                <a:latin typeface="Inter"/>
+              </a:rPr>
+              <a:t>Пульс</a:t>
+            </a:r>
+            <a:r>
+              <a:rPr sz="1400" b="0">
+                <a:solidFill>
+                  <a:srgbClr val="1F2233"/>
+                </a:solidFill>
+                <a:latin typeface="Inter"/>
+              </a:rPr>
+              <a:t> ровный в глубоком сне N3 и скачет при пробуждениях</a:t>
+            </a:r>
+          </a:p>
+          <a:p>
+            <a:pPr algn="l" marL="270000" indent="-270000">
+              <a:lnSpc>
+                <a:spcPct val="110000"/>
+              </a:lnSpc>
+              <a:spcAft>
+                <a:spcPts val="623"/>
+              </a:spcAft>
+              <a:buClr>
+                <a:srgbClr val="434B9A"/>
+              </a:buClr>
+              <a:buFont typeface="Arial"/>
+              <a:buChar char="•"/>
+            </a:pPr>
+            <a:r>
+              <a:rPr sz="1400" b="1">
+                <a:solidFill>
+                  <a:srgbClr val="434B9A"/>
+                </a:solidFill>
+                <a:latin typeface="Inter"/>
+              </a:rPr>
+              <a:t>Стадии</a:t>
+            </a:r>
+            <a:r>
+              <a:rPr sz="1400" b="0">
+                <a:solidFill>
+                  <a:srgbClr val="1F2233"/>
+                </a:solidFill>
+                <a:latin typeface="Inter"/>
+              </a:rPr>
+              <a:t> идут циклами ≈ 90 мин: N3 — в начале ночи, REM к утру длиннее</a:t>
+            </a:r>
+          </a:p>
+          <a:p>
+            <a:pPr algn="l" marL="270000" indent="-270000">
+              <a:lnSpc>
+                <a:spcPct val="110000"/>
+              </a:lnSpc>
+              <a:spcAft>
+                <a:spcPts val="623"/>
+              </a:spcAft>
+              <a:buClr>
+                <a:srgbClr val="434B9A"/>
+              </a:buClr>
+              <a:buFont typeface="Arial"/>
+              <a:buChar char="•"/>
+            </a:pPr>
+            <a:r>
+              <a:rPr sz="1400" b="1">
+                <a:solidFill>
+                  <a:srgbClr val="434B9A"/>
+                </a:solidFill>
+                <a:latin typeface="Inter"/>
+              </a:rPr>
+              <a:t>Трудное место:</a:t>
+            </a:r>
+            <a:r>
+              <a:rPr sz="1400" b="0">
+                <a:solidFill>
+                  <a:srgbClr val="1F2233"/>
+                </a:solidFill>
+                <a:latin typeface="Inter"/>
+              </a:rPr>
+              <a:t> в начале ночи человек не спит, но почти не двигается — по часам это бодрствование не видно</a:t>
+            </a:r>
+          </a:p>
+        </p:txBody>
+      </p:sp>
+      <p:sp>
+        <p:nvSpPr>
+          <p:cNvPr id="32" name="Rounded Rectangle 31"/>
           <p:cNvSpPr/>
           <p:nvPr/>
         </p:nvSpPr>
         <p:spPr>
           <a:xfrm>
-            <a:off x="2376000" y="19608686"/>
-            <a:ext cx="12492000" cy="5200869"/>
+            <a:off x="2376000" y="19920823"/>
+            <a:ext cx="12492000" cy="5120824"/>
           </a:xfrm>
           <a:prstGeom prst="roundRect">
             <a:avLst>
@@ -2259,13 +2452,13 @@
       </p:sp>
       <p:sp>
         <p:nvSpPr>
-          <p:cNvPr id="31" name="TextBox 30"/>
+          <p:cNvPr id="33" name="TextBox 32"/>
           <p:cNvSpPr txBox="1"/>
           <p:nvPr/>
         </p:nvSpPr>
         <p:spPr>
           <a:xfrm>
-            <a:off x="2628000" y="19860686"/>
+            <a:off x="2628000" y="20172823"/>
             <a:ext cx="11988000" cy="504628"/>
           </a:xfrm>
           <a:prstGeom prst="rect">
@@ -2299,13 +2492,13 @@
       </p:sp>
       <p:sp>
         <p:nvSpPr>
-          <p:cNvPr id="32" name="Rectangle 31"/>
+          <p:cNvPr id="34" name="Rectangle 33"/>
           <p:cNvSpPr/>
           <p:nvPr/>
         </p:nvSpPr>
         <p:spPr>
           <a:xfrm>
-            <a:off x="2628000" y="20401314"/>
+            <a:off x="2628000" y="20713452"/>
             <a:ext cx="2160000" cy="43200"/>
           </a:xfrm>
           <a:prstGeom prst="rect">
@@ -2342,13 +2535,13 @@
       </p:sp>
       <p:sp>
         <p:nvSpPr>
-          <p:cNvPr id="33" name="TextBox 32"/>
+          <p:cNvPr id="35" name="TextBox 34"/>
           <p:cNvSpPr txBox="1"/>
           <p:nvPr/>
         </p:nvSpPr>
         <p:spPr>
           <a:xfrm>
-            <a:off x="2628000" y="20527314"/>
+            <a:off x="2628000" y="20839452"/>
             <a:ext cx="11988000" cy="2652471"/>
           </a:xfrm>
           <a:prstGeom prst="rect">
@@ -2522,7 +2715,7 @@
       </p:sp>
       <p:pic>
         <p:nvPicPr>
-          <p:cNvPr id="34" name="Picture 33" descr="formula_clock.png"/>
+          <p:cNvPr id="36" name="Picture 35" descr="formula_clock.png"/>
           <p:cNvPicPr>
             <a:picLocks noChangeAspect="1"/>
           </p:cNvPicPr>
@@ -2536,7 +2729,7 @@
         </p:blipFill>
         <p:spPr>
           <a:xfrm>
-            <a:off x="7277892" y="23179786"/>
+            <a:off x="7277892" y="23491923"/>
             <a:ext cx="2688215" cy="684000"/>
           </a:xfrm>
           <a:prstGeom prst="rect">
@@ -2546,13 +2739,13 @@
       </p:pic>
       <p:sp>
         <p:nvSpPr>
-          <p:cNvPr id="35" name="TextBox 34"/>
+          <p:cNvPr id="37" name="TextBox 36"/>
           <p:cNvSpPr txBox="1"/>
           <p:nvPr/>
         </p:nvSpPr>
         <p:spPr>
           <a:xfrm>
-            <a:off x="2628000" y="23971786"/>
+            <a:off x="2628000" y="24283923"/>
             <a:ext cx="11988000" cy="504628"/>
           </a:xfrm>
           <a:prstGeom prst="rect">
@@ -2586,14 +2779,14 @@
       </p:sp>
       <p:sp>
         <p:nvSpPr>
-          <p:cNvPr id="36" name="Rounded Rectangle 35"/>
+          <p:cNvPr id="38" name="Rounded Rectangle 37"/>
           <p:cNvSpPr/>
           <p:nvPr/>
         </p:nvSpPr>
         <p:spPr>
           <a:xfrm>
-            <a:off x="2376000" y="25061556"/>
-            <a:ext cx="12492000" cy="5740780"/>
+            <a:off x="2376000" y="25257647"/>
+            <a:ext cx="12492000" cy="5660734"/>
           </a:xfrm>
           <a:prstGeom prst="roundRect">
             <a:avLst>
@@ -2634,13 +2827,13 @@
       </p:sp>
       <p:sp>
         <p:nvSpPr>
-          <p:cNvPr id="37" name="TextBox 36"/>
+          <p:cNvPr id="39" name="TextBox 38"/>
           <p:cNvSpPr txBox="1"/>
           <p:nvPr/>
         </p:nvSpPr>
         <p:spPr>
           <a:xfrm>
-            <a:off x="2628000" y="25313556"/>
+            <a:off x="2628000" y="25509647"/>
             <a:ext cx="11988000" cy="504628"/>
           </a:xfrm>
           <a:prstGeom prst="rect">
@@ -2674,13 +2867,13 @@
       </p:sp>
       <p:sp>
         <p:nvSpPr>
-          <p:cNvPr id="38" name="Rectangle 37"/>
+          <p:cNvPr id="40" name="Rectangle 39"/>
           <p:cNvSpPr/>
           <p:nvPr/>
         </p:nvSpPr>
         <p:spPr>
           <a:xfrm>
-            <a:off x="2628000" y="25854184"/>
+            <a:off x="2628000" y="26050276"/>
             <a:ext cx="2160000" cy="43200"/>
           </a:xfrm>
           <a:prstGeom prst="rect">
@@ -2717,13 +2910,13 @@
       </p:sp>
       <p:sp>
         <p:nvSpPr>
-          <p:cNvPr id="39" name="TextBox 38"/>
+          <p:cNvPr id="41" name="TextBox 40"/>
           <p:cNvSpPr txBox="1"/>
           <p:nvPr/>
         </p:nvSpPr>
         <p:spPr>
           <a:xfrm>
-            <a:off x="2628000" y="25980184"/>
+            <a:off x="2628000" y="26176276"/>
             <a:ext cx="11988000" cy="1996553"/>
           </a:xfrm>
           <a:prstGeom prst="rect">
@@ -2846,7 +3039,7 @@
       </p:sp>
       <p:pic>
         <p:nvPicPr>
-          <p:cNvPr id="40" name="Picture 39" descr="formula_logreg.png"/>
+          <p:cNvPr id="42" name="Picture 41" descr="formula_logreg.png"/>
           <p:cNvPicPr>
             <a:picLocks noChangeAspect="1"/>
           </p:cNvPicPr>
@@ -2860,7 +3053,7 @@
         </p:blipFill>
         <p:spPr>
           <a:xfrm>
-            <a:off x="6222501" y="27976738"/>
+            <a:off x="6222501" y="28172829"/>
             <a:ext cx="4798997" cy="576000"/>
           </a:xfrm>
           <a:prstGeom prst="rect">
@@ -2870,13 +3063,13 @@
       </p:pic>
       <p:sp>
         <p:nvSpPr>
-          <p:cNvPr id="41" name="TextBox 40"/>
+          <p:cNvPr id="43" name="TextBox 42"/>
           <p:cNvSpPr txBox="1"/>
           <p:nvPr/>
         </p:nvSpPr>
         <p:spPr>
           <a:xfrm>
-            <a:off x="2628000" y="28660738"/>
+            <a:off x="2628000" y="28856829"/>
             <a:ext cx="11988000" cy="1196456"/>
           </a:xfrm>
           <a:prstGeom prst="rect">
@@ -3047,7 +3240,7 @@
       </p:sp>
       <p:pic>
         <p:nvPicPr>
-          <p:cNvPr id="42" name="Picture 41" descr="formula_kappa.png"/>
+          <p:cNvPr id="44" name="Picture 43" descr="formula_kappa.png"/>
           <p:cNvPicPr>
             <a:picLocks noChangeAspect="1"/>
           </p:cNvPicPr>
@@ -3061,7 +3254,7 @@
         </p:blipFill>
         <p:spPr>
           <a:xfrm>
-            <a:off x="5961865" y="29857194"/>
+            <a:off x="5961865" y="30053286"/>
             <a:ext cx="1407263" cy="612000"/>
           </a:xfrm>
           <a:prstGeom prst="rect">
@@ -3071,7 +3264,7 @@
       </p:pic>
       <p:pic>
         <p:nvPicPr>
-          <p:cNvPr id="43" name="Picture 42" descr="formula_f1.png"/>
+          <p:cNvPr id="45" name="Picture 44" descr="formula_f1.png"/>
           <p:cNvPicPr>
             <a:picLocks noChangeAspect="1"/>
           </p:cNvPicPr>
@@ -3085,7 +3278,7 @@
         </p:blipFill>
         <p:spPr>
           <a:xfrm>
-            <a:off x="8629129" y="29857194"/>
+            <a:off x="8629129" y="30053286"/>
             <a:ext cx="2653004" cy="612000"/>
           </a:xfrm>
           <a:prstGeom prst="rect">
@@ -3095,14 +3288,14 @@
       </p:pic>
       <p:sp>
         <p:nvSpPr>
-          <p:cNvPr id="44" name="Rounded Rectangle 43"/>
+          <p:cNvPr id="46" name="Rounded Rectangle 45"/>
           <p:cNvSpPr/>
           <p:nvPr/>
         </p:nvSpPr>
         <p:spPr>
           <a:xfrm>
-            <a:off x="2376000" y="31054336"/>
-            <a:ext cx="12492000" cy="9121663"/>
+            <a:off x="2376000" y="31134382"/>
+            <a:ext cx="12492000" cy="9041617"/>
           </a:xfrm>
           <a:prstGeom prst="roundRect">
             <a:avLst>
@@ -3143,13 +3336,13 @@
       </p:sp>
       <p:sp>
         <p:nvSpPr>
-          <p:cNvPr id="45" name="TextBox 44"/>
+          <p:cNvPr id="47" name="TextBox 46"/>
           <p:cNvSpPr txBox="1"/>
           <p:nvPr/>
         </p:nvSpPr>
         <p:spPr>
           <a:xfrm>
-            <a:off x="2628000" y="31306336"/>
+            <a:off x="2628000" y="31386382"/>
             <a:ext cx="11988000" cy="504628"/>
           </a:xfrm>
           <a:prstGeom prst="rect">
@@ -3183,13 +3376,13 @@
       </p:sp>
       <p:sp>
         <p:nvSpPr>
-          <p:cNvPr id="46" name="Rectangle 45"/>
+          <p:cNvPr id="48" name="Rectangle 47"/>
           <p:cNvSpPr/>
           <p:nvPr/>
         </p:nvSpPr>
         <p:spPr>
           <a:xfrm>
-            <a:off x="2628000" y="31846964"/>
+            <a:off x="2628000" y="31927010"/>
             <a:ext cx="2160000" cy="43200"/>
           </a:xfrm>
           <a:prstGeom prst="rect">
@@ -3226,13 +3419,13 @@
       </p:sp>
       <p:sp>
         <p:nvSpPr>
-          <p:cNvPr id="47" name="TextBox 46"/>
+          <p:cNvPr id="49" name="TextBox 48"/>
           <p:cNvSpPr txBox="1"/>
           <p:nvPr/>
         </p:nvSpPr>
         <p:spPr>
           <a:xfrm>
-            <a:off x="2628000" y="31972964"/>
+            <a:off x="2628000" y="32053010"/>
             <a:ext cx="11988000" cy="252314"/>
           </a:xfrm>
           <a:prstGeom prst="rect">
@@ -3275,14 +3468,14 @@
       </p:sp>
       <p:graphicFrame>
         <p:nvGraphicFramePr>
-          <p:cNvPr id="48" name="Table 47"/>
+          <p:cNvPr id="50" name="Table 49"/>
           <p:cNvGraphicFramePr>
             <a:graphicFrameLocks noGrp="1"/>
           </p:cNvGraphicFramePr>
           <p:nvPr/>
         </p:nvGraphicFramePr>
         <p:xfrm>
-          <a:off x="2628000" y="32333278"/>
+          <a:off x="2628000" y="32413324"/>
           <a:ext cx="11987993" cy="2540377"/>
         </p:xfrm>
         <a:graphic>
@@ -5857,13 +6050,13 @@
       </p:graphicFrame>
       <p:sp>
         <p:nvSpPr>
-          <p:cNvPr id="49" name="TextBox 48"/>
+          <p:cNvPr id="51" name="TextBox 50"/>
           <p:cNvSpPr txBox="1"/>
           <p:nvPr/>
         </p:nvSpPr>
         <p:spPr>
           <a:xfrm>
-            <a:off x="2628000" y="34981656"/>
+            <a:off x="2628000" y="35061702"/>
             <a:ext cx="11988000" cy="504628"/>
           </a:xfrm>
           <a:prstGeom prst="rect">
@@ -5906,14 +6099,14 @@
       </p:sp>
       <p:graphicFrame>
         <p:nvGraphicFramePr>
-          <p:cNvPr id="50" name="Table 49"/>
+          <p:cNvPr id="52" name="Table 51"/>
           <p:cNvGraphicFramePr>
             <a:graphicFrameLocks noGrp="1"/>
           </p:cNvGraphicFramePr>
           <p:nvPr/>
         </p:nvGraphicFramePr>
         <p:xfrm>
-          <a:off x="2628000" y="35594285"/>
+          <a:off x="2628000" y="35674330"/>
           <a:ext cx="11987995" cy="2540377"/>
         </p:xfrm>
         <a:graphic>
@@ -8280,13 +8473,13 @@
       </p:graphicFrame>
       <p:sp>
         <p:nvSpPr>
-          <p:cNvPr id="51" name="TextBox 50"/>
+          <p:cNvPr id="53" name="TextBox 52"/>
           <p:cNvSpPr txBox="1"/>
           <p:nvPr/>
         </p:nvSpPr>
         <p:spPr>
           <a:xfrm>
-            <a:off x="2628000" y="38242663"/>
+            <a:off x="2628000" y="38322709"/>
             <a:ext cx="11988000" cy="1708194"/>
           </a:xfrm>
           <a:prstGeom prst="rect">
@@ -8400,14 +8593,14 @@
       </p:sp>
       <p:sp>
         <p:nvSpPr>
-          <p:cNvPr id="52" name="Rounded Rectangle 51"/>
+          <p:cNvPr id="54" name="Rounded Rectangle 53"/>
           <p:cNvSpPr/>
           <p:nvPr/>
         </p:nvSpPr>
         <p:spPr>
           <a:xfrm>
             <a:off x="15408000" y="10404000"/>
-            <a:ext cx="12492000" cy="10125355"/>
+            <a:ext cx="12492000" cy="10149355"/>
           </a:xfrm>
           <a:prstGeom prst="roundRect">
             <a:avLst>
@@ -8448,7 +8641,7 @@
       </p:sp>
       <p:sp>
         <p:nvSpPr>
-          <p:cNvPr id="53" name="TextBox 52"/>
+          <p:cNvPr id="55" name="TextBox 54"/>
           <p:cNvSpPr txBox="1"/>
           <p:nvPr/>
         </p:nvSpPr>
@@ -8488,7 +8681,7 @@
       </p:sp>
       <p:sp>
         <p:nvSpPr>
-          <p:cNvPr id="54" name="Rectangle 53"/>
+          <p:cNvPr id="56" name="Rectangle 55"/>
           <p:cNvSpPr/>
           <p:nvPr/>
         </p:nvSpPr>
@@ -8531,7 +8724,7 @@
       </p:sp>
       <p:pic>
         <p:nvPicPr>
-          <p:cNvPr id="55" name="Picture 54" descr="formula_shapley.png"/>
+          <p:cNvPr id="57" name="Picture 56" descr="formula_shapley.png"/>
           <p:cNvPicPr>
             <a:picLocks noChangeAspect="1"/>
           </p:cNvPicPr>
@@ -8555,7 +8748,7 @@
       </p:pic>
       <p:sp>
         <p:nvSpPr>
-          <p:cNvPr id="56" name="TextBox 55"/>
+          <p:cNvPr id="58" name="TextBox 57"/>
           <p:cNvSpPr txBox="1"/>
           <p:nvPr/>
         </p:nvSpPr>
@@ -8708,7 +8901,7 @@
       </p:sp>
       <p:pic>
         <p:nvPicPr>
-          <p:cNvPr id="57" name="Picture 56" descr="shapley_poster.png"/>
+          <p:cNvPr id="59" name="Picture 58" descr="shapley_poster.png"/>
           <p:cNvPicPr>
             <a:picLocks noChangeAspect="1"/>
           </p:cNvPicPr>
@@ -8732,14 +8925,14 @@
       </p:pic>
       <p:sp>
         <p:nvSpPr>
-          <p:cNvPr id="58" name="Rounded Rectangle 57"/>
+          <p:cNvPr id="60" name="Rounded Rectangle 59"/>
           <p:cNvSpPr/>
           <p:nvPr/>
         </p:nvSpPr>
         <p:spPr>
           <a:xfrm>
-            <a:off x="15408000" y="20781355"/>
-            <a:ext cx="12492000" cy="14936033"/>
+            <a:off x="15408000" y="20769355"/>
+            <a:ext cx="12492000" cy="14960033"/>
           </a:xfrm>
           <a:prstGeom prst="roundRect">
             <a:avLst>
@@ -8780,13 +8973,13 @@
       </p:sp>
       <p:sp>
         <p:nvSpPr>
-          <p:cNvPr id="59" name="TextBox 58"/>
+          <p:cNvPr id="61" name="TextBox 60"/>
           <p:cNvSpPr txBox="1"/>
           <p:nvPr/>
         </p:nvSpPr>
         <p:spPr>
           <a:xfrm>
-            <a:off x="15660000" y="21033355"/>
+            <a:off x="15660000" y="21021355"/>
             <a:ext cx="11988000" cy="504628"/>
           </a:xfrm>
           <a:prstGeom prst="rect">
@@ -8820,13 +9013,13 @@
       </p:sp>
       <p:sp>
         <p:nvSpPr>
-          <p:cNvPr id="60" name="Rectangle 59"/>
+          <p:cNvPr id="62" name="Rectangle 61"/>
           <p:cNvSpPr/>
           <p:nvPr/>
         </p:nvSpPr>
         <p:spPr>
           <a:xfrm>
-            <a:off x="15660000" y="21573984"/>
+            <a:off x="15660000" y="21561984"/>
             <a:ext cx="2160000" cy="43200"/>
           </a:xfrm>
           <a:prstGeom prst="rect">
@@ -8863,13 +9056,13 @@
       </p:sp>
       <p:sp>
         <p:nvSpPr>
-          <p:cNvPr id="61" name="TextBox 60"/>
+          <p:cNvPr id="63" name="TextBox 62"/>
           <p:cNvSpPr txBox="1"/>
           <p:nvPr/>
         </p:nvSpPr>
         <p:spPr>
           <a:xfrm>
-            <a:off x="15660000" y="21699984"/>
+            <a:off x="15660000" y="21687984"/>
             <a:ext cx="11988000" cy="865076"/>
           </a:xfrm>
           <a:prstGeom prst="rect">
@@ -8903,7 +9096,7 @@
       </p:sp>
       <p:pic>
         <p:nvPicPr>
-          <p:cNvPr id="62" name="Picture 61" descr="formula_fpeak.png"/>
+          <p:cNvPr id="64" name="Picture 63" descr="formula_fpeak.png"/>
           <p:cNvPicPr>
             <a:picLocks noChangeAspect="1"/>
           </p:cNvPicPr>
@@ -8917,7 +9110,7 @@
         </p:blipFill>
         <p:spPr>
           <a:xfrm>
-            <a:off x="16266976" y="22673060"/>
+            <a:off x="16266976" y="22661060"/>
             <a:ext cx="2999828" cy="684000"/>
           </a:xfrm>
           <a:prstGeom prst="rect">
@@ -8927,7 +9120,7 @@
       </p:pic>
       <p:pic>
         <p:nvPicPr>
-          <p:cNvPr id="63" name="Picture 62" descr="formula_factive.png"/>
+          <p:cNvPr id="65" name="Picture 64" descr="formula_factive.png"/>
           <p:cNvPicPr>
             <a:picLocks noChangeAspect="1"/>
           </p:cNvPicPr>
@@ -8941,7 +9134,7 @@
         </p:blipFill>
         <p:spPr>
           <a:xfrm>
-            <a:off x="19986804" y="22673060"/>
+            <a:off x="19986804" y="22661060"/>
             <a:ext cx="4312095" cy="684000"/>
           </a:xfrm>
           <a:prstGeom prst="rect">
@@ -8951,7 +9144,7 @@
       </p:pic>
       <p:pic>
         <p:nvPicPr>
-          <p:cNvPr id="64" name="Picture 63" descr="formula_fhr.png"/>
+          <p:cNvPr id="66" name="Picture 65" descr="formula_fhr.png"/>
           <p:cNvPicPr>
             <a:picLocks noChangeAspect="1"/>
           </p:cNvPicPr>
@@ -8965,7 +9158,7 @@
         </p:blipFill>
         <p:spPr>
           <a:xfrm>
-            <a:off x="25018899" y="22673060"/>
+            <a:off x="25018899" y="22661060"/>
             <a:ext cx="2022124" cy="684000"/>
           </a:xfrm>
           <a:prstGeom prst="rect">
@@ -8975,13 +9168,13 @@
       </p:pic>
       <p:sp>
         <p:nvSpPr>
-          <p:cNvPr id="65" name="TextBox 64"/>
+          <p:cNvPr id="67" name="TextBox 66"/>
           <p:cNvSpPr txBox="1"/>
           <p:nvPr/>
         </p:nvSpPr>
         <p:spPr>
           <a:xfrm>
-            <a:off x="15660000" y="23465060"/>
+            <a:off x="15660000" y="23453060"/>
             <a:ext cx="11988000" cy="1708194"/>
           </a:xfrm>
           <a:prstGeom prst="rect">
@@ -9095,7 +9288,7 @@
       </p:sp>
       <p:pic>
         <p:nvPicPr>
-          <p:cNvPr id="66" name="Picture 65" descr="experiments.png"/>
+          <p:cNvPr id="68" name="Picture 67" descr="experiments.png"/>
           <p:cNvPicPr>
             <a:picLocks noChangeAspect="1"/>
           </p:cNvPicPr>
@@ -9109,7 +9302,7 @@
         </p:blipFill>
         <p:spPr>
           <a:xfrm>
-            <a:off x="17218440" y="25173255"/>
+            <a:off x="17218440" y="25161255"/>
             <a:ext cx="8871120" cy="3309620"/>
           </a:xfrm>
           <a:prstGeom prst="rect">
@@ -9119,13 +9312,13 @@
       </p:pic>
       <p:sp>
         <p:nvSpPr>
-          <p:cNvPr id="67" name="TextBox 66"/>
+          <p:cNvPr id="69" name="TextBox 68"/>
           <p:cNvSpPr txBox="1"/>
           <p:nvPr/>
         </p:nvSpPr>
         <p:spPr>
           <a:xfrm>
-            <a:off x="15660000" y="28572875"/>
+            <a:off x="15660000" y="28560875"/>
             <a:ext cx="11988000" cy="252314"/>
           </a:xfrm>
           <a:prstGeom prst="rect">
@@ -9159,7 +9352,7 @@
       </p:sp>
       <p:pic>
         <p:nvPicPr>
-          <p:cNvPr id="68" name="Picture 67" descr="shap_fast_right.png"/>
+          <p:cNvPr id="70" name="Picture 69" descr="shap_fast_right.png"/>
           <p:cNvPicPr>
             <a:picLocks noChangeAspect="1"/>
           </p:cNvPicPr>
@@ -9173,7 +9366,7 @@
         </p:blipFill>
         <p:spPr>
           <a:xfrm>
-            <a:off x="15660000" y="28933189"/>
+            <a:off x="15660000" y="28921189"/>
             <a:ext cx="5179680" cy="4713815"/>
           </a:xfrm>
           <a:prstGeom prst="rect">
@@ -9183,13 +9376,13 @@
       </p:pic>
       <p:sp>
         <p:nvSpPr>
-          <p:cNvPr id="69" name="TextBox 68"/>
+          <p:cNvPr id="71" name="TextBox 70"/>
           <p:cNvSpPr txBox="1"/>
           <p:nvPr/>
         </p:nvSpPr>
         <p:spPr>
           <a:xfrm>
-            <a:off x="15660000" y="33737005"/>
+            <a:off x="15660000" y="33725005"/>
             <a:ext cx="5179680" cy="252314"/>
           </a:xfrm>
           <a:prstGeom prst="rect">
@@ -9223,13 +9416,13 @@
       </p:sp>
       <p:sp>
         <p:nvSpPr>
-          <p:cNvPr id="70" name="TextBox 69"/>
+          <p:cNvPr id="72" name="TextBox 71"/>
           <p:cNvSpPr txBox="1"/>
           <p:nvPr/>
         </p:nvSpPr>
         <p:spPr>
           <a:xfrm>
-            <a:off x="21055680" y="28933189"/>
+            <a:off x="21055680" y="28921189"/>
             <a:ext cx="6592320" cy="5247702"/>
           </a:xfrm>
           <a:prstGeom prst="rect">
@@ -9394,13 +9587,13 @@
       </p:sp>
       <p:sp>
         <p:nvSpPr>
-          <p:cNvPr id="71" name="TextBox 70"/>
+          <p:cNvPr id="73" name="TextBox 72"/>
           <p:cNvSpPr txBox="1"/>
           <p:nvPr/>
         </p:nvSpPr>
         <p:spPr>
           <a:xfrm>
-            <a:off x="15660000" y="34180892"/>
+            <a:off x="15660000" y="34168892"/>
             <a:ext cx="11988000" cy="504628"/>
           </a:xfrm>
           <a:prstGeom prst="rect">
@@ -9452,14 +9645,14 @@
       </p:sp>
       <p:sp>
         <p:nvSpPr>
-          <p:cNvPr id="72" name="Rounded Rectangle 71"/>
+          <p:cNvPr id="74" name="Rounded Rectangle 73"/>
           <p:cNvSpPr/>
           <p:nvPr/>
         </p:nvSpPr>
         <p:spPr>
           <a:xfrm>
-            <a:off x="15408000" y="35969389"/>
-            <a:ext cx="12492000" cy="4206610"/>
+            <a:off x="15408000" y="35945389"/>
+            <a:ext cx="12492000" cy="4230610"/>
           </a:xfrm>
           <a:prstGeom prst="roundRect">
             <a:avLst>
@@ -9500,13 +9693,13 @@
       </p:sp>
       <p:sp>
         <p:nvSpPr>
-          <p:cNvPr id="73" name="TextBox 72"/>
+          <p:cNvPr id="75" name="TextBox 74"/>
           <p:cNvSpPr txBox="1"/>
           <p:nvPr/>
         </p:nvSpPr>
         <p:spPr>
           <a:xfrm>
-            <a:off x="15660000" y="36221389"/>
+            <a:off x="15660000" y="36197389"/>
             <a:ext cx="11988000" cy="504628"/>
           </a:xfrm>
           <a:prstGeom prst="rect">
@@ -9540,13 +9733,13 @@
       </p:sp>
       <p:sp>
         <p:nvSpPr>
-          <p:cNvPr id="74" name="Rectangle 73"/>
+          <p:cNvPr id="76" name="Rectangle 75"/>
           <p:cNvSpPr/>
           <p:nvPr/>
         </p:nvSpPr>
         <p:spPr>
           <a:xfrm>
-            <a:off x="15660000" y="36762017"/>
+            <a:off x="15660000" y="36738017"/>
             <a:ext cx="2160000" cy="43200"/>
           </a:xfrm>
           <a:prstGeom prst="rect">
@@ -9583,13 +9776,13 @@
       </p:sp>
       <p:sp>
         <p:nvSpPr>
-          <p:cNvPr id="75" name="TextBox 74"/>
+          <p:cNvPr id="77" name="TextBox 76"/>
           <p:cNvSpPr txBox="1"/>
           <p:nvPr/>
         </p:nvSpPr>
         <p:spPr>
           <a:xfrm>
-            <a:off x="15660000" y="36888017"/>
+            <a:off x="15660000" y="36864017"/>
             <a:ext cx="11988000" cy="2364112"/>
           </a:xfrm>
           <a:prstGeom prst="rect">
@@ -9788,7 +9981,7 @@
       </p:sp>
       <p:sp>
         <p:nvSpPr>
-          <p:cNvPr id="76" name="TextBox 75"/>
+          <p:cNvPr id="78" name="TextBox 77"/>
           <p:cNvSpPr txBox="1"/>
           <p:nvPr/>
         </p:nvSpPr>

</xml_diff>

<commit_message>
Poster: describe motion and hr without filter jargon
Co-Authored-By: Claude Opus 5.5 <noreply@anthropic.com>
</commit_message>
<xml_diff>
--- a/poster/Команда_11_Постер.pptx
+++ b/poster/Команда_11_Постер.pptx
@@ -2582,7 +2582,7 @@
                 </a:solidFill>
                 <a:latin typeface="Inter"/>
               </a:rPr>
-              <a:t> — сколько человек двигался: ускорение по оси z → полосовой фильтр 3–11 Гц (убирает гравитацию и шум) → суммы за 15 с («activity counts», как у актиграфов) → сглаживание окном ≈ 10 мин</a:t>
+              <a:t> — сколько человек двигался: из ускорения убираются гравитация и шум, движения суммируются за 15 с («activity counts», как у медицинских актиграфов) и усредняются за ≈ 10 мин</a:t>
             </a:r>
           </a:p>
           <a:p>
@@ -2615,7 +2615,7 @@
                 </a:solidFill>
                 <a:latin typeface="Inter"/>
               </a:rPr>
-              <a:t> — локальная вариабельность пульса: стандартное отклонение за ≈ 10 мин после полосового фильтра «разность гауссиан» (убирает дрейф за ночь); мала в глубоком сне, велика при пробуждениях</a:t>
+              <a:t> — насколько сильно меняется пульс вокруг эпохи: разброс пульса за ≈ 10 мин, без медленного изменения за ночь; мал в глубоком сне, велик при пробуждениях</a:t>
             </a:r>
           </a:p>
           <a:p>

</xml_diff>

<commit_message>
Poster: fast features on CatBoost and MLP (AUC 0.880 -> 0.890)
Card 6 shows the team's run of repro/10_fast_features.py: base features
against base + fast features for CatBoost and the paper MLP, with clock or
cosine as time of night; conclusions updated.

Co-Authored-By: Claude Opus 5.5 <noreply@anthropic.com>
</commit_message>
<xml_diff>
--- a/poster/Команда_11_Постер.pptx
+++ b/poster/Команда_11_Постер.pptx
@@ -8600,7 +8600,7 @@
         <p:spPr>
           <a:xfrm>
             <a:off x="15408000" y="10404000"/>
-            <a:ext cx="12492000" cy="10149355"/>
+            <a:ext cx="12492000" cy="8929764"/>
           </a:xfrm>
           <a:prstGeom prst="roundRect">
             <a:avLst>
@@ -8915,8 +8915,8 @@
         </p:blipFill>
         <p:spPr>
           <a:xfrm>
-            <a:off x="16499160" y="15668176"/>
-            <a:ext cx="10309680" cy="3829309"/>
+            <a:off x="17098560" y="15668176"/>
+            <a:ext cx="9110880" cy="3384041"/>
           </a:xfrm>
           <a:prstGeom prst="rect">
             <a:avLst/>
@@ -8931,8 +8931,8 @@
         </p:nvSpPr>
         <p:spPr>
           <a:xfrm>
-            <a:off x="15408000" y="20769355"/>
-            <a:ext cx="12492000" cy="14960033"/>
+            <a:off x="15408000" y="19549764"/>
+            <a:ext cx="12492000" cy="16953948"/>
           </a:xfrm>
           <a:prstGeom prst="roundRect">
             <a:avLst>
@@ -8979,7 +8979,7 @@
         </p:nvSpPr>
         <p:spPr>
           <a:xfrm>
-            <a:off x="15660000" y="21021355"/>
+            <a:off x="15660000" y="19801764"/>
             <a:ext cx="11988000" cy="504628"/>
           </a:xfrm>
           <a:prstGeom prst="rect">
@@ -9019,7 +9019,7 @@
         </p:nvSpPr>
         <p:spPr>
           <a:xfrm>
-            <a:off x="15660000" y="21561984"/>
+            <a:off x="15660000" y="20342392"/>
             <a:ext cx="2160000" cy="43200"/>
           </a:xfrm>
           <a:prstGeom prst="rect">
@@ -9062,7 +9062,7 @@
         </p:nvSpPr>
         <p:spPr>
           <a:xfrm>
-            <a:off x="15660000" y="21687984"/>
+            <a:off x="15660000" y="20468392"/>
             <a:ext cx="11988000" cy="865076"/>
           </a:xfrm>
           <a:prstGeom prst="rect">
@@ -9110,7 +9110,7 @@
         </p:blipFill>
         <p:spPr>
           <a:xfrm>
-            <a:off x="16266976" y="22661060"/>
+            <a:off x="16266976" y="21441469"/>
             <a:ext cx="2999828" cy="684000"/>
           </a:xfrm>
           <a:prstGeom prst="rect">
@@ -9134,7 +9134,7 @@
         </p:blipFill>
         <p:spPr>
           <a:xfrm>
-            <a:off x="19986804" y="22661060"/>
+            <a:off x="19986804" y="21441469"/>
             <a:ext cx="4312095" cy="684000"/>
           </a:xfrm>
           <a:prstGeom prst="rect">
@@ -9158,7 +9158,7 @@
         </p:blipFill>
         <p:spPr>
           <a:xfrm>
-            <a:off x="25018899" y="22661060"/>
+            <a:off x="25018899" y="21441469"/>
             <a:ext cx="2022124" cy="684000"/>
           </a:xfrm>
           <a:prstGeom prst="rect">
@@ -9174,7 +9174,7 @@
         </p:nvSpPr>
         <p:spPr>
           <a:xfrm>
-            <a:off x="15660000" y="23453060"/>
+            <a:off x="15660000" y="22233469"/>
             <a:ext cx="11988000" cy="1708194"/>
           </a:xfrm>
           <a:prstGeom prst="rect">
@@ -9302,8 +9302,8 @@
         </p:blipFill>
         <p:spPr>
           <a:xfrm>
-            <a:off x="17218440" y="25161255"/>
-            <a:ext cx="8871120" cy="3309620"/>
+            <a:off x="17817840" y="23941664"/>
+            <a:ext cx="7672320" cy="2862374"/>
           </a:xfrm>
           <a:prstGeom prst="rect">
             <a:avLst/>
@@ -9318,7 +9318,7 @@
         </p:nvSpPr>
         <p:spPr>
           <a:xfrm>
-            <a:off x="15660000" y="28560875"/>
+            <a:off x="15660000" y="26894038"/>
             <a:ext cx="11988000" cy="252314"/>
           </a:xfrm>
           <a:prstGeom prst="rect">
@@ -9366,8 +9366,8 @@
         </p:blipFill>
         <p:spPr>
           <a:xfrm>
-            <a:off x="15660000" y="28921189"/>
-            <a:ext cx="5179680" cy="4713815"/>
+            <a:off x="15660000" y="27254352"/>
+            <a:ext cx="4944240" cy="4499550"/>
           </a:xfrm>
           <a:prstGeom prst="rect">
             <a:avLst/>
@@ -9382,8 +9382,8 @@
         </p:nvSpPr>
         <p:spPr>
           <a:xfrm>
-            <a:off x="15660000" y="33725005"/>
-            <a:ext cx="5179680" cy="252314"/>
+            <a:off x="15660000" y="31843903"/>
+            <a:ext cx="4944240" cy="252314"/>
           </a:xfrm>
           <a:prstGeom prst="rect">
             <a:avLst/>
@@ -9422,8 +9422,8 @@
         </p:nvSpPr>
         <p:spPr>
           <a:xfrm>
-            <a:off x="21055680" y="28921189"/>
-            <a:ext cx="6592320" cy="5247702"/>
+            <a:off x="20820240" y="27393792"/>
+            <a:ext cx="6827760" cy="4670984"/>
           </a:xfrm>
           <a:prstGeom prst="rect">
             <a:avLst/>
@@ -9496,7 +9496,7 @@
                 </a:solidFill>
                 <a:latin typeface="Inter"/>
               </a:rPr>
-              <a:t> соседние эпохи и статистики короткого окна: сон «липкий», контекст соседних минут подсказывает стадию. </a:t>
+              <a:t> соседние эпохи и статистики короткого окна — контекст соседних минут. </a:t>
             </a:r>
             <a:r>
               <a:rPr sz="1600" b="1">
@@ -9514,7 +9514,7 @@
                 </a:solidFill>
                 <a:latin typeface="Inter"/>
               </a:rPr>
-              <a:t> повтор примеров бодрствования (модель переобучается на редких примерах, AUC падает) и разности соседних эпох без сглаживания (слишком шумные)</a:t>
+              <a:t> повтор примеров бодрствования (переобучение, AUC падает) и разности эпох без сглаживания (шум)</a:t>
             </a:r>
           </a:p>
           <a:p>
@@ -9593,7 +9593,7 @@
         </p:nvSpPr>
         <p:spPr>
           <a:xfrm>
-            <a:off x="15660000" y="34168892"/>
+            <a:off x="15660000" y="32204217"/>
             <a:ext cx="11988000" cy="504628"/>
           </a:xfrm>
           <a:prstGeom prst="rect">
@@ -9614,14 +9614,2101 @@
               </a:spcAft>
             </a:pPr>
             <a:r>
+              <a:rPr sz="1400" b="1">
+                <a:solidFill>
+                  <a:srgbClr val="434B9A"/>
+                </a:solidFill>
+                <a:latin typeface="Inter"/>
+              </a:rPr>
+              <a:t>Те же признаки на CatBoost и нейросети статьи</a:t>
+            </a:r>
+            <a:r>
               <a:rPr sz="1400" b="0">
                 <a:solidFill>
                   <a:srgbClr val="1F2233"/>
                 </a:solidFill>
                 <a:latin typeface="Inter"/>
               </a:rPr>
-              <a:t>Те же признаки добавлены к </a:t>
-            </a:r>
+              <a:t> — общая постановка проекта: leave-one-subject-out, порог найдёт 90% сна, время ночи — clock или cosine:</a:t>
+            </a:r>
+          </a:p>
+        </p:txBody>
+      </p:sp>
+      <p:graphicFrame>
+        <p:nvGraphicFramePr>
+          <p:cNvPr id="74" name="Table 73"/>
+          <p:cNvGraphicFramePr>
+            <a:graphicFrameLocks noGrp="1"/>
+          </p:cNvGraphicFramePr>
+          <p:nvPr/>
+        </p:nvGraphicFramePr>
+        <p:xfrm>
+          <a:off x="15660000" y="32816845"/>
+          <a:ext cx="11987999" cy="2208863"/>
+        </p:xfrm>
+        <a:graphic>
+          <a:graphicData uri="http://schemas.openxmlformats.org/drawingml/2006/table">
+            <a:tbl>
+              <a:tblPr firstRow="0" bandRow="0">
+                <a:tableStyleId>{5C22544A-7EE6-4342-B048-85BDC9FD1C3A}</a:tableStyleId>
+              </a:tblPr>
+              <a:tblGrid>
+                <a:gridCol w="2976023"/>
+                <a:gridCol w="848979"/>
+                <a:gridCol w="848979"/>
+                <a:gridCol w="1110072"/>
+                <a:gridCol w="848979"/>
+                <a:gridCol w="848979"/>
+                <a:gridCol w="848979"/>
+                <a:gridCol w="848979"/>
+                <a:gridCol w="1110072"/>
+                <a:gridCol w="848979"/>
+                <a:gridCol w="848979"/>
+              </a:tblGrid>
+              <a:tr h="306269">
+                <a:tc>
+                  <a:txBody>
+                    <a:bodyPr wrap="square"/>
+                    <a:lstStyle/>
+                    <a:p/>
+                  </a:txBody>
+                  <a:tcPr marL="64800" marR="64800" marT="21600" marB="21600" anchor="ctr">
+                    <a:solidFill>
+                      <a:srgbClr val="FFFFFF"/>
+                    </a:solidFill>
+                  </a:tcPr>
+                </a:tc>
+                <a:tc gridSpan="5">
+                  <a:txBody>
+                    <a:bodyPr wrap="square"/>
+                    <a:lstStyle/>
+                    <a:p>
+                      <a:pPr algn="ctr">
+                        <a:lnSpc>
+                          <a:spcPct val="110000"/>
+                        </a:lnSpc>
+                        <a:spcAft>
+                          <a:spcPts val="0"/>
+                        </a:spcAft>
+                      </a:pPr>
+                      <a:r>
+                        <a:rPr sz="1200" b="1">
+                          <a:solidFill>
+                            <a:srgbClr val="FFFFFF"/>
+                          </a:solidFill>
+                          <a:latin typeface="Inter"/>
+                        </a:rPr>
+                        <a:t>Без быстрых признаков</a:t>
+                      </a:r>
+                    </a:p>
+                  </a:txBody>
+                  <a:tcPr marL="64800" marR="64800" marT="21600" marB="21600" anchor="ctr">
+                    <a:solidFill>
+                      <a:srgbClr val="2E3473"/>
+                    </a:solidFill>
+                  </a:tcPr>
+                </a:tc>
+                <a:tc hMerge="1">
+                  <a:txBody>
+                    <a:bodyPr/>
+                    <a:lstStyle/>
+                    <a:p/>
+                  </a:txBody>
+                  <a:tcPr/>
+                </a:tc>
+                <a:tc hMerge="1">
+                  <a:txBody>
+                    <a:bodyPr/>
+                    <a:lstStyle/>
+                    <a:p/>
+                  </a:txBody>
+                  <a:tcPr/>
+                </a:tc>
+                <a:tc hMerge="1">
+                  <a:txBody>
+                    <a:bodyPr/>
+                    <a:lstStyle/>
+                    <a:p/>
+                  </a:txBody>
+                  <a:tcPr/>
+                </a:tc>
+                <a:tc hMerge="1">
+                  <a:txBody>
+                    <a:bodyPr/>
+                    <a:lstStyle/>
+                    <a:p/>
+                  </a:txBody>
+                  <a:tcPr/>
+                </a:tc>
+                <a:tc gridSpan="5">
+                  <a:txBody>
+                    <a:bodyPr wrap="square"/>
+                    <a:lstStyle/>
+                    <a:p>
+                      <a:pPr algn="ctr">
+                        <a:lnSpc>
+                          <a:spcPct val="110000"/>
+                        </a:lnSpc>
+                        <a:spcAft>
+                          <a:spcPts val="0"/>
+                        </a:spcAft>
+                      </a:pPr>
+                      <a:r>
+                        <a:rPr sz="1200" b="1">
+                          <a:solidFill>
+                            <a:srgbClr val="FFFFFF"/>
+                          </a:solidFill>
+                          <a:latin typeface="Inter"/>
+                        </a:rPr>
+                        <a:t>С быстрыми признаками</a:t>
+                      </a:r>
+                    </a:p>
+                  </a:txBody>
+                  <a:tcPr marL="64800" marR="64800" marT="21600" marB="21600" anchor="ctr">
+                    <a:solidFill>
+                      <a:srgbClr val="2E3473"/>
+                    </a:solidFill>
+                  </a:tcPr>
+                </a:tc>
+                <a:tc hMerge="1">
+                  <a:txBody>
+                    <a:bodyPr/>
+                    <a:lstStyle/>
+                    <a:p/>
+                  </a:txBody>
+                  <a:tcPr/>
+                </a:tc>
+                <a:tc hMerge="1">
+                  <a:txBody>
+                    <a:bodyPr/>
+                    <a:lstStyle/>
+                    <a:p/>
+                  </a:txBody>
+                  <a:tcPr/>
+                </a:tc>
+                <a:tc hMerge="1">
+                  <a:txBody>
+                    <a:bodyPr/>
+                    <a:lstStyle/>
+                    <a:p/>
+                  </a:txBody>
+                  <a:tcPr/>
+                </a:tc>
+                <a:tc hMerge="1">
+                  <a:txBody>
+                    <a:bodyPr/>
+                    <a:lstStyle/>
+                    <a:p/>
+                  </a:txBody>
+                  <a:tcPr/>
+                </a:tc>
+              </a:tr>
+              <a:tr h="576538">
+                <a:tc>
+                  <a:txBody>
+                    <a:bodyPr wrap="square"/>
+                    <a:lstStyle/>
+                    <a:p>
+                      <a:pPr algn="l">
+                        <a:lnSpc>
+                          <a:spcPct val="110000"/>
+                        </a:lnSpc>
+                        <a:spcAft>
+                          <a:spcPts val="0"/>
+                        </a:spcAft>
+                      </a:pPr>
+                      <a:r>
+                        <a:rPr sz="1200" b="1">
+                          <a:solidFill>
+                            <a:srgbClr val="FFFFFF"/>
+                          </a:solidFill>
+                          <a:latin typeface="Inter"/>
+                        </a:rPr>
+                        <a:t>Модель · время</a:t>
+                      </a:r>
+                    </a:p>
+                    <a:p>
+                      <a:pPr algn="l">
+                        <a:lnSpc>
+                          <a:spcPct val="110000"/>
+                        </a:lnSpc>
+                        <a:spcAft>
+                          <a:spcPts val="0"/>
+                        </a:spcAft>
+                      </a:pPr>
+                      <a:r>
+                        <a:rPr sz="1200" b="1">
+                          <a:solidFill>
+                            <a:srgbClr val="FFFFFF"/>
+                          </a:solidFill>
+                          <a:latin typeface="Inter"/>
+                        </a:rPr>
+                        <a:t>ночи</a:t>
+                      </a:r>
+                    </a:p>
+                  </a:txBody>
+                  <a:tcPr marL="64800" marR="64800" marT="21600" marB="21600" anchor="ctr">
+                    <a:solidFill>
+                      <a:srgbClr val="434B9A"/>
+                    </a:solidFill>
+                  </a:tcPr>
+                </a:tc>
+                <a:tc>
+                  <a:txBody>
+                    <a:bodyPr wrap="square"/>
+                    <a:lstStyle/>
+                    <a:p>
+                      <a:pPr algn="ctr">
+                        <a:lnSpc>
+                          <a:spcPct val="110000"/>
+                        </a:lnSpc>
+                        <a:spcAft>
+                          <a:spcPts val="0"/>
+                        </a:spcAft>
+                      </a:pPr>
+                      <a:r>
+                        <a:rPr sz="1200" b="1">
+                          <a:solidFill>
+                            <a:srgbClr val="FFFFFF"/>
+                          </a:solidFill>
+                          <a:latin typeface="Inter"/>
+                        </a:rPr>
+                        <a:t> </a:t>
+                      </a:r>
+                    </a:p>
+                    <a:p>
+                      <a:pPr algn="ctr">
+                        <a:lnSpc>
+                          <a:spcPct val="110000"/>
+                        </a:lnSpc>
+                        <a:spcAft>
+                          <a:spcPts val="0"/>
+                        </a:spcAft>
+                      </a:pPr>
+                      <a:r>
+                        <a:rPr sz="1200" b="1">
+                          <a:solidFill>
+                            <a:srgbClr val="FFFFFF"/>
+                          </a:solidFill>
+                          <a:latin typeface="Inter"/>
+                        </a:rPr>
+                        <a:t>AUC</a:t>
+                      </a:r>
+                    </a:p>
+                  </a:txBody>
+                  <a:tcPr marL="64800" marR="64800" marT="21600" marB="21600" anchor="ctr">
+                    <a:solidFill>
+                      <a:srgbClr val="434B9A"/>
+                    </a:solidFill>
+                  </a:tcPr>
+                </a:tc>
+                <a:tc>
+                  <a:txBody>
+                    <a:bodyPr wrap="square"/>
+                    <a:lstStyle/>
+                    <a:p>
+                      <a:pPr algn="ctr">
+                        <a:lnSpc>
+                          <a:spcPct val="110000"/>
+                        </a:lnSpc>
+                        <a:spcAft>
+                          <a:spcPts val="0"/>
+                        </a:spcAft>
+                      </a:pPr>
+                      <a:r>
+                        <a:rPr sz="1200" b="1">
+                          <a:solidFill>
+                            <a:srgbClr val="FFFFFF"/>
+                          </a:solidFill>
+                          <a:latin typeface="Inter"/>
+                        </a:rPr>
+                        <a:t>AP</a:t>
+                      </a:r>
+                    </a:p>
+                    <a:p>
+                      <a:pPr algn="ctr">
+                        <a:lnSpc>
+                          <a:spcPct val="110000"/>
+                        </a:lnSpc>
+                        <a:spcAft>
+                          <a:spcPts val="0"/>
+                        </a:spcAft>
+                      </a:pPr>
+                      <a:r>
+                        <a:rPr sz="1200" b="1">
+                          <a:solidFill>
+                            <a:srgbClr val="FFFFFF"/>
+                          </a:solidFill>
+                          <a:latin typeface="Inter"/>
+                        </a:rPr>
+                        <a:t>wake</a:t>
+                      </a:r>
+                    </a:p>
+                  </a:txBody>
+                  <a:tcPr marL="64800" marR="64800" marT="21600" marB="21600" anchor="ctr">
+                    <a:solidFill>
+                      <a:srgbClr val="434B9A"/>
+                    </a:solidFill>
+                  </a:tcPr>
+                </a:tc>
+                <a:tc>
+                  <a:txBody>
+                    <a:bodyPr wrap="square"/>
+                    <a:lstStyle/>
+                    <a:p>
+                      <a:pPr algn="ctr">
+                        <a:lnSpc>
+                          <a:spcPct val="110000"/>
+                        </a:lnSpc>
+                        <a:spcAft>
+                          <a:spcPts val="0"/>
+                        </a:spcAft>
+                      </a:pPr>
+                      <a:r>
+                        <a:rPr sz="1200" b="1">
+                          <a:solidFill>
+                            <a:srgbClr val="FFFFFF"/>
+                          </a:solidFill>
+                          <a:latin typeface="Inter"/>
+                        </a:rPr>
+                        <a:t>Найдено</a:t>
+                      </a:r>
+                    </a:p>
+                    <a:p>
+                      <a:pPr algn="ctr">
+                        <a:lnSpc>
+                          <a:spcPct val="110000"/>
+                        </a:lnSpc>
+                        <a:spcAft>
+                          <a:spcPts val="0"/>
+                        </a:spcAft>
+                      </a:pPr>
+                      <a:r>
+                        <a:rPr sz="1200" b="1">
+                          <a:solidFill>
+                            <a:srgbClr val="FFFFFF"/>
+                          </a:solidFill>
+                          <a:latin typeface="Inter"/>
+                        </a:rPr>
+                        <a:t>wake</a:t>
+                      </a:r>
+                    </a:p>
+                  </a:txBody>
+                  <a:tcPr marL="64800" marR="64800" marT="21600" marB="21600" anchor="ctr">
+                    <a:solidFill>
+                      <a:srgbClr val="434B9A"/>
+                    </a:solidFill>
+                  </a:tcPr>
+                </a:tc>
+                <a:tc>
+                  <a:txBody>
+                    <a:bodyPr wrap="square"/>
+                    <a:lstStyle/>
+                    <a:p>
+                      <a:pPr algn="ctr">
+                        <a:lnSpc>
+                          <a:spcPct val="110000"/>
+                        </a:lnSpc>
+                        <a:spcAft>
+                          <a:spcPts val="0"/>
+                        </a:spcAft>
+                      </a:pPr>
+                      <a:r>
+                        <a:rPr sz="1200" b="1">
+                          <a:solidFill>
+                            <a:srgbClr val="FFFFFF"/>
+                          </a:solidFill>
+                          <a:latin typeface="Inter"/>
+                        </a:rPr>
+                        <a:t> </a:t>
+                      </a:r>
+                    </a:p>
+                    <a:p>
+                      <a:pPr algn="ctr">
+                        <a:lnSpc>
+                          <a:spcPct val="110000"/>
+                        </a:lnSpc>
+                        <a:spcAft>
+                          <a:spcPts val="0"/>
+                        </a:spcAft>
+                      </a:pPr>
+                      <a:r>
+                        <a:rPr sz="1200" b="1">
+                          <a:solidFill>
+                            <a:srgbClr val="FFFFFF"/>
+                          </a:solidFill>
+                          <a:latin typeface="Inter"/>
+                        </a:rPr>
+                        <a:t>κ</a:t>
+                      </a:r>
+                    </a:p>
+                  </a:txBody>
+                  <a:tcPr marL="64800" marR="64800" marT="21600" marB="21600" anchor="ctr">
+                    <a:solidFill>
+                      <a:srgbClr val="434B9A"/>
+                    </a:solidFill>
+                  </a:tcPr>
+                </a:tc>
+                <a:tc>
+                  <a:txBody>
+                    <a:bodyPr wrap="square"/>
+                    <a:lstStyle/>
+                    <a:p>
+                      <a:pPr algn="ctr">
+                        <a:lnSpc>
+                          <a:spcPct val="110000"/>
+                        </a:lnSpc>
+                        <a:spcAft>
+                          <a:spcPts val="0"/>
+                        </a:spcAft>
+                      </a:pPr>
+                      <a:r>
+                        <a:rPr sz="1200" b="1">
+                          <a:solidFill>
+                            <a:srgbClr val="FFFFFF"/>
+                          </a:solidFill>
+                          <a:latin typeface="Inter"/>
+                        </a:rPr>
+                        <a:t>F1</a:t>
+                      </a:r>
+                    </a:p>
+                    <a:p>
+                      <a:pPr algn="ctr">
+                        <a:lnSpc>
+                          <a:spcPct val="110000"/>
+                        </a:lnSpc>
+                        <a:spcAft>
+                          <a:spcPts val="0"/>
+                        </a:spcAft>
+                      </a:pPr>
+                      <a:r>
+                        <a:rPr sz="1200" b="1">
+                          <a:solidFill>
+                            <a:srgbClr val="FFFFFF"/>
+                          </a:solidFill>
+                          <a:latin typeface="Inter"/>
+                        </a:rPr>
+                        <a:t>wake</a:t>
+                      </a:r>
+                    </a:p>
+                  </a:txBody>
+                  <a:tcPr marL="64800" marR="64800" marT="21600" marB="21600" anchor="ctr">
+                    <a:solidFill>
+                      <a:srgbClr val="434B9A"/>
+                    </a:solidFill>
+                  </a:tcPr>
+                </a:tc>
+                <a:tc>
+                  <a:txBody>
+                    <a:bodyPr wrap="square"/>
+                    <a:lstStyle/>
+                    <a:p>
+                      <a:pPr algn="ctr">
+                        <a:lnSpc>
+                          <a:spcPct val="110000"/>
+                        </a:lnSpc>
+                        <a:spcAft>
+                          <a:spcPts val="0"/>
+                        </a:spcAft>
+                      </a:pPr>
+                      <a:r>
+                        <a:rPr sz="1200" b="1">
+                          <a:solidFill>
+                            <a:srgbClr val="FFFFFF"/>
+                          </a:solidFill>
+                          <a:latin typeface="Inter"/>
+                        </a:rPr>
+                        <a:t> </a:t>
+                      </a:r>
+                    </a:p>
+                    <a:p>
+                      <a:pPr algn="ctr">
+                        <a:lnSpc>
+                          <a:spcPct val="110000"/>
+                        </a:lnSpc>
+                        <a:spcAft>
+                          <a:spcPts val="0"/>
+                        </a:spcAft>
+                      </a:pPr>
+                      <a:r>
+                        <a:rPr sz="1200" b="1">
+                          <a:solidFill>
+                            <a:srgbClr val="FFFFFF"/>
+                          </a:solidFill>
+                          <a:latin typeface="Inter"/>
+                        </a:rPr>
+                        <a:t>AUC</a:t>
+                      </a:r>
+                    </a:p>
+                  </a:txBody>
+                  <a:tcPr marL="64800" marR="64800" marT="21600" marB="21600" anchor="ctr">
+                    <a:solidFill>
+                      <a:srgbClr val="434B9A"/>
+                    </a:solidFill>
+                  </a:tcPr>
+                </a:tc>
+                <a:tc>
+                  <a:txBody>
+                    <a:bodyPr wrap="square"/>
+                    <a:lstStyle/>
+                    <a:p>
+                      <a:pPr algn="ctr">
+                        <a:lnSpc>
+                          <a:spcPct val="110000"/>
+                        </a:lnSpc>
+                        <a:spcAft>
+                          <a:spcPts val="0"/>
+                        </a:spcAft>
+                      </a:pPr>
+                      <a:r>
+                        <a:rPr sz="1200" b="1">
+                          <a:solidFill>
+                            <a:srgbClr val="FFFFFF"/>
+                          </a:solidFill>
+                          <a:latin typeface="Inter"/>
+                        </a:rPr>
+                        <a:t>AP</a:t>
+                      </a:r>
+                    </a:p>
+                    <a:p>
+                      <a:pPr algn="ctr">
+                        <a:lnSpc>
+                          <a:spcPct val="110000"/>
+                        </a:lnSpc>
+                        <a:spcAft>
+                          <a:spcPts val="0"/>
+                        </a:spcAft>
+                      </a:pPr>
+                      <a:r>
+                        <a:rPr sz="1200" b="1">
+                          <a:solidFill>
+                            <a:srgbClr val="FFFFFF"/>
+                          </a:solidFill>
+                          <a:latin typeface="Inter"/>
+                        </a:rPr>
+                        <a:t>wake</a:t>
+                      </a:r>
+                    </a:p>
+                  </a:txBody>
+                  <a:tcPr marL="64800" marR="64800" marT="21600" marB="21600" anchor="ctr">
+                    <a:solidFill>
+                      <a:srgbClr val="434B9A"/>
+                    </a:solidFill>
+                  </a:tcPr>
+                </a:tc>
+                <a:tc>
+                  <a:txBody>
+                    <a:bodyPr wrap="square"/>
+                    <a:lstStyle/>
+                    <a:p>
+                      <a:pPr algn="ctr">
+                        <a:lnSpc>
+                          <a:spcPct val="110000"/>
+                        </a:lnSpc>
+                        <a:spcAft>
+                          <a:spcPts val="0"/>
+                        </a:spcAft>
+                      </a:pPr>
+                      <a:r>
+                        <a:rPr sz="1200" b="1">
+                          <a:solidFill>
+                            <a:srgbClr val="FFFFFF"/>
+                          </a:solidFill>
+                          <a:latin typeface="Inter"/>
+                        </a:rPr>
+                        <a:t>Найдено</a:t>
+                      </a:r>
+                    </a:p>
+                    <a:p>
+                      <a:pPr algn="ctr">
+                        <a:lnSpc>
+                          <a:spcPct val="110000"/>
+                        </a:lnSpc>
+                        <a:spcAft>
+                          <a:spcPts val="0"/>
+                        </a:spcAft>
+                      </a:pPr>
+                      <a:r>
+                        <a:rPr sz="1200" b="1">
+                          <a:solidFill>
+                            <a:srgbClr val="FFFFFF"/>
+                          </a:solidFill>
+                          <a:latin typeface="Inter"/>
+                        </a:rPr>
+                        <a:t>wake</a:t>
+                      </a:r>
+                    </a:p>
+                  </a:txBody>
+                  <a:tcPr marL="64800" marR="64800" marT="21600" marB="21600" anchor="ctr">
+                    <a:solidFill>
+                      <a:srgbClr val="434B9A"/>
+                    </a:solidFill>
+                  </a:tcPr>
+                </a:tc>
+                <a:tc>
+                  <a:txBody>
+                    <a:bodyPr wrap="square"/>
+                    <a:lstStyle/>
+                    <a:p>
+                      <a:pPr algn="ctr">
+                        <a:lnSpc>
+                          <a:spcPct val="110000"/>
+                        </a:lnSpc>
+                        <a:spcAft>
+                          <a:spcPts val="0"/>
+                        </a:spcAft>
+                      </a:pPr>
+                      <a:r>
+                        <a:rPr sz="1200" b="1">
+                          <a:solidFill>
+                            <a:srgbClr val="FFFFFF"/>
+                          </a:solidFill>
+                          <a:latin typeface="Inter"/>
+                        </a:rPr>
+                        <a:t> </a:t>
+                      </a:r>
+                    </a:p>
+                    <a:p>
+                      <a:pPr algn="ctr">
+                        <a:lnSpc>
+                          <a:spcPct val="110000"/>
+                        </a:lnSpc>
+                        <a:spcAft>
+                          <a:spcPts val="0"/>
+                        </a:spcAft>
+                      </a:pPr>
+                      <a:r>
+                        <a:rPr sz="1200" b="1">
+                          <a:solidFill>
+                            <a:srgbClr val="FFFFFF"/>
+                          </a:solidFill>
+                          <a:latin typeface="Inter"/>
+                        </a:rPr>
+                        <a:t>κ</a:t>
+                      </a:r>
+                    </a:p>
+                  </a:txBody>
+                  <a:tcPr marL="64800" marR="64800" marT="21600" marB="21600" anchor="ctr">
+                    <a:solidFill>
+                      <a:srgbClr val="434B9A"/>
+                    </a:solidFill>
+                  </a:tcPr>
+                </a:tc>
+                <a:tc>
+                  <a:txBody>
+                    <a:bodyPr wrap="square"/>
+                    <a:lstStyle/>
+                    <a:p>
+                      <a:pPr algn="ctr">
+                        <a:lnSpc>
+                          <a:spcPct val="110000"/>
+                        </a:lnSpc>
+                        <a:spcAft>
+                          <a:spcPts val="0"/>
+                        </a:spcAft>
+                      </a:pPr>
+                      <a:r>
+                        <a:rPr sz="1200" b="1">
+                          <a:solidFill>
+                            <a:srgbClr val="FFFFFF"/>
+                          </a:solidFill>
+                          <a:latin typeface="Inter"/>
+                        </a:rPr>
+                        <a:t>F1</a:t>
+                      </a:r>
+                    </a:p>
+                    <a:p>
+                      <a:pPr algn="ctr">
+                        <a:lnSpc>
+                          <a:spcPct val="110000"/>
+                        </a:lnSpc>
+                        <a:spcAft>
+                          <a:spcPts val="0"/>
+                        </a:spcAft>
+                      </a:pPr>
+                      <a:r>
+                        <a:rPr sz="1200" b="1">
+                          <a:solidFill>
+                            <a:srgbClr val="FFFFFF"/>
+                          </a:solidFill>
+                          <a:latin typeface="Inter"/>
+                        </a:rPr>
+                        <a:t>wake</a:t>
+                      </a:r>
+                    </a:p>
+                  </a:txBody>
+                  <a:tcPr marL="64800" marR="64800" marT="21600" marB="21600" anchor="ctr">
+                    <a:solidFill>
+                      <a:srgbClr val="434B9A"/>
+                    </a:solidFill>
+                  </a:tcPr>
+                </a:tc>
+              </a:tr>
+              <a:tr h="331514">
+                <a:tc>
+                  <a:txBody>
+                    <a:bodyPr wrap="square"/>
+                    <a:lstStyle/>
+                    <a:p>
+                      <a:pPr algn="l">
+                        <a:lnSpc>
+                          <a:spcPct val="110000"/>
+                        </a:lnSpc>
+                        <a:spcAft>
+                          <a:spcPts val="0"/>
+                        </a:spcAft>
+                      </a:pPr>
+                      <a:r>
+                        <a:rPr sz="1400" b="0">
+                          <a:solidFill>
+                            <a:srgbClr val="1F2233"/>
+                          </a:solidFill>
+                          <a:latin typeface="Inter"/>
+                        </a:rPr>
+                        <a:t>CatBoost · clock</a:t>
+                      </a:r>
+                    </a:p>
+                  </a:txBody>
+                  <a:tcPr marL="64800" marR="64800" marT="21600" marB="21600" anchor="ctr">
+                    <a:solidFill>
+                      <a:srgbClr val="FFFFFF"/>
+                    </a:solidFill>
+                  </a:tcPr>
+                </a:tc>
+                <a:tc>
+                  <a:txBody>
+                    <a:bodyPr wrap="square"/>
+                    <a:lstStyle/>
+                    <a:p>
+                      <a:pPr algn="ctr">
+                        <a:lnSpc>
+                          <a:spcPct val="110000"/>
+                        </a:lnSpc>
+                        <a:spcAft>
+                          <a:spcPts val="0"/>
+                        </a:spcAft>
+                      </a:pPr>
+                      <a:r>
+                        <a:rPr sz="1400" b="0">
+                          <a:solidFill>
+                            <a:srgbClr val="1F2233"/>
+                          </a:solidFill>
+                          <a:latin typeface="Inter"/>
+                        </a:rPr>
+                        <a:t>0.880</a:t>
+                      </a:r>
+                    </a:p>
+                  </a:txBody>
+                  <a:tcPr marL="64800" marR="64800" marT="21600" marB="21600" anchor="ctr">
+                    <a:solidFill>
+                      <a:srgbClr val="FFFFFF"/>
+                    </a:solidFill>
+                  </a:tcPr>
+                </a:tc>
+                <a:tc>
+                  <a:txBody>
+                    <a:bodyPr wrap="square"/>
+                    <a:lstStyle/>
+                    <a:p>
+                      <a:pPr algn="ctr">
+                        <a:lnSpc>
+                          <a:spcPct val="110000"/>
+                        </a:lnSpc>
+                        <a:spcAft>
+                          <a:spcPts val="0"/>
+                        </a:spcAft>
+                      </a:pPr>
+                      <a:r>
+                        <a:rPr sz="1400" b="0">
+                          <a:solidFill>
+                            <a:srgbClr val="1F2233"/>
+                          </a:solidFill>
+                          <a:latin typeface="Inter"/>
+                        </a:rPr>
+                        <a:t>0.547</a:t>
+                      </a:r>
+                    </a:p>
+                  </a:txBody>
+                  <a:tcPr marL="64800" marR="64800" marT="21600" marB="21600" anchor="ctr">
+                    <a:solidFill>
+                      <a:srgbClr val="FFFFFF"/>
+                    </a:solidFill>
+                  </a:tcPr>
+                </a:tc>
+                <a:tc>
+                  <a:txBody>
+                    <a:bodyPr wrap="square"/>
+                    <a:lstStyle/>
+                    <a:p>
+                      <a:pPr algn="ctr">
+                        <a:lnSpc>
+                          <a:spcPct val="110000"/>
+                        </a:lnSpc>
+                        <a:spcAft>
+                          <a:spcPts val="0"/>
+                        </a:spcAft>
+                      </a:pPr>
+                      <a:r>
+                        <a:rPr sz="1400" b="0">
+                          <a:solidFill>
+                            <a:srgbClr val="1F2233"/>
+                          </a:solidFill>
+                          <a:latin typeface="Inter"/>
+                        </a:rPr>
+                        <a:t>0.680</a:t>
+                      </a:r>
+                    </a:p>
+                  </a:txBody>
+                  <a:tcPr marL="64800" marR="64800" marT="21600" marB="21600" anchor="ctr">
+                    <a:solidFill>
+                      <a:srgbClr val="FFFFFF"/>
+                    </a:solidFill>
+                  </a:tcPr>
+                </a:tc>
+                <a:tc>
+                  <a:txBody>
+                    <a:bodyPr wrap="square"/>
+                    <a:lstStyle/>
+                    <a:p>
+                      <a:pPr algn="ctr">
+                        <a:lnSpc>
+                          <a:spcPct val="110000"/>
+                        </a:lnSpc>
+                        <a:spcAft>
+                          <a:spcPts val="0"/>
+                        </a:spcAft>
+                      </a:pPr>
+                      <a:r>
+                        <a:rPr sz="1400" b="0">
+                          <a:solidFill>
+                            <a:srgbClr val="1F2233"/>
+                          </a:solidFill>
+                          <a:latin typeface="Inter"/>
+                        </a:rPr>
+                        <a:t>0.431</a:t>
+                      </a:r>
+                    </a:p>
+                  </a:txBody>
+                  <a:tcPr marL="64800" marR="64800" marT="21600" marB="21600" anchor="ctr">
+                    <a:solidFill>
+                      <a:srgbClr val="FFFFFF"/>
+                    </a:solidFill>
+                  </a:tcPr>
+                </a:tc>
+                <a:tc>
+                  <a:txBody>
+                    <a:bodyPr wrap="square"/>
+                    <a:lstStyle/>
+                    <a:p>
+                      <a:pPr algn="ctr">
+                        <a:lnSpc>
+                          <a:spcPct val="110000"/>
+                        </a:lnSpc>
+                        <a:spcAft>
+                          <a:spcPts val="0"/>
+                        </a:spcAft>
+                      </a:pPr>
+                      <a:r>
+                        <a:rPr sz="1400" b="0">
+                          <a:solidFill>
+                            <a:srgbClr val="1F2233"/>
+                          </a:solidFill>
+                          <a:latin typeface="Inter"/>
+                        </a:rPr>
+                        <a:t>0.492</a:t>
+                      </a:r>
+                    </a:p>
+                  </a:txBody>
+                  <a:tcPr marL="64800" marR="64800" marT="21600" marB="21600" anchor="ctr">
+                    <a:solidFill>
+                      <a:srgbClr val="FFFFFF"/>
+                    </a:solidFill>
+                  </a:tcPr>
+                </a:tc>
+                <a:tc>
+                  <a:txBody>
+                    <a:bodyPr wrap="square"/>
+                    <a:lstStyle/>
+                    <a:p>
+                      <a:pPr algn="ctr">
+                        <a:lnSpc>
+                          <a:spcPct val="110000"/>
+                        </a:lnSpc>
+                        <a:spcAft>
+                          <a:spcPts val="0"/>
+                        </a:spcAft>
+                      </a:pPr>
+                      <a:r>
+                        <a:rPr sz="1400" b="0">
+                          <a:solidFill>
+                            <a:srgbClr val="1F2233"/>
+                          </a:solidFill>
+                          <a:latin typeface="Inter"/>
+                        </a:rPr>
+                        <a:t>0.890</a:t>
+                      </a:r>
+                    </a:p>
+                  </a:txBody>
+                  <a:tcPr marL="64800" marR="64800" marT="21600" marB="21600" anchor="ctr">
+                    <a:solidFill>
+                      <a:srgbClr val="FFFFFF"/>
+                    </a:solidFill>
+                  </a:tcPr>
+                </a:tc>
+                <a:tc>
+                  <a:txBody>
+                    <a:bodyPr wrap="square"/>
+                    <a:lstStyle/>
+                    <a:p>
+                      <a:pPr algn="ctr">
+                        <a:lnSpc>
+                          <a:spcPct val="110000"/>
+                        </a:lnSpc>
+                        <a:spcAft>
+                          <a:spcPts val="0"/>
+                        </a:spcAft>
+                      </a:pPr>
+                      <a:r>
+                        <a:rPr sz="1400" b="0">
+                          <a:solidFill>
+                            <a:srgbClr val="1F2233"/>
+                          </a:solidFill>
+                          <a:latin typeface="Inter"/>
+                        </a:rPr>
+                        <a:t>0.585</a:t>
+                      </a:r>
+                    </a:p>
+                  </a:txBody>
+                  <a:tcPr marL="64800" marR="64800" marT="21600" marB="21600" anchor="ctr">
+                    <a:solidFill>
+                      <a:srgbClr val="FFFFFF"/>
+                    </a:solidFill>
+                  </a:tcPr>
+                </a:tc>
+                <a:tc>
+                  <a:txBody>
+                    <a:bodyPr wrap="square"/>
+                    <a:lstStyle/>
+                    <a:p>
+                      <a:pPr algn="ctr">
+                        <a:lnSpc>
+                          <a:spcPct val="110000"/>
+                        </a:lnSpc>
+                        <a:spcAft>
+                          <a:spcPts val="0"/>
+                        </a:spcAft>
+                      </a:pPr>
+                      <a:r>
+                        <a:rPr sz="1400" b="0">
+                          <a:solidFill>
+                            <a:srgbClr val="1F2233"/>
+                          </a:solidFill>
+                          <a:latin typeface="Inter"/>
+                        </a:rPr>
+                        <a:t>0.709</a:t>
+                      </a:r>
+                    </a:p>
+                  </a:txBody>
+                  <a:tcPr marL="64800" marR="64800" marT="21600" marB="21600" anchor="ctr">
+                    <a:solidFill>
+                      <a:srgbClr val="FFFFFF"/>
+                    </a:solidFill>
+                  </a:tcPr>
+                </a:tc>
+                <a:tc>
+                  <a:txBody>
+                    <a:bodyPr wrap="square"/>
+                    <a:lstStyle/>
+                    <a:p>
+                      <a:pPr algn="ctr">
+                        <a:lnSpc>
+                          <a:spcPct val="110000"/>
+                        </a:lnSpc>
+                        <a:spcAft>
+                          <a:spcPts val="0"/>
+                        </a:spcAft>
+                      </a:pPr>
+                      <a:r>
+                        <a:rPr sz="1400" b="0">
+                          <a:solidFill>
+                            <a:srgbClr val="1F2233"/>
+                          </a:solidFill>
+                          <a:latin typeface="Inter"/>
+                        </a:rPr>
+                        <a:t>0.448</a:t>
+                      </a:r>
+                    </a:p>
+                  </a:txBody>
+                  <a:tcPr marL="64800" marR="64800" marT="21600" marB="21600" anchor="ctr">
+                    <a:solidFill>
+                      <a:srgbClr val="FFFFFF"/>
+                    </a:solidFill>
+                  </a:tcPr>
+                </a:tc>
+                <a:tc>
+                  <a:txBody>
+                    <a:bodyPr wrap="square"/>
+                    <a:lstStyle/>
+                    <a:p>
+                      <a:pPr algn="ctr">
+                        <a:lnSpc>
+                          <a:spcPct val="110000"/>
+                        </a:lnSpc>
+                        <a:spcAft>
+                          <a:spcPts val="0"/>
+                        </a:spcAft>
+                      </a:pPr>
+                      <a:r>
+                        <a:rPr sz="1400" b="0">
+                          <a:solidFill>
+                            <a:srgbClr val="1F2233"/>
+                          </a:solidFill>
+                          <a:latin typeface="Inter"/>
+                        </a:rPr>
+                        <a:t>0.508</a:t>
+                      </a:r>
+                    </a:p>
+                  </a:txBody>
+                  <a:tcPr marL="64800" marR="64800" marT="21600" marB="21600" anchor="ctr">
+                    <a:solidFill>
+                      <a:srgbClr val="FFFFFF"/>
+                    </a:solidFill>
+                  </a:tcPr>
+                </a:tc>
+              </a:tr>
+              <a:tr h="331514">
+                <a:tc>
+                  <a:txBody>
+                    <a:bodyPr wrap="square"/>
+                    <a:lstStyle/>
+                    <a:p>
+                      <a:pPr algn="l">
+                        <a:lnSpc>
+                          <a:spcPct val="110000"/>
+                        </a:lnSpc>
+                        <a:spcAft>
+                          <a:spcPts val="0"/>
+                        </a:spcAft>
+                      </a:pPr>
+                      <a:r>
+                        <a:rPr sz="1400" b="0">
+                          <a:solidFill>
+                            <a:srgbClr val="1F2233"/>
+                          </a:solidFill>
+                          <a:latin typeface="Inter"/>
+                        </a:rPr>
+                        <a:t>CatBoost · cosine</a:t>
+                      </a:r>
+                    </a:p>
+                  </a:txBody>
+                  <a:tcPr marL="64800" marR="64800" marT="21600" marB="21600" anchor="ctr">
+                    <a:solidFill>
+                      <a:srgbClr val="F1F2FA"/>
+                    </a:solidFill>
+                  </a:tcPr>
+                </a:tc>
+                <a:tc>
+                  <a:txBody>
+                    <a:bodyPr wrap="square"/>
+                    <a:lstStyle/>
+                    <a:p>
+                      <a:pPr algn="ctr">
+                        <a:lnSpc>
+                          <a:spcPct val="110000"/>
+                        </a:lnSpc>
+                        <a:spcAft>
+                          <a:spcPts val="0"/>
+                        </a:spcAft>
+                      </a:pPr>
+                      <a:r>
+                        <a:rPr sz="1400" b="0">
+                          <a:solidFill>
+                            <a:srgbClr val="1F2233"/>
+                          </a:solidFill>
+                          <a:latin typeface="Inter"/>
+                        </a:rPr>
+                        <a:t>0.877</a:t>
+                      </a:r>
+                    </a:p>
+                  </a:txBody>
+                  <a:tcPr marL="64800" marR="64800" marT="21600" marB="21600" anchor="ctr">
+                    <a:solidFill>
+                      <a:srgbClr val="F1F2FA"/>
+                    </a:solidFill>
+                  </a:tcPr>
+                </a:tc>
+                <a:tc>
+                  <a:txBody>
+                    <a:bodyPr wrap="square"/>
+                    <a:lstStyle/>
+                    <a:p>
+                      <a:pPr algn="ctr">
+                        <a:lnSpc>
+                          <a:spcPct val="110000"/>
+                        </a:lnSpc>
+                        <a:spcAft>
+                          <a:spcPts val="0"/>
+                        </a:spcAft>
+                      </a:pPr>
+                      <a:r>
+                        <a:rPr sz="1400" b="0">
+                          <a:solidFill>
+                            <a:srgbClr val="1F2233"/>
+                          </a:solidFill>
+                          <a:latin typeface="Inter"/>
+                        </a:rPr>
+                        <a:t>0.593</a:t>
+                      </a:r>
+                    </a:p>
+                  </a:txBody>
+                  <a:tcPr marL="64800" marR="64800" marT="21600" marB="21600" anchor="ctr">
+                    <a:solidFill>
+                      <a:srgbClr val="F1F2FA"/>
+                    </a:solidFill>
+                  </a:tcPr>
+                </a:tc>
+                <a:tc>
+                  <a:txBody>
+                    <a:bodyPr wrap="square"/>
+                    <a:lstStyle/>
+                    <a:p>
+                      <a:pPr algn="ctr">
+                        <a:lnSpc>
+                          <a:spcPct val="110000"/>
+                        </a:lnSpc>
+                        <a:spcAft>
+                          <a:spcPts val="0"/>
+                        </a:spcAft>
+                      </a:pPr>
+                      <a:r>
+                        <a:rPr sz="1400" b="0">
+                          <a:solidFill>
+                            <a:srgbClr val="1F2233"/>
+                          </a:solidFill>
+                          <a:latin typeface="Inter"/>
+                        </a:rPr>
+                        <a:t>0.695</a:t>
+                      </a:r>
+                    </a:p>
+                  </a:txBody>
+                  <a:tcPr marL="64800" marR="64800" marT="21600" marB="21600" anchor="ctr">
+                    <a:solidFill>
+                      <a:srgbClr val="F1F2FA"/>
+                    </a:solidFill>
+                  </a:tcPr>
+                </a:tc>
+                <a:tc>
+                  <a:txBody>
+                    <a:bodyPr wrap="square"/>
+                    <a:lstStyle/>
+                    <a:p>
+                      <a:pPr algn="ctr">
+                        <a:lnSpc>
+                          <a:spcPct val="110000"/>
+                        </a:lnSpc>
+                        <a:spcAft>
+                          <a:spcPts val="0"/>
+                        </a:spcAft>
+                      </a:pPr>
+                      <a:r>
+                        <a:rPr sz="1400" b="0">
+                          <a:solidFill>
+                            <a:srgbClr val="1F2233"/>
+                          </a:solidFill>
+                          <a:latin typeface="Inter"/>
+                        </a:rPr>
+                        <a:t>0.440</a:t>
+                      </a:r>
+                    </a:p>
+                  </a:txBody>
+                  <a:tcPr marL="64800" marR="64800" marT="21600" marB="21600" anchor="ctr">
+                    <a:solidFill>
+                      <a:srgbClr val="F1F2FA"/>
+                    </a:solidFill>
+                  </a:tcPr>
+                </a:tc>
+                <a:tc>
+                  <a:txBody>
+                    <a:bodyPr wrap="square"/>
+                    <a:lstStyle/>
+                    <a:p>
+                      <a:pPr algn="ctr">
+                        <a:lnSpc>
+                          <a:spcPct val="110000"/>
+                        </a:lnSpc>
+                        <a:spcAft>
+                          <a:spcPts val="0"/>
+                        </a:spcAft>
+                      </a:pPr>
+                      <a:r>
+                        <a:rPr sz="1400" b="0">
+                          <a:solidFill>
+                            <a:srgbClr val="1F2233"/>
+                          </a:solidFill>
+                          <a:latin typeface="Inter"/>
+                        </a:rPr>
+                        <a:t>0.500</a:t>
+                      </a:r>
+                    </a:p>
+                  </a:txBody>
+                  <a:tcPr marL="64800" marR="64800" marT="21600" marB="21600" anchor="ctr">
+                    <a:solidFill>
+                      <a:srgbClr val="F1F2FA"/>
+                    </a:solidFill>
+                  </a:tcPr>
+                </a:tc>
+                <a:tc>
+                  <a:txBody>
+                    <a:bodyPr wrap="square"/>
+                    <a:lstStyle/>
+                    <a:p>
+                      <a:pPr algn="ctr">
+                        <a:lnSpc>
+                          <a:spcPct val="110000"/>
+                        </a:lnSpc>
+                        <a:spcAft>
+                          <a:spcPts val="0"/>
+                        </a:spcAft>
+                      </a:pPr>
+                      <a:r>
+                        <a:rPr sz="1400" b="0">
+                          <a:solidFill>
+                            <a:srgbClr val="1F2233"/>
+                          </a:solidFill>
+                          <a:latin typeface="Inter"/>
+                        </a:rPr>
+                        <a:t>0.885</a:t>
+                      </a:r>
+                    </a:p>
+                  </a:txBody>
+                  <a:tcPr marL="64800" marR="64800" marT="21600" marB="21600" anchor="ctr">
+                    <a:solidFill>
+                      <a:srgbClr val="F1F2FA"/>
+                    </a:solidFill>
+                  </a:tcPr>
+                </a:tc>
+                <a:tc>
+                  <a:txBody>
+                    <a:bodyPr wrap="square"/>
+                    <a:lstStyle/>
+                    <a:p>
+                      <a:pPr algn="ctr">
+                        <a:lnSpc>
+                          <a:spcPct val="110000"/>
+                        </a:lnSpc>
+                        <a:spcAft>
+                          <a:spcPts val="0"/>
+                        </a:spcAft>
+                      </a:pPr>
+                      <a:r>
+                        <a:rPr sz="1400" b="0">
+                          <a:solidFill>
+                            <a:srgbClr val="1F2233"/>
+                          </a:solidFill>
+                          <a:latin typeface="Inter"/>
+                        </a:rPr>
+                        <a:t>0.616</a:t>
+                      </a:r>
+                    </a:p>
+                  </a:txBody>
+                  <a:tcPr marL="64800" marR="64800" marT="21600" marB="21600" anchor="ctr">
+                    <a:solidFill>
+                      <a:srgbClr val="F1F2FA"/>
+                    </a:solidFill>
+                  </a:tcPr>
+                </a:tc>
+                <a:tc>
+                  <a:txBody>
+                    <a:bodyPr wrap="square"/>
+                    <a:lstStyle/>
+                    <a:p>
+                      <a:pPr algn="ctr">
+                        <a:lnSpc>
+                          <a:spcPct val="110000"/>
+                        </a:lnSpc>
+                        <a:spcAft>
+                          <a:spcPts val="0"/>
+                        </a:spcAft>
+                      </a:pPr>
+                      <a:r>
+                        <a:rPr sz="1400" b="0">
+                          <a:solidFill>
+                            <a:srgbClr val="1F2233"/>
+                          </a:solidFill>
+                          <a:latin typeface="Inter"/>
+                        </a:rPr>
+                        <a:t>0.706</a:t>
+                      </a:r>
+                    </a:p>
+                  </a:txBody>
+                  <a:tcPr marL="64800" marR="64800" marT="21600" marB="21600" anchor="ctr">
+                    <a:solidFill>
+                      <a:srgbClr val="F1F2FA"/>
+                    </a:solidFill>
+                  </a:tcPr>
+                </a:tc>
+                <a:tc>
+                  <a:txBody>
+                    <a:bodyPr wrap="square"/>
+                    <a:lstStyle/>
+                    <a:p>
+                      <a:pPr algn="ctr">
+                        <a:lnSpc>
+                          <a:spcPct val="110000"/>
+                        </a:lnSpc>
+                        <a:spcAft>
+                          <a:spcPts val="0"/>
+                        </a:spcAft>
+                      </a:pPr>
+                      <a:r>
+                        <a:rPr sz="1400" b="0">
+                          <a:solidFill>
+                            <a:srgbClr val="1F2233"/>
+                          </a:solidFill>
+                          <a:latin typeface="Inter"/>
+                        </a:rPr>
+                        <a:t>0.446</a:t>
+                      </a:r>
+                    </a:p>
+                  </a:txBody>
+                  <a:tcPr marL="64800" marR="64800" marT="21600" marB="21600" anchor="ctr">
+                    <a:solidFill>
+                      <a:srgbClr val="F1F2FA"/>
+                    </a:solidFill>
+                  </a:tcPr>
+                </a:tc>
+                <a:tc>
+                  <a:txBody>
+                    <a:bodyPr wrap="square"/>
+                    <a:lstStyle/>
+                    <a:p>
+                      <a:pPr algn="ctr">
+                        <a:lnSpc>
+                          <a:spcPct val="110000"/>
+                        </a:lnSpc>
+                        <a:spcAft>
+                          <a:spcPts val="0"/>
+                        </a:spcAft>
+                      </a:pPr>
+                      <a:r>
+                        <a:rPr sz="1400" b="0">
+                          <a:solidFill>
+                            <a:srgbClr val="1F2233"/>
+                          </a:solidFill>
+                          <a:latin typeface="Inter"/>
+                        </a:rPr>
+                        <a:t>0.506</a:t>
+                      </a:r>
+                    </a:p>
+                  </a:txBody>
+                  <a:tcPr marL="64800" marR="64800" marT="21600" marB="21600" anchor="ctr">
+                    <a:solidFill>
+                      <a:srgbClr val="F1F2FA"/>
+                    </a:solidFill>
+                  </a:tcPr>
+                </a:tc>
+              </a:tr>
+              <a:tr h="331514">
+                <a:tc>
+                  <a:txBody>
+                    <a:bodyPr wrap="square"/>
+                    <a:lstStyle/>
+                    <a:p>
+                      <a:pPr algn="l">
+                        <a:lnSpc>
+                          <a:spcPct val="110000"/>
+                        </a:lnSpc>
+                        <a:spcAft>
+                          <a:spcPts val="0"/>
+                        </a:spcAft>
+                      </a:pPr>
+                      <a:r>
+                        <a:rPr sz="1400" b="0">
+                          <a:solidFill>
+                            <a:srgbClr val="1F2233"/>
+                          </a:solidFill>
+                          <a:latin typeface="Inter"/>
+                        </a:rPr>
+                        <a:t>MLP · clock</a:t>
+                      </a:r>
+                    </a:p>
+                  </a:txBody>
+                  <a:tcPr marL="64800" marR="64800" marT="21600" marB="21600" anchor="ctr">
+                    <a:solidFill>
+                      <a:srgbClr val="FFFFFF"/>
+                    </a:solidFill>
+                  </a:tcPr>
+                </a:tc>
+                <a:tc>
+                  <a:txBody>
+                    <a:bodyPr wrap="square"/>
+                    <a:lstStyle/>
+                    <a:p>
+                      <a:pPr algn="ctr">
+                        <a:lnSpc>
+                          <a:spcPct val="110000"/>
+                        </a:lnSpc>
+                        <a:spcAft>
+                          <a:spcPts val="0"/>
+                        </a:spcAft>
+                      </a:pPr>
+                      <a:r>
+                        <a:rPr sz="1400" b="0">
+                          <a:solidFill>
+                            <a:srgbClr val="1F2233"/>
+                          </a:solidFill>
+                          <a:latin typeface="Inter"/>
+                        </a:rPr>
+                        <a:t>0.877</a:t>
+                      </a:r>
+                    </a:p>
+                  </a:txBody>
+                  <a:tcPr marL="64800" marR="64800" marT="21600" marB="21600" anchor="ctr">
+                    <a:solidFill>
+                      <a:srgbClr val="FFFFFF"/>
+                    </a:solidFill>
+                  </a:tcPr>
+                </a:tc>
+                <a:tc>
+                  <a:txBody>
+                    <a:bodyPr wrap="square"/>
+                    <a:lstStyle/>
+                    <a:p>
+                      <a:pPr algn="ctr">
+                        <a:lnSpc>
+                          <a:spcPct val="110000"/>
+                        </a:lnSpc>
+                        <a:spcAft>
+                          <a:spcPts val="0"/>
+                        </a:spcAft>
+                      </a:pPr>
+                      <a:r>
+                        <a:rPr sz="1400" b="0">
+                          <a:solidFill>
+                            <a:srgbClr val="1F2233"/>
+                          </a:solidFill>
+                          <a:latin typeface="Inter"/>
+                        </a:rPr>
+                        <a:t>0.560</a:t>
+                      </a:r>
+                    </a:p>
+                  </a:txBody>
+                  <a:tcPr marL="64800" marR="64800" marT="21600" marB="21600" anchor="ctr">
+                    <a:solidFill>
+                      <a:srgbClr val="FFFFFF"/>
+                    </a:solidFill>
+                  </a:tcPr>
+                </a:tc>
+                <a:tc>
+                  <a:txBody>
+                    <a:bodyPr wrap="square"/>
+                    <a:lstStyle/>
+                    <a:p>
+                      <a:pPr algn="ctr">
+                        <a:lnSpc>
+                          <a:spcPct val="110000"/>
+                        </a:lnSpc>
+                        <a:spcAft>
+                          <a:spcPts val="0"/>
+                        </a:spcAft>
+                      </a:pPr>
+                      <a:r>
+                        <a:rPr sz="1400" b="0">
+                          <a:solidFill>
+                            <a:srgbClr val="1F2233"/>
+                          </a:solidFill>
+                          <a:latin typeface="Inter"/>
+                        </a:rPr>
+                        <a:t>0.677</a:t>
+                      </a:r>
+                    </a:p>
+                  </a:txBody>
+                  <a:tcPr marL="64800" marR="64800" marT="21600" marB="21600" anchor="ctr">
+                    <a:solidFill>
+                      <a:srgbClr val="FFFFFF"/>
+                    </a:solidFill>
+                  </a:tcPr>
+                </a:tc>
+                <a:tc>
+                  <a:txBody>
+                    <a:bodyPr wrap="square"/>
+                    <a:lstStyle/>
+                    <a:p>
+                      <a:pPr algn="ctr">
+                        <a:lnSpc>
+                          <a:spcPct val="110000"/>
+                        </a:lnSpc>
+                        <a:spcAft>
+                          <a:spcPts val="0"/>
+                        </a:spcAft>
+                      </a:pPr>
+                      <a:r>
+                        <a:rPr sz="1400" b="0">
+                          <a:solidFill>
+                            <a:srgbClr val="1F2233"/>
+                          </a:solidFill>
+                          <a:latin typeface="Inter"/>
+                        </a:rPr>
+                        <a:t>0.429</a:t>
+                      </a:r>
+                    </a:p>
+                  </a:txBody>
+                  <a:tcPr marL="64800" marR="64800" marT="21600" marB="21600" anchor="ctr">
+                    <a:solidFill>
+                      <a:srgbClr val="FFFFFF"/>
+                    </a:solidFill>
+                  </a:tcPr>
+                </a:tc>
+                <a:tc>
+                  <a:txBody>
+                    <a:bodyPr wrap="square"/>
+                    <a:lstStyle/>
+                    <a:p>
+                      <a:pPr algn="ctr">
+                        <a:lnSpc>
+                          <a:spcPct val="110000"/>
+                        </a:lnSpc>
+                        <a:spcAft>
+                          <a:spcPts val="0"/>
+                        </a:spcAft>
+                      </a:pPr>
+                      <a:r>
+                        <a:rPr sz="1400" b="0">
+                          <a:solidFill>
+                            <a:srgbClr val="1F2233"/>
+                          </a:solidFill>
+                          <a:latin typeface="Inter"/>
+                        </a:rPr>
+                        <a:t>0.491</a:t>
+                      </a:r>
+                    </a:p>
+                  </a:txBody>
+                  <a:tcPr marL="64800" marR="64800" marT="21600" marB="21600" anchor="ctr">
+                    <a:solidFill>
+                      <a:srgbClr val="FFFFFF"/>
+                    </a:solidFill>
+                  </a:tcPr>
+                </a:tc>
+                <a:tc>
+                  <a:txBody>
+                    <a:bodyPr wrap="square"/>
+                    <a:lstStyle/>
+                    <a:p>
+                      <a:pPr algn="ctr">
+                        <a:lnSpc>
+                          <a:spcPct val="110000"/>
+                        </a:lnSpc>
+                        <a:spcAft>
+                          <a:spcPts val="0"/>
+                        </a:spcAft>
+                      </a:pPr>
+                      <a:r>
+                        <a:rPr sz="1400" b="0">
+                          <a:solidFill>
+                            <a:srgbClr val="1F2233"/>
+                          </a:solidFill>
+                          <a:latin typeface="Inter"/>
+                        </a:rPr>
+                        <a:t>0.883</a:t>
+                      </a:r>
+                    </a:p>
+                  </a:txBody>
+                  <a:tcPr marL="64800" marR="64800" marT="21600" marB="21600" anchor="ctr">
+                    <a:solidFill>
+                      <a:srgbClr val="FFFFFF"/>
+                    </a:solidFill>
+                  </a:tcPr>
+                </a:tc>
+                <a:tc>
+                  <a:txBody>
+                    <a:bodyPr wrap="square"/>
+                    <a:lstStyle/>
+                    <a:p>
+                      <a:pPr algn="ctr">
+                        <a:lnSpc>
+                          <a:spcPct val="110000"/>
+                        </a:lnSpc>
+                        <a:spcAft>
+                          <a:spcPts val="0"/>
+                        </a:spcAft>
+                      </a:pPr>
+                      <a:r>
+                        <a:rPr sz="1400" b="0">
+                          <a:solidFill>
+                            <a:srgbClr val="1F2233"/>
+                          </a:solidFill>
+                          <a:latin typeface="Inter"/>
+                        </a:rPr>
+                        <a:t>0.556</a:t>
+                      </a:r>
+                    </a:p>
+                  </a:txBody>
+                  <a:tcPr marL="64800" marR="64800" marT="21600" marB="21600" anchor="ctr">
+                    <a:solidFill>
+                      <a:srgbClr val="FFFFFF"/>
+                    </a:solidFill>
+                  </a:tcPr>
+                </a:tc>
+                <a:tc>
+                  <a:txBody>
+                    <a:bodyPr wrap="square"/>
+                    <a:lstStyle/>
+                    <a:p>
+                      <a:pPr algn="ctr">
+                        <a:lnSpc>
+                          <a:spcPct val="110000"/>
+                        </a:lnSpc>
+                        <a:spcAft>
+                          <a:spcPts val="0"/>
+                        </a:spcAft>
+                      </a:pPr>
+                      <a:r>
+                        <a:rPr sz="1400" b="0">
+                          <a:solidFill>
+                            <a:srgbClr val="1F2233"/>
+                          </a:solidFill>
+                          <a:latin typeface="Inter"/>
+                        </a:rPr>
+                        <a:t>0.709</a:t>
+                      </a:r>
+                    </a:p>
+                  </a:txBody>
+                  <a:tcPr marL="64800" marR="64800" marT="21600" marB="21600" anchor="ctr">
+                    <a:solidFill>
+                      <a:srgbClr val="FFFFFF"/>
+                    </a:solidFill>
+                  </a:tcPr>
+                </a:tc>
+                <a:tc>
+                  <a:txBody>
+                    <a:bodyPr wrap="square"/>
+                    <a:lstStyle/>
+                    <a:p>
+                      <a:pPr algn="ctr">
+                        <a:lnSpc>
+                          <a:spcPct val="110000"/>
+                        </a:lnSpc>
+                        <a:spcAft>
+                          <a:spcPts val="0"/>
+                        </a:spcAft>
+                      </a:pPr>
+                      <a:r>
+                        <a:rPr sz="1400" b="0">
+                          <a:solidFill>
+                            <a:srgbClr val="1F2233"/>
+                          </a:solidFill>
+                          <a:latin typeface="Inter"/>
+                        </a:rPr>
+                        <a:t>0.448</a:t>
+                      </a:r>
+                    </a:p>
+                  </a:txBody>
+                  <a:tcPr marL="64800" marR="64800" marT="21600" marB="21600" anchor="ctr">
+                    <a:solidFill>
+                      <a:srgbClr val="FFFFFF"/>
+                    </a:solidFill>
+                  </a:tcPr>
+                </a:tc>
+                <a:tc>
+                  <a:txBody>
+                    <a:bodyPr wrap="square"/>
+                    <a:lstStyle/>
+                    <a:p>
+                      <a:pPr algn="ctr">
+                        <a:lnSpc>
+                          <a:spcPct val="110000"/>
+                        </a:lnSpc>
+                        <a:spcAft>
+                          <a:spcPts val="0"/>
+                        </a:spcAft>
+                      </a:pPr>
+                      <a:r>
+                        <a:rPr sz="1400" b="0">
+                          <a:solidFill>
+                            <a:srgbClr val="1F2233"/>
+                          </a:solidFill>
+                          <a:latin typeface="Inter"/>
+                        </a:rPr>
+                        <a:t>0.507</a:t>
+                      </a:r>
+                    </a:p>
+                  </a:txBody>
+                  <a:tcPr marL="64800" marR="64800" marT="21600" marB="21600" anchor="ctr">
+                    <a:solidFill>
+                      <a:srgbClr val="FFFFFF"/>
+                    </a:solidFill>
+                  </a:tcPr>
+                </a:tc>
+              </a:tr>
+              <a:tr h="331514">
+                <a:tc>
+                  <a:txBody>
+                    <a:bodyPr wrap="square"/>
+                    <a:lstStyle/>
+                    <a:p>
+                      <a:pPr algn="l">
+                        <a:lnSpc>
+                          <a:spcPct val="110000"/>
+                        </a:lnSpc>
+                        <a:spcAft>
+                          <a:spcPts val="0"/>
+                        </a:spcAft>
+                      </a:pPr>
+                      <a:r>
+                        <a:rPr sz="1400" b="0">
+                          <a:solidFill>
+                            <a:srgbClr val="1F2233"/>
+                          </a:solidFill>
+                          <a:latin typeface="Inter"/>
+                        </a:rPr>
+                        <a:t>MLP · cosine</a:t>
+                      </a:r>
+                    </a:p>
+                  </a:txBody>
+                  <a:tcPr marL="64800" marR="64800" marT="21600" marB="21600" anchor="ctr">
+                    <a:solidFill>
+                      <a:srgbClr val="F1F2FA"/>
+                    </a:solidFill>
+                  </a:tcPr>
+                </a:tc>
+                <a:tc>
+                  <a:txBody>
+                    <a:bodyPr wrap="square"/>
+                    <a:lstStyle/>
+                    <a:p>
+                      <a:pPr algn="ctr">
+                        <a:lnSpc>
+                          <a:spcPct val="110000"/>
+                        </a:lnSpc>
+                        <a:spcAft>
+                          <a:spcPts val="0"/>
+                        </a:spcAft>
+                      </a:pPr>
+                      <a:r>
+                        <a:rPr sz="1400" b="0">
+                          <a:solidFill>
+                            <a:srgbClr val="1F2233"/>
+                          </a:solidFill>
+                          <a:latin typeface="Inter"/>
+                        </a:rPr>
+                        <a:t>0.876</a:t>
+                      </a:r>
+                    </a:p>
+                  </a:txBody>
+                  <a:tcPr marL="64800" marR="64800" marT="21600" marB="21600" anchor="ctr">
+                    <a:solidFill>
+                      <a:srgbClr val="F1F2FA"/>
+                    </a:solidFill>
+                  </a:tcPr>
+                </a:tc>
+                <a:tc>
+                  <a:txBody>
+                    <a:bodyPr wrap="square"/>
+                    <a:lstStyle/>
+                    <a:p>
+                      <a:pPr algn="ctr">
+                        <a:lnSpc>
+                          <a:spcPct val="110000"/>
+                        </a:lnSpc>
+                        <a:spcAft>
+                          <a:spcPts val="0"/>
+                        </a:spcAft>
+                      </a:pPr>
+                      <a:r>
+                        <a:rPr sz="1400" b="0">
+                          <a:solidFill>
+                            <a:srgbClr val="1F2233"/>
+                          </a:solidFill>
+                          <a:latin typeface="Inter"/>
+                        </a:rPr>
+                        <a:t>0.586</a:t>
+                      </a:r>
+                    </a:p>
+                  </a:txBody>
+                  <a:tcPr marL="64800" marR="64800" marT="21600" marB="21600" anchor="ctr">
+                    <a:solidFill>
+                      <a:srgbClr val="F1F2FA"/>
+                    </a:solidFill>
+                  </a:tcPr>
+                </a:tc>
+                <a:tc>
+                  <a:txBody>
+                    <a:bodyPr wrap="square"/>
+                    <a:lstStyle/>
+                    <a:p>
+                      <a:pPr algn="ctr">
+                        <a:lnSpc>
+                          <a:spcPct val="110000"/>
+                        </a:lnSpc>
+                        <a:spcAft>
+                          <a:spcPts val="0"/>
+                        </a:spcAft>
+                      </a:pPr>
+                      <a:r>
+                        <a:rPr sz="1400" b="0">
+                          <a:solidFill>
+                            <a:srgbClr val="1F2233"/>
+                          </a:solidFill>
+                          <a:latin typeface="Inter"/>
+                        </a:rPr>
+                        <a:t>0.699</a:t>
+                      </a:r>
+                    </a:p>
+                  </a:txBody>
+                  <a:tcPr marL="64800" marR="64800" marT="21600" marB="21600" anchor="ctr">
+                    <a:solidFill>
+                      <a:srgbClr val="F1F2FA"/>
+                    </a:solidFill>
+                  </a:tcPr>
+                </a:tc>
+                <a:tc>
+                  <a:txBody>
+                    <a:bodyPr wrap="square"/>
+                    <a:lstStyle/>
+                    <a:p>
+                      <a:pPr algn="ctr">
+                        <a:lnSpc>
+                          <a:spcPct val="110000"/>
+                        </a:lnSpc>
+                        <a:spcAft>
+                          <a:spcPts val="0"/>
+                        </a:spcAft>
+                      </a:pPr>
+                      <a:r>
+                        <a:rPr sz="1400" b="0">
+                          <a:solidFill>
+                            <a:srgbClr val="1F2233"/>
+                          </a:solidFill>
+                          <a:latin typeface="Inter"/>
+                        </a:rPr>
+                        <a:t>0.442</a:t>
+                      </a:r>
+                    </a:p>
+                  </a:txBody>
+                  <a:tcPr marL="64800" marR="64800" marT="21600" marB="21600" anchor="ctr">
+                    <a:solidFill>
+                      <a:srgbClr val="F1F2FA"/>
+                    </a:solidFill>
+                  </a:tcPr>
+                </a:tc>
+                <a:tc>
+                  <a:txBody>
+                    <a:bodyPr wrap="square"/>
+                    <a:lstStyle/>
+                    <a:p>
+                      <a:pPr algn="ctr">
+                        <a:lnSpc>
+                          <a:spcPct val="110000"/>
+                        </a:lnSpc>
+                        <a:spcAft>
+                          <a:spcPts val="0"/>
+                        </a:spcAft>
+                      </a:pPr>
+                      <a:r>
+                        <a:rPr sz="1400" b="0">
+                          <a:solidFill>
+                            <a:srgbClr val="1F2233"/>
+                          </a:solidFill>
+                          <a:latin typeface="Inter"/>
+                        </a:rPr>
+                        <a:t>0.502</a:t>
+                      </a:r>
+                    </a:p>
+                  </a:txBody>
+                  <a:tcPr marL="64800" marR="64800" marT="21600" marB="21600" anchor="ctr">
+                    <a:solidFill>
+                      <a:srgbClr val="F1F2FA"/>
+                    </a:solidFill>
+                  </a:tcPr>
+                </a:tc>
+                <a:tc>
+                  <a:txBody>
+                    <a:bodyPr wrap="square"/>
+                    <a:lstStyle/>
+                    <a:p>
+                      <a:pPr algn="ctr">
+                        <a:lnSpc>
+                          <a:spcPct val="110000"/>
+                        </a:lnSpc>
+                        <a:spcAft>
+                          <a:spcPts val="0"/>
+                        </a:spcAft>
+                      </a:pPr>
+                      <a:r>
+                        <a:rPr sz="1400" b="0">
+                          <a:solidFill>
+                            <a:srgbClr val="1F2233"/>
+                          </a:solidFill>
+                          <a:latin typeface="Inter"/>
+                        </a:rPr>
+                        <a:t>0.877</a:t>
+                      </a:r>
+                    </a:p>
+                  </a:txBody>
+                  <a:tcPr marL="64800" marR="64800" marT="21600" marB="21600" anchor="ctr">
+                    <a:solidFill>
+                      <a:srgbClr val="F1F2FA"/>
+                    </a:solidFill>
+                  </a:tcPr>
+                </a:tc>
+                <a:tc>
+                  <a:txBody>
+                    <a:bodyPr wrap="square"/>
+                    <a:lstStyle/>
+                    <a:p>
+                      <a:pPr algn="ctr">
+                        <a:lnSpc>
+                          <a:spcPct val="110000"/>
+                        </a:lnSpc>
+                        <a:spcAft>
+                          <a:spcPts val="0"/>
+                        </a:spcAft>
+                      </a:pPr>
+                      <a:r>
+                        <a:rPr sz="1400" b="0">
+                          <a:solidFill>
+                            <a:srgbClr val="1F2233"/>
+                          </a:solidFill>
+                          <a:latin typeface="Inter"/>
+                        </a:rPr>
+                        <a:t>0.593</a:t>
+                      </a:r>
+                    </a:p>
+                  </a:txBody>
+                  <a:tcPr marL="64800" marR="64800" marT="21600" marB="21600" anchor="ctr">
+                    <a:solidFill>
+                      <a:srgbClr val="F1F2FA"/>
+                    </a:solidFill>
+                  </a:tcPr>
+                </a:tc>
+                <a:tc>
+                  <a:txBody>
+                    <a:bodyPr wrap="square"/>
+                    <a:lstStyle/>
+                    <a:p>
+                      <a:pPr algn="ctr">
+                        <a:lnSpc>
+                          <a:spcPct val="110000"/>
+                        </a:lnSpc>
+                        <a:spcAft>
+                          <a:spcPts val="0"/>
+                        </a:spcAft>
+                      </a:pPr>
+                      <a:r>
+                        <a:rPr sz="1400" b="0">
+                          <a:solidFill>
+                            <a:srgbClr val="1F2233"/>
+                          </a:solidFill>
+                          <a:latin typeface="Inter"/>
+                        </a:rPr>
+                        <a:t>0.715</a:t>
+                      </a:r>
+                    </a:p>
+                  </a:txBody>
+                  <a:tcPr marL="64800" marR="64800" marT="21600" marB="21600" anchor="ctr">
+                    <a:solidFill>
+                      <a:srgbClr val="F1F2FA"/>
+                    </a:solidFill>
+                  </a:tcPr>
+                </a:tc>
+                <a:tc>
+                  <a:txBody>
+                    <a:bodyPr wrap="square"/>
+                    <a:lstStyle/>
+                    <a:p>
+                      <a:pPr algn="ctr">
+                        <a:lnSpc>
+                          <a:spcPct val="110000"/>
+                        </a:lnSpc>
+                        <a:spcAft>
+                          <a:spcPts val="0"/>
+                        </a:spcAft>
+                      </a:pPr>
+                      <a:r>
+                        <a:rPr sz="1400" b="0">
+                          <a:solidFill>
+                            <a:srgbClr val="1F2233"/>
+                          </a:solidFill>
+                          <a:latin typeface="Inter"/>
+                        </a:rPr>
+                        <a:t>0.451</a:t>
+                      </a:r>
+                    </a:p>
+                  </a:txBody>
+                  <a:tcPr marL="64800" marR="64800" marT="21600" marB="21600" anchor="ctr">
+                    <a:solidFill>
+                      <a:srgbClr val="F1F2FA"/>
+                    </a:solidFill>
+                  </a:tcPr>
+                </a:tc>
+                <a:tc>
+                  <a:txBody>
+                    <a:bodyPr wrap="square"/>
+                    <a:lstStyle/>
+                    <a:p>
+                      <a:pPr algn="ctr">
+                        <a:lnSpc>
+                          <a:spcPct val="110000"/>
+                        </a:lnSpc>
+                        <a:spcAft>
+                          <a:spcPts val="0"/>
+                        </a:spcAft>
+                      </a:pPr>
+                      <a:r>
+                        <a:rPr sz="1400" b="0">
+                          <a:solidFill>
+                            <a:srgbClr val="1F2233"/>
+                          </a:solidFill>
+                          <a:latin typeface="Inter"/>
+                        </a:rPr>
+                        <a:t>0.511</a:t>
+                      </a:r>
+                    </a:p>
+                  </a:txBody>
+                  <a:tcPr marL="64800" marR="64800" marT="21600" marB="21600" anchor="ctr">
+                    <a:solidFill>
+                      <a:srgbClr val="F1F2FA"/>
+                    </a:solidFill>
+                  </a:tcPr>
+                </a:tc>
+              </a:tr>
+            </a:tbl>
+          </a:graphicData>
+        </a:graphic>
+      </p:graphicFrame>
+      <p:sp>
+        <p:nvSpPr>
+          <p:cNvPr id="75" name="TextBox 74"/>
+          <p:cNvSpPr txBox="1"/>
+          <p:nvPr/>
+        </p:nvSpPr>
+        <p:spPr>
+          <a:xfrm>
+            <a:off x="15660000" y="35133709"/>
+            <a:ext cx="11988000" cy="1196456"/>
+          </a:xfrm>
+          <a:prstGeom prst="rect">
+            <a:avLst/>
+          </a:prstGeom>
+          <a:noFill/>
+        </p:spPr>
+        <p:txBody>
+          <a:bodyPr wrap="square" lIns="0" rIns="0" tIns="0" bIns="0" anchor="t"/>
+          <a:lstStyle/>
+          <a:p>
+            <a:pPr algn="l" marL="270000" indent="-270000">
+              <a:lnSpc>
+                <a:spcPct val="110000"/>
+              </a:lnSpc>
+              <a:spcAft>
+                <a:spcPts val="623"/>
+              </a:spcAft>
+              <a:buClr>
+                <a:srgbClr val="434B9A"/>
+              </a:buClr>
+              <a:buFont typeface="Arial"/>
+              <a:buChar char="•"/>
+            </a:pPr>
             <a:r>
               <a:rPr sz="1400" b="1">
                 <a:solidFill>
@@ -9629,7 +11716,7 @@
                 </a:solidFill>
                 <a:latin typeface="Inter"/>
               </a:rPr>
-              <a:t>CatBoost</a:t>
+              <a:t>Быстрые признаки улучшают обе модели почти по всем метрикам.</a:t>
             </a:r>
             <a:r>
               <a:rPr sz="1400" b="0">
@@ -9638,21 +11725,63 @@
                 </a:solidFill>
                 <a:latin typeface="Inter"/>
               </a:rPr>
-              <a:t> и нейросети в общей постановке проекта (motion, hr, clock; leave-one-subject-out): python repro/10_fast_features.py — после запуска таблица появится здесь</a:t>
+              <a:t> CatBoost: AUC 0.880 → </a:t>
+            </a:r>
+            <a:r>
+              <a:rPr sz="1400" b="1">
+                <a:solidFill>
+                  <a:srgbClr val="434B9A"/>
+                </a:solidFill>
+                <a:latin typeface="Inter"/>
+              </a:rPr>
+              <a:t>0.890</a:t>
+            </a:r>
+            <a:r>
+              <a:rPr sz="1400" b="0">
+                <a:solidFill>
+                  <a:srgbClr val="1F2233"/>
+                </a:solidFill>
+                <a:latin typeface="Inter"/>
+              </a:rPr>
+              <a:t> — лучший результат проекта; найдено бодрствования 68% → 71%, AP wake 0.547 → 0.585, κ 0.431 → 0.448</a:t>
+            </a:r>
+          </a:p>
+          <a:p>
+            <a:pPr algn="l" marL="270000" indent="-270000">
+              <a:lnSpc>
+                <a:spcPct val="110000"/>
+              </a:lnSpc>
+              <a:spcAft>
+                <a:spcPts val="623"/>
+              </a:spcAft>
+              <a:buClr>
+                <a:srgbClr val="434B9A"/>
+              </a:buClr>
+              <a:buFont typeface="Arial"/>
+              <a:buChar char="•"/>
+            </a:pPr>
+            <a:r>
+              <a:rPr sz="1400" b="0">
+                <a:solidFill>
+                  <a:srgbClr val="1F2233"/>
+                </a:solidFill>
+                <a:latin typeface="Inter"/>
+              </a:rPr>
+              <a:t>Прирост — именно там, где модели слабы: в поиске бодрствования. С cosine вместо clock результаты близкие (AP wake даже выше)</a:t>
             </a:r>
           </a:p>
         </p:txBody>
       </p:sp>
       <p:sp>
         <p:nvSpPr>
-          <p:cNvPr id="74" name="Rounded Rectangle 73"/>
+          <p:cNvPr id="76" name="Rounded Rectangle 75"/>
           <p:cNvSpPr/>
           <p:nvPr/>
         </p:nvSpPr>
         <p:spPr>
           <a:xfrm>
-            <a:off x="15408000" y="35945389"/>
-            <a:ext cx="12492000" cy="4230610"/>
+            <a:off x="15408000" y="36719712"/>
+            <a:ext cx="12492000" cy="3456287"/>
           </a:xfrm>
           <a:prstGeom prst="roundRect">
             <a:avLst>
@@ -9693,13 +11822,13 @@
       </p:sp>
       <p:sp>
         <p:nvSpPr>
-          <p:cNvPr id="75" name="TextBox 74"/>
+          <p:cNvPr id="77" name="TextBox 76"/>
           <p:cNvSpPr txBox="1"/>
           <p:nvPr/>
         </p:nvSpPr>
         <p:spPr>
           <a:xfrm>
-            <a:off x="15660000" y="36197389"/>
+            <a:off x="15660000" y="36971712"/>
             <a:ext cx="11988000" cy="504628"/>
           </a:xfrm>
           <a:prstGeom prst="rect">
@@ -9733,13 +11862,13 @@
       </p:sp>
       <p:sp>
         <p:nvSpPr>
-          <p:cNvPr id="76" name="Rectangle 75"/>
+          <p:cNvPr id="78" name="Rectangle 77"/>
           <p:cNvSpPr/>
           <p:nvPr/>
         </p:nvSpPr>
         <p:spPr>
           <a:xfrm>
-            <a:off x="15660000" y="36738017"/>
+            <a:off x="15660000" y="37512340"/>
             <a:ext cx="2160000" cy="43200"/>
           </a:xfrm>
           <a:prstGeom prst="rect">
@@ -9776,13 +11905,13 @@
       </p:sp>
       <p:sp>
         <p:nvSpPr>
-          <p:cNvPr id="77" name="TextBox 76"/>
+          <p:cNvPr id="79" name="TextBox 78"/>
           <p:cNvSpPr txBox="1"/>
           <p:nvPr/>
         </p:nvSpPr>
         <p:spPr>
           <a:xfrm>
-            <a:off x="15660000" y="36864017"/>
+            <a:off x="15660000" y="37638340"/>
             <a:ext cx="11988000" cy="2364112"/>
           </a:xfrm>
           <a:prstGeom prst="rect">
@@ -9974,14 +12103,14 @@
                 </a:solidFill>
                 <a:latin typeface="Inter"/>
               </a:rPr>
-              <a:t> движения и пульса за 5 секунд — минуту поднимают κ нейросети с 0.496 до 0.534 и AUC с 0.908 до 0.917; их проверка на CatBoost — в репозитории</a:t>
+              <a:t> движения и пульса за 5 секунд — минуту улучшают все модели: нейросеть команды — κ 0.496 → 0.534; CatBoost в общей постановке — AUC 0.880 → 0.890, лучший результат проекта</a:t>
             </a:r>
           </a:p>
         </p:txBody>
       </p:sp>
       <p:sp>
         <p:nvSpPr>
-          <p:cNvPr id="78" name="TextBox 77"/>
+          <p:cNvPr id="80" name="TextBox 79"/>
           <p:cNvSpPr txBox="1"/>
           <p:nvPr/>
         </p:nvSpPr>

</xml_diff>

<commit_message>
Poster: card 6 text and layout from the team's PowerPoint edits
Team text for the MLP experiment, the three indicators described in words next
to the extended-model SHAP figure with their formulas below; the CatBoost
fast-feature table stays underneath.

Co-Authored-By: Claude Opus 5.5 <noreply@anthropic.com>
</commit_message>
<xml_diff>
--- a/poster/Команда_11_Постер.pptx
+++ b/poster/Команда_11_Постер.pptx
@@ -8600,7 +8600,7 @@
         <p:spPr>
           <a:xfrm>
             <a:off x="15408000" y="10404000"/>
-            <a:ext cx="12492000" cy="8929764"/>
+            <a:ext cx="12492000" cy="9600697"/>
           </a:xfrm>
           <a:prstGeom prst="roundRect">
             <a:avLst>
@@ -8915,8 +8915,8 @@
         </p:blipFill>
         <p:spPr>
           <a:xfrm>
-            <a:off x="17098560" y="15668176"/>
-            <a:ext cx="9110880" cy="3384041"/>
+            <a:off x="16499160" y="15668176"/>
+            <a:ext cx="10309680" cy="3829309"/>
           </a:xfrm>
           <a:prstGeom prst="rect">
             <a:avLst/>
@@ -8931,8 +8931,8 @@
         </p:nvSpPr>
         <p:spPr>
           <a:xfrm>
-            <a:off x="15408000" y="19549764"/>
-            <a:ext cx="12492000" cy="16953948"/>
+            <a:off x="15408000" y="20220697"/>
+            <a:ext cx="12492000" cy="16057350"/>
           </a:xfrm>
           <a:prstGeom prst="roundRect">
             <a:avLst>
@@ -8979,7 +8979,7 @@
         </p:nvSpPr>
         <p:spPr>
           <a:xfrm>
-            <a:off x="15660000" y="19801764"/>
+            <a:off x="15660000" y="20472697"/>
             <a:ext cx="11988000" cy="504628"/>
           </a:xfrm>
           <a:prstGeom prst="rect">
@@ -9019,7 +9019,7 @@
         </p:nvSpPr>
         <p:spPr>
           <a:xfrm>
-            <a:off x="15660000" y="20342392"/>
+            <a:off x="15660000" y="21013325"/>
             <a:ext cx="2160000" cy="43200"/>
           </a:xfrm>
           <a:prstGeom prst="rect">
@@ -9062,8 +9062,8 @@
         </p:nvSpPr>
         <p:spPr>
           <a:xfrm>
-            <a:off x="15660000" y="20468392"/>
-            <a:ext cx="11988000" cy="865076"/>
+            <a:off x="15660000" y="21139325"/>
+            <a:ext cx="11988000" cy="576717"/>
           </a:xfrm>
           <a:prstGeom prst="rect">
             <a:avLst/>
@@ -9089,14 +9089,94 @@
                 </a:solidFill>
                 <a:latin typeface="Inter"/>
               </a:rPr>
-              <a:t>Эксперимент команды: нейросеть MLP (15, 15, 15), порог P(сон) ≥ 0.5, признаки motion, hr и время ночи. Добавили 3 «быстрых» признака, которые считаются по 5-секундным отрезкам: m — корень из суммы дисперсий ускорения по трём осям, τ = 0.02 g, минутное окно W = [t − 15, t + 45) с</a:t>
+              <a:t>Эксперимент команды MLP: исследованы соседние эпохи, статистики и изменения сигналов, балансировка классов и подбор порога.</a:t>
+            </a:r>
+          </a:p>
+        </p:txBody>
+      </p:sp>
+      <p:sp>
+        <p:nvSpPr>
+          <p:cNvPr id="64" name="TextBox 63"/>
+          <p:cNvSpPr txBox="1"/>
+          <p:nvPr/>
+        </p:nvSpPr>
+        <p:spPr>
+          <a:xfrm>
+            <a:off x="15660000" y="21824043"/>
+            <a:ext cx="11988000" cy="288358"/>
+          </a:xfrm>
+          <a:prstGeom prst="rect">
+            <a:avLst/>
+          </a:prstGeom>
+          <a:noFill/>
+        </p:spPr>
+        <p:txBody>
+          <a:bodyPr wrap="square" lIns="0" rIns="0" tIns="0" bIns="0" anchor="t"/>
+          <a:lstStyle/>
+          <a:p>
+            <a:pPr algn="l">
+              <a:lnSpc>
+                <a:spcPct val="110000"/>
+              </a:lnSpc>
+              <a:spcAft>
+                <a:spcPts val="0"/>
+              </a:spcAft>
+            </a:pPr>
+            <a:r>
+              <a:rPr sz="1600" b="0">
+                <a:solidFill>
+                  <a:srgbClr val="1F2233"/>
+                </a:solidFill>
+                <a:latin typeface="Inter"/>
+              </a:rPr>
+              <a:t>Лучший результат дало добавление трёх локальных признаков движения и пульса:</a:t>
+            </a:r>
+          </a:p>
+        </p:txBody>
+      </p:sp>
+      <p:sp>
+        <p:nvSpPr>
+          <p:cNvPr id="65" name="TextBox 64"/>
+          <p:cNvSpPr txBox="1"/>
+          <p:nvPr/>
+        </p:nvSpPr>
+        <p:spPr>
+          <a:xfrm>
+            <a:off x="15660000" y="22220402"/>
+            <a:ext cx="11988000" cy="288358"/>
+          </a:xfrm>
+          <a:prstGeom prst="rect">
+            <a:avLst/>
+          </a:prstGeom>
+          <a:noFill/>
+        </p:spPr>
+        <p:txBody>
+          <a:bodyPr wrap="square" lIns="0" rIns="0" tIns="0" bIns="0" anchor="t"/>
+          <a:lstStyle/>
+          <a:p>
+            <a:pPr algn="l">
+              <a:lnSpc>
+                <a:spcPct val="110000"/>
+              </a:lnSpc>
+              <a:spcAft>
+                <a:spcPts val="0"/>
+              </a:spcAft>
+            </a:pPr>
+            <a:r>
+              <a:rPr sz="1600" b="0">
+                <a:solidFill>
+                  <a:srgbClr val="1F2233"/>
+                </a:solidFill>
+                <a:latin typeface="Inter"/>
+              </a:rPr>
+              <a:t>Cohen’s κ выросла с 0,496 до 0,534, ROC AUC — с 0,908 до 0,917 при проверке с разделением по участникам.</a:t>
             </a:r>
           </a:p>
         </p:txBody>
       </p:sp>
       <p:pic>
         <p:nvPicPr>
-          <p:cNvPr id="64" name="Picture 63" descr="formula_fpeak.png"/>
+          <p:cNvPr id="66" name="Picture 65" descr="experiments.png"/>
           <p:cNvPicPr>
             <a:picLocks noChangeAspect="1"/>
           </p:cNvPicPr>
@@ -9110,8 +9190,8 @@
         </p:blipFill>
         <p:spPr>
           <a:xfrm>
-            <a:off x="16266976" y="21441469"/>
-            <a:ext cx="2999828" cy="684000"/>
+            <a:off x="16619040" y="22616761"/>
+            <a:ext cx="10069920" cy="3756866"/>
           </a:xfrm>
           <a:prstGeom prst="rect">
             <a:avLst/>
@@ -9120,7 +9200,7 @@
       </p:pic>
       <p:pic>
         <p:nvPicPr>
-          <p:cNvPr id="65" name="Picture 64" descr="formula_factive.png"/>
+          <p:cNvPr id="67" name="Picture 66" descr="shap_fast_right.png"/>
           <p:cNvPicPr>
             <a:picLocks noChangeAspect="1"/>
           </p:cNvPicPr>
@@ -9134,32 +9214,8 @@
         </p:blipFill>
         <p:spPr>
           <a:xfrm>
-            <a:off x="19986804" y="21441469"/>
-            <a:ext cx="4312095" cy="684000"/>
-          </a:xfrm>
-          <a:prstGeom prst="rect">
-            <a:avLst/>
-          </a:prstGeom>
-        </p:spPr>
-      </p:pic>
-      <p:pic>
-        <p:nvPicPr>
-          <p:cNvPr id="66" name="Picture 65" descr="formula_fhr.png"/>
-          <p:cNvPicPr>
-            <a:picLocks noChangeAspect="1"/>
-          </p:cNvPicPr>
-          <p:nvPr/>
-        </p:nvPicPr>
-        <p:blipFill>
-          <a:blip r:embed="rId14"/>
-          <a:stretch>
-            <a:fillRect/>
-          </a:stretch>
-        </p:blipFill>
-        <p:spPr>
-          <a:xfrm>
-            <a:off x="25018899" y="21441469"/>
-            <a:ext cx="2022124" cy="684000"/>
+            <a:off x="15660000" y="26481627"/>
+            <a:ext cx="5297400" cy="4820947"/>
           </a:xfrm>
           <a:prstGeom prst="rect">
             <a:avLst/>
@@ -9168,14 +9224,54 @@
       </p:pic>
       <p:sp>
         <p:nvSpPr>
-          <p:cNvPr id="67" name="TextBox 66"/>
+          <p:cNvPr id="68" name="TextBox 67"/>
           <p:cNvSpPr txBox="1"/>
           <p:nvPr/>
         </p:nvSpPr>
         <p:spPr>
           <a:xfrm>
-            <a:off x="15660000" y="22233469"/>
-            <a:ext cx="11988000" cy="1708194"/>
+            <a:off x="15660000" y="31392574"/>
+            <a:ext cx="5297400" cy="252314"/>
+          </a:xfrm>
+          <a:prstGeom prst="rect">
+            <a:avLst/>
+          </a:prstGeom>
+          <a:noFill/>
+        </p:spPr>
+        <p:txBody>
+          <a:bodyPr wrap="square" lIns="0" rIns="0" tIns="0" bIns="0" anchor="t"/>
+          <a:lstStyle/>
+          <a:p>
+            <a:pPr algn="ctr">
+              <a:lnSpc>
+                <a:spcPct val="110000"/>
+              </a:lnSpc>
+              <a:spcAft>
+                <a:spcPts val="0"/>
+              </a:spcAft>
+            </a:pPr>
+            <a:r>
+              <a:rPr sz="1400" b="0">
+                <a:solidFill>
+                  <a:srgbClr val="5B6075"/>
+                </a:solidFill>
+                <a:latin typeface="Inter"/>
+              </a:rPr>
+              <a:t>SHAP расширенного MLP (график команды)</a:t>
+            </a:r>
+          </a:p>
+        </p:txBody>
+      </p:sp>
+      <p:sp>
+        <p:nvSpPr>
+          <p:cNvPr id="69" name="TextBox 68"/>
+          <p:cNvSpPr txBox="1"/>
+          <p:nvPr/>
+        </p:nvSpPr>
+        <p:spPr>
+          <a:xfrm>
+            <a:off x="21173400" y="26512842"/>
+            <a:ext cx="6474600" cy="2940830"/>
           </a:xfrm>
           <a:prstGeom prst="rect">
             <a:avLst/>
@@ -9200,22 +9296,13 @@
               <a:buChar char="•"/>
             </a:pPr>
             <a:r>
-              <a:rPr sz="1600" b="1">
-                <a:solidFill>
-                  <a:srgbClr val="434B9A"/>
-                </a:solidFill>
-                <a:latin typeface="Inter"/>
-              </a:rPr>
-              <a:t>f_peak</a:t>
-            </a:r>
-            <a:r>
               <a:rPr sz="1600" b="0">
                 <a:solidFill>
                   <a:srgbClr val="1F2233"/>
                 </a:solidFill>
                 <a:latin typeface="Inter"/>
               </a:rPr>
-              <a:t> — самый сильный короткий всплеск движения в эпохе; логарифм гасит редкие очень большие значения (при max m = 0.04 g получаем ln 3 ≈ 1.1)</a:t>
+              <a:t>Лучше всего было когда к исходным признакам добавлены три показателя:</a:t>
             </a:r>
           </a:p>
           <a:p>
@@ -9233,22 +9320,13 @@
               <a:buChar char="•"/>
             </a:pPr>
             <a:r>
-              <a:rPr sz="1600" b="1">
-                <a:solidFill>
-                  <a:srgbClr val="434B9A"/>
-                </a:solidFill>
-                <a:latin typeface="Inter"/>
-              </a:rPr>
-              <a:t>f_active</a:t>
-            </a:r>
-            <a:r>
               <a:rPr sz="1600" b="0">
                 <a:solidFill>
                   <a:srgbClr val="1F2233"/>
                 </a:solidFill>
                 <a:latin typeface="Inter"/>
               </a:rPr>
-              <a:t> — как часто двигались в течение минуты: доля 5-секундных отрезков с m ≥ τ (от 0 до 1)</a:t>
+              <a:t>Пик движения: максимальные колебания ускорения на 5-секундном отрезке внутри текущей эпохи.</a:t>
             </a:r>
           </a:p>
           <a:p>
@@ -9266,204 +9344,13 @@
               <a:buChar char="•"/>
             </a:pPr>
             <a:r>
-              <a:rPr sz="1600" b="1">
-                <a:solidFill>
-                  <a:srgbClr val="434B9A"/>
-                </a:solidFill>
-                <a:latin typeface="Inter"/>
-              </a:rPr>
-              <a:t>f_HR</a:t>
-            </a:r>
-            <a:r>
               <a:rPr sz="1600" b="0">
                 <a:solidFill>
                   <a:srgbClr val="1F2233"/>
                 </a:solidFill>
                 <a:latin typeface="Inter"/>
               </a:rPr>
-              <a:t> — средний пульс за минуту относительно медианы всей записи: +0.1 — на 10% выше обычного для этого человека, −0.05 — на 5% ниже</a:t>
-            </a:r>
-          </a:p>
-        </p:txBody>
-      </p:sp>
-      <p:pic>
-        <p:nvPicPr>
-          <p:cNvPr id="68" name="Picture 67" descr="experiments.png"/>
-          <p:cNvPicPr>
-            <a:picLocks noChangeAspect="1"/>
-          </p:cNvPicPr>
-          <p:nvPr/>
-        </p:nvPicPr>
-        <p:blipFill>
-          <a:blip r:embed="rId15"/>
-          <a:stretch>
-            <a:fillRect/>
-          </a:stretch>
-        </p:blipFill>
-        <p:spPr>
-          <a:xfrm>
-            <a:off x="17817840" y="23941664"/>
-            <a:ext cx="7672320" cy="2862374"/>
-          </a:xfrm>
-          <a:prstGeom prst="rect">
-            <a:avLst/>
-          </a:prstGeom>
-        </p:spPr>
-      </p:pic>
-      <p:sp>
-        <p:nvSpPr>
-          <p:cNvPr id="69" name="TextBox 68"/>
-          <p:cNvSpPr txBox="1"/>
-          <p:nvPr/>
-        </p:nvSpPr>
-        <p:spPr>
-          <a:xfrm>
-            <a:off x="15660000" y="26894038"/>
-            <a:ext cx="11988000" cy="252314"/>
-          </a:xfrm>
-          <a:prstGeom prst="rect">
-            <a:avLst/>
-          </a:prstGeom>
-          <a:noFill/>
-        </p:spPr>
-        <p:txBody>
-          <a:bodyPr wrap="square" lIns="0" rIns="0" tIns="0" bIns="0" anchor="t"/>
-          <a:lstStyle/>
-          <a:p>
-            <a:pPr algn="ctr">
-              <a:lnSpc>
-                <a:spcPct val="110000"/>
-              </a:lnSpc>
-              <a:spcAft>
-                <a:spcPts val="0"/>
-              </a:spcAft>
-            </a:pPr>
-            <a:r>
-              <a:rPr sz="1400" b="0">
-                <a:solidFill>
-                  <a:srgbClr val="5B6075"/>
-                </a:solidFill>
-                <a:latin typeface="Inter"/>
-              </a:rPr>
-              <a:t>Все варианты, которые пробовала команда: точка правее пунктира — лучше исходной модели</a:t>
-            </a:r>
-          </a:p>
-        </p:txBody>
-      </p:sp>
-      <p:pic>
-        <p:nvPicPr>
-          <p:cNvPr id="70" name="Picture 69" descr="shap_fast_right.png"/>
-          <p:cNvPicPr>
-            <a:picLocks noChangeAspect="1"/>
-          </p:cNvPicPr>
-          <p:nvPr/>
-        </p:nvPicPr>
-        <p:blipFill>
-          <a:blip r:embed="rId16"/>
-          <a:stretch>
-            <a:fillRect/>
-          </a:stretch>
-        </p:blipFill>
-        <p:spPr>
-          <a:xfrm>
-            <a:off x="15660000" y="27254352"/>
-            <a:ext cx="4944240" cy="4499550"/>
-          </a:xfrm>
-          <a:prstGeom prst="rect">
-            <a:avLst/>
-          </a:prstGeom>
-        </p:spPr>
-      </p:pic>
-      <p:sp>
-        <p:nvSpPr>
-          <p:cNvPr id="71" name="TextBox 70"/>
-          <p:cNvSpPr txBox="1"/>
-          <p:nvPr/>
-        </p:nvSpPr>
-        <p:spPr>
-          <a:xfrm>
-            <a:off x="15660000" y="31843903"/>
-            <a:ext cx="4944240" cy="252314"/>
-          </a:xfrm>
-          <a:prstGeom prst="rect">
-            <a:avLst/>
-          </a:prstGeom>
-          <a:noFill/>
-        </p:spPr>
-        <p:txBody>
-          <a:bodyPr wrap="square" lIns="0" rIns="0" tIns="0" bIns="0" anchor="t"/>
-          <a:lstStyle/>
-          <a:p>
-            <a:pPr algn="ctr">
-              <a:lnSpc>
-                <a:spcPct val="110000"/>
-              </a:lnSpc>
-              <a:spcAft>
-                <a:spcPts val="0"/>
-              </a:spcAft>
-            </a:pPr>
-            <a:r>
-              <a:rPr sz="1400" b="0">
-                <a:solidFill>
-                  <a:srgbClr val="5B6075"/>
-                </a:solidFill>
-                <a:latin typeface="Inter"/>
-              </a:rPr>
-              <a:t>SHAP расширенного MLP (график команды)</a:t>
-            </a:r>
-          </a:p>
-        </p:txBody>
-      </p:sp>
-      <p:sp>
-        <p:nvSpPr>
-          <p:cNvPr id="72" name="TextBox 71"/>
-          <p:cNvSpPr txBox="1"/>
-          <p:nvPr/>
-        </p:nvSpPr>
-        <p:spPr>
-          <a:xfrm>
-            <a:off x="20820240" y="27393792"/>
-            <a:ext cx="6827760" cy="4670984"/>
-          </a:xfrm>
-          <a:prstGeom prst="rect">
-            <a:avLst/>
-          </a:prstGeom>
-          <a:noFill/>
-        </p:spPr>
-        <p:txBody>
-          <a:bodyPr wrap="square" lIns="0" rIns="0" tIns="0" bIns="0" anchor="t"/>
-          <a:lstStyle/>
-          <a:p>
-            <a:pPr algn="l" marL="270000" indent="-270000">
-              <a:lnSpc>
-                <a:spcPct val="110000"/>
-              </a:lnSpc>
-              <a:spcAft>
-                <a:spcPts val="623"/>
-              </a:spcAft>
-              <a:buClr>
-                <a:srgbClr val="434B9A"/>
-              </a:buClr>
-              <a:buFont typeface="Arial"/>
-              <a:buChar char="•"/>
-            </a:pPr>
-            <a:r>
-              <a:rPr sz="1600" b="1">
-                <a:solidFill>
-                  <a:srgbClr val="434B9A"/>
-                </a:solidFill>
-                <a:latin typeface="Inter"/>
-              </a:rPr>
-              <a:t>Лучше всего — исходные признаки + 3 быстрых:</a:t>
-            </a:r>
-            <a:r>
-              <a:rPr sz="1600" b="0">
-                <a:solidFill>
-                  <a:srgbClr val="1F2233"/>
-                </a:solidFill>
-                <a:latin typeface="Inter"/>
-              </a:rPr>
-              <a:t> κ 0.496 → 0.534, AUC 0.908 → 0.917. Быстрые признаки ловят короткие движения и учащение пульса, которые сглаженный motion «размазывает» по 10 минутам</a:t>
+              <a:t>Доля движения: доля активных 5-секундных отрезков в минутном окне — текущая эпоха и по 15 секунд до и после неё.</a:t>
             </a:r>
           </a:p>
           <a:p>
@@ -9481,110 +9368,89 @@
               <a:buChar char="•"/>
             </a:pPr>
             <a:r>
-              <a:rPr sz="1600" b="1">
-                <a:solidFill>
-                  <a:srgbClr val="434B9A"/>
-                </a:solidFill>
-                <a:latin typeface="Inter"/>
-              </a:rPr>
-              <a:t>Помогают</a:t>
-            </a:r>
-            <a:r>
               <a:rPr sz="1600" b="0">
                 <a:solidFill>
                   <a:srgbClr val="1F2233"/>
                 </a:solidFill>
                 <a:latin typeface="Inter"/>
               </a:rPr>
-              <a:t> соседние эпохи и статистики короткого окна — контекст соседних минут. </a:t>
-            </a:r>
-            <a:r>
-              <a:rPr sz="1600" b="1">
-                <a:solidFill>
-                  <a:srgbClr val="434B9A"/>
-                </a:solidFill>
-                <a:latin typeface="Inter"/>
-              </a:rPr>
-              <a:t>Не помогают</a:t>
-            </a:r>
-            <a:r>
-              <a:rPr sz="1600" b="0">
-                <a:solidFill>
-                  <a:srgbClr val="1F2233"/>
-                </a:solidFill>
-                <a:latin typeface="Inter"/>
-              </a:rPr>
-              <a:t> повтор примеров бодрствования (переобучение, AUC падает) и разности эпох без сглаживания (шум)</a:t>
-            </a:r>
-          </a:p>
-          <a:p>
-            <a:pPr algn="l" marL="270000" indent="-270000">
-              <a:lnSpc>
-                <a:spcPct val="110000"/>
-              </a:lnSpc>
-              <a:spcAft>
-                <a:spcPts val="623"/>
-              </a:spcAft>
-              <a:buClr>
-                <a:srgbClr val="434B9A"/>
-              </a:buClr>
-              <a:buFont typeface="Arial"/>
-              <a:buChar char="•"/>
-            </a:pPr>
-            <a:r>
-              <a:rPr sz="1600" b="1">
-                <a:solidFill>
-                  <a:srgbClr val="434B9A"/>
-                </a:solidFill>
-                <a:latin typeface="Inter"/>
-              </a:rPr>
-              <a:t>SHAP расширенной модели:</a:t>
-            </a:r>
-            <a:r>
-              <a:rPr sz="1600" b="0">
-                <a:solidFill>
-                  <a:srgbClr val="1F2233"/>
-                </a:solidFill>
-                <a:latin typeface="Inter"/>
-              </a:rPr>
-              <a:t> доля движения за минуту (|SHAP| 0.024) работает почти как motion (0.034); пик движения и относительный пульс слабее (0.009 и 0.005); время ночи остаётся самым сильным признаком (0.049)</a:t>
-            </a:r>
-          </a:p>
-          <a:p>
-            <a:pPr algn="l" marL="270000" indent="-270000">
-              <a:lnSpc>
-                <a:spcPct val="110000"/>
-              </a:lnSpc>
-              <a:spcAft>
-                <a:spcPts val="623"/>
-              </a:spcAft>
-              <a:buClr>
-                <a:srgbClr val="434B9A"/>
-              </a:buClr>
-              <a:buFont typeface="Arial"/>
-              <a:buChar char="•"/>
-            </a:pPr>
-            <a:r>
-              <a:rPr sz="1600" b="1">
-                <a:solidFill>
-                  <a:srgbClr val="434B9A"/>
-                </a:solidFill>
-                <a:latin typeface="Inter"/>
-              </a:rPr>
-              <a:t>Ограничение:</a:t>
-            </a:r>
-            <a:r>
-              <a:rPr sz="1600" b="0">
-                <a:solidFill>
-                  <a:srgbClr val="1F2233"/>
-                </a:solidFill>
-                <a:latin typeface="Inter"/>
-              </a:rPr>
-              <a:t> окно заглядывает на 15 с вперёд, а медиана пульса берётся по всей записи — это анализ готовой записи, а не предсказание в реальном времени</a:t>
+              <a:t>Относительный пульс: отклонение среднего пульса за минуту от медианы записи, делённое на медиану.</a:t>
             </a:r>
           </a:p>
         </p:txBody>
       </p:sp>
+      <p:pic>
+        <p:nvPicPr>
+          <p:cNvPr id="70" name="Picture 69" descr="formula_fpeak.png"/>
+          <p:cNvPicPr>
+            <a:picLocks noChangeAspect="1"/>
+          </p:cNvPicPr>
+          <p:nvPr/>
+        </p:nvPicPr>
+        <p:blipFill>
+          <a:blip r:embed="rId14"/>
+          <a:stretch>
+            <a:fillRect/>
+          </a:stretch>
+        </p:blipFill>
+        <p:spPr>
+          <a:xfrm>
+            <a:off x="22989728" y="29453673"/>
+            <a:ext cx="2841942" cy="648000"/>
+          </a:xfrm>
+          <a:prstGeom prst="rect">
+            <a:avLst/>
+          </a:prstGeom>
+        </p:spPr>
+      </p:pic>
+      <p:pic>
+        <p:nvPicPr>
+          <p:cNvPr id="71" name="Picture 70" descr="formula_factive.png"/>
+          <p:cNvPicPr>
+            <a:picLocks noChangeAspect="1"/>
+          </p:cNvPicPr>
+          <p:nvPr/>
+        </p:nvPicPr>
+        <p:blipFill>
+          <a:blip r:embed="rId15"/>
+          <a:stretch>
+            <a:fillRect/>
+          </a:stretch>
+        </p:blipFill>
+        <p:spPr>
+          <a:xfrm>
+            <a:off x="22368128" y="30209673"/>
+            <a:ext cx="4085142" cy="648000"/>
+          </a:xfrm>
+          <a:prstGeom prst="rect">
+            <a:avLst/>
+          </a:prstGeom>
+        </p:spPr>
+      </p:pic>
+      <p:pic>
+        <p:nvPicPr>
+          <p:cNvPr id="72" name="Picture 71" descr="formula_fhr.png"/>
+          <p:cNvPicPr>
+            <a:picLocks noChangeAspect="1"/>
+          </p:cNvPicPr>
+          <p:nvPr/>
+        </p:nvPicPr>
+        <p:blipFill>
+          <a:blip r:embed="rId16"/>
+          <a:stretch>
+            <a:fillRect/>
+          </a:stretch>
+        </p:blipFill>
+        <p:spPr>
+          <a:xfrm>
+            <a:off x="23452851" y="30965673"/>
+            <a:ext cx="1915696" cy="648000"/>
+          </a:xfrm>
+          <a:prstGeom prst="rect">
+            <a:avLst/>
+          </a:prstGeom>
+        </p:spPr>
+      </p:pic>
       <p:sp>
         <p:nvSpPr>
           <p:cNvPr id="73" name="TextBox 72"/>
@@ -9593,7 +9459,7 @@
         </p:nvSpPr>
         <p:spPr>
           <a:xfrm>
-            <a:off x="15660000" y="32204217"/>
+            <a:off x="15660000" y="31752888"/>
             <a:ext cx="11988000" cy="504628"/>
           </a:xfrm>
           <a:prstGeom prst="rect">
@@ -9643,7 +9509,7 @@
           <p:nvPr/>
         </p:nvGraphicFramePr>
         <p:xfrm>
-          <a:off x="15660000" y="32816845"/>
+          <a:off x="15660000" y="32365517"/>
           <a:ext cx="11987999" cy="2208863"/>
         </p:xfrm>
         <a:graphic>
@@ -11684,7 +11550,7 @@
         </p:nvSpPr>
         <p:spPr>
           <a:xfrm>
-            <a:off x="15660000" y="35133709"/>
+            <a:off x="15660000" y="34682381"/>
             <a:ext cx="11988000" cy="1196456"/>
           </a:xfrm>
           <a:prstGeom prst="rect">
@@ -11780,8 +11646,8 @@
         </p:nvSpPr>
         <p:spPr>
           <a:xfrm>
-            <a:off x="15408000" y="36719712"/>
-            <a:ext cx="12492000" cy="3456287"/>
+            <a:off x="15408000" y="36494048"/>
+            <a:ext cx="12492000" cy="3681951"/>
           </a:xfrm>
           <a:prstGeom prst="roundRect">
             <a:avLst>
@@ -11828,7 +11694,7 @@
         </p:nvSpPr>
         <p:spPr>
           <a:xfrm>
-            <a:off x="15660000" y="36971712"/>
+            <a:off x="15660000" y="36746048"/>
             <a:ext cx="11988000" cy="504628"/>
           </a:xfrm>
           <a:prstGeom prst="rect">
@@ -11868,7 +11734,7 @@
         </p:nvSpPr>
         <p:spPr>
           <a:xfrm>
-            <a:off x="15660000" y="37512340"/>
+            <a:off x="15660000" y="37286676"/>
             <a:ext cx="2160000" cy="43200"/>
           </a:xfrm>
           <a:prstGeom prst="rect">
@@ -11911,7 +11777,7 @@
         </p:nvSpPr>
         <p:spPr>
           <a:xfrm>
-            <a:off x="15660000" y="37638340"/>
+            <a:off x="15660000" y="37412676"/>
             <a:ext cx="11988000" cy="2364112"/>
           </a:xfrm>
           <a:prstGeom prst="rect">

</xml_diff>

<commit_message>
Poster: remove the GitHub link from the footer
Co-Authored-By: Claude Opus 5.5 <noreply@anthropic.com>
</commit_message>
<xml_diff>
--- a/poster/Команда_11_Постер.pptx
+++ b/poster/Команда_11_Постер.pptx
@@ -12022,22 +12022,13 @@
               </a:spcAft>
             </a:pPr>
             <a:r>
-              <a:rPr sz="1900" b="1">
+              <a:rPr sz="1900" b="0">
                 <a:solidFill>
                   <a:srgbClr val="5B6075"/>
                 </a:solidFill>
                 <a:latin typeface="Inter"/>
               </a:rPr>
-              <a:t>Код и все результаты:</a:t>
-            </a:r>
-            <a:r>
-              <a:rPr sz="1900" b="0">
-                <a:solidFill>
-                  <a:srgbClr val="5B6075"/>
-                </a:solidFill>
-                <a:latin typeface="Inter"/>
-              </a:rPr>
-              <a:t> github.com/AlisaPopova25/ai_school_october      AI360 · Проектная школа · 2026</a:t>
+              <a:t>AI360 · Проектная школа · 2026</a:t>
             </a:r>
           </a:p>
         </p:txBody>

</xml_diff>

<commit_message>
Poster: expanded conclusions (six points with numbers and next steps)
Co-Authored-By: Claude Opus 5.5 <noreply@anthropic.com>
</commit_message>
<xml_diff>
--- a/poster/Команда_11_Постер.pptx
+++ b/poster/Команда_11_Постер.pptx
@@ -8600,7 +8600,7 @@
         <p:spPr>
           <a:xfrm>
             <a:off x="15408000" y="10404000"/>
-            <a:ext cx="12492000" cy="9600697"/>
+            <a:ext cx="12492000" cy="8733067"/>
           </a:xfrm>
           <a:prstGeom prst="roundRect">
             <a:avLst>
@@ -8915,8 +8915,8 @@
         </p:blipFill>
         <p:spPr>
           <a:xfrm>
-            <a:off x="16499160" y="15668176"/>
-            <a:ext cx="10309680" cy="3829309"/>
+            <a:off x="17338320" y="15668176"/>
+            <a:ext cx="8631360" cy="3205933"/>
           </a:xfrm>
           <a:prstGeom prst="rect">
             <a:avLst/>
@@ -8931,8 +8931,8 @@
         </p:nvSpPr>
         <p:spPr>
           <a:xfrm>
-            <a:off x="15408000" y="20220697"/>
-            <a:ext cx="12492000" cy="16057350"/>
+            <a:off x="15408000" y="19353067"/>
+            <a:ext cx="12492000" cy="13838885"/>
           </a:xfrm>
           <a:prstGeom prst="roundRect">
             <a:avLst>
@@ -8979,7 +8979,7 @@
         </p:nvSpPr>
         <p:spPr>
           <a:xfrm>
-            <a:off x="15660000" y="20472697"/>
+            <a:off x="15660000" y="19605067"/>
             <a:ext cx="11988000" cy="504628"/>
           </a:xfrm>
           <a:prstGeom prst="rect">
@@ -9019,7 +9019,7 @@
         </p:nvSpPr>
         <p:spPr>
           <a:xfrm>
-            <a:off x="15660000" y="21013325"/>
+            <a:off x="15660000" y="20145695"/>
             <a:ext cx="2160000" cy="43200"/>
           </a:xfrm>
           <a:prstGeom prst="rect">
@@ -9062,7 +9062,7 @@
         </p:nvSpPr>
         <p:spPr>
           <a:xfrm>
-            <a:off x="15660000" y="21139325"/>
+            <a:off x="15660000" y="20271695"/>
             <a:ext cx="11988000" cy="576717"/>
           </a:xfrm>
           <a:prstGeom prst="rect">
@@ -9102,7 +9102,7 @@
         </p:nvSpPr>
         <p:spPr>
           <a:xfrm>
-            <a:off x="15660000" y="21824043"/>
+            <a:off x="15660000" y="20956413"/>
             <a:ext cx="11988000" cy="288358"/>
           </a:xfrm>
           <a:prstGeom prst="rect">
@@ -9142,7 +9142,7 @@
         </p:nvSpPr>
         <p:spPr>
           <a:xfrm>
-            <a:off x="15660000" y="22220402"/>
+            <a:off x="15660000" y="21352772"/>
             <a:ext cx="11988000" cy="288358"/>
           </a:xfrm>
           <a:prstGeom prst="rect">
@@ -9190,8 +9190,8 @@
         </p:blipFill>
         <p:spPr>
           <a:xfrm>
-            <a:off x="16619040" y="22616761"/>
-            <a:ext cx="10069920" cy="3756866"/>
+            <a:off x="17578080" y="21749131"/>
+            <a:ext cx="8151840" cy="3041272"/>
           </a:xfrm>
           <a:prstGeom prst="rect">
             <a:avLst/>
@@ -9214,8 +9214,8 @@
         </p:blipFill>
         <p:spPr>
           <a:xfrm>
-            <a:off x="15660000" y="26481627"/>
-            <a:ext cx="5297400" cy="4820947"/>
+            <a:off x="15660000" y="24898404"/>
+            <a:ext cx="4473360" cy="4071022"/>
           </a:xfrm>
           <a:prstGeom prst="rect">
             <a:avLst/>
@@ -9230,8 +9230,8 @@
         </p:nvSpPr>
         <p:spPr>
           <a:xfrm>
-            <a:off x="15660000" y="31392574"/>
-            <a:ext cx="5297400" cy="252314"/>
+            <a:off x="15660000" y="29059426"/>
+            <a:ext cx="4473360" cy="252314"/>
           </a:xfrm>
           <a:prstGeom prst="rect">
             <a:avLst/>
@@ -9270,8 +9270,8 @@
         </p:nvSpPr>
         <p:spPr>
           <a:xfrm>
-            <a:off x="21173400" y="26512842"/>
-            <a:ext cx="6474600" cy="2940830"/>
+            <a:off x="20349360" y="24898404"/>
+            <a:ext cx="7298640" cy="2652471"/>
           </a:xfrm>
           <a:prstGeom prst="rect">
             <a:avLst/>
@@ -9395,8 +9395,8 @@
         </p:blipFill>
         <p:spPr>
           <a:xfrm>
-            <a:off x="22989728" y="29453673"/>
-            <a:ext cx="2841942" cy="648000"/>
+            <a:off x="22814537" y="27550875"/>
+            <a:ext cx="2368285" cy="540000"/>
           </a:xfrm>
           <a:prstGeom prst="rect">
             <a:avLst/>
@@ -9419,8 +9419,8 @@
         </p:blipFill>
         <p:spPr>
           <a:xfrm>
-            <a:off x="22368128" y="30209673"/>
-            <a:ext cx="4085142" cy="648000"/>
+            <a:off x="22296537" y="28198875"/>
+            <a:ext cx="3404285" cy="540000"/>
           </a:xfrm>
           <a:prstGeom prst="rect">
             <a:avLst/>
@@ -9443,8 +9443,8 @@
         </p:blipFill>
         <p:spPr>
           <a:xfrm>
-            <a:off x="23452851" y="30965673"/>
-            <a:ext cx="1915696" cy="648000"/>
+            <a:off x="23200473" y="28846875"/>
+            <a:ext cx="1596413" cy="540000"/>
           </a:xfrm>
           <a:prstGeom prst="rect">
             <a:avLst/>
@@ -9459,7 +9459,7 @@
         </p:nvSpPr>
         <p:spPr>
           <a:xfrm>
-            <a:off x="15660000" y="31752888"/>
+            <a:off x="15660000" y="29494875"/>
             <a:ext cx="11988000" cy="504628"/>
           </a:xfrm>
           <a:prstGeom prst="rect">
@@ -9509,7 +9509,7 @@
           <p:nvPr/>
         </p:nvGraphicFramePr>
         <p:xfrm>
-          <a:off x="15660000" y="32365517"/>
+          <a:off x="15660000" y="30107504"/>
           <a:ext cx="11987999" cy="2208863"/>
         </p:xfrm>
         <a:graphic>
@@ -11550,8 +11550,8 @@
         </p:nvSpPr>
         <p:spPr>
           <a:xfrm>
-            <a:off x="15660000" y="34682381"/>
-            <a:ext cx="11988000" cy="1196456"/>
+            <a:off x="15660000" y="32424368"/>
+            <a:ext cx="11988000" cy="612628"/>
           </a:xfrm>
           <a:prstGeom prst="rect">
             <a:avLst/>
@@ -11612,30 +11612,6 @@
               <a:t> — лучший результат проекта; найдено бодрствования 68% → 71%, AP wake 0.547 → 0.585, κ 0.431 → 0.448</a:t>
             </a:r>
           </a:p>
-          <a:p>
-            <a:pPr algn="l" marL="270000" indent="-270000">
-              <a:lnSpc>
-                <a:spcPct val="110000"/>
-              </a:lnSpc>
-              <a:spcAft>
-                <a:spcPts val="623"/>
-              </a:spcAft>
-              <a:buClr>
-                <a:srgbClr val="434B9A"/>
-              </a:buClr>
-              <a:buFont typeface="Arial"/>
-              <a:buChar char="•"/>
-            </a:pPr>
-            <a:r>
-              <a:rPr sz="1400" b="0">
-                <a:solidFill>
-                  <a:srgbClr val="1F2233"/>
-                </a:solidFill>
-                <a:latin typeface="Inter"/>
-              </a:rPr>
-              <a:t>Прирост — именно там, где модели слабы: в поиске бодрствования. С cosine вместо clock результаты близкие (AP wake даже выше)</a:t>
-            </a:r>
-          </a:p>
         </p:txBody>
       </p:sp>
       <p:sp>
@@ -11646,8 +11622,8 @@
         </p:nvSpPr>
         <p:spPr>
           <a:xfrm>
-            <a:off x="15408000" y="36494048"/>
-            <a:ext cx="12492000" cy="3681951"/>
+            <a:off x="15408000" y="33407953"/>
+            <a:ext cx="12492000" cy="6768046"/>
           </a:xfrm>
           <a:prstGeom prst="roundRect">
             <a:avLst>
@@ -11694,7 +11670,7 @@
         </p:nvSpPr>
         <p:spPr>
           <a:xfrm>
-            <a:off x="15660000" y="36746048"/>
+            <a:off x="15660000" y="33659953"/>
             <a:ext cx="11988000" cy="504628"/>
           </a:xfrm>
           <a:prstGeom prst="rect">
@@ -11734,7 +11710,7 @@
         </p:nvSpPr>
         <p:spPr>
           <a:xfrm>
-            <a:off x="15660000" y="37286676"/>
+            <a:off x="15660000" y="34200581"/>
             <a:ext cx="2160000" cy="43200"/>
           </a:xfrm>
           <a:prstGeom prst="rect">
@@ -11777,8 +11753,8 @@
         </p:nvSpPr>
         <p:spPr>
           <a:xfrm>
-            <a:off x="15660000" y="37412676"/>
-            <a:ext cx="11988000" cy="2364112"/>
+            <a:off x="15660000" y="34326581"/>
+            <a:ext cx="11988000" cy="5694461"/>
           </a:xfrm>
           <a:prstGeom prst="rect">
             <a:avLst/>
@@ -11822,7 +11798,7 @@
                 </a:solidFill>
                 <a:latin typeface="Inter"/>
               </a:rPr>
-              <a:t>Воспроизвели статью</a:t>
+              <a:t>Статья воспроизводится.</a:t>
             </a:r>
             <a:r>
               <a:rPr sz="1600" b="0">
@@ -11831,7 +11807,7 @@
                 </a:solidFill>
                 <a:latin typeface="Inter"/>
               </a:rPr>
-              <a:t> на открытых данных и современном Python: AUC 0.86–0.88 и доли найденных стадий — как у авторов; добавленный CatBoost — AUC 0.880, лучший, но с минимальным отрывом</a:t>
+              <a:t> На открытых данных и современном Python AUC моделей (0.86–0.88), accuracy и доли найденных стадий совпали с авторскими в пределах 0.01–0.03, хотя мы проверяли строже: каждого человека предсказывала модель, которая его не видела. Значит, результат статьи переносится на новых людей</a:t>
             </a:r>
           </a:p>
           <a:p>
@@ -11868,7 +11844,7 @@
                 </a:solidFill>
                 <a:latin typeface="Inter"/>
               </a:rPr>
-              <a:t>Главные признаки</a:t>
+              <a:t>Модель почти не важна — важны признаки.</a:t>
             </a:r>
             <a:r>
               <a:rPr sz="1600" b="0">
@@ -11877,7 +11853,7 @@
                 </a:solidFill>
                 <a:latin typeface="Inter"/>
               </a:rPr>
-              <a:t> — движение и время ночи (clock); пульс добавляет меньше всего, особенно для поиска бодрствования</a:t>
+              <a:t> Пять моделей, от логистической регрессии до CatBoost, различаются по AUC лишь на 0.02. CatBoost лучший (AUC 0.880), но отрыв от нейросети статьи — в тысячных</a:t>
             </a:r>
           </a:p>
           <a:p>
@@ -11914,7 +11890,7 @@
                 </a:solidFill>
                 <a:latin typeface="Inter"/>
               </a:rPr>
-              <a:t>Слабые места</a:t>
+              <a:t>Главное — движение и время ночи.</a:t>
             </a:r>
             <a:r>
               <a:rPr sz="1600" b="0">
@@ -11923,7 +11899,7 @@
                 </a:solidFill>
                 <a:latin typeface="Inter"/>
               </a:rPr>
-              <a:t> — тихое бодрствование без движения и REM; accuracy это скрывает, поэтому нужны κ, F1 и AP</a:t>
+              <a:t> По Шепли около половины прироста качества даёт движение, четверть–треть — clock, пульс — меньше всего, а для поиска бодрствования лишь 12–18%. Картина одинакова у всех моделей, то есть это свойство данных, а не модели</a:t>
             </a:r>
           </a:p>
           <a:p>
@@ -11960,7 +11936,7 @@
                 </a:solidFill>
                 <a:latin typeface="Inter"/>
               </a:rPr>
-              <a:t>Быстрые признаки</a:t>
+              <a:t>Accuracy скрывает главную слабость.</a:t>
             </a:r>
             <a:r>
               <a:rPr sz="1600" b="0">
@@ -11969,7 +11945,99 @@
                 </a:solidFill>
                 <a:latin typeface="Inter"/>
               </a:rPr>
-              <a:t> движения и пульса за 5 секунд — минуту улучшают все модели: нейросеть команды — κ 0.496 → 0.534; CatBoost в общей постановке — AUC 0.880 → 0.890, лучший результат проекта</a:t>
+              <a:t> «Всегда сон» даёт 0.916 — больше, чем 0.88 у моделей. Модели находят около 2/3 бодрствования, но верна лишь каждая третья метка «бодрствование»: тихое бодрствование без движения по часам не видно. REM — самый трудный класс (F1 ≈ 0.5). Поэтому оцениваем по κ, AP и F1</a:t>
+            </a:r>
+          </a:p>
+          <a:p>
+            <a:pPr algn="l">
+              <a:lnSpc>
+                <a:spcPct val="110000"/>
+              </a:lnSpc>
+              <a:spcAft>
+                <a:spcPts val="623"/>
+              </a:spcAft>
+            </a:pPr>
+            <a:r>
+              <a:rPr sz="1600" b="1">
+                <a:solidFill>
+                  <a:srgbClr val="434B9A"/>
+                </a:solidFill>
+                <a:latin typeface="Inter"/>
+              </a:rPr>
+              <a:t>5.</a:t>
+            </a:r>
+            <a:r>
+              <a:rPr sz="1600" b="0">
+                <a:solidFill>
+                  <a:srgbClr val="1F2233"/>
+                </a:solidFill>
+                <a:latin typeface="Inter"/>
+              </a:rPr>
+              <a:t> </a:t>
+            </a:r>
+            <a:r>
+              <a:rPr sz="1600" b="1">
+                <a:solidFill>
+                  <a:srgbClr val="434B9A"/>
+                </a:solidFill>
+                <a:latin typeface="Inter"/>
+              </a:rPr>
+              <a:t>Быстрые признаки помогают всем моделям.</a:t>
+            </a:r>
+            <a:r>
+              <a:rPr sz="1600" b="0">
+                <a:solidFill>
+                  <a:srgbClr val="1F2233"/>
+                </a:solidFill>
+                <a:latin typeface="Inter"/>
+              </a:rPr>
+              <a:t> Пик движения, доля движения за минуту и относительный пульс по 5-секундным отрезкам подняли κ нейросети команды с 0.496 до 0.534, а у CatBoost в общей постановке — AUC с 0.880 до 0.890 (лучший результат проекта) и долю найденного бодрствования с 68% до 71%</a:t>
+            </a:r>
+          </a:p>
+          <a:p>
+            <a:pPr algn="l">
+              <a:lnSpc>
+                <a:spcPct val="110000"/>
+              </a:lnSpc>
+              <a:spcAft>
+                <a:spcPts val="623"/>
+              </a:spcAft>
+            </a:pPr>
+            <a:r>
+              <a:rPr sz="1600" b="1">
+                <a:solidFill>
+                  <a:srgbClr val="434B9A"/>
+                </a:solidFill>
+                <a:latin typeface="Inter"/>
+              </a:rPr>
+              <a:t>6.</a:t>
+            </a:r>
+            <a:r>
+              <a:rPr sz="1600" b="0">
+                <a:solidFill>
+                  <a:srgbClr val="1F2233"/>
+                </a:solidFill>
+                <a:latin typeface="Inter"/>
+              </a:rPr>
+              <a:t> </a:t>
+            </a:r>
+            <a:r>
+              <a:rPr sz="1600" b="1">
+                <a:solidFill>
+                  <a:srgbClr val="434B9A"/>
+                </a:solidFill>
+                <a:latin typeface="Inter"/>
+              </a:rPr>
+              <a:t>Что дальше:</a:t>
+            </a:r>
+            <a:r>
+              <a:rPr sz="1600" b="0">
+                <a:solidFill>
+                  <a:srgbClr val="1F2233"/>
+                </a:solidFill>
+                <a:latin typeface="Inter"/>
+              </a:rPr>
+              <a:t> признаки, которые видят тихое бодрствование и REM (дыхание и вариабельность пульса по сырому сигналу PPG), учёт последовательности эпох во времени, проверка на других людях и устройствах (MESA) и вариант быстрых признаков без «заглядывания» на 15 с вперёд — для работы в реальном времени</a:t>
             </a:r>
           </a:p>
         </p:txBody>

</xml_diff>

<commit_message>
Poster: no fixed 4 a.m. for the circadian minimum; only CatBoost with clock in card 6
Co-Authored-By: Claude Opus 5.5 <noreply@anthropic.com>
</commit_message>
<xml_diff>
--- a/poster/Команда_11_Постер.pptx
+++ b/poster/Команда_11_Постер.pptx
@@ -2772,7 +2772,7 @@
                 </a:solidFill>
                 <a:latin typeface="Inter"/>
               </a:rPr>
-              <a:t>x — состояние модели внутренних часов (без единиц). Шкала перевёрнута: clock = 0 — человек лёг, 1 — дно суточного ритма (≈ 4 ч ночи, минимум x); под утро clock снова уменьшается</a:t>
+              <a:t>x — состояние модели внутренних часов (без единиц). Шкала перевёрнута: clock = 0 — человек лёг, 1 — дно суточного ритма (минимум x, у каждого в своё время); под утро clock снова уменьшается</a:t>
             </a:r>
           </a:p>
         </p:txBody>
@@ -8600,7 +8600,7 @@
         <p:spPr>
           <a:xfrm>
             <a:off x="15408000" y="10404000"/>
-            <a:ext cx="12492000" cy="8733067"/>
+            <a:ext cx="12492000" cy="9212345"/>
           </a:xfrm>
           <a:prstGeom prst="roundRect">
             <a:avLst>
@@ -8915,8 +8915,8 @@
         </p:blipFill>
         <p:spPr>
           <a:xfrm>
-            <a:off x="17338320" y="15668176"/>
-            <a:ext cx="8631360" cy="3205933"/>
+            <a:off x="16738920" y="15668176"/>
+            <a:ext cx="9830160" cy="3651202"/>
           </a:xfrm>
           <a:prstGeom prst="rect">
             <a:avLst/>
@@ -8931,8 +8931,8 @@
         </p:nvSpPr>
         <p:spPr>
           <a:xfrm>
-            <a:off x="15408000" y="19353067"/>
-            <a:ext cx="12492000" cy="13838885"/>
+            <a:off x="15408000" y="19832345"/>
+            <a:ext cx="12492000" cy="13325598"/>
           </a:xfrm>
           <a:prstGeom prst="roundRect">
             <a:avLst>
@@ -8979,7 +8979,7 @@
         </p:nvSpPr>
         <p:spPr>
           <a:xfrm>
-            <a:off x="15660000" y="19605067"/>
+            <a:off x="15660000" y="20084345"/>
             <a:ext cx="11988000" cy="504628"/>
           </a:xfrm>
           <a:prstGeom prst="rect">
@@ -9019,7 +9019,7 @@
         </p:nvSpPr>
         <p:spPr>
           <a:xfrm>
-            <a:off x="15660000" y="20145695"/>
+            <a:off x="15660000" y="20624973"/>
             <a:ext cx="2160000" cy="43200"/>
           </a:xfrm>
           <a:prstGeom prst="rect">
@@ -9062,7 +9062,7 @@
         </p:nvSpPr>
         <p:spPr>
           <a:xfrm>
-            <a:off x="15660000" y="20271695"/>
+            <a:off x="15660000" y="20750973"/>
             <a:ext cx="11988000" cy="576717"/>
           </a:xfrm>
           <a:prstGeom prst="rect">
@@ -9102,7 +9102,7 @@
         </p:nvSpPr>
         <p:spPr>
           <a:xfrm>
-            <a:off x="15660000" y="20956413"/>
+            <a:off x="15660000" y="21435691"/>
             <a:ext cx="11988000" cy="288358"/>
           </a:xfrm>
           <a:prstGeom prst="rect">
@@ -9142,7 +9142,7 @@
         </p:nvSpPr>
         <p:spPr>
           <a:xfrm>
-            <a:off x="15660000" y="21352772"/>
+            <a:off x="15660000" y="21832050"/>
             <a:ext cx="11988000" cy="288358"/>
           </a:xfrm>
           <a:prstGeom prst="rect">
@@ -9190,8 +9190,8 @@
         </p:blipFill>
         <p:spPr>
           <a:xfrm>
-            <a:off x="17578080" y="21749131"/>
-            <a:ext cx="8151840" cy="3041272"/>
+            <a:off x="16978680" y="22228409"/>
+            <a:ext cx="9350640" cy="3488518"/>
           </a:xfrm>
           <a:prstGeom prst="rect">
             <a:avLst/>
@@ -9214,7 +9214,7 @@
         </p:blipFill>
         <p:spPr>
           <a:xfrm>
-            <a:off x="15660000" y="24898404"/>
+            <a:off x="15660000" y="25824927"/>
             <a:ext cx="4473360" cy="4071022"/>
           </a:xfrm>
           <a:prstGeom prst="rect">
@@ -9230,7 +9230,7 @@
         </p:nvSpPr>
         <p:spPr>
           <a:xfrm>
-            <a:off x="15660000" y="29059426"/>
+            <a:off x="15660000" y="29985950"/>
             <a:ext cx="4473360" cy="252314"/>
           </a:xfrm>
           <a:prstGeom prst="rect">
@@ -9270,7 +9270,7 @@
         </p:nvSpPr>
         <p:spPr>
           <a:xfrm>
-            <a:off x="20349360" y="24898404"/>
+            <a:off x="20349360" y="25824927"/>
             <a:ext cx="7298640" cy="2652471"/>
           </a:xfrm>
           <a:prstGeom prst="rect">
@@ -9395,7 +9395,7 @@
         </p:blipFill>
         <p:spPr>
           <a:xfrm>
-            <a:off x="22814537" y="27550875"/>
+            <a:off x="22814537" y="28477399"/>
             <a:ext cx="2368285" cy="540000"/>
           </a:xfrm>
           <a:prstGeom prst="rect">
@@ -9419,7 +9419,7 @@
         </p:blipFill>
         <p:spPr>
           <a:xfrm>
-            <a:off x="22296537" y="28198875"/>
+            <a:off x="22296537" y="29125399"/>
             <a:ext cx="3404285" cy="540000"/>
           </a:xfrm>
           <a:prstGeom prst="rect">
@@ -9443,7 +9443,7 @@
         </p:blipFill>
         <p:spPr>
           <a:xfrm>
-            <a:off x="23200473" y="28846875"/>
+            <a:off x="23200473" y="29773399"/>
             <a:ext cx="1596413" cy="540000"/>
           </a:xfrm>
           <a:prstGeom prst="rect">
@@ -9459,7 +9459,7 @@
         </p:nvSpPr>
         <p:spPr>
           <a:xfrm>
-            <a:off x="15660000" y="29494875"/>
+            <a:off x="15660000" y="30421399"/>
             <a:ext cx="11988000" cy="504628"/>
           </a:xfrm>
           <a:prstGeom prst="rect">
@@ -9486,7 +9486,7 @@
                 </a:solidFill>
                 <a:latin typeface="Inter"/>
               </a:rPr>
-              <a:t>Те же признаки на CatBoost и нейросети статьи</a:t>
+              <a:t>Те же признаки на CatBoost</a:t>
             </a:r>
             <a:r>
               <a:rPr sz="1400" b="0">
@@ -9495,7 +9495,7 @@
                 </a:solidFill>
                 <a:latin typeface="Inter"/>
               </a:rPr>
-              <a:t> — общая постановка проекта: leave-one-subject-out, порог найдёт 90% сна, время ночи — clock или cosine:</a:t>
+              <a:t> — общая постановка проекта: leave-one-subject-out, признаки motion + hr + clock, порог найдёт 90% сна:</a:t>
             </a:r>
           </a:p>
         </p:txBody>
@@ -9509,8 +9509,8 @@
           <p:nvPr/>
         </p:nvGraphicFramePr>
         <p:xfrm>
-          <a:off x="15660000" y="30107504"/>
-          <a:ext cx="11987999" cy="2208863"/>
+          <a:off x="15660000" y="31034027"/>
+          <a:ext cx="11987996" cy="1214321"/>
         </p:xfrm>
         <a:graphic>
           <a:graphicData uri="http://schemas.openxmlformats.org/drawingml/2006/table">
@@ -9519,17 +9519,17 @@
                 <a:tableStyleId>{5C22544A-7EE6-4342-B048-85BDC9FD1C3A}</a:tableStyleId>
               </a:tblPr>
               <a:tblGrid>
-                <a:gridCol w="2976023"/>
-                <a:gridCol w="848979"/>
-                <a:gridCol w="848979"/>
-                <a:gridCol w="1110072"/>
-                <a:gridCol w="848979"/>
-                <a:gridCol w="848979"/>
-                <a:gridCol w="848979"/>
-                <a:gridCol w="848979"/>
-                <a:gridCol w="1110072"/>
-                <a:gridCol w="848979"/>
-                <a:gridCol w="848979"/>
+                <a:gridCol w="2910890"/>
+                <a:gridCol w="855492"/>
+                <a:gridCol w="855492"/>
+                <a:gridCol w="1116585"/>
+                <a:gridCol w="855492"/>
+                <a:gridCol w="855492"/>
+                <a:gridCol w="855492"/>
+                <a:gridCol w="855492"/>
+                <a:gridCol w="1116585"/>
+                <a:gridCol w="855492"/>
+                <a:gridCol w="855492"/>
               </a:tblGrid>
               <a:tr h="306269">
                 <a:tc>
@@ -9690,7 +9690,7 @@
                           </a:solidFill>
                           <a:latin typeface="Inter"/>
                         </a:rPr>
-                        <a:t>Модель · время</a:t>
+                        <a:t> </a:t>
                       </a:r>
                     </a:p>
                     <a:p>
@@ -9709,7 +9709,7 @@
                           </a:solidFill>
                           <a:latin typeface="Inter"/>
                         </a:rPr>
-                        <a:t>ночи</a:t>
+                        <a:t>Модель</a:t>
                       </a:r>
                     </a:p>
                   </a:txBody>
@@ -10538,1002 +10538,6 @@
                   <a:tcPr marL="64800" marR="64800" marT="21600" marB="21600" anchor="ctr">
                     <a:solidFill>
                       <a:srgbClr val="FFFFFF"/>
-                    </a:solidFill>
-                  </a:tcPr>
-                </a:tc>
-              </a:tr>
-              <a:tr h="331514">
-                <a:tc>
-                  <a:txBody>
-                    <a:bodyPr wrap="square"/>
-                    <a:lstStyle/>
-                    <a:p>
-                      <a:pPr algn="l">
-                        <a:lnSpc>
-                          <a:spcPct val="110000"/>
-                        </a:lnSpc>
-                        <a:spcAft>
-                          <a:spcPts val="0"/>
-                        </a:spcAft>
-                      </a:pPr>
-                      <a:r>
-                        <a:rPr sz="1400" b="0">
-                          <a:solidFill>
-                            <a:srgbClr val="1F2233"/>
-                          </a:solidFill>
-                          <a:latin typeface="Inter"/>
-                        </a:rPr>
-                        <a:t>CatBoost · cosine</a:t>
-                      </a:r>
-                    </a:p>
-                  </a:txBody>
-                  <a:tcPr marL="64800" marR="64800" marT="21600" marB="21600" anchor="ctr">
-                    <a:solidFill>
-                      <a:srgbClr val="F1F2FA"/>
-                    </a:solidFill>
-                  </a:tcPr>
-                </a:tc>
-                <a:tc>
-                  <a:txBody>
-                    <a:bodyPr wrap="square"/>
-                    <a:lstStyle/>
-                    <a:p>
-                      <a:pPr algn="ctr">
-                        <a:lnSpc>
-                          <a:spcPct val="110000"/>
-                        </a:lnSpc>
-                        <a:spcAft>
-                          <a:spcPts val="0"/>
-                        </a:spcAft>
-                      </a:pPr>
-                      <a:r>
-                        <a:rPr sz="1400" b="0">
-                          <a:solidFill>
-                            <a:srgbClr val="1F2233"/>
-                          </a:solidFill>
-                          <a:latin typeface="Inter"/>
-                        </a:rPr>
-                        <a:t>0.877</a:t>
-                      </a:r>
-                    </a:p>
-                  </a:txBody>
-                  <a:tcPr marL="64800" marR="64800" marT="21600" marB="21600" anchor="ctr">
-                    <a:solidFill>
-                      <a:srgbClr val="F1F2FA"/>
-                    </a:solidFill>
-                  </a:tcPr>
-                </a:tc>
-                <a:tc>
-                  <a:txBody>
-                    <a:bodyPr wrap="square"/>
-                    <a:lstStyle/>
-                    <a:p>
-                      <a:pPr algn="ctr">
-                        <a:lnSpc>
-                          <a:spcPct val="110000"/>
-                        </a:lnSpc>
-                        <a:spcAft>
-                          <a:spcPts val="0"/>
-                        </a:spcAft>
-                      </a:pPr>
-                      <a:r>
-                        <a:rPr sz="1400" b="0">
-                          <a:solidFill>
-                            <a:srgbClr val="1F2233"/>
-                          </a:solidFill>
-                          <a:latin typeface="Inter"/>
-                        </a:rPr>
-                        <a:t>0.593</a:t>
-                      </a:r>
-                    </a:p>
-                  </a:txBody>
-                  <a:tcPr marL="64800" marR="64800" marT="21600" marB="21600" anchor="ctr">
-                    <a:solidFill>
-                      <a:srgbClr val="F1F2FA"/>
-                    </a:solidFill>
-                  </a:tcPr>
-                </a:tc>
-                <a:tc>
-                  <a:txBody>
-                    <a:bodyPr wrap="square"/>
-                    <a:lstStyle/>
-                    <a:p>
-                      <a:pPr algn="ctr">
-                        <a:lnSpc>
-                          <a:spcPct val="110000"/>
-                        </a:lnSpc>
-                        <a:spcAft>
-                          <a:spcPts val="0"/>
-                        </a:spcAft>
-                      </a:pPr>
-                      <a:r>
-                        <a:rPr sz="1400" b="0">
-                          <a:solidFill>
-                            <a:srgbClr val="1F2233"/>
-                          </a:solidFill>
-                          <a:latin typeface="Inter"/>
-                        </a:rPr>
-                        <a:t>0.695</a:t>
-                      </a:r>
-                    </a:p>
-                  </a:txBody>
-                  <a:tcPr marL="64800" marR="64800" marT="21600" marB="21600" anchor="ctr">
-                    <a:solidFill>
-                      <a:srgbClr val="F1F2FA"/>
-                    </a:solidFill>
-                  </a:tcPr>
-                </a:tc>
-                <a:tc>
-                  <a:txBody>
-                    <a:bodyPr wrap="square"/>
-                    <a:lstStyle/>
-                    <a:p>
-                      <a:pPr algn="ctr">
-                        <a:lnSpc>
-                          <a:spcPct val="110000"/>
-                        </a:lnSpc>
-                        <a:spcAft>
-                          <a:spcPts val="0"/>
-                        </a:spcAft>
-                      </a:pPr>
-                      <a:r>
-                        <a:rPr sz="1400" b="0">
-                          <a:solidFill>
-                            <a:srgbClr val="1F2233"/>
-                          </a:solidFill>
-                          <a:latin typeface="Inter"/>
-                        </a:rPr>
-                        <a:t>0.440</a:t>
-                      </a:r>
-                    </a:p>
-                  </a:txBody>
-                  <a:tcPr marL="64800" marR="64800" marT="21600" marB="21600" anchor="ctr">
-                    <a:solidFill>
-                      <a:srgbClr val="F1F2FA"/>
-                    </a:solidFill>
-                  </a:tcPr>
-                </a:tc>
-                <a:tc>
-                  <a:txBody>
-                    <a:bodyPr wrap="square"/>
-                    <a:lstStyle/>
-                    <a:p>
-                      <a:pPr algn="ctr">
-                        <a:lnSpc>
-                          <a:spcPct val="110000"/>
-                        </a:lnSpc>
-                        <a:spcAft>
-                          <a:spcPts val="0"/>
-                        </a:spcAft>
-                      </a:pPr>
-                      <a:r>
-                        <a:rPr sz="1400" b="0">
-                          <a:solidFill>
-                            <a:srgbClr val="1F2233"/>
-                          </a:solidFill>
-                          <a:latin typeface="Inter"/>
-                        </a:rPr>
-                        <a:t>0.500</a:t>
-                      </a:r>
-                    </a:p>
-                  </a:txBody>
-                  <a:tcPr marL="64800" marR="64800" marT="21600" marB="21600" anchor="ctr">
-                    <a:solidFill>
-                      <a:srgbClr val="F1F2FA"/>
-                    </a:solidFill>
-                  </a:tcPr>
-                </a:tc>
-                <a:tc>
-                  <a:txBody>
-                    <a:bodyPr wrap="square"/>
-                    <a:lstStyle/>
-                    <a:p>
-                      <a:pPr algn="ctr">
-                        <a:lnSpc>
-                          <a:spcPct val="110000"/>
-                        </a:lnSpc>
-                        <a:spcAft>
-                          <a:spcPts val="0"/>
-                        </a:spcAft>
-                      </a:pPr>
-                      <a:r>
-                        <a:rPr sz="1400" b="0">
-                          <a:solidFill>
-                            <a:srgbClr val="1F2233"/>
-                          </a:solidFill>
-                          <a:latin typeface="Inter"/>
-                        </a:rPr>
-                        <a:t>0.885</a:t>
-                      </a:r>
-                    </a:p>
-                  </a:txBody>
-                  <a:tcPr marL="64800" marR="64800" marT="21600" marB="21600" anchor="ctr">
-                    <a:solidFill>
-                      <a:srgbClr val="F1F2FA"/>
-                    </a:solidFill>
-                  </a:tcPr>
-                </a:tc>
-                <a:tc>
-                  <a:txBody>
-                    <a:bodyPr wrap="square"/>
-                    <a:lstStyle/>
-                    <a:p>
-                      <a:pPr algn="ctr">
-                        <a:lnSpc>
-                          <a:spcPct val="110000"/>
-                        </a:lnSpc>
-                        <a:spcAft>
-                          <a:spcPts val="0"/>
-                        </a:spcAft>
-                      </a:pPr>
-                      <a:r>
-                        <a:rPr sz="1400" b="0">
-                          <a:solidFill>
-                            <a:srgbClr val="1F2233"/>
-                          </a:solidFill>
-                          <a:latin typeface="Inter"/>
-                        </a:rPr>
-                        <a:t>0.616</a:t>
-                      </a:r>
-                    </a:p>
-                  </a:txBody>
-                  <a:tcPr marL="64800" marR="64800" marT="21600" marB="21600" anchor="ctr">
-                    <a:solidFill>
-                      <a:srgbClr val="F1F2FA"/>
-                    </a:solidFill>
-                  </a:tcPr>
-                </a:tc>
-                <a:tc>
-                  <a:txBody>
-                    <a:bodyPr wrap="square"/>
-                    <a:lstStyle/>
-                    <a:p>
-                      <a:pPr algn="ctr">
-                        <a:lnSpc>
-                          <a:spcPct val="110000"/>
-                        </a:lnSpc>
-                        <a:spcAft>
-                          <a:spcPts val="0"/>
-                        </a:spcAft>
-                      </a:pPr>
-                      <a:r>
-                        <a:rPr sz="1400" b="0">
-                          <a:solidFill>
-                            <a:srgbClr val="1F2233"/>
-                          </a:solidFill>
-                          <a:latin typeface="Inter"/>
-                        </a:rPr>
-                        <a:t>0.706</a:t>
-                      </a:r>
-                    </a:p>
-                  </a:txBody>
-                  <a:tcPr marL="64800" marR="64800" marT="21600" marB="21600" anchor="ctr">
-                    <a:solidFill>
-                      <a:srgbClr val="F1F2FA"/>
-                    </a:solidFill>
-                  </a:tcPr>
-                </a:tc>
-                <a:tc>
-                  <a:txBody>
-                    <a:bodyPr wrap="square"/>
-                    <a:lstStyle/>
-                    <a:p>
-                      <a:pPr algn="ctr">
-                        <a:lnSpc>
-                          <a:spcPct val="110000"/>
-                        </a:lnSpc>
-                        <a:spcAft>
-                          <a:spcPts val="0"/>
-                        </a:spcAft>
-                      </a:pPr>
-                      <a:r>
-                        <a:rPr sz="1400" b="0">
-                          <a:solidFill>
-                            <a:srgbClr val="1F2233"/>
-                          </a:solidFill>
-                          <a:latin typeface="Inter"/>
-                        </a:rPr>
-                        <a:t>0.446</a:t>
-                      </a:r>
-                    </a:p>
-                  </a:txBody>
-                  <a:tcPr marL="64800" marR="64800" marT="21600" marB="21600" anchor="ctr">
-                    <a:solidFill>
-                      <a:srgbClr val="F1F2FA"/>
-                    </a:solidFill>
-                  </a:tcPr>
-                </a:tc>
-                <a:tc>
-                  <a:txBody>
-                    <a:bodyPr wrap="square"/>
-                    <a:lstStyle/>
-                    <a:p>
-                      <a:pPr algn="ctr">
-                        <a:lnSpc>
-                          <a:spcPct val="110000"/>
-                        </a:lnSpc>
-                        <a:spcAft>
-                          <a:spcPts val="0"/>
-                        </a:spcAft>
-                      </a:pPr>
-                      <a:r>
-                        <a:rPr sz="1400" b="0">
-                          <a:solidFill>
-                            <a:srgbClr val="1F2233"/>
-                          </a:solidFill>
-                          <a:latin typeface="Inter"/>
-                        </a:rPr>
-                        <a:t>0.506</a:t>
-                      </a:r>
-                    </a:p>
-                  </a:txBody>
-                  <a:tcPr marL="64800" marR="64800" marT="21600" marB="21600" anchor="ctr">
-                    <a:solidFill>
-                      <a:srgbClr val="F1F2FA"/>
-                    </a:solidFill>
-                  </a:tcPr>
-                </a:tc>
-              </a:tr>
-              <a:tr h="331514">
-                <a:tc>
-                  <a:txBody>
-                    <a:bodyPr wrap="square"/>
-                    <a:lstStyle/>
-                    <a:p>
-                      <a:pPr algn="l">
-                        <a:lnSpc>
-                          <a:spcPct val="110000"/>
-                        </a:lnSpc>
-                        <a:spcAft>
-                          <a:spcPts val="0"/>
-                        </a:spcAft>
-                      </a:pPr>
-                      <a:r>
-                        <a:rPr sz="1400" b="0">
-                          <a:solidFill>
-                            <a:srgbClr val="1F2233"/>
-                          </a:solidFill>
-                          <a:latin typeface="Inter"/>
-                        </a:rPr>
-                        <a:t>MLP · clock</a:t>
-                      </a:r>
-                    </a:p>
-                  </a:txBody>
-                  <a:tcPr marL="64800" marR="64800" marT="21600" marB="21600" anchor="ctr">
-                    <a:solidFill>
-                      <a:srgbClr val="FFFFFF"/>
-                    </a:solidFill>
-                  </a:tcPr>
-                </a:tc>
-                <a:tc>
-                  <a:txBody>
-                    <a:bodyPr wrap="square"/>
-                    <a:lstStyle/>
-                    <a:p>
-                      <a:pPr algn="ctr">
-                        <a:lnSpc>
-                          <a:spcPct val="110000"/>
-                        </a:lnSpc>
-                        <a:spcAft>
-                          <a:spcPts val="0"/>
-                        </a:spcAft>
-                      </a:pPr>
-                      <a:r>
-                        <a:rPr sz="1400" b="0">
-                          <a:solidFill>
-                            <a:srgbClr val="1F2233"/>
-                          </a:solidFill>
-                          <a:latin typeface="Inter"/>
-                        </a:rPr>
-                        <a:t>0.877</a:t>
-                      </a:r>
-                    </a:p>
-                  </a:txBody>
-                  <a:tcPr marL="64800" marR="64800" marT="21600" marB="21600" anchor="ctr">
-                    <a:solidFill>
-                      <a:srgbClr val="FFFFFF"/>
-                    </a:solidFill>
-                  </a:tcPr>
-                </a:tc>
-                <a:tc>
-                  <a:txBody>
-                    <a:bodyPr wrap="square"/>
-                    <a:lstStyle/>
-                    <a:p>
-                      <a:pPr algn="ctr">
-                        <a:lnSpc>
-                          <a:spcPct val="110000"/>
-                        </a:lnSpc>
-                        <a:spcAft>
-                          <a:spcPts val="0"/>
-                        </a:spcAft>
-                      </a:pPr>
-                      <a:r>
-                        <a:rPr sz="1400" b="0">
-                          <a:solidFill>
-                            <a:srgbClr val="1F2233"/>
-                          </a:solidFill>
-                          <a:latin typeface="Inter"/>
-                        </a:rPr>
-                        <a:t>0.560</a:t>
-                      </a:r>
-                    </a:p>
-                  </a:txBody>
-                  <a:tcPr marL="64800" marR="64800" marT="21600" marB="21600" anchor="ctr">
-                    <a:solidFill>
-                      <a:srgbClr val="FFFFFF"/>
-                    </a:solidFill>
-                  </a:tcPr>
-                </a:tc>
-                <a:tc>
-                  <a:txBody>
-                    <a:bodyPr wrap="square"/>
-                    <a:lstStyle/>
-                    <a:p>
-                      <a:pPr algn="ctr">
-                        <a:lnSpc>
-                          <a:spcPct val="110000"/>
-                        </a:lnSpc>
-                        <a:spcAft>
-                          <a:spcPts val="0"/>
-                        </a:spcAft>
-                      </a:pPr>
-                      <a:r>
-                        <a:rPr sz="1400" b="0">
-                          <a:solidFill>
-                            <a:srgbClr val="1F2233"/>
-                          </a:solidFill>
-                          <a:latin typeface="Inter"/>
-                        </a:rPr>
-                        <a:t>0.677</a:t>
-                      </a:r>
-                    </a:p>
-                  </a:txBody>
-                  <a:tcPr marL="64800" marR="64800" marT="21600" marB="21600" anchor="ctr">
-                    <a:solidFill>
-                      <a:srgbClr val="FFFFFF"/>
-                    </a:solidFill>
-                  </a:tcPr>
-                </a:tc>
-                <a:tc>
-                  <a:txBody>
-                    <a:bodyPr wrap="square"/>
-                    <a:lstStyle/>
-                    <a:p>
-                      <a:pPr algn="ctr">
-                        <a:lnSpc>
-                          <a:spcPct val="110000"/>
-                        </a:lnSpc>
-                        <a:spcAft>
-                          <a:spcPts val="0"/>
-                        </a:spcAft>
-                      </a:pPr>
-                      <a:r>
-                        <a:rPr sz="1400" b="0">
-                          <a:solidFill>
-                            <a:srgbClr val="1F2233"/>
-                          </a:solidFill>
-                          <a:latin typeface="Inter"/>
-                        </a:rPr>
-                        <a:t>0.429</a:t>
-                      </a:r>
-                    </a:p>
-                  </a:txBody>
-                  <a:tcPr marL="64800" marR="64800" marT="21600" marB="21600" anchor="ctr">
-                    <a:solidFill>
-                      <a:srgbClr val="FFFFFF"/>
-                    </a:solidFill>
-                  </a:tcPr>
-                </a:tc>
-                <a:tc>
-                  <a:txBody>
-                    <a:bodyPr wrap="square"/>
-                    <a:lstStyle/>
-                    <a:p>
-                      <a:pPr algn="ctr">
-                        <a:lnSpc>
-                          <a:spcPct val="110000"/>
-                        </a:lnSpc>
-                        <a:spcAft>
-                          <a:spcPts val="0"/>
-                        </a:spcAft>
-                      </a:pPr>
-                      <a:r>
-                        <a:rPr sz="1400" b="0">
-                          <a:solidFill>
-                            <a:srgbClr val="1F2233"/>
-                          </a:solidFill>
-                          <a:latin typeface="Inter"/>
-                        </a:rPr>
-                        <a:t>0.491</a:t>
-                      </a:r>
-                    </a:p>
-                  </a:txBody>
-                  <a:tcPr marL="64800" marR="64800" marT="21600" marB="21600" anchor="ctr">
-                    <a:solidFill>
-                      <a:srgbClr val="FFFFFF"/>
-                    </a:solidFill>
-                  </a:tcPr>
-                </a:tc>
-                <a:tc>
-                  <a:txBody>
-                    <a:bodyPr wrap="square"/>
-                    <a:lstStyle/>
-                    <a:p>
-                      <a:pPr algn="ctr">
-                        <a:lnSpc>
-                          <a:spcPct val="110000"/>
-                        </a:lnSpc>
-                        <a:spcAft>
-                          <a:spcPts val="0"/>
-                        </a:spcAft>
-                      </a:pPr>
-                      <a:r>
-                        <a:rPr sz="1400" b="0">
-                          <a:solidFill>
-                            <a:srgbClr val="1F2233"/>
-                          </a:solidFill>
-                          <a:latin typeface="Inter"/>
-                        </a:rPr>
-                        <a:t>0.883</a:t>
-                      </a:r>
-                    </a:p>
-                  </a:txBody>
-                  <a:tcPr marL="64800" marR="64800" marT="21600" marB="21600" anchor="ctr">
-                    <a:solidFill>
-                      <a:srgbClr val="FFFFFF"/>
-                    </a:solidFill>
-                  </a:tcPr>
-                </a:tc>
-                <a:tc>
-                  <a:txBody>
-                    <a:bodyPr wrap="square"/>
-                    <a:lstStyle/>
-                    <a:p>
-                      <a:pPr algn="ctr">
-                        <a:lnSpc>
-                          <a:spcPct val="110000"/>
-                        </a:lnSpc>
-                        <a:spcAft>
-                          <a:spcPts val="0"/>
-                        </a:spcAft>
-                      </a:pPr>
-                      <a:r>
-                        <a:rPr sz="1400" b="0">
-                          <a:solidFill>
-                            <a:srgbClr val="1F2233"/>
-                          </a:solidFill>
-                          <a:latin typeface="Inter"/>
-                        </a:rPr>
-                        <a:t>0.556</a:t>
-                      </a:r>
-                    </a:p>
-                  </a:txBody>
-                  <a:tcPr marL="64800" marR="64800" marT="21600" marB="21600" anchor="ctr">
-                    <a:solidFill>
-                      <a:srgbClr val="FFFFFF"/>
-                    </a:solidFill>
-                  </a:tcPr>
-                </a:tc>
-                <a:tc>
-                  <a:txBody>
-                    <a:bodyPr wrap="square"/>
-                    <a:lstStyle/>
-                    <a:p>
-                      <a:pPr algn="ctr">
-                        <a:lnSpc>
-                          <a:spcPct val="110000"/>
-                        </a:lnSpc>
-                        <a:spcAft>
-                          <a:spcPts val="0"/>
-                        </a:spcAft>
-                      </a:pPr>
-                      <a:r>
-                        <a:rPr sz="1400" b="0">
-                          <a:solidFill>
-                            <a:srgbClr val="1F2233"/>
-                          </a:solidFill>
-                          <a:latin typeface="Inter"/>
-                        </a:rPr>
-                        <a:t>0.709</a:t>
-                      </a:r>
-                    </a:p>
-                  </a:txBody>
-                  <a:tcPr marL="64800" marR="64800" marT="21600" marB="21600" anchor="ctr">
-                    <a:solidFill>
-                      <a:srgbClr val="FFFFFF"/>
-                    </a:solidFill>
-                  </a:tcPr>
-                </a:tc>
-                <a:tc>
-                  <a:txBody>
-                    <a:bodyPr wrap="square"/>
-                    <a:lstStyle/>
-                    <a:p>
-                      <a:pPr algn="ctr">
-                        <a:lnSpc>
-                          <a:spcPct val="110000"/>
-                        </a:lnSpc>
-                        <a:spcAft>
-                          <a:spcPts val="0"/>
-                        </a:spcAft>
-                      </a:pPr>
-                      <a:r>
-                        <a:rPr sz="1400" b="0">
-                          <a:solidFill>
-                            <a:srgbClr val="1F2233"/>
-                          </a:solidFill>
-                          <a:latin typeface="Inter"/>
-                        </a:rPr>
-                        <a:t>0.448</a:t>
-                      </a:r>
-                    </a:p>
-                  </a:txBody>
-                  <a:tcPr marL="64800" marR="64800" marT="21600" marB="21600" anchor="ctr">
-                    <a:solidFill>
-                      <a:srgbClr val="FFFFFF"/>
-                    </a:solidFill>
-                  </a:tcPr>
-                </a:tc>
-                <a:tc>
-                  <a:txBody>
-                    <a:bodyPr wrap="square"/>
-                    <a:lstStyle/>
-                    <a:p>
-                      <a:pPr algn="ctr">
-                        <a:lnSpc>
-                          <a:spcPct val="110000"/>
-                        </a:lnSpc>
-                        <a:spcAft>
-                          <a:spcPts val="0"/>
-                        </a:spcAft>
-                      </a:pPr>
-                      <a:r>
-                        <a:rPr sz="1400" b="0">
-                          <a:solidFill>
-                            <a:srgbClr val="1F2233"/>
-                          </a:solidFill>
-                          <a:latin typeface="Inter"/>
-                        </a:rPr>
-                        <a:t>0.507</a:t>
-                      </a:r>
-                    </a:p>
-                  </a:txBody>
-                  <a:tcPr marL="64800" marR="64800" marT="21600" marB="21600" anchor="ctr">
-                    <a:solidFill>
-                      <a:srgbClr val="FFFFFF"/>
-                    </a:solidFill>
-                  </a:tcPr>
-                </a:tc>
-              </a:tr>
-              <a:tr h="331514">
-                <a:tc>
-                  <a:txBody>
-                    <a:bodyPr wrap="square"/>
-                    <a:lstStyle/>
-                    <a:p>
-                      <a:pPr algn="l">
-                        <a:lnSpc>
-                          <a:spcPct val="110000"/>
-                        </a:lnSpc>
-                        <a:spcAft>
-                          <a:spcPts val="0"/>
-                        </a:spcAft>
-                      </a:pPr>
-                      <a:r>
-                        <a:rPr sz="1400" b="0">
-                          <a:solidFill>
-                            <a:srgbClr val="1F2233"/>
-                          </a:solidFill>
-                          <a:latin typeface="Inter"/>
-                        </a:rPr>
-                        <a:t>MLP · cosine</a:t>
-                      </a:r>
-                    </a:p>
-                  </a:txBody>
-                  <a:tcPr marL="64800" marR="64800" marT="21600" marB="21600" anchor="ctr">
-                    <a:solidFill>
-                      <a:srgbClr val="F1F2FA"/>
-                    </a:solidFill>
-                  </a:tcPr>
-                </a:tc>
-                <a:tc>
-                  <a:txBody>
-                    <a:bodyPr wrap="square"/>
-                    <a:lstStyle/>
-                    <a:p>
-                      <a:pPr algn="ctr">
-                        <a:lnSpc>
-                          <a:spcPct val="110000"/>
-                        </a:lnSpc>
-                        <a:spcAft>
-                          <a:spcPts val="0"/>
-                        </a:spcAft>
-                      </a:pPr>
-                      <a:r>
-                        <a:rPr sz="1400" b="0">
-                          <a:solidFill>
-                            <a:srgbClr val="1F2233"/>
-                          </a:solidFill>
-                          <a:latin typeface="Inter"/>
-                        </a:rPr>
-                        <a:t>0.876</a:t>
-                      </a:r>
-                    </a:p>
-                  </a:txBody>
-                  <a:tcPr marL="64800" marR="64800" marT="21600" marB="21600" anchor="ctr">
-                    <a:solidFill>
-                      <a:srgbClr val="F1F2FA"/>
-                    </a:solidFill>
-                  </a:tcPr>
-                </a:tc>
-                <a:tc>
-                  <a:txBody>
-                    <a:bodyPr wrap="square"/>
-                    <a:lstStyle/>
-                    <a:p>
-                      <a:pPr algn="ctr">
-                        <a:lnSpc>
-                          <a:spcPct val="110000"/>
-                        </a:lnSpc>
-                        <a:spcAft>
-                          <a:spcPts val="0"/>
-                        </a:spcAft>
-                      </a:pPr>
-                      <a:r>
-                        <a:rPr sz="1400" b="0">
-                          <a:solidFill>
-                            <a:srgbClr val="1F2233"/>
-                          </a:solidFill>
-                          <a:latin typeface="Inter"/>
-                        </a:rPr>
-                        <a:t>0.586</a:t>
-                      </a:r>
-                    </a:p>
-                  </a:txBody>
-                  <a:tcPr marL="64800" marR="64800" marT="21600" marB="21600" anchor="ctr">
-                    <a:solidFill>
-                      <a:srgbClr val="F1F2FA"/>
-                    </a:solidFill>
-                  </a:tcPr>
-                </a:tc>
-                <a:tc>
-                  <a:txBody>
-                    <a:bodyPr wrap="square"/>
-                    <a:lstStyle/>
-                    <a:p>
-                      <a:pPr algn="ctr">
-                        <a:lnSpc>
-                          <a:spcPct val="110000"/>
-                        </a:lnSpc>
-                        <a:spcAft>
-                          <a:spcPts val="0"/>
-                        </a:spcAft>
-                      </a:pPr>
-                      <a:r>
-                        <a:rPr sz="1400" b="0">
-                          <a:solidFill>
-                            <a:srgbClr val="1F2233"/>
-                          </a:solidFill>
-                          <a:latin typeface="Inter"/>
-                        </a:rPr>
-                        <a:t>0.699</a:t>
-                      </a:r>
-                    </a:p>
-                  </a:txBody>
-                  <a:tcPr marL="64800" marR="64800" marT="21600" marB="21600" anchor="ctr">
-                    <a:solidFill>
-                      <a:srgbClr val="F1F2FA"/>
-                    </a:solidFill>
-                  </a:tcPr>
-                </a:tc>
-                <a:tc>
-                  <a:txBody>
-                    <a:bodyPr wrap="square"/>
-                    <a:lstStyle/>
-                    <a:p>
-                      <a:pPr algn="ctr">
-                        <a:lnSpc>
-                          <a:spcPct val="110000"/>
-                        </a:lnSpc>
-                        <a:spcAft>
-                          <a:spcPts val="0"/>
-                        </a:spcAft>
-                      </a:pPr>
-                      <a:r>
-                        <a:rPr sz="1400" b="0">
-                          <a:solidFill>
-                            <a:srgbClr val="1F2233"/>
-                          </a:solidFill>
-                          <a:latin typeface="Inter"/>
-                        </a:rPr>
-                        <a:t>0.442</a:t>
-                      </a:r>
-                    </a:p>
-                  </a:txBody>
-                  <a:tcPr marL="64800" marR="64800" marT="21600" marB="21600" anchor="ctr">
-                    <a:solidFill>
-                      <a:srgbClr val="F1F2FA"/>
-                    </a:solidFill>
-                  </a:tcPr>
-                </a:tc>
-                <a:tc>
-                  <a:txBody>
-                    <a:bodyPr wrap="square"/>
-                    <a:lstStyle/>
-                    <a:p>
-                      <a:pPr algn="ctr">
-                        <a:lnSpc>
-                          <a:spcPct val="110000"/>
-                        </a:lnSpc>
-                        <a:spcAft>
-                          <a:spcPts val="0"/>
-                        </a:spcAft>
-                      </a:pPr>
-                      <a:r>
-                        <a:rPr sz="1400" b="0">
-                          <a:solidFill>
-                            <a:srgbClr val="1F2233"/>
-                          </a:solidFill>
-                          <a:latin typeface="Inter"/>
-                        </a:rPr>
-                        <a:t>0.502</a:t>
-                      </a:r>
-                    </a:p>
-                  </a:txBody>
-                  <a:tcPr marL="64800" marR="64800" marT="21600" marB="21600" anchor="ctr">
-                    <a:solidFill>
-                      <a:srgbClr val="F1F2FA"/>
-                    </a:solidFill>
-                  </a:tcPr>
-                </a:tc>
-                <a:tc>
-                  <a:txBody>
-                    <a:bodyPr wrap="square"/>
-                    <a:lstStyle/>
-                    <a:p>
-                      <a:pPr algn="ctr">
-                        <a:lnSpc>
-                          <a:spcPct val="110000"/>
-                        </a:lnSpc>
-                        <a:spcAft>
-                          <a:spcPts val="0"/>
-                        </a:spcAft>
-                      </a:pPr>
-                      <a:r>
-                        <a:rPr sz="1400" b="0">
-                          <a:solidFill>
-                            <a:srgbClr val="1F2233"/>
-                          </a:solidFill>
-                          <a:latin typeface="Inter"/>
-                        </a:rPr>
-                        <a:t>0.877</a:t>
-                      </a:r>
-                    </a:p>
-                  </a:txBody>
-                  <a:tcPr marL="64800" marR="64800" marT="21600" marB="21600" anchor="ctr">
-                    <a:solidFill>
-                      <a:srgbClr val="F1F2FA"/>
-                    </a:solidFill>
-                  </a:tcPr>
-                </a:tc>
-                <a:tc>
-                  <a:txBody>
-                    <a:bodyPr wrap="square"/>
-                    <a:lstStyle/>
-                    <a:p>
-                      <a:pPr algn="ctr">
-                        <a:lnSpc>
-                          <a:spcPct val="110000"/>
-                        </a:lnSpc>
-                        <a:spcAft>
-                          <a:spcPts val="0"/>
-                        </a:spcAft>
-                      </a:pPr>
-                      <a:r>
-                        <a:rPr sz="1400" b="0">
-                          <a:solidFill>
-                            <a:srgbClr val="1F2233"/>
-                          </a:solidFill>
-                          <a:latin typeface="Inter"/>
-                        </a:rPr>
-                        <a:t>0.593</a:t>
-                      </a:r>
-                    </a:p>
-                  </a:txBody>
-                  <a:tcPr marL="64800" marR="64800" marT="21600" marB="21600" anchor="ctr">
-                    <a:solidFill>
-                      <a:srgbClr val="F1F2FA"/>
-                    </a:solidFill>
-                  </a:tcPr>
-                </a:tc>
-                <a:tc>
-                  <a:txBody>
-                    <a:bodyPr wrap="square"/>
-                    <a:lstStyle/>
-                    <a:p>
-                      <a:pPr algn="ctr">
-                        <a:lnSpc>
-                          <a:spcPct val="110000"/>
-                        </a:lnSpc>
-                        <a:spcAft>
-                          <a:spcPts val="0"/>
-                        </a:spcAft>
-                      </a:pPr>
-                      <a:r>
-                        <a:rPr sz="1400" b="0">
-                          <a:solidFill>
-                            <a:srgbClr val="1F2233"/>
-                          </a:solidFill>
-                          <a:latin typeface="Inter"/>
-                        </a:rPr>
-                        <a:t>0.715</a:t>
-                      </a:r>
-                    </a:p>
-                  </a:txBody>
-                  <a:tcPr marL="64800" marR="64800" marT="21600" marB="21600" anchor="ctr">
-                    <a:solidFill>
-                      <a:srgbClr val="F1F2FA"/>
-                    </a:solidFill>
-                  </a:tcPr>
-                </a:tc>
-                <a:tc>
-                  <a:txBody>
-                    <a:bodyPr wrap="square"/>
-                    <a:lstStyle/>
-                    <a:p>
-                      <a:pPr algn="ctr">
-                        <a:lnSpc>
-                          <a:spcPct val="110000"/>
-                        </a:lnSpc>
-                        <a:spcAft>
-                          <a:spcPts val="0"/>
-                        </a:spcAft>
-                      </a:pPr>
-                      <a:r>
-                        <a:rPr sz="1400" b="0">
-                          <a:solidFill>
-                            <a:srgbClr val="1F2233"/>
-                          </a:solidFill>
-                          <a:latin typeface="Inter"/>
-                        </a:rPr>
-                        <a:t>0.451</a:t>
-                      </a:r>
-                    </a:p>
-                  </a:txBody>
-                  <a:tcPr marL="64800" marR="64800" marT="21600" marB="21600" anchor="ctr">
-                    <a:solidFill>
-                      <a:srgbClr val="F1F2FA"/>
-                    </a:solidFill>
-                  </a:tcPr>
-                </a:tc>
-                <a:tc>
-                  <a:txBody>
-                    <a:bodyPr wrap="square"/>
-                    <a:lstStyle/>
-                    <a:p>
-                      <a:pPr algn="ctr">
-                        <a:lnSpc>
-                          <a:spcPct val="110000"/>
-                        </a:lnSpc>
-                        <a:spcAft>
-                          <a:spcPts val="0"/>
-                        </a:spcAft>
-                      </a:pPr>
-                      <a:r>
-                        <a:rPr sz="1400" b="0">
-                          <a:solidFill>
-                            <a:srgbClr val="1F2233"/>
-                          </a:solidFill>
-                          <a:latin typeface="Inter"/>
-                        </a:rPr>
-                        <a:t>0.511</a:t>
-                      </a:r>
-                    </a:p>
-                  </a:txBody>
-                  <a:tcPr marL="64800" marR="64800" marT="21600" marB="21600" anchor="ctr">
-                    <a:solidFill>
-                      <a:srgbClr val="F1F2FA"/>
                     </a:solidFill>
                   </a:tcPr>
                 </a:tc>
@@ -11550,7 +10554,7 @@
         </p:nvSpPr>
         <p:spPr>
           <a:xfrm>
-            <a:off x="15660000" y="32424368"/>
+            <a:off x="15660000" y="32356349"/>
             <a:ext cx="11988000" cy="612628"/>
           </a:xfrm>
           <a:prstGeom prst="rect">
@@ -11582,7 +10586,7 @@
                 </a:solidFill>
                 <a:latin typeface="Inter"/>
               </a:rPr>
-              <a:t>Быстрые признаки улучшают обе модели почти по всем метрикам.</a:t>
+              <a:t>Быстрые признаки улучшают CatBoost по всем метрикам:</a:t>
             </a:r>
             <a:r>
               <a:rPr sz="1400" b="0">
@@ -11591,7 +10595,7 @@
                 </a:solidFill>
                 <a:latin typeface="Inter"/>
               </a:rPr>
-              <a:t> CatBoost: AUC 0.880 → </a:t>
+              <a:t> AUC 0.880 → </a:t>
             </a:r>
             <a:r>
               <a:rPr sz="1400" b="1">
@@ -11622,8 +10626,8 @@
         </p:nvSpPr>
         <p:spPr>
           <a:xfrm>
-            <a:off x="15408000" y="33407953"/>
-            <a:ext cx="12492000" cy="6768046"/>
+            <a:off x="15408000" y="33373944"/>
+            <a:ext cx="12492000" cy="6802055"/>
           </a:xfrm>
           <a:prstGeom prst="roundRect">
             <a:avLst>
@@ -11670,7 +10674,7 @@
         </p:nvSpPr>
         <p:spPr>
           <a:xfrm>
-            <a:off x="15660000" y="33659953"/>
+            <a:off x="15660000" y="33625944"/>
             <a:ext cx="11988000" cy="504628"/>
           </a:xfrm>
           <a:prstGeom prst="rect">
@@ -11710,7 +10714,7 @@
         </p:nvSpPr>
         <p:spPr>
           <a:xfrm>
-            <a:off x="15660000" y="34200581"/>
+            <a:off x="15660000" y="34166572"/>
             <a:ext cx="2160000" cy="43200"/>
           </a:xfrm>
           <a:prstGeom prst="rect">
@@ -11753,7 +10757,7 @@
         </p:nvSpPr>
         <p:spPr>
           <a:xfrm>
-            <a:off x="15660000" y="34326581"/>
+            <a:off x="15660000" y="34292572"/>
             <a:ext cx="11988000" cy="5694461"/>
           </a:xfrm>
           <a:prstGeom prst="rect">

</xml_diff>